<commit_message>
Add graphs sheet + references to week 3 deck and briefing
New sheet 09 (Victor): the physics as two matplotlib figures in deck
style. Left, channel utilization versus broadcast interval with the
collapse point at 1 s, the 25 percent duty ceiling, and our 10 s
operating point. Right, displayed position error over time at 45 mph
comparing a raw held fix (200 m sawtooth) with dead reckoning (bounded
near 25 m worst case). Compact source strip on the sheet; briefing
gains the graph walkthrough script and ten full citations (Semtech
datasheets and AN1200.22, Meshtastic docs and protobufs, FCC 15.247,
ITU-R M.1371, Sinnott haversine, Bluetooth Core, our own repo docs).

Co-Authored-By: Claude Fable 5 <noreply@anthropic.com>
</commit_message>
<xml_diff>
--- a/docs/presentations/Group9_Presentation3_Week3.pptx
+++ b/docs/presentations/Group9_Presentation3_Week3.pptx
@@ -15,9 +15,10 @@
     <p:sldId id="263" r:id="rId9"/>
     <p:sldId id="264" r:id="rId10"/>
     <p:sldId id="265" r:id="rId11"/>
+    <p:sldId id="266" r:id="rId12"/>
   </p:sldIdLst>
   <p:notesMasterIdLst>
-    <p:notesMasterId r:id="rId12"/>
+    <p:notesMasterId r:id="rId13"/>
   </p:notesMasterIdLst>
   <p:sldSz cx="12192000" cy="6858000"/>
   <p:notesSz cx="6858000" cy="12192000"/>
@@ -599,7 +600,7 @@
           <a:p>
             <a:r>
               <a:rPr lang="en-US" dirty="0"/>
-              <a:t/>
+              <a:t>Each card becomes a line item in the test protocol. The strength of this slide is provenance: phantom speed, the advertise-once trap, the charger cutoff, and the configuration revert were all found by us, on our hardware, and every one is documented in the repository with its fix.</a:t>
             </a:r>
             <a:endParaRPr lang="en-US" dirty="0"/>
           </a:p>
@@ -623,6 +624,94 @@
             <a:fld id="{F7021451-1387-4CA6-816F-3879F97B5CBC}" type="slidenum">
               <a:rPr lang="en-US"/>
               <a:t>10</a:t>
+            </a:fld>
+            <a:endParaRPr lang="en-US"/>
+          </a:p>
+        </p:txBody>
+      </p:sp>
+    </p:spTree>
+    <p:extLst>
+      <p:ext uri="{BB962C8B-B14F-4D97-AF65-F5344CB8AC3E}">
+        <p14:creationId xmlns:p14="http://schemas.microsoft.com/office/powerpoint/2010/main" val="1024086991"/>
+      </p:ext>
+    </p:extLst>
+  </p:cSld>
+  <p:clrMapOvr>
+    <a:masterClrMapping/>
+  </p:clrMapOvr>
+</p:notes>
+</file>
+
+<file path=ppt/notesSlides/notesSlide11.xml><?xml version="1.0" encoding="utf-8"?>
+<p:notes xmlns:a="http://schemas.openxmlformats.org/drawingml/2006/main" xmlns:r="http://schemas.openxmlformats.org/officeDocument/2006/relationships" xmlns:p="http://schemas.openxmlformats.org/presentationml/2006/main">
+  <p:cSld>
+    <p:spTree>
+      <p:nvGrpSpPr>
+        <p:cNvPr id="1" name=""/>
+        <p:cNvGrpSpPr/>
+        <p:nvPr/>
+      </p:nvGrpSpPr>
+      <p:grpSpPr>
+        <a:xfrm>
+          <a:off x="0" y="0"/>
+          <a:ext cx="0" cy="0"/>
+          <a:chOff x="0" y="0"/>
+          <a:chExt cx="0" cy="0"/>
+        </a:xfrm>
+      </p:grpSpPr>
+      <p:sp>
+        <p:nvSpPr>
+          <p:cNvPr id="2" name="Slide Image Placeholder 1"/>
+          <p:cNvSpPr>
+            <a:spLocks noGrp="1" noRot="1" noChangeAspect="1"/>
+          </p:cNvSpPr>
+          <p:nvPr>
+            <p:ph type="sldImg"/>
+          </p:nvPr>
+        </p:nvSpPr>
+        <p:spPr/>
+      </p:sp>
+      <p:sp>
+        <p:nvSpPr>
+          <p:cNvPr id="3" name="Notes Placeholder 2"/>
+          <p:cNvSpPr>
+            <a:spLocks noGrp="1"/>
+          </p:cNvSpPr>
+          <p:nvPr>
+            <p:ph type="body" idx="1"/>
+          </p:nvPr>
+        </p:nvSpPr>
+        <p:spPr/>
+        <p:txBody>
+          <a:bodyPr/>
+          <a:lstStyle/>
+          <a:p>
+            <a:r>
+              <a:rPr lang="en-US" dirty="0"/>
+              <a:t/>
+            </a:r>
+            <a:endParaRPr lang="en-US" dirty="0"/>
+          </a:p>
+        </p:txBody>
+      </p:sp>
+      <p:sp>
+        <p:nvSpPr>
+          <p:cNvPr id="4" name="Slide Number Placeholder 3"/>
+          <p:cNvSpPr>
+            <a:spLocks noGrp="1"/>
+          </p:cNvSpPr>
+          <p:nvPr>
+            <p:ph type="sldNum" sz="quarter" idx="10"/>
+          </p:nvPr>
+        </p:nvSpPr>
+        <p:spPr/>
+        <p:txBody>
+          <a:bodyPr/>
+          <a:lstStyle/>
+          <a:p>
+            <a:fld id="{F7021451-1387-4CA6-816F-3879F97B5CBC}" type="slidenum">
+              <a:rPr lang="en-US"/>
+              <a:t>11</a:t>
             </a:fld>
             <a:endParaRPr lang="en-US"/>
           </a:p>
@@ -1303,7 +1392,7 @@
           <a:p>
             <a:r>
               <a:rPr lang="en-US" dirty="0"/>
-              <a:t>Each card becomes a line item in the test protocol. The strength of this slide is provenance: phantom speed, the advertise-once trap, the charger cutoff, and the configuration revert were all found by us, on our hardware, and every one is documented in the repository with its fix.</a:t>
+              <a:t>Two pictures replace ten minutes of argument. Left graph: utilization is inversely proportional to the interval; the 1 s point is literally impossible and the dashed line is Meshtastic's own 25 percent duty limit; we sit at 10 percent. Right graph: the sawtooth is the display error over time at 45 mph; orange is what holding the raw fix would show, up to 200 meters stale; navy is dead reckoning with a worst-case maneuver assumption of 0.5 m/s^2, bounded near 25 meters and typically a few meters in steady driving. Sources are on this sheet's reference list in the notes: the SNR-per-spreading-factor table and airtime equations are from Semtech's datasheet and AN1200.22, the duty limit and configuration from the Meshtastic documentation, and the AIS precedent from ITU-R M.1371.</a:t>
             </a:r>
             <a:endParaRPr lang="en-US" dirty="0"/>
           </a:p>
@@ -1832,7 +1921,7 @@
                 <a:ea typeface="Courier New" pitchFamily="34" charset="-122"/>
                 <a:cs typeface="Courier New" pitchFamily="34" charset="-120"/>
               </a:rPr>
-              <a:t>SHEET 01/10  REV C  2026-09-07</a:t>
+              <a:t>SHEET 01/11  REV C  2026-09-07</a:t>
             </a:r>
             <a:endParaRPr lang="en-US" sz="900" dirty="0"/>
           </a:p>
@@ -4647,7 +4736,7 @@
                 <a:ea typeface="Courier New" pitchFamily="34" charset="-122"/>
                 <a:cs typeface="Courier New" pitchFamily="34" charset="-120"/>
               </a:rPr>
-              <a:t>STATUS AND NEXT STEPS</a:t>
+              <a:t>INTEGRATION CONSTRAINTS</a:t>
             </a:r>
             <a:endParaRPr lang="en-US" sz="900" dirty="0"/>
           </a:p>
@@ -4686,7 +4775,1046 @@
                 <a:ea typeface="Courier New" pitchFamily="34" charset="-122"/>
                 <a:cs typeface="Courier New" pitchFamily="34" charset="-120"/>
               </a:rPr>
-              <a:t>SHEET 10/10  REV C  2026-09-07</a:t>
+              <a:t>SHEET 10/11  REV C  2026-09-07</a:t>
+            </a:r>
+            <a:endParaRPr lang="en-US" sz="900" dirty="0"/>
+          </a:p>
+        </p:txBody>
+      </p:sp>
+      <p:sp>
+        <p:nvSpPr>
+          <p:cNvPr id="7" name="Shape 5"/>
+          <p:cNvSpPr/>
+          <p:nvPr/>
+        </p:nvSpPr>
+        <p:spPr>
+          <a:xfrm>
+            <a:off x="9646920" y="347472"/>
+            <a:ext cx="2148840" cy="420624"/>
+          </a:xfrm>
+          <a:prstGeom prst="rect">
+            <a:avLst/>
+          </a:prstGeom>
+          <a:solidFill>
+            <a:srgbClr val="FFFFFF"/>
+          </a:solidFill>
+          <a:ln w="19050">
+            <a:solidFill>
+              <a:srgbClr val="D9488C"/>
+            </a:solidFill>
+            <a:prstDash val="solid"/>
+          </a:ln>
+        </p:spPr>
+      </p:sp>
+      <p:sp>
+        <p:nvSpPr>
+          <p:cNvPr id="8" name="Text 6"/>
+          <p:cNvSpPr txBox="1"/>
+          <p:nvPr/>
+        </p:nvSpPr>
+        <p:spPr>
+          <a:xfrm>
+            <a:off x="9646920" y="402336"/>
+            <a:ext cx="2148840" cy="310896"/>
+          </a:xfrm>
+          <a:prstGeom prst="rect">
+            <a:avLst/>
+          </a:prstGeom>
+          <a:noFill/>
+          <a:ln/>
+        </p:spPr>
+        <p:txBody>
+          <a:bodyPr wrap="square" lIns="0" tIns="0" rIns="0" bIns="0" rtlCol="0" anchor="ctr"/>
+          <a:lstStyle/>
+          <a:p>
+            <a:pPr algn="ctr" indent="0" marL="0">
+              <a:buNone/>
+            </a:pPr>
+            <a:r>
+              <a:rPr lang="en-US" sz="1100" b="1" dirty="0">
+                <a:solidFill>
+                  <a:srgbClr val="D9488C"/>
+                </a:solidFill>
+                <a:latin typeface="Courier New" pitchFamily="34" charset="0"/>
+                <a:ea typeface="Courier New" pitchFamily="34" charset="-122"/>
+                <a:cs typeface="Courier New" pitchFamily="34" charset="-120"/>
+              </a:rPr>
+              <a:t>OWNER: CANNON</a:t>
+            </a:r>
+            <a:endParaRPr lang="en-US" sz="1100" dirty="0"/>
+          </a:p>
+        </p:txBody>
+      </p:sp>
+      <p:sp>
+        <p:nvSpPr>
+          <p:cNvPr id="9" name="Text 7"/>
+          <p:cNvSpPr txBox="1"/>
+          <p:nvPr/>
+        </p:nvSpPr>
+        <p:spPr>
+          <a:xfrm>
+            <a:off x="457200" y="329184"/>
+            <a:ext cx="9052560" cy="566928"/>
+          </a:xfrm>
+          <a:prstGeom prst="rect">
+            <a:avLst/>
+          </a:prstGeom>
+          <a:noFill/>
+          <a:ln/>
+        </p:spPr>
+        <p:txBody>
+          <a:bodyPr wrap="square" lIns="0" tIns="0" rIns="0" bIns="0" rtlCol="0" anchor="ctr"/>
+          <a:lstStyle/>
+          <a:p>
+            <a:pPr indent="0" marL="0">
+              <a:buNone/>
+            </a:pPr>
+            <a:r>
+              <a:rPr lang="en-US" sz="2300" b="1" spc="200" kern="0" dirty="0">
+                <a:solidFill>
+                  <a:srgbClr val="16213D"/>
+                </a:solidFill>
+                <a:latin typeface="Arial" pitchFamily="34" charset="0"/>
+                <a:ea typeface="Arial" pitchFamily="34" charset="-122"/>
+                <a:cs typeface="Arial" pitchFamily="34" charset="-120"/>
+              </a:rPr>
+              <a:t>INTEGRATION CONSTRAINTS: THE LEDGER</a:t>
+            </a:r>
+            <a:endParaRPr lang="en-US" sz="2300" dirty="0"/>
+          </a:p>
+        </p:txBody>
+      </p:sp>
+      <p:pic>
+        <p:nvPicPr>
+          <p:cNvPr id="10" name="Image 0" descr="C:/Users/deogr/AppData/Local/Temp/claude/C--Users-deogr-Documents-Fall-Project-Off-Grid-Vehicle-dection-project/e8b2e8fa-1513-4aa8-a8f6-ce4fcd20e664/scratchpad/mermaid_png/diag1.png">    </p:cNvPr>
+          <p:cNvPicPr>
+            <a:picLocks noChangeAspect="1"/>
+          </p:cNvPicPr>
+          <p:nvPr/>
+        </p:nvPicPr>
+        <p:blipFill>
+          <a:blip r:embed="rId1"/>
+          <a:stretch>
+            <a:fillRect/>
+          </a:stretch>
+        </p:blipFill>
+        <p:spPr>
+          <a:xfrm>
+            <a:off x="457200" y="1005840"/>
+            <a:ext cx="5669280" cy="1938528"/>
+          </a:xfrm>
+          <a:prstGeom prst="rect">
+            <a:avLst/>
+          </a:prstGeom>
+        </p:spPr>
+      </p:pic>
+      <p:sp>
+        <p:nvSpPr>
+          <p:cNvPr id="11" name="Shape 8"/>
+          <p:cNvSpPr/>
+          <p:nvPr/>
+        </p:nvSpPr>
+        <p:spPr>
+          <a:xfrm>
+            <a:off x="457200" y="1005840"/>
+            <a:ext cx="5669280" cy="1938528"/>
+          </a:xfrm>
+          <a:prstGeom prst="rect">
+            <a:avLst/>
+          </a:prstGeom>
+          <a:ln w="12700">
+            <a:solidFill>
+              <a:srgbClr val="9AA7BE"/>
+            </a:solidFill>
+            <a:prstDash val="solid"/>
+          </a:ln>
+        </p:spPr>
+      </p:sp>
+      <p:sp>
+        <p:nvSpPr>
+          <p:cNvPr id="12" name="Text 9"/>
+          <p:cNvSpPr txBox="1"/>
+          <p:nvPr/>
+        </p:nvSpPr>
+        <p:spPr>
+          <a:xfrm>
+            <a:off x="6400800" y="1097280"/>
+            <a:ext cx="5257800" cy="777240"/>
+          </a:xfrm>
+          <a:prstGeom prst="rect">
+            <a:avLst/>
+          </a:prstGeom>
+          <a:noFill/>
+          <a:ln/>
+        </p:spPr>
+        <p:txBody>
+          <a:bodyPr wrap="square" lIns="0" tIns="0" rIns="0" bIns="0" rtlCol="0" anchor="ctr"/>
+          <a:lstStyle/>
+          <a:p>
+            <a:pPr indent="0" marL="0">
+              <a:buNone/>
+            </a:pPr>
+            <a:r>
+              <a:rPr lang="en-US" sz="1250" dirty="0">
+                <a:solidFill>
+                  <a:srgbClr val="222A3F"/>
+                </a:solidFill>
+                <a:latin typeface="Arial" pitchFamily="34" charset="0"/>
+                <a:ea typeface="Arial" pitchFamily="34" charset="-122"/>
+                <a:cs typeface="Arial" pitchFamily="34" charset="-120"/>
+              </a:rPr>
+              <a:t>Every constraint below was discovered on the bench or on the road, and each one shaped the design. None are theoretical.</a:t>
+            </a:r>
+            <a:endParaRPr lang="en-US" sz="1250" dirty="0"/>
+          </a:p>
+        </p:txBody>
+      </p:sp>
+      <p:sp>
+        <p:nvSpPr>
+          <p:cNvPr id="13" name="Text 10"/>
+          <p:cNvSpPr txBox="1"/>
+          <p:nvPr/>
+        </p:nvSpPr>
+        <p:spPr>
+          <a:xfrm>
+            <a:off x="6400800" y="1965960"/>
+            <a:ext cx="5257800" cy="868680"/>
+          </a:xfrm>
+          <a:prstGeom prst="rect">
+            <a:avLst/>
+          </a:prstGeom>
+          <a:noFill/>
+          <a:ln/>
+        </p:spPr>
+        <p:txBody>
+          <a:bodyPr wrap="square" lIns="0" tIns="0" rIns="0" bIns="0" rtlCol="0" anchor="ctr"/>
+          <a:lstStyle/>
+          <a:p>
+            <a:pPr indent="0" marL="0">
+              <a:buNone/>
+            </a:pPr>
+            <a:r>
+              <a:rPr lang="en-US" sz="1200" b="1" dirty="0">
+                <a:solidFill>
+                  <a:srgbClr val="16213D"/>
+                </a:solidFill>
+                <a:latin typeface="Courier New" pitchFamily="34" charset="0"/>
+                <a:ea typeface="Courier New" pitchFamily="34" charset="-122"/>
+                <a:cs typeface="Courier New" pitchFamily="34" charset="-120"/>
+              </a:rPr>
+              <a:t>TEST SEQUENCE: provision radio 2, bench two-radio decode, two-vehicle drive test, range characterization.</a:t>
+            </a:r>
+            <a:endParaRPr lang="en-US" sz="1200" dirty="0"/>
+          </a:p>
+        </p:txBody>
+      </p:sp>
+      <p:sp>
+        <p:nvSpPr>
+          <p:cNvPr id="14" name="Shape 11"/>
+          <p:cNvSpPr/>
+          <p:nvPr/>
+        </p:nvSpPr>
+        <p:spPr>
+          <a:xfrm>
+            <a:off x="457200" y="3154680"/>
+            <a:ext cx="3657600" cy="1426464"/>
+          </a:xfrm>
+          <a:prstGeom prst="rect">
+            <a:avLst/>
+          </a:prstGeom>
+          <a:solidFill>
+            <a:srgbClr val="F2F5FA"/>
+          </a:solidFill>
+          <a:ln w="15875">
+            <a:solidFill>
+              <a:srgbClr val="D9488C"/>
+            </a:solidFill>
+            <a:prstDash val="solid"/>
+          </a:ln>
+        </p:spPr>
+      </p:sp>
+      <p:sp>
+        <p:nvSpPr>
+          <p:cNvPr id="15" name="Text 12"/>
+          <p:cNvSpPr txBox="1"/>
+          <p:nvPr/>
+        </p:nvSpPr>
+        <p:spPr>
+          <a:xfrm>
+            <a:off x="585216" y="3218688"/>
+            <a:ext cx="3383280" cy="237744"/>
+          </a:xfrm>
+          <a:prstGeom prst="rect">
+            <a:avLst/>
+          </a:prstGeom>
+          <a:noFill/>
+          <a:ln/>
+        </p:spPr>
+        <p:txBody>
+          <a:bodyPr wrap="square" lIns="0" tIns="0" rIns="0" bIns="0" rtlCol="0" anchor="ctr"/>
+          <a:lstStyle/>
+          <a:p>
+            <a:pPr indent="0" marL="0">
+              <a:buNone/>
+            </a:pPr>
+            <a:r>
+              <a:rPr lang="en-US" sz="1050" b="1" dirty="0">
+                <a:solidFill>
+                  <a:srgbClr val="D9488C"/>
+                </a:solidFill>
+                <a:latin typeface="Courier New" pitchFamily="34" charset="0"/>
+                <a:ea typeface="Courier New" pitchFamily="34" charset="-122"/>
+                <a:cs typeface="Courier New" pitchFamily="34" charset="-120"/>
+              </a:rPr>
+              <a:t>RADIO / PHY</a:t>
+            </a:r>
+            <a:endParaRPr lang="en-US" sz="1050" dirty="0"/>
+          </a:p>
+        </p:txBody>
+      </p:sp>
+      <p:sp>
+        <p:nvSpPr>
+          <p:cNvPr id="16" name="Text 13"/>
+          <p:cNvSpPr txBox="1"/>
+          <p:nvPr/>
+        </p:nvSpPr>
+        <p:spPr>
+          <a:xfrm>
+            <a:off x="585216" y="3483864"/>
+            <a:ext cx="3419856" cy="1060704"/>
+          </a:xfrm>
+          <a:prstGeom prst="rect">
+            <a:avLst/>
+          </a:prstGeom>
+          <a:noFill/>
+          <a:ln/>
+        </p:spPr>
+        <p:txBody>
+          <a:bodyPr wrap="square" lIns="0" tIns="0" rIns="0" bIns="0" rtlCol="0" anchor="ctr"/>
+          <a:lstStyle/>
+          <a:p>
+            <a:pPr indent="0" marL="0">
+              <a:buNone/>
+            </a:pPr>
+            <a:r>
+              <a:rPr lang="en-US" sz="950" dirty="0">
+                <a:solidFill>
+                  <a:srgbClr val="222A3F"/>
+                </a:solidFill>
+                <a:latin typeface="Arial" pitchFamily="34" charset="0"/>
+                <a:ea typeface="Arial" pitchFamily="34" charset="-122"/>
+                <a:cs typeface="Arial" pitchFamily="34" charset="-120"/>
+              </a:rPr>
+              <a:t>Half a second of airtime per packet caps cadence at ten seconds. Utilization must stay under about 25%. The region must be set or transmit is disabled. The roof antenna is the single biggest range factor.</a:t>
+            </a:r>
+            <a:endParaRPr lang="en-US" sz="950" dirty="0"/>
+          </a:p>
+        </p:txBody>
+      </p:sp>
+      <p:sp>
+        <p:nvSpPr>
+          <p:cNvPr id="17" name="Shape 14"/>
+          <p:cNvSpPr/>
+          <p:nvPr/>
+        </p:nvSpPr>
+        <p:spPr>
+          <a:xfrm>
+            <a:off x="4297680" y="3154680"/>
+            <a:ext cx="3657600" cy="1426464"/>
+          </a:xfrm>
+          <a:prstGeom prst="rect">
+            <a:avLst/>
+          </a:prstGeom>
+          <a:solidFill>
+            <a:srgbClr val="F2F5FA"/>
+          </a:solidFill>
+          <a:ln w="15875">
+            <a:solidFill>
+              <a:srgbClr val="D9488C"/>
+            </a:solidFill>
+            <a:prstDash val="solid"/>
+          </a:ln>
+        </p:spPr>
+      </p:sp>
+      <p:sp>
+        <p:nvSpPr>
+          <p:cNvPr id="18" name="Text 15"/>
+          <p:cNvSpPr txBox="1"/>
+          <p:nvPr/>
+        </p:nvSpPr>
+        <p:spPr>
+          <a:xfrm>
+            <a:off x="4425696" y="3218688"/>
+            <a:ext cx="3383280" cy="237744"/>
+          </a:xfrm>
+          <a:prstGeom prst="rect">
+            <a:avLst/>
+          </a:prstGeom>
+          <a:noFill/>
+          <a:ln/>
+        </p:spPr>
+        <p:txBody>
+          <a:bodyPr wrap="square" lIns="0" tIns="0" rIns="0" bIns="0" rtlCol="0" anchor="ctr"/>
+          <a:lstStyle/>
+          <a:p>
+            <a:pPr indent="0" marL="0">
+              <a:buNone/>
+            </a:pPr>
+            <a:r>
+              <a:rPr lang="en-US" sz="1050" b="1" dirty="0">
+                <a:solidFill>
+                  <a:srgbClr val="D9488C"/>
+                </a:solidFill>
+                <a:latin typeface="Courier New" pitchFamily="34" charset="0"/>
+                <a:ea typeface="Courier New" pitchFamily="34" charset="-122"/>
+                <a:cs typeface="Courier New" pitchFamily="34" charset="-120"/>
+              </a:rPr>
+              <a:t>GPS</a:t>
+            </a:r>
+            <a:endParaRPr lang="en-US" sz="1050" dirty="0"/>
+          </a:p>
+        </p:txBody>
+      </p:sp>
+      <p:sp>
+        <p:nvSpPr>
+          <p:cNvPr id="19" name="Text 16"/>
+          <p:cNvSpPr txBox="1"/>
+          <p:nvPr/>
+        </p:nvSpPr>
+        <p:spPr>
+          <a:xfrm>
+            <a:off x="4425696" y="3483864"/>
+            <a:ext cx="3419856" cy="1060704"/>
+          </a:xfrm>
+          <a:prstGeom prst="rect">
+            <a:avLst/>
+          </a:prstGeom>
+          <a:noFill/>
+          <a:ln/>
+        </p:spPr>
+        <p:txBody>
+          <a:bodyPr wrap="square" lIns="0" tIns="0" rIns="0" bIns="0" rtlCol="0" anchor="ctr"/>
+          <a:lstStyle/>
+          <a:p>
+            <a:pPr indent="0" marL="0">
+              <a:buNone/>
+            </a:pPr>
+            <a:r>
+              <a:rPr lang="en-US" sz="950" dirty="0">
+                <a:solidFill>
+                  <a:srgbClr val="222A3F"/>
+                </a:solidFill>
+                <a:latin typeface="Arial" pitchFamily="34" charset="0"/>
+                <a:ea typeface="Arial" pitchFamily="34" charset="-122"/>
+                <a:cs typeface="Arial" pitchFamily="34" charset="-120"/>
+              </a:rPr>
+              <a:t>Needs sky view: a windshield works, a desk does not. Cold start takes minutes. Indoor multipath fakes small phantom speeds, which the deadband removes. Fix rate must match broadcast rate.</a:t>
+            </a:r>
+            <a:endParaRPr lang="en-US" sz="950" dirty="0"/>
+          </a:p>
+        </p:txBody>
+      </p:sp>
+      <p:sp>
+        <p:nvSpPr>
+          <p:cNvPr id="20" name="Shape 17"/>
+          <p:cNvSpPr/>
+          <p:nvPr/>
+        </p:nvSpPr>
+        <p:spPr>
+          <a:xfrm>
+            <a:off x="8138160" y="3154680"/>
+            <a:ext cx="3657600" cy="1426464"/>
+          </a:xfrm>
+          <a:prstGeom prst="rect">
+            <a:avLst/>
+          </a:prstGeom>
+          <a:solidFill>
+            <a:srgbClr val="F2F5FA"/>
+          </a:solidFill>
+          <a:ln w="15875">
+            <a:solidFill>
+              <a:srgbClr val="D9488C"/>
+            </a:solidFill>
+            <a:prstDash val="solid"/>
+          </a:ln>
+        </p:spPr>
+      </p:sp>
+      <p:sp>
+        <p:nvSpPr>
+          <p:cNvPr id="21" name="Text 18"/>
+          <p:cNvSpPr txBox="1"/>
+          <p:nvPr/>
+        </p:nvSpPr>
+        <p:spPr>
+          <a:xfrm>
+            <a:off x="8266176" y="3218688"/>
+            <a:ext cx="3383280" cy="237744"/>
+          </a:xfrm>
+          <a:prstGeom prst="rect">
+            <a:avLst/>
+          </a:prstGeom>
+          <a:noFill/>
+          <a:ln/>
+        </p:spPr>
+        <p:txBody>
+          <a:bodyPr wrap="square" lIns="0" tIns="0" rIns="0" bIns="0" rtlCol="0" anchor="ctr"/>
+          <a:lstStyle/>
+          <a:p>
+            <a:pPr indent="0" marL="0">
+              <a:buNone/>
+            </a:pPr>
+            <a:r>
+              <a:rPr lang="en-US" sz="1050" b="1" dirty="0">
+                <a:solidFill>
+                  <a:srgbClr val="D9488C"/>
+                </a:solidFill>
+                <a:latin typeface="Courier New" pitchFamily="34" charset="0"/>
+                <a:ea typeface="Courier New" pitchFamily="34" charset="-122"/>
+                <a:cs typeface="Courier New" pitchFamily="34" charset="-120"/>
+              </a:rPr>
+              <a:t>BLE LINK</a:t>
+            </a:r>
+            <a:endParaRPr lang="en-US" sz="1050" dirty="0"/>
+          </a:p>
+        </p:txBody>
+      </p:sp>
+      <p:sp>
+        <p:nvSpPr>
+          <p:cNvPr id="22" name="Text 19"/>
+          <p:cNvSpPr txBox="1"/>
+          <p:nvPr/>
+        </p:nvSpPr>
+        <p:spPr>
+          <a:xfrm>
+            <a:off x="8266176" y="3483864"/>
+            <a:ext cx="3419856" cy="1060704"/>
+          </a:xfrm>
+          <a:prstGeom prst="rect">
+            <a:avLst/>
+          </a:prstGeom>
+          <a:noFill/>
+          <a:ln/>
+        </p:spPr>
+        <p:txBody>
+          <a:bodyPr wrap="square" lIns="0" tIns="0" rIns="0" bIns="0" rtlCol="0" anchor="ctr"/>
+          <a:lstStyle/>
+          <a:p>
+            <a:pPr indent="0" marL="0">
+              <a:buNone/>
+            </a:pPr>
+            <a:r>
+              <a:rPr lang="en-US" sz="950" dirty="0">
+                <a:solidFill>
+                  <a:srgbClr val="222A3F"/>
+                </a:solidFill>
+                <a:latin typeface="Arial" pitchFamily="34" charset="0"/>
+                <a:ea typeface="Arial" pitchFamily="34" charset="-122"/>
+                <a:cs typeface="Arial" pitchFamily="34" charset="-120"/>
+              </a:rPr>
+              <a:t>The radio advertises only from boot until its first disconnect, so both units power up together. Exactly one client at a time: a phone app or USB session will take or mute the link.</a:t>
+            </a:r>
+            <a:endParaRPr lang="en-US" sz="950" dirty="0"/>
+          </a:p>
+        </p:txBody>
+      </p:sp>
+      <p:sp>
+        <p:nvSpPr>
+          <p:cNvPr id="23" name="Shape 20"/>
+          <p:cNvSpPr/>
+          <p:nvPr/>
+        </p:nvSpPr>
+        <p:spPr>
+          <a:xfrm>
+            <a:off x="457200" y="4690872"/>
+            <a:ext cx="3657600" cy="1426464"/>
+          </a:xfrm>
+          <a:prstGeom prst="rect">
+            <a:avLst/>
+          </a:prstGeom>
+          <a:solidFill>
+            <a:srgbClr val="F2F5FA"/>
+          </a:solidFill>
+          <a:ln w="15875">
+            <a:solidFill>
+              <a:srgbClr val="D9488C"/>
+            </a:solidFill>
+            <a:prstDash val="solid"/>
+          </a:ln>
+        </p:spPr>
+      </p:sp>
+      <p:sp>
+        <p:nvSpPr>
+          <p:cNvPr id="24" name="Text 21"/>
+          <p:cNvSpPr txBox="1"/>
+          <p:nvPr/>
+        </p:nvSpPr>
+        <p:spPr>
+          <a:xfrm>
+            <a:off x="585216" y="4754880"/>
+            <a:ext cx="3383280" cy="237744"/>
+          </a:xfrm>
+          <a:prstGeom prst="rect">
+            <a:avLst/>
+          </a:prstGeom>
+          <a:noFill/>
+          <a:ln/>
+        </p:spPr>
+        <p:txBody>
+          <a:bodyPr wrap="square" lIns="0" tIns="0" rIns="0" bIns="0" rtlCol="0" anchor="ctr"/>
+          <a:lstStyle/>
+          <a:p>
+            <a:pPr indent="0" marL="0">
+              <a:buNone/>
+            </a:pPr>
+            <a:r>
+              <a:rPr lang="en-US" sz="1050" b="1" dirty="0">
+                <a:solidFill>
+                  <a:srgbClr val="D9488C"/>
+                </a:solidFill>
+                <a:latin typeface="Courier New" pitchFamily="34" charset="0"/>
+                <a:ea typeface="Courier New" pitchFamily="34" charset="-122"/>
+                <a:cs typeface="Courier New" pitchFamily="34" charset="-120"/>
+              </a:rPr>
+              <a:t>DISPLAY</a:t>
+            </a:r>
+            <a:endParaRPr lang="en-US" sz="1050" dirty="0"/>
+          </a:p>
+        </p:txBody>
+      </p:sp>
+      <p:sp>
+        <p:nvSpPr>
+          <p:cNvPr id="25" name="Text 22"/>
+          <p:cNvSpPr txBox="1"/>
+          <p:nvPr/>
+        </p:nvSpPr>
+        <p:spPr>
+          <a:xfrm>
+            <a:off x="585216" y="5020056"/>
+            <a:ext cx="3419856" cy="1060704"/>
+          </a:xfrm>
+          <a:prstGeom prst="rect">
+            <a:avLst/>
+          </a:prstGeom>
+          <a:noFill/>
+          <a:ln/>
+        </p:spPr>
+        <p:txBody>
+          <a:bodyPr wrap="square" lIns="0" tIns="0" rIns="0" bIns="0" rtlCol="0" anchor="ctr"/>
+          <a:lstStyle/>
+          <a:p>
+            <a:pPr indent="0" marL="0">
+              <a:buNone/>
+            </a:pPr>
+            <a:r>
+              <a:rPr lang="en-US" sz="950" dirty="0">
+                <a:solidFill>
+                  <a:srgbClr val="222A3F"/>
+                </a:solidFill>
+                <a:latin typeface="Arial" pitchFamily="34" charset="0"/>
+                <a:ea typeface="Arial" pitchFamily="34" charset="-122"/>
+                <a:cs typeface="Arial" pitchFamily="34" charset="-120"/>
+              </a:rPr>
+              <a:t>A one-bit reflective panel has no grayscale and needs ambient light at night; edge lighting is planned. The redraw budget is two full frames per second.</a:t>
+            </a:r>
+            <a:endParaRPr lang="en-US" sz="950" dirty="0"/>
+          </a:p>
+        </p:txBody>
+      </p:sp>
+      <p:sp>
+        <p:nvSpPr>
+          <p:cNvPr id="26" name="Shape 23"/>
+          <p:cNvSpPr/>
+          <p:nvPr/>
+        </p:nvSpPr>
+        <p:spPr>
+          <a:xfrm>
+            <a:off x="4297680" y="4690872"/>
+            <a:ext cx="3657600" cy="1426464"/>
+          </a:xfrm>
+          <a:prstGeom prst="rect">
+            <a:avLst/>
+          </a:prstGeom>
+          <a:solidFill>
+            <a:srgbClr val="F2F5FA"/>
+          </a:solidFill>
+          <a:ln w="15875">
+            <a:solidFill>
+              <a:srgbClr val="D9488C"/>
+            </a:solidFill>
+            <a:prstDash val="solid"/>
+          </a:ln>
+        </p:spPr>
+      </p:sp>
+      <p:sp>
+        <p:nvSpPr>
+          <p:cNvPr id="27" name="Text 24"/>
+          <p:cNvSpPr txBox="1"/>
+          <p:nvPr/>
+        </p:nvSpPr>
+        <p:spPr>
+          <a:xfrm>
+            <a:off x="4425696" y="4754880"/>
+            <a:ext cx="3383280" cy="237744"/>
+          </a:xfrm>
+          <a:prstGeom prst="rect">
+            <a:avLst/>
+          </a:prstGeom>
+          <a:noFill/>
+          <a:ln/>
+        </p:spPr>
+        <p:txBody>
+          <a:bodyPr wrap="square" lIns="0" tIns="0" rIns="0" bIns="0" rtlCol="0" anchor="ctr"/>
+          <a:lstStyle/>
+          <a:p>
+            <a:pPr indent="0" marL="0">
+              <a:buNone/>
+            </a:pPr>
+            <a:r>
+              <a:rPr lang="en-US" sz="1050" b="1" dirty="0">
+                <a:solidFill>
+                  <a:srgbClr val="D9488C"/>
+                </a:solidFill>
+                <a:latin typeface="Courier New" pitchFamily="34" charset="0"/>
+                <a:ea typeface="Courier New" pitchFamily="34" charset="-122"/>
+                <a:cs typeface="Courier New" pitchFamily="34" charset="-120"/>
+              </a:rPr>
+              <a:t>POWER</a:t>
+            </a:r>
+            <a:endParaRPr lang="en-US" sz="1050" dirty="0"/>
+          </a:p>
+        </p:txBody>
+      </p:sp>
+      <p:sp>
+        <p:nvSpPr>
+          <p:cNvPr id="28" name="Text 25"/>
+          <p:cNvSpPr txBox="1"/>
+          <p:nvPr/>
+        </p:nvSpPr>
+        <p:spPr>
+          <a:xfrm>
+            <a:off x="4425696" y="5020056"/>
+            <a:ext cx="3419856" cy="1060704"/>
+          </a:xfrm>
+          <a:prstGeom prst="rect">
+            <a:avLst/>
+          </a:prstGeom>
+          <a:noFill/>
+          <a:ln/>
+        </p:spPr>
+        <p:txBody>
+          <a:bodyPr wrap="square" lIns="0" tIns="0" rIns="0" bIns="0" rtlCol="0" anchor="ctr"/>
+          <a:lstStyle/>
+          <a:p>
+            <a:pPr indent="0" marL="0">
+              <a:buNone/>
+            </a:pPr>
+            <a:r>
+              <a:rPr lang="en-US" sz="950" dirty="0">
+                <a:solidFill>
+                  <a:srgbClr val="222A3F"/>
+                </a:solidFill>
+                <a:latin typeface="Arial" pitchFamily="34" charset="0"/>
+                <a:ea typeface="Arial" pitchFamily="34" charset="-122"/>
+                <a:cs typeface="Arial" pitchFamily="34" charset="-120"/>
+              </a:rPr>
+              <a:t>Cheap 12 volt USB adapters cut off on the radio's low current draw, so every adapter gets validated. Both units must share the vehicle's power timing.</a:t>
+            </a:r>
+            <a:endParaRPr lang="en-US" sz="950" dirty="0"/>
+          </a:p>
+        </p:txBody>
+      </p:sp>
+      <p:sp>
+        <p:nvSpPr>
+          <p:cNvPr id="29" name="Shape 26"/>
+          <p:cNvSpPr/>
+          <p:nvPr/>
+        </p:nvSpPr>
+        <p:spPr>
+          <a:xfrm>
+            <a:off x="8138160" y="4690872"/>
+            <a:ext cx="3657600" cy="1426464"/>
+          </a:xfrm>
+          <a:prstGeom prst="rect">
+            <a:avLst/>
+          </a:prstGeom>
+          <a:solidFill>
+            <a:srgbClr val="F2F5FA"/>
+          </a:solidFill>
+          <a:ln w="15875">
+            <a:solidFill>
+              <a:srgbClr val="D9488C"/>
+            </a:solidFill>
+            <a:prstDash val="solid"/>
+          </a:ln>
+        </p:spPr>
+      </p:sp>
+      <p:sp>
+        <p:nvSpPr>
+          <p:cNvPr id="30" name="Text 27"/>
+          <p:cNvSpPr txBox="1"/>
+          <p:nvPr/>
+        </p:nvSpPr>
+        <p:spPr>
+          <a:xfrm>
+            <a:off x="8266176" y="4754880"/>
+            <a:ext cx="3383280" cy="237744"/>
+          </a:xfrm>
+          <a:prstGeom prst="rect">
+            <a:avLst/>
+          </a:prstGeom>
+          <a:noFill/>
+          <a:ln/>
+        </p:spPr>
+        <p:txBody>
+          <a:bodyPr wrap="square" lIns="0" tIns="0" rIns="0" bIns="0" rtlCol="0" anchor="ctr"/>
+          <a:lstStyle/>
+          <a:p>
+            <a:pPr indent="0" marL="0">
+              <a:buNone/>
+            </a:pPr>
+            <a:r>
+              <a:rPr lang="en-US" sz="1050" b="1" dirty="0">
+                <a:solidFill>
+                  <a:srgbClr val="D9488C"/>
+                </a:solidFill>
+                <a:latin typeface="Courier New" pitchFamily="34" charset="0"/>
+                <a:ea typeface="Courier New" pitchFamily="34" charset="-122"/>
+                <a:cs typeface="Courier New" pitchFamily="34" charset="-120"/>
+              </a:rPr>
+              <a:t>PROVISIONING</a:t>
+            </a:r>
+            <a:endParaRPr lang="en-US" sz="1050" dirty="0"/>
+          </a:p>
+        </p:txBody>
+      </p:sp>
+      <p:sp>
+        <p:nvSpPr>
+          <p:cNvPr id="31" name="Text 28"/>
+          <p:cNvSpPr txBox="1"/>
+          <p:nvPr/>
+        </p:nvSpPr>
+        <p:spPr>
+          <a:xfrm>
+            <a:off x="8266176" y="5020056"/>
+            <a:ext cx="3419856" cy="1060704"/>
+          </a:xfrm>
+          <a:prstGeom prst="rect">
+            <a:avLst/>
+          </a:prstGeom>
+          <a:noFill/>
+          <a:ln/>
+        </p:spPr>
+        <p:txBody>
+          <a:bodyPr wrap="square" lIns="0" tIns="0" rIns="0" bIns="0" rtlCol="0" anchor="ctr"/>
+          <a:lstStyle/>
+          <a:p>
+            <a:pPr indent="0" marL="0">
+              <a:buNone/>
+            </a:pPr>
+            <a:r>
+              <a:rPr lang="en-US" sz="950" dirty="0">
+                <a:solidFill>
+                  <a:srgbClr val="222A3F"/>
+                </a:solidFill>
+                <a:latin typeface="Arial" pitchFamily="34" charset="0"/>
+                <a:ea typeface="Arial" pitchFamily="34" charset="-122"/>
+                <a:cs typeface="Arial" pitchFamily="34" charset="-120"/>
+              </a:rPr>
+              <a:t>The channel URL carrying the encryption key must match on every radio. Node identities derive from the MAC address and survive reflashes. Every configuration write is read back and verified.</a:t>
+            </a:r>
+            <a:endParaRPr lang="en-US" sz="950" dirty="0"/>
+          </a:p>
+        </p:txBody>
+      </p:sp>
+    </p:spTree>
+  </p:cSld>
+  <p:clrMapOvr>
+    <a:masterClrMapping/>
+  </p:clrMapOvr>
+</p:sld>
+</file>
+
+<file path=ppt/slides/slide11.xml><?xml version="1.0" encoding="utf-8"?>
+<p:sld xmlns:a="http://schemas.openxmlformats.org/drawingml/2006/main" xmlns:r="http://schemas.openxmlformats.org/officeDocument/2006/relationships" xmlns:p="http://schemas.openxmlformats.org/presentationml/2006/main">
+  <p:cSld name="Slide 11">
+    <p:bg>
+      <p:bgPr>
+        <a:solidFill>
+          <a:srgbClr val="FFFFFF"/>
+        </a:solidFill>
+      </p:bgPr>
+    </p:bg>
+    <p:spTree>
+      <p:nvGrpSpPr>
+        <p:cNvPr id="1" name=""/>
+        <p:cNvGrpSpPr/>
+        <p:nvPr/>
+      </p:nvGrpSpPr>
+      <p:grpSpPr>
+        <a:xfrm>
+          <a:off x="0" y="0"/>
+          <a:ext cx="0" cy="0"/>
+          <a:chOff x="0" y="0"/>
+          <a:chExt cx="0" cy="0"/>
+        </a:xfrm>
+      </p:grpSpPr>
+      <p:sp>
+        <p:nvSpPr>
+          <p:cNvPr id="2" name="Shape 0"/>
+          <p:cNvSpPr/>
+          <p:nvPr/>
+        </p:nvSpPr>
+        <p:spPr>
+          <a:xfrm>
+            <a:off x="164592" y="146304"/>
+            <a:ext cx="11859768" cy="6565392"/>
+          </a:xfrm>
+          <a:prstGeom prst="rect">
+            <a:avLst/>
+          </a:prstGeom>
+          <a:ln w="22225">
+            <a:solidFill>
+              <a:srgbClr val="16213D"/>
+            </a:solidFill>
+            <a:prstDash val="solid"/>
+          </a:ln>
+        </p:spPr>
+      </p:sp>
+      <p:sp>
+        <p:nvSpPr>
+          <p:cNvPr id="3" name="Shape 1"/>
+          <p:cNvSpPr/>
+          <p:nvPr/>
+        </p:nvSpPr>
+        <p:spPr>
+          <a:xfrm>
+            <a:off x="164592" y="6272784"/>
+            <a:ext cx="11859768" cy="0"/>
+          </a:xfrm>
+          <a:prstGeom prst="line">
+            <a:avLst/>
+          </a:prstGeom>
+          <a:noFill/>
+          <a:ln w="12700">
+            <a:solidFill>
+              <a:srgbClr val="16213D"/>
+            </a:solidFill>
+            <a:prstDash val="solid"/>
+          </a:ln>
+        </p:spPr>
+      </p:sp>
+      <p:sp>
+        <p:nvSpPr>
+          <p:cNvPr id="4" name="Text 2"/>
+          <p:cNvSpPr txBox="1"/>
+          <p:nvPr/>
+        </p:nvSpPr>
+        <p:spPr>
+          <a:xfrm>
+            <a:off x="320040" y="6345936"/>
+            <a:ext cx="4206240" cy="292608"/>
+          </a:xfrm>
+          <a:prstGeom prst="rect">
+            <a:avLst/>
+          </a:prstGeom>
+          <a:noFill/>
+          <a:ln/>
+        </p:spPr>
+        <p:txBody>
+          <a:bodyPr wrap="square" lIns="0" tIns="0" rIns="0" bIns="0" rtlCol="0" anchor="ctr"/>
+          <a:lstStyle/>
+          <a:p>
+            <a:pPr indent="0" marL="0">
+              <a:buNone/>
+            </a:pPr>
+            <a:r>
+              <a:rPr lang="en-US" sz="900" dirty="0">
+                <a:solidFill>
+                  <a:srgbClr val="5E6B85"/>
+                </a:solidFill>
+                <a:latin typeface="Courier New" pitchFamily="34" charset="0"/>
+                <a:ea typeface="Courier New" pitchFamily="34" charset="-122"/>
+                <a:cs typeface="Courier New" pitchFamily="34" charset="-120"/>
+              </a:rPr>
+              <a:t>GROUP 9  |  OFF-GRID VEHICLE TRACKER</a:t>
+            </a:r>
+            <a:endParaRPr lang="en-US" sz="900" dirty="0"/>
+          </a:p>
+        </p:txBody>
+      </p:sp>
+      <p:sp>
+        <p:nvSpPr>
+          <p:cNvPr id="5" name="Text 3"/>
+          <p:cNvSpPr txBox="1"/>
+          <p:nvPr/>
+        </p:nvSpPr>
+        <p:spPr>
+          <a:xfrm>
+            <a:off x="4572000" y="6345936"/>
+            <a:ext cx="4206240" cy="292608"/>
+          </a:xfrm>
+          <a:prstGeom prst="rect">
+            <a:avLst/>
+          </a:prstGeom>
+          <a:noFill/>
+          <a:ln/>
+        </p:spPr>
+        <p:txBody>
+          <a:bodyPr wrap="square" lIns="0" tIns="0" rIns="0" bIns="0" rtlCol="0" anchor="ctr"/>
+          <a:lstStyle/>
+          <a:p>
+            <a:pPr algn="ctr" indent="0" marL="0">
+              <a:buNone/>
+            </a:pPr>
+            <a:r>
+              <a:rPr lang="en-US" sz="900" dirty="0">
+                <a:solidFill>
+                  <a:srgbClr val="5E6B85"/>
+                </a:solidFill>
+                <a:latin typeface="Courier New" pitchFamily="34" charset="0"/>
+                <a:ea typeface="Courier New" pitchFamily="34" charset="-122"/>
+                <a:cs typeface="Courier New" pitchFamily="34" charset="-120"/>
+              </a:rPr>
+              <a:t>STATUS AND NEXT STEPS</a:t>
+            </a:r>
+            <a:endParaRPr lang="en-US" sz="900" dirty="0"/>
+          </a:p>
+        </p:txBody>
+      </p:sp>
+      <p:sp>
+        <p:nvSpPr>
+          <p:cNvPr id="6" name="Text 4"/>
+          <p:cNvSpPr txBox="1"/>
+          <p:nvPr/>
+        </p:nvSpPr>
+        <p:spPr>
+          <a:xfrm>
+            <a:off x="8869680" y="6345936"/>
+            <a:ext cx="3017520" cy="292608"/>
+          </a:xfrm>
+          <a:prstGeom prst="rect">
+            <a:avLst/>
+          </a:prstGeom>
+          <a:noFill/>
+          <a:ln/>
+        </p:spPr>
+        <p:txBody>
+          <a:bodyPr wrap="square" lIns="0" tIns="0" rIns="0" bIns="0" rtlCol="0" anchor="ctr"/>
+          <a:lstStyle/>
+          <a:p>
+            <a:pPr algn="r" indent="0" marL="0">
+              <a:buNone/>
+            </a:pPr>
+            <a:r>
+              <a:rPr lang="en-US" sz="900" dirty="0">
+                <a:solidFill>
+                  <a:srgbClr val="5E6B85"/>
+                </a:solidFill>
+                <a:latin typeface="Courier New" pitchFamily="34" charset="0"/>
+                <a:ea typeface="Courier New" pitchFamily="34" charset="-122"/>
+                <a:cs typeface="Courier New" pitchFamily="34" charset="-120"/>
+              </a:rPr>
+              <a:t>SHEET 11/11  REV C  2026-09-07</a:t>
             </a:r>
             <a:endParaRPr lang="en-US" sz="900" dirty="0"/>
           </a:p>
@@ -5674,7 +6802,7 @@
                 <a:ea typeface="Courier New" pitchFamily="34" charset="-122"/>
                 <a:cs typeface="Courier New" pitchFamily="34" charset="-120"/>
               </a:rPr>
-              <a:t>SHEET 02/10  REV C  2026-09-07</a:t>
+              <a:t>SHEET 02/11  REV C  2026-09-07</a:t>
             </a:r>
             <a:endParaRPr lang="en-US" sz="900" dirty="0"/>
           </a:p>
@@ -6238,7 +7366,7 @@
                 <a:ea typeface="Courier New" pitchFamily="34" charset="-122"/>
                 <a:cs typeface="Courier New" pitchFamily="34" charset="-120"/>
               </a:rPr>
-              <a:t>SHEET 03/10  REV C  2026-09-07</a:t>
+              <a:t>SHEET 03/11  REV C  2026-09-07</a:t>
             </a:r>
             <a:endParaRPr lang="en-US" sz="900" dirty="0"/>
           </a:p>
@@ -6663,7 +7791,7 @@
                 <a:ea typeface="Courier New" pitchFamily="34" charset="-122"/>
                 <a:cs typeface="Courier New" pitchFamily="34" charset="-120"/>
               </a:rPr>
-              <a:t>SHEET 04/10  REV C  2026-09-07</a:t>
+              <a:t>SHEET 04/11  REV C  2026-09-07</a:t>
             </a:r>
             <a:endParaRPr lang="en-US" sz="900" dirty="0"/>
           </a:p>
@@ -7785,7 +8913,7 @@
                 <a:ea typeface="Courier New" pitchFamily="34" charset="-122"/>
                 <a:cs typeface="Courier New" pitchFamily="34" charset="-120"/>
               </a:rPr>
-              <a:t>SHEET 05/10  REV C  2026-09-07</a:t>
+              <a:t>SHEET 05/11  REV C  2026-09-07</a:t>
             </a:r>
             <a:endParaRPr lang="en-US" sz="900" dirty="0"/>
           </a:p>
@@ -8883,7 +10011,7 @@
                 <a:ea typeface="Courier New" pitchFamily="34" charset="-122"/>
                 <a:cs typeface="Courier New" pitchFamily="34" charset="-120"/>
               </a:rPr>
-              <a:t>SHEET 06/10  REV C  2026-09-07</a:t>
+              <a:t>SHEET 06/11  REV C  2026-09-07</a:t>
             </a:r>
             <a:endParaRPr lang="en-US" sz="900" dirty="0"/>
           </a:p>
@@ -9687,7 +10815,7 @@
                 <a:ea typeface="Courier New" pitchFamily="34" charset="-122"/>
                 <a:cs typeface="Courier New" pitchFamily="34" charset="-120"/>
               </a:rPr>
-              <a:t>SHEET 07/10  REV C  2026-09-07</a:t>
+              <a:t>SHEET 07/11  REV C  2026-09-07</a:t>
             </a:r>
             <a:endParaRPr lang="en-US" sz="900" dirty="0"/>
           </a:p>
@@ -10405,7 +11533,7 @@
                 <a:ea typeface="Courier New" pitchFamily="34" charset="-122"/>
                 <a:cs typeface="Courier New" pitchFamily="34" charset="-120"/>
               </a:rPr>
-              <a:t>SHEET 08/10  REV C  2026-09-07</a:t>
+              <a:t>SHEET 08/11  REV C  2026-09-07</a:t>
             </a:r>
             <a:endParaRPr lang="en-US" sz="900" dirty="0"/>
           </a:p>
@@ -11057,7 +12185,7 @@
                 <a:ea typeface="Courier New" pitchFamily="34" charset="-122"/>
                 <a:cs typeface="Courier New" pitchFamily="34" charset="-120"/>
               </a:rPr>
-              <a:t>INTEGRATION CONSTRAINTS</a:t>
+              <a:t>LINK BEHAVIOR, GRAPHED</a:t>
             </a:r>
             <a:endParaRPr lang="en-US" sz="900" dirty="0"/>
           </a:p>
@@ -11096,7 +12224,7 @@
                 <a:ea typeface="Courier New" pitchFamily="34" charset="-122"/>
                 <a:cs typeface="Courier New" pitchFamily="34" charset="-120"/>
               </a:rPr>
-              <a:t>SHEET 09/10  REV C  2026-09-07</a:t>
+              <a:t>SHEET 09/11  REV C  2026-09-07</a:t>
             </a:r>
             <a:endParaRPr lang="en-US" sz="900" dirty="0"/>
           </a:p>
@@ -11121,7 +12249,7 @@
           </a:solidFill>
           <a:ln w="19050">
             <a:solidFill>
-              <a:srgbClr val="D9488C"/>
+              <a:srgbClr val="E58E1A"/>
             </a:solidFill>
             <a:prstDash val="solid"/>
           </a:ln>
@@ -11154,13 +12282,13 @@
             <a:r>
               <a:rPr lang="en-US" sz="1100" b="1" dirty="0">
                 <a:solidFill>
-                  <a:srgbClr val="D9488C"/>
+                  <a:srgbClr val="E58E1A"/>
                 </a:solidFill>
                 <a:latin typeface="Courier New" pitchFamily="34" charset="0"/>
                 <a:ea typeface="Courier New" pitchFamily="34" charset="-122"/>
                 <a:cs typeface="Courier New" pitchFamily="34" charset="-120"/>
               </a:rPr>
-              <a:t>OWNER: CANNON</a:t>
+              <a:t>OWNER: VICTOR</a:t>
             </a:r>
             <a:endParaRPr lang="en-US" sz="1100" dirty="0"/>
           </a:p>
@@ -11199,7 +12327,7 @@
                 <a:ea typeface="Arial" pitchFamily="34" charset="-122"/>
                 <a:cs typeface="Arial" pitchFamily="34" charset="-120"/>
               </a:rPr>
-              <a:t>INTEGRATION CONSTRAINTS: THE LEDGER</a:t>
+              <a:t>THE SAME PHYSICS, GRAPHED</a:t>
             </a:r>
             <a:endParaRPr lang="en-US" sz="2300" dirty="0"/>
           </a:p>
@@ -11207,7 +12335,7 @@
       </p:sp>
       <p:pic>
         <p:nvPicPr>
-          <p:cNvPr id="10" name="Image 0" descr="C:/Users/deogr/AppData/Local/Temp/claude/C--Users-deogr-Documents-Fall-Project-Off-Grid-Vehicle-dection-project/e8b2e8fa-1513-4aa8-a8f6-ce4fcd20e664/scratchpad/mermaid_png/diag1.png">    </p:cNvPr>
+          <p:cNvPr id="10" name="Image 0" descr="C:/Users/deogr/AppData/Local/Temp/claude/C--Users-deogr-Documents-Fall-Project-Off-Grid-Vehicle-dection-project/e8b2e8fa-1513-4aa8-a8f6-ce4fcd20e664/scratchpad/deck3/g_utilization.png">    </p:cNvPr>
           <p:cNvPicPr>
             <a:picLocks noChangeAspect="1"/>
           </p:cNvPicPr>
@@ -11221,8 +12349,8 @@
         </p:blipFill>
         <p:spPr>
           <a:xfrm>
-            <a:off x="457200" y="1005840"/>
-            <a:ext cx="5669280" cy="1938528"/>
+            <a:off x="457200" y="1024128"/>
+            <a:ext cx="5394960" cy="3739896"/>
           </a:xfrm>
           <a:prstGeom prst="rect">
             <a:avLst/>
@@ -11237,8 +12365,8 @@
         </p:nvSpPr>
         <p:spPr>
           <a:xfrm>
-            <a:off x="457200" y="1005840"/>
-            <a:ext cx="5669280" cy="1938528"/>
+            <a:off x="457200" y="1024128"/>
+            <a:ext cx="5394960" cy="3739896"/>
           </a:xfrm>
           <a:prstGeom prst="rect">
             <a:avLst/>
@@ -11251,16 +12379,62 @@
           </a:ln>
         </p:spPr>
       </p:sp>
-      <p:sp>
-        <p:nvSpPr>
-          <p:cNvPr id="12" name="Text 9"/>
-          <p:cNvSpPr txBox="1"/>
-          <p:nvPr/>
-        </p:nvSpPr>
-        <p:spPr>
-          <a:xfrm>
-            <a:off x="6400800" y="1097280"/>
-            <a:ext cx="5257800" cy="777240"/>
+      <p:pic>
+        <p:nvPicPr>
+          <p:cNvPr id="12" name="Image 1" descr="C:/Users/deogr/AppData/Local/Temp/claude/C--Users-deogr-Documents-Fall-Project-Off-Grid-Vehicle-dection-project/e8b2e8fa-1513-4aa8-a8f6-ce4fcd20e664/scratchpad/deck3/g_deadreckon.png">    </p:cNvPr>
+          <p:cNvPicPr>
+            <a:picLocks noChangeAspect="1"/>
+          </p:cNvPicPr>
+          <p:nvPr/>
+        </p:nvPicPr>
+        <p:blipFill>
+          <a:blip r:embed="rId2"/>
+          <a:stretch>
+            <a:fillRect/>
+          </a:stretch>
+        </p:blipFill>
+        <p:spPr>
+          <a:xfrm>
+            <a:off x="6309360" y="1024128"/>
+            <a:ext cx="5394960" cy="3739896"/>
+          </a:xfrm>
+          <a:prstGeom prst="rect">
+            <a:avLst/>
+          </a:prstGeom>
+        </p:spPr>
+      </p:pic>
+      <p:sp>
+        <p:nvSpPr>
+          <p:cNvPr id="13" name="Shape 9"/>
+          <p:cNvSpPr/>
+          <p:nvPr/>
+        </p:nvSpPr>
+        <p:spPr>
+          <a:xfrm>
+            <a:off x="6309360" y="1024128"/>
+            <a:ext cx="5394960" cy="3739896"/>
+          </a:xfrm>
+          <a:prstGeom prst="rect">
+            <a:avLst/>
+          </a:prstGeom>
+          <a:ln w="12700">
+            <a:solidFill>
+              <a:srgbClr val="9AA7BE"/>
+            </a:solidFill>
+            <a:prstDash val="solid"/>
+          </a:ln>
+        </p:spPr>
+      </p:sp>
+      <p:sp>
+        <p:nvSpPr>
+          <p:cNvPr id="14" name="Text 10"/>
+          <p:cNvSpPr txBox="1"/>
+          <p:nvPr/>
+        </p:nvSpPr>
+        <p:spPr>
+          <a:xfrm>
+            <a:off x="457200" y="4864608"/>
+            <a:ext cx="5394960" cy="960120"/>
           </a:xfrm>
           <a:prstGeom prst="rect">
             <a:avLst/>
@@ -11276,7 +12450,7 @@
               <a:buNone/>
             </a:pPr>
             <a:r>
-              <a:rPr lang="en-US" sz="1250" dirty="0">
+              <a:rPr lang="en-US" sz="1050" dirty="0">
                 <a:solidFill>
                   <a:srgbClr val="222A3F"/>
                 </a:solidFill>
@@ -11284,22 +12458,22 @@
                 <a:ea typeface="Arial" pitchFamily="34" charset="-122"/>
                 <a:cs typeface="Arial" pitchFamily="34" charset="-120"/>
               </a:rPr>
-              <a:t>Every constraint below was discovered on the bench or on the road, and each one shaped the design. None are theoretical.</a:t>
-            </a:r>
-            <a:endParaRPr lang="en-US" sz="1250" dirty="0"/>
-          </a:p>
-        </p:txBody>
-      </p:sp>
-      <p:sp>
-        <p:nvSpPr>
-          <p:cNvPr id="13" name="Text 10"/>
-          <p:cNvSpPr txBox="1"/>
-          <p:nvPr/>
-        </p:nvSpPr>
-        <p:spPr>
-          <a:xfrm>
-            <a:off x="6400800" y="1965960"/>
-            <a:ext cx="5257800" cy="868680"/>
+              <a:t>The update-rate wall. Channel airtime versus broadcast interval for two vehicles at 0.5 s per packet. One second sits at 100 percent, physical collapse; our 10 second point uses 10 percent, comfortably under the 25 percent ceiling the firmware enforces.</a:t>
+            </a:r>
+            <a:endParaRPr lang="en-US" sz="1050" dirty="0"/>
+          </a:p>
+        </p:txBody>
+      </p:sp>
+      <p:sp>
+        <p:nvSpPr>
+          <p:cNvPr id="15" name="Text 11"/>
+          <p:cNvSpPr txBox="1"/>
+          <p:nvPr/>
+        </p:nvSpPr>
+        <p:spPr>
+          <a:xfrm>
+            <a:off x="6309360" y="4864608"/>
+            <a:ext cx="5394960" cy="960120"/>
           </a:xfrm>
           <a:prstGeom prst="rect">
             <a:avLst/>
@@ -11315,635 +12489,79 @@
               <a:buNone/>
             </a:pPr>
             <a:r>
-              <a:rPr lang="en-US" sz="1200" b="1" dirty="0">
-                <a:solidFill>
-                  <a:srgbClr val="16213D"/>
+              <a:rPr lang="en-US" sz="1050" dirty="0">
+                <a:solidFill>
+                  <a:srgbClr val="222A3F"/>
+                </a:solidFill>
+                <a:latin typeface="Arial" pitchFamily="34" charset="0"/>
+                <a:ea typeface="Arial" pitchFamily="34" charset="-122"/>
+                <a:cs typeface="Arial" pitchFamily="34" charset="-120"/>
+              </a:rPr>
+              <a:t>What the driver would see. Holding the raw fix leaves the display up to 200 m behind a vehicle at 45 mph. Dead reckoning bounds the worst case near 25 m during a maneuver, and each real fix snaps the error back to zero.</a:t>
+            </a:r>
+            <a:endParaRPr lang="en-US" sz="1050" dirty="0"/>
+          </a:p>
+        </p:txBody>
+      </p:sp>
+      <p:sp>
+        <p:nvSpPr>
+          <p:cNvPr id="16" name="Shape 12"/>
+          <p:cNvSpPr/>
+          <p:nvPr/>
+        </p:nvSpPr>
+        <p:spPr>
+          <a:xfrm>
+            <a:off x="457200" y="5870448"/>
+            <a:ext cx="11292840" cy="0"/>
+          </a:xfrm>
+          <a:prstGeom prst="line">
+            <a:avLst/>
+          </a:prstGeom>
+          <a:noFill/>
+          <a:ln w="9525">
+            <a:solidFill>
+              <a:srgbClr val="9AA7BE"/>
+            </a:solidFill>
+            <a:prstDash val="solid"/>
+          </a:ln>
+        </p:spPr>
+      </p:sp>
+      <p:sp>
+        <p:nvSpPr>
+          <p:cNvPr id="17" name="Text 13"/>
+          <p:cNvSpPr txBox="1"/>
+          <p:nvPr/>
+        </p:nvSpPr>
+        <p:spPr>
+          <a:xfrm>
+            <a:off x="457200" y="5943600"/>
+            <a:ext cx="11292840" cy="274320"/>
+          </a:xfrm>
+          <a:prstGeom prst="rect">
+            <a:avLst/>
+          </a:prstGeom>
+          <a:noFill/>
+          <a:ln/>
+        </p:spPr>
+        <p:txBody>
+          <a:bodyPr wrap="square" lIns="0" tIns="0" rIns="0" bIns="0" rtlCol="0" anchor="ctr"/>
+          <a:lstStyle/>
+          <a:p>
+            <a:pPr indent="0" marL="0">
+              <a:buNone/>
+            </a:pPr>
+            <a:r>
+              <a:rPr lang="en-US" sz="850" dirty="0">
+                <a:solidFill>
+                  <a:srgbClr val="5E6B85"/>
                 </a:solidFill>
                 <a:latin typeface="Courier New" pitchFamily="34" charset="0"/>
                 <a:ea typeface="Courier New" pitchFamily="34" charset="-122"/>
                 <a:cs typeface="Courier New" pitchFamily="34" charset="-120"/>
               </a:rPr>
-              <a:t>TEST SEQUENCE: provision radio 2, bench two-radio decode, two-vehicle drive test, range characterization.</a:t>
-            </a:r>
-            <a:endParaRPr lang="en-US" sz="1200" dirty="0"/>
-          </a:p>
-        </p:txBody>
-      </p:sp>
-      <p:sp>
-        <p:nvSpPr>
-          <p:cNvPr id="14" name="Shape 11"/>
-          <p:cNvSpPr/>
-          <p:nvPr/>
-        </p:nvSpPr>
-        <p:spPr>
-          <a:xfrm>
-            <a:off x="457200" y="3154680"/>
-            <a:ext cx="3657600" cy="1426464"/>
-          </a:xfrm>
-          <a:prstGeom prst="rect">
-            <a:avLst/>
-          </a:prstGeom>
-          <a:solidFill>
-            <a:srgbClr val="F2F5FA"/>
-          </a:solidFill>
-          <a:ln w="15875">
-            <a:solidFill>
-              <a:srgbClr val="D9488C"/>
-            </a:solidFill>
-            <a:prstDash val="solid"/>
-          </a:ln>
-        </p:spPr>
-      </p:sp>
-      <p:sp>
-        <p:nvSpPr>
-          <p:cNvPr id="15" name="Text 12"/>
-          <p:cNvSpPr txBox="1"/>
-          <p:nvPr/>
-        </p:nvSpPr>
-        <p:spPr>
-          <a:xfrm>
-            <a:off x="585216" y="3218688"/>
-            <a:ext cx="3383280" cy="237744"/>
-          </a:xfrm>
-          <a:prstGeom prst="rect">
-            <a:avLst/>
-          </a:prstGeom>
-          <a:noFill/>
-          <a:ln/>
-        </p:spPr>
-        <p:txBody>
-          <a:bodyPr wrap="square" lIns="0" tIns="0" rIns="0" bIns="0" rtlCol="0" anchor="ctr"/>
-          <a:lstStyle/>
-          <a:p>
-            <a:pPr indent="0" marL="0">
-              <a:buNone/>
-            </a:pPr>
-            <a:r>
-              <a:rPr lang="en-US" sz="1050" b="1" dirty="0">
-                <a:solidFill>
-                  <a:srgbClr val="D9488C"/>
-                </a:solidFill>
-                <a:latin typeface="Courier New" pitchFamily="34" charset="0"/>
-                <a:ea typeface="Courier New" pitchFamily="34" charset="-122"/>
-                <a:cs typeface="Courier New" pitchFamily="34" charset="-120"/>
-              </a:rPr>
-              <a:t>RADIO / PHY</a:t>
-            </a:r>
-            <a:endParaRPr lang="en-US" sz="1050" dirty="0"/>
-          </a:p>
-        </p:txBody>
-      </p:sp>
-      <p:sp>
-        <p:nvSpPr>
-          <p:cNvPr id="16" name="Text 13"/>
-          <p:cNvSpPr txBox="1"/>
-          <p:nvPr/>
-        </p:nvSpPr>
-        <p:spPr>
-          <a:xfrm>
-            <a:off x="585216" y="3483864"/>
-            <a:ext cx="3419856" cy="1060704"/>
-          </a:xfrm>
-          <a:prstGeom prst="rect">
-            <a:avLst/>
-          </a:prstGeom>
-          <a:noFill/>
-          <a:ln/>
-        </p:spPr>
-        <p:txBody>
-          <a:bodyPr wrap="square" lIns="0" tIns="0" rIns="0" bIns="0" rtlCol="0" anchor="ctr"/>
-          <a:lstStyle/>
-          <a:p>
-            <a:pPr indent="0" marL="0">
-              <a:buNone/>
-            </a:pPr>
-            <a:r>
-              <a:rPr lang="en-US" sz="950" dirty="0">
-                <a:solidFill>
-                  <a:srgbClr val="222A3F"/>
-                </a:solidFill>
-                <a:latin typeface="Arial" pitchFamily="34" charset="0"/>
-                <a:ea typeface="Arial" pitchFamily="34" charset="-122"/>
-                <a:cs typeface="Arial" pitchFamily="34" charset="-120"/>
-              </a:rPr>
-              <a:t>Half a second of airtime per packet caps cadence at ten seconds. Utilization must stay under about 25%. The region must be set or transmit is disabled. The roof antenna is the single biggest range factor.</a:t>
-            </a:r>
-            <a:endParaRPr lang="en-US" sz="950" dirty="0"/>
-          </a:p>
-        </p:txBody>
-      </p:sp>
-      <p:sp>
-        <p:nvSpPr>
-          <p:cNvPr id="17" name="Shape 14"/>
-          <p:cNvSpPr/>
-          <p:nvPr/>
-        </p:nvSpPr>
-        <p:spPr>
-          <a:xfrm>
-            <a:off x="4297680" y="3154680"/>
-            <a:ext cx="3657600" cy="1426464"/>
-          </a:xfrm>
-          <a:prstGeom prst="rect">
-            <a:avLst/>
-          </a:prstGeom>
-          <a:solidFill>
-            <a:srgbClr val="F2F5FA"/>
-          </a:solidFill>
-          <a:ln w="15875">
-            <a:solidFill>
-              <a:srgbClr val="D9488C"/>
-            </a:solidFill>
-            <a:prstDash val="solid"/>
-          </a:ln>
-        </p:spPr>
-      </p:sp>
-      <p:sp>
-        <p:nvSpPr>
-          <p:cNvPr id="18" name="Text 15"/>
-          <p:cNvSpPr txBox="1"/>
-          <p:nvPr/>
-        </p:nvSpPr>
-        <p:spPr>
-          <a:xfrm>
-            <a:off x="4425696" y="3218688"/>
-            <a:ext cx="3383280" cy="237744"/>
-          </a:xfrm>
-          <a:prstGeom prst="rect">
-            <a:avLst/>
-          </a:prstGeom>
-          <a:noFill/>
-          <a:ln/>
-        </p:spPr>
-        <p:txBody>
-          <a:bodyPr wrap="square" lIns="0" tIns="0" rIns="0" bIns="0" rtlCol="0" anchor="ctr"/>
-          <a:lstStyle/>
-          <a:p>
-            <a:pPr indent="0" marL="0">
-              <a:buNone/>
-            </a:pPr>
-            <a:r>
-              <a:rPr lang="en-US" sz="1050" b="1" dirty="0">
-                <a:solidFill>
-                  <a:srgbClr val="D9488C"/>
-                </a:solidFill>
-                <a:latin typeface="Courier New" pitchFamily="34" charset="0"/>
-                <a:ea typeface="Courier New" pitchFamily="34" charset="-122"/>
-                <a:cs typeface="Courier New" pitchFamily="34" charset="-120"/>
-              </a:rPr>
-              <a:t>GPS</a:t>
-            </a:r>
-            <a:endParaRPr lang="en-US" sz="1050" dirty="0"/>
-          </a:p>
-        </p:txBody>
-      </p:sp>
-      <p:sp>
-        <p:nvSpPr>
-          <p:cNvPr id="19" name="Text 16"/>
-          <p:cNvSpPr txBox="1"/>
-          <p:nvPr/>
-        </p:nvSpPr>
-        <p:spPr>
-          <a:xfrm>
-            <a:off x="4425696" y="3483864"/>
-            <a:ext cx="3419856" cy="1060704"/>
-          </a:xfrm>
-          <a:prstGeom prst="rect">
-            <a:avLst/>
-          </a:prstGeom>
-          <a:noFill/>
-          <a:ln/>
-        </p:spPr>
-        <p:txBody>
-          <a:bodyPr wrap="square" lIns="0" tIns="0" rIns="0" bIns="0" rtlCol="0" anchor="ctr"/>
-          <a:lstStyle/>
-          <a:p>
-            <a:pPr indent="0" marL="0">
-              <a:buNone/>
-            </a:pPr>
-            <a:r>
-              <a:rPr lang="en-US" sz="950" dirty="0">
-                <a:solidFill>
-                  <a:srgbClr val="222A3F"/>
-                </a:solidFill>
-                <a:latin typeface="Arial" pitchFamily="34" charset="0"/>
-                <a:ea typeface="Arial" pitchFamily="34" charset="-122"/>
-                <a:cs typeface="Arial" pitchFamily="34" charset="-120"/>
-              </a:rPr>
-              <a:t>Needs sky view: a windshield works, a desk does not. Cold start takes minutes. Indoor multipath fakes small phantom speeds, which the deadband removes. Fix rate must match broadcast rate.</a:t>
-            </a:r>
-            <a:endParaRPr lang="en-US" sz="950" dirty="0"/>
-          </a:p>
-        </p:txBody>
-      </p:sp>
-      <p:sp>
-        <p:nvSpPr>
-          <p:cNvPr id="20" name="Shape 17"/>
-          <p:cNvSpPr/>
-          <p:nvPr/>
-        </p:nvSpPr>
-        <p:spPr>
-          <a:xfrm>
-            <a:off x="8138160" y="3154680"/>
-            <a:ext cx="3657600" cy="1426464"/>
-          </a:xfrm>
-          <a:prstGeom prst="rect">
-            <a:avLst/>
-          </a:prstGeom>
-          <a:solidFill>
-            <a:srgbClr val="F2F5FA"/>
-          </a:solidFill>
-          <a:ln w="15875">
-            <a:solidFill>
-              <a:srgbClr val="D9488C"/>
-            </a:solidFill>
-            <a:prstDash val="solid"/>
-          </a:ln>
-        </p:spPr>
-      </p:sp>
-      <p:sp>
-        <p:nvSpPr>
-          <p:cNvPr id="21" name="Text 18"/>
-          <p:cNvSpPr txBox="1"/>
-          <p:nvPr/>
-        </p:nvSpPr>
-        <p:spPr>
-          <a:xfrm>
-            <a:off x="8266176" y="3218688"/>
-            <a:ext cx="3383280" cy="237744"/>
-          </a:xfrm>
-          <a:prstGeom prst="rect">
-            <a:avLst/>
-          </a:prstGeom>
-          <a:noFill/>
-          <a:ln/>
-        </p:spPr>
-        <p:txBody>
-          <a:bodyPr wrap="square" lIns="0" tIns="0" rIns="0" bIns="0" rtlCol="0" anchor="ctr"/>
-          <a:lstStyle/>
-          <a:p>
-            <a:pPr indent="0" marL="0">
-              <a:buNone/>
-            </a:pPr>
-            <a:r>
-              <a:rPr lang="en-US" sz="1050" b="1" dirty="0">
-                <a:solidFill>
-                  <a:srgbClr val="D9488C"/>
-                </a:solidFill>
-                <a:latin typeface="Courier New" pitchFamily="34" charset="0"/>
-                <a:ea typeface="Courier New" pitchFamily="34" charset="-122"/>
-                <a:cs typeface="Courier New" pitchFamily="34" charset="-120"/>
-              </a:rPr>
-              <a:t>BLE LINK</a:t>
-            </a:r>
-            <a:endParaRPr lang="en-US" sz="1050" dirty="0"/>
-          </a:p>
-        </p:txBody>
-      </p:sp>
-      <p:sp>
-        <p:nvSpPr>
-          <p:cNvPr id="22" name="Text 19"/>
-          <p:cNvSpPr txBox="1"/>
-          <p:nvPr/>
-        </p:nvSpPr>
-        <p:spPr>
-          <a:xfrm>
-            <a:off x="8266176" y="3483864"/>
-            <a:ext cx="3419856" cy="1060704"/>
-          </a:xfrm>
-          <a:prstGeom prst="rect">
-            <a:avLst/>
-          </a:prstGeom>
-          <a:noFill/>
-          <a:ln/>
-        </p:spPr>
-        <p:txBody>
-          <a:bodyPr wrap="square" lIns="0" tIns="0" rIns="0" bIns="0" rtlCol="0" anchor="ctr"/>
-          <a:lstStyle/>
-          <a:p>
-            <a:pPr indent="0" marL="0">
-              <a:buNone/>
-            </a:pPr>
-            <a:r>
-              <a:rPr lang="en-US" sz="950" dirty="0">
-                <a:solidFill>
-                  <a:srgbClr val="222A3F"/>
-                </a:solidFill>
-                <a:latin typeface="Arial" pitchFamily="34" charset="0"/>
-                <a:ea typeface="Arial" pitchFamily="34" charset="-122"/>
-                <a:cs typeface="Arial" pitchFamily="34" charset="-120"/>
-              </a:rPr>
-              <a:t>The radio advertises only from boot until its first disconnect, so both units power up together. Exactly one client at a time: a phone app or USB session will take or mute the link.</a:t>
-            </a:r>
-            <a:endParaRPr lang="en-US" sz="950" dirty="0"/>
-          </a:p>
-        </p:txBody>
-      </p:sp>
-      <p:sp>
-        <p:nvSpPr>
-          <p:cNvPr id="23" name="Shape 20"/>
-          <p:cNvSpPr/>
-          <p:nvPr/>
-        </p:nvSpPr>
-        <p:spPr>
-          <a:xfrm>
-            <a:off x="457200" y="4690872"/>
-            <a:ext cx="3657600" cy="1426464"/>
-          </a:xfrm>
-          <a:prstGeom prst="rect">
-            <a:avLst/>
-          </a:prstGeom>
-          <a:solidFill>
-            <a:srgbClr val="F2F5FA"/>
-          </a:solidFill>
-          <a:ln w="15875">
-            <a:solidFill>
-              <a:srgbClr val="D9488C"/>
-            </a:solidFill>
-            <a:prstDash val="solid"/>
-          </a:ln>
-        </p:spPr>
-      </p:sp>
-      <p:sp>
-        <p:nvSpPr>
-          <p:cNvPr id="24" name="Text 21"/>
-          <p:cNvSpPr txBox="1"/>
-          <p:nvPr/>
-        </p:nvSpPr>
-        <p:spPr>
-          <a:xfrm>
-            <a:off x="585216" y="4754880"/>
-            <a:ext cx="3383280" cy="237744"/>
-          </a:xfrm>
-          <a:prstGeom prst="rect">
-            <a:avLst/>
-          </a:prstGeom>
-          <a:noFill/>
-          <a:ln/>
-        </p:spPr>
-        <p:txBody>
-          <a:bodyPr wrap="square" lIns="0" tIns="0" rIns="0" bIns="0" rtlCol="0" anchor="ctr"/>
-          <a:lstStyle/>
-          <a:p>
-            <a:pPr indent="0" marL="0">
-              <a:buNone/>
-            </a:pPr>
-            <a:r>
-              <a:rPr lang="en-US" sz="1050" b="1" dirty="0">
-                <a:solidFill>
-                  <a:srgbClr val="D9488C"/>
-                </a:solidFill>
-                <a:latin typeface="Courier New" pitchFamily="34" charset="0"/>
-                <a:ea typeface="Courier New" pitchFamily="34" charset="-122"/>
-                <a:cs typeface="Courier New" pitchFamily="34" charset="-120"/>
-              </a:rPr>
-              <a:t>DISPLAY</a:t>
-            </a:r>
-            <a:endParaRPr lang="en-US" sz="1050" dirty="0"/>
-          </a:p>
-        </p:txBody>
-      </p:sp>
-      <p:sp>
-        <p:nvSpPr>
-          <p:cNvPr id="25" name="Text 22"/>
-          <p:cNvSpPr txBox="1"/>
-          <p:nvPr/>
-        </p:nvSpPr>
-        <p:spPr>
-          <a:xfrm>
-            <a:off x="585216" y="5020056"/>
-            <a:ext cx="3419856" cy="1060704"/>
-          </a:xfrm>
-          <a:prstGeom prst="rect">
-            <a:avLst/>
-          </a:prstGeom>
-          <a:noFill/>
-          <a:ln/>
-        </p:spPr>
-        <p:txBody>
-          <a:bodyPr wrap="square" lIns="0" tIns="0" rIns="0" bIns="0" rtlCol="0" anchor="ctr"/>
-          <a:lstStyle/>
-          <a:p>
-            <a:pPr indent="0" marL="0">
-              <a:buNone/>
-            </a:pPr>
-            <a:r>
-              <a:rPr lang="en-US" sz="950" dirty="0">
-                <a:solidFill>
-                  <a:srgbClr val="222A3F"/>
-                </a:solidFill>
-                <a:latin typeface="Arial" pitchFamily="34" charset="0"/>
-                <a:ea typeface="Arial" pitchFamily="34" charset="-122"/>
-                <a:cs typeface="Arial" pitchFamily="34" charset="-120"/>
-              </a:rPr>
-              <a:t>A one-bit reflective panel has no grayscale and needs ambient light at night; edge lighting is planned. The redraw budget is two full frames per second.</a:t>
-            </a:r>
-            <a:endParaRPr lang="en-US" sz="950" dirty="0"/>
-          </a:p>
-        </p:txBody>
-      </p:sp>
-      <p:sp>
-        <p:nvSpPr>
-          <p:cNvPr id="26" name="Shape 23"/>
-          <p:cNvSpPr/>
-          <p:nvPr/>
-        </p:nvSpPr>
-        <p:spPr>
-          <a:xfrm>
-            <a:off x="4297680" y="4690872"/>
-            <a:ext cx="3657600" cy="1426464"/>
-          </a:xfrm>
-          <a:prstGeom prst="rect">
-            <a:avLst/>
-          </a:prstGeom>
-          <a:solidFill>
-            <a:srgbClr val="F2F5FA"/>
-          </a:solidFill>
-          <a:ln w="15875">
-            <a:solidFill>
-              <a:srgbClr val="D9488C"/>
-            </a:solidFill>
-            <a:prstDash val="solid"/>
-          </a:ln>
-        </p:spPr>
-      </p:sp>
-      <p:sp>
-        <p:nvSpPr>
-          <p:cNvPr id="27" name="Text 24"/>
-          <p:cNvSpPr txBox="1"/>
-          <p:nvPr/>
-        </p:nvSpPr>
-        <p:spPr>
-          <a:xfrm>
-            <a:off x="4425696" y="4754880"/>
-            <a:ext cx="3383280" cy="237744"/>
-          </a:xfrm>
-          <a:prstGeom prst="rect">
-            <a:avLst/>
-          </a:prstGeom>
-          <a:noFill/>
-          <a:ln/>
-        </p:spPr>
-        <p:txBody>
-          <a:bodyPr wrap="square" lIns="0" tIns="0" rIns="0" bIns="0" rtlCol="0" anchor="ctr"/>
-          <a:lstStyle/>
-          <a:p>
-            <a:pPr indent="0" marL="0">
-              <a:buNone/>
-            </a:pPr>
-            <a:r>
-              <a:rPr lang="en-US" sz="1050" b="1" dirty="0">
-                <a:solidFill>
-                  <a:srgbClr val="D9488C"/>
-                </a:solidFill>
-                <a:latin typeface="Courier New" pitchFamily="34" charset="0"/>
-                <a:ea typeface="Courier New" pitchFamily="34" charset="-122"/>
-                <a:cs typeface="Courier New" pitchFamily="34" charset="-120"/>
-              </a:rPr>
-              <a:t>POWER</a:t>
-            </a:r>
-            <a:endParaRPr lang="en-US" sz="1050" dirty="0"/>
-          </a:p>
-        </p:txBody>
-      </p:sp>
-      <p:sp>
-        <p:nvSpPr>
-          <p:cNvPr id="28" name="Text 25"/>
-          <p:cNvSpPr txBox="1"/>
-          <p:nvPr/>
-        </p:nvSpPr>
-        <p:spPr>
-          <a:xfrm>
-            <a:off x="4425696" y="5020056"/>
-            <a:ext cx="3419856" cy="1060704"/>
-          </a:xfrm>
-          <a:prstGeom prst="rect">
-            <a:avLst/>
-          </a:prstGeom>
-          <a:noFill/>
-          <a:ln/>
-        </p:spPr>
-        <p:txBody>
-          <a:bodyPr wrap="square" lIns="0" tIns="0" rIns="0" bIns="0" rtlCol="0" anchor="ctr"/>
-          <a:lstStyle/>
-          <a:p>
-            <a:pPr indent="0" marL="0">
-              <a:buNone/>
-            </a:pPr>
-            <a:r>
-              <a:rPr lang="en-US" sz="950" dirty="0">
-                <a:solidFill>
-                  <a:srgbClr val="222A3F"/>
-                </a:solidFill>
-                <a:latin typeface="Arial" pitchFamily="34" charset="0"/>
-                <a:ea typeface="Arial" pitchFamily="34" charset="-122"/>
-                <a:cs typeface="Arial" pitchFamily="34" charset="-120"/>
-              </a:rPr>
-              <a:t>Cheap 12 volt USB adapters cut off on the radio's low current draw, so every adapter gets validated. Both units must share the vehicle's power timing.</a:t>
-            </a:r>
-            <a:endParaRPr lang="en-US" sz="950" dirty="0"/>
-          </a:p>
-        </p:txBody>
-      </p:sp>
-      <p:sp>
-        <p:nvSpPr>
-          <p:cNvPr id="29" name="Shape 26"/>
-          <p:cNvSpPr/>
-          <p:nvPr/>
-        </p:nvSpPr>
-        <p:spPr>
-          <a:xfrm>
-            <a:off x="8138160" y="4690872"/>
-            <a:ext cx="3657600" cy="1426464"/>
-          </a:xfrm>
-          <a:prstGeom prst="rect">
-            <a:avLst/>
-          </a:prstGeom>
-          <a:solidFill>
-            <a:srgbClr val="F2F5FA"/>
-          </a:solidFill>
-          <a:ln w="15875">
-            <a:solidFill>
-              <a:srgbClr val="D9488C"/>
-            </a:solidFill>
-            <a:prstDash val="solid"/>
-          </a:ln>
-        </p:spPr>
-      </p:sp>
-      <p:sp>
-        <p:nvSpPr>
-          <p:cNvPr id="30" name="Text 27"/>
-          <p:cNvSpPr txBox="1"/>
-          <p:nvPr/>
-        </p:nvSpPr>
-        <p:spPr>
-          <a:xfrm>
-            <a:off x="8266176" y="4754880"/>
-            <a:ext cx="3383280" cy="237744"/>
-          </a:xfrm>
-          <a:prstGeom prst="rect">
-            <a:avLst/>
-          </a:prstGeom>
-          <a:noFill/>
-          <a:ln/>
-        </p:spPr>
-        <p:txBody>
-          <a:bodyPr wrap="square" lIns="0" tIns="0" rIns="0" bIns="0" rtlCol="0" anchor="ctr"/>
-          <a:lstStyle/>
-          <a:p>
-            <a:pPr indent="0" marL="0">
-              <a:buNone/>
-            </a:pPr>
-            <a:r>
-              <a:rPr lang="en-US" sz="1050" b="1" dirty="0">
-                <a:solidFill>
-                  <a:srgbClr val="D9488C"/>
-                </a:solidFill>
-                <a:latin typeface="Courier New" pitchFamily="34" charset="0"/>
-                <a:ea typeface="Courier New" pitchFamily="34" charset="-122"/>
-                <a:cs typeface="Courier New" pitchFamily="34" charset="-120"/>
-              </a:rPr>
-              <a:t>PROVISIONING</a:t>
-            </a:r>
-            <a:endParaRPr lang="en-US" sz="1050" dirty="0"/>
-          </a:p>
-        </p:txBody>
-      </p:sp>
-      <p:sp>
-        <p:nvSpPr>
-          <p:cNvPr id="31" name="Text 28"/>
-          <p:cNvSpPr txBox="1"/>
-          <p:nvPr/>
-        </p:nvSpPr>
-        <p:spPr>
-          <a:xfrm>
-            <a:off x="8266176" y="5020056"/>
-            <a:ext cx="3419856" cy="1060704"/>
-          </a:xfrm>
-          <a:prstGeom prst="rect">
-            <a:avLst/>
-          </a:prstGeom>
-          <a:noFill/>
-          <a:ln/>
-        </p:spPr>
-        <p:txBody>
-          <a:bodyPr wrap="square" lIns="0" tIns="0" rIns="0" bIns="0" rtlCol="0" anchor="ctr"/>
-          <a:lstStyle/>
-          <a:p>
-            <a:pPr indent="0" marL="0">
-              <a:buNone/>
-            </a:pPr>
-            <a:r>
-              <a:rPr lang="en-US" sz="950" dirty="0">
-                <a:solidFill>
-                  <a:srgbClr val="222A3F"/>
-                </a:solidFill>
-                <a:latin typeface="Arial" pitchFamily="34" charset="0"/>
-                <a:ea typeface="Arial" pitchFamily="34" charset="-122"/>
-                <a:cs typeface="Arial" pitchFamily="34" charset="-120"/>
-              </a:rPr>
-              <a:t>The channel URL carrying the encryption key must match on every radio. Node identities derive from the MAC address and survive reflashes. Every configuration write is read back and verified.</a:t>
-            </a:r>
-            <a:endParaRPr lang="en-US" sz="950" dirty="0"/>
+              <a:t>SOURCES  [1] Semtech SX1276 datasheet, SNR limit per spreading factor   [2] Semtech AN1200.22, LoRa modulation and airtime   [3] Meshtastic docs, LoRa config and duty limit   [4] ITU-R M.1371, AIS reporting intervals   (full citations in the notes)</a:t>
+            </a:r>
+            <a:endParaRPr lang="en-US" sz="850" dirty="0"/>
           </a:p>
         </p:txBody>
       </p:sp>

</xml_diff>

<commit_message>
Deck 13 sheets: Cannon integration milestone + references sheet
New sheet 10 (Cannon): the integration story. A five-layer stack (GPS
to radio, radio to display, decode to TrackerState, navigation and UI,
partner over LoRa) with PROVEN stamps quoting the evidence line from
this morning's photos, the two photos themselves, and the one-device
test strategy. New sheet 13: full ten-entry references sheet. Briefing
gains the Cannon integration section with script and Q&A. Gantt synced
to task-basis claims: 42 percent, 18/46 done.

Co-Authored-By: Claude Fable 5 <noreply@anthropic.com>
</commit_message>
<xml_diff>
--- a/docs/presentations/Group9_Presentation3_Week3.pptx
+++ b/docs/presentations/Group9_Presentation3_Week3.pptx
@@ -16,9 +16,11 @@
     <p:sldId id="264" r:id="rId10"/>
     <p:sldId id="265" r:id="rId11"/>
     <p:sldId id="266" r:id="rId12"/>
+    <p:sldId id="267" r:id="rId13"/>
+    <p:sldId id="268" r:id="rId14"/>
   </p:sldIdLst>
   <p:notesMasterIdLst>
-    <p:notesMasterId r:id="rId13"/>
+    <p:notesMasterId r:id="rId15"/>
   </p:notesMasterIdLst>
   <p:sldSz cx="12192000" cy="6858000"/>
   <p:notesSz cx="6858000" cy="12192000"/>
@@ -600,7 +602,7 @@
           <a:p>
             <a:r>
               <a:rPr lang="en-US" dirty="0"/>
-              <a:t>Each card becomes a line item in the test protocol. The strength of this slide is provenance: phantom speed, the advertise-once trap, the charger cutoff, and the configuration revert were all found by us, on our hardware, and every one is documented in the repository with its fix.</a:t>
+              <a:t>This sheet is the integration story: the two halves of the firmware are joined and running on real hardware. Walk the stack top to bottom, and point at the photo text that proves each layer: own GPS locked proves layer one, radio link connected proves layer two, the live coordinates prove decoding, and the clock reading Central time proves the navigation layer is deriving timezone from position. The dashed layer is the honest gap, and the display itself says it: no partner heard yet. The strategy: one device tracking itself exercises everything except the LoRa hop, so integration bugs get found cheaply before the two-vehicle test. Radio two closes the loop without changing a line of display code.</a:t>
             </a:r>
             <a:endParaRPr lang="en-US" dirty="0"/>
           </a:p>
@@ -688,7 +690,7 @@
           <a:p>
             <a:r>
               <a:rPr lang="en-US" dirty="0"/>
-              <a:t/>
+              <a:t>Each card becomes a line item in the test protocol. The strength of this slide is provenance: phantom speed, the advertise-once trap, the charger cutoff, and the configuration revert were all found by us, on our hardware, and every one is documented in the repository with its fix.</a:t>
             </a:r>
             <a:endParaRPr lang="en-US" dirty="0"/>
           </a:p>
@@ -712,6 +714,182 @@
             <a:fld id="{F7021451-1387-4CA6-816F-3879F97B5CBC}" type="slidenum">
               <a:rPr lang="en-US"/>
               <a:t>11</a:t>
+            </a:fld>
+            <a:endParaRPr lang="en-US"/>
+          </a:p>
+        </p:txBody>
+      </p:sp>
+    </p:spTree>
+    <p:extLst>
+      <p:ext uri="{BB962C8B-B14F-4D97-AF65-F5344CB8AC3E}">
+        <p14:creationId xmlns:p14="http://schemas.microsoft.com/office/powerpoint/2010/main" val="1024086991"/>
+      </p:ext>
+    </p:extLst>
+  </p:cSld>
+  <p:clrMapOvr>
+    <a:masterClrMapping/>
+  </p:clrMapOvr>
+</p:notes>
+</file>
+
+<file path=ppt/notesSlides/notesSlide12.xml><?xml version="1.0" encoding="utf-8"?>
+<p:notes xmlns:a="http://schemas.openxmlformats.org/drawingml/2006/main" xmlns:r="http://schemas.openxmlformats.org/officeDocument/2006/relationships" xmlns:p="http://schemas.openxmlformats.org/presentationml/2006/main">
+  <p:cSld>
+    <p:spTree>
+      <p:nvGrpSpPr>
+        <p:cNvPr id="1" name=""/>
+        <p:cNvGrpSpPr/>
+        <p:nvPr/>
+      </p:nvGrpSpPr>
+      <p:grpSpPr>
+        <a:xfrm>
+          <a:off x="0" y="0"/>
+          <a:ext cx="0" cy="0"/>
+          <a:chOff x="0" y="0"/>
+          <a:chExt cx="0" cy="0"/>
+        </a:xfrm>
+      </p:grpSpPr>
+      <p:sp>
+        <p:nvSpPr>
+          <p:cNvPr id="2" name="Slide Image Placeholder 1"/>
+          <p:cNvSpPr>
+            <a:spLocks noGrp="1" noRot="1" noChangeAspect="1"/>
+          </p:cNvSpPr>
+          <p:nvPr>
+            <p:ph type="sldImg"/>
+          </p:nvPr>
+        </p:nvSpPr>
+        <p:spPr/>
+      </p:sp>
+      <p:sp>
+        <p:nvSpPr>
+          <p:cNvPr id="3" name="Notes Placeholder 2"/>
+          <p:cNvSpPr>
+            <a:spLocks noGrp="1"/>
+          </p:cNvSpPr>
+          <p:nvPr>
+            <p:ph type="body" idx="1"/>
+          </p:nvPr>
+        </p:nvSpPr>
+        <p:spPr/>
+        <p:txBody>
+          <a:bodyPr/>
+          <a:lstStyle/>
+          <a:p>
+            <a:r>
+              <a:rPr lang="en-US" dirty="0"/>
+              <a:t/>
+            </a:r>
+            <a:endParaRPr lang="en-US" dirty="0"/>
+          </a:p>
+        </p:txBody>
+      </p:sp>
+      <p:sp>
+        <p:nvSpPr>
+          <p:cNvPr id="4" name="Slide Number Placeholder 3"/>
+          <p:cNvSpPr>
+            <a:spLocks noGrp="1"/>
+          </p:cNvSpPr>
+          <p:nvPr>
+            <p:ph type="sldNum" sz="quarter" idx="10"/>
+          </p:nvPr>
+        </p:nvSpPr>
+        <p:spPr/>
+        <p:txBody>
+          <a:bodyPr/>
+          <a:lstStyle/>
+          <a:p>
+            <a:fld id="{F7021451-1387-4CA6-816F-3879F97B5CBC}" type="slidenum">
+              <a:rPr lang="en-US"/>
+              <a:t>12</a:t>
+            </a:fld>
+            <a:endParaRPr lang="en-US"/>
+          </a:p>
+        </p:txBody>
+      </p:sp>
+    </p:spTree>
+    <p:extLst>
+      <p:ext uri="{BB962C8B-B14F-4D97-AF65-F5344CB8AC3E}">
+        <p14:creationId xmlns:p14="http://schemas.microsoft.com/office/powerpoint/2010/main" val="1024086991"/>
+      </p:ext>
+    </p:extLst>
+  </p:cSld>
+  <p:clrMapOvr>
+    <a:masterClrMapping/>
+  </p:clrMapOvr>
+</p:notes>
+</file>
+
+<file path=ppt/notesSlides/notesSlide13.xml><?xml version="1.0" encoding="utf-8"?>
+<p:notes xmlns:a="http://schemas.openxmlformats.org/drawingml/2006/main" xmlns:r="http://schemas.openxmlformats.org/officeDocument/2006/relationships" xmlns:p="http://schemas.openxmlformats.org/presentationml/2006/main">
+  <p:cSld>
+    <p:spTree>
+      <p:nvGrpSpPr>
+        <p:cNvPr id="1" name=""/>
+        <p:cNvGrpSpPr/>
+        <p:nvPr/>
+      </p:nvGrpSpPr>
+      <p:grpSpPr>
+        <a:xfrm>
+          <a:off x="0" y="0"/>
+          <a:ext cx="0" cy="0"/>
+          <a:chOff x="0" y="0"/>
+          <a:chExt cx="0" cy="0"/>
+        </a:xfrm>
+      </p:grpSpPr>
+      <p:sp>
+        <p:nvSpPr>
+          <p:cNvPr id="2" name="Slide Image Placeholder 1"/>
+          <p:cNvSpPr>
+            <a:spLocks noGrp="1" noRot="1" noChangeAspect="1"/>
+          </p:cNvSpPr>
+          <p:nvPr>
+            <p:ph type="sldImg"/>
+          </p:nvPr>
+        </p:nvSpPr>
+        <p:spPr/>
+      </p:sp>
+      <p:sp>
+        <p:nvSpPr>
+          <p:cNvPr id="3" name="Notes Placeholder 2"/>
+          <p:cNvSpPr>
+            <a:spLocks noGrp="1"/>
+          </p:cNvSpPr>
+          <p:nvPr>
+            <p:ph type="body" idx="1"/>
+          </p:nvPr>
+        </p:nvSpPr>
+        <p:spPr/>
+        <p:txBody>
+          <a:bodyPr/>
+          <a:lstStyle/>
+          <a:p>
+            <a:r>
+              <a:rPr lang="en-US" dirty="0"/>
+              <a:t>Leave this up during questions. If a number is challenged, the sources are: equations from Semtech [1][2], configuration behavior from Meshtastic docs [4], wire units from the protobuf schema itself [5], and the AIS precedent [7].</a:t>
+            </a:r>
+            <a:endParaRPr lang="en-US" dirty="0"/>
+          </a:p>
+        </p:txBody>
+      </p:sp>
+      <p:sp>
+        <p:nvSpPr>
+          <p:cNvPr id="4" name="Slide Number Placeholder 3"/>
+          <p:cNvSpPr>
+            <a:spLocks noGrp="1"/>
+          </p:cNvSpPr>
+          <p:nvPr>
+            <p:ph type="sldNum" sz="quarter" idx="10"/>
+          </p:nvPr>
+        </p:nvSpPr>
+        <p:spPr/>
+        <p:txBody>
+          <a:bodyPr/>
+          <a:lstStyle/>
+          <a:p>
+            <a:fld id="{F7021451-1387-4CA6-816F-3879F97B5CBC}" type="slidenum">
+              <a:rPr lang="en-US"/>
+              <a:t>13</a:t>
             </a:fld>
             <a:endParaRPr lang="en-US"/>
           </a:p>
@@ -1921,7 +2099,7 @@
                 <a:ea typeface="Courier New" pitchFamily="34" charset="-122"/>
                 <a:cs typeface="Courier New" pitchFamily="34" charset="-120"/>
               </a:rPr>
-              <a:t>SHEET 01/11  REV C  2026-09-07</a:t>
+              <a:t>SHEET 01/13  REV C  2026-09-07</a:t>
             </a:r>
             <a:endParaRPr lang="en-US" sz="900" dirty="0"/>
           </a:p>
@@ -4736,7 +4914,7 @@
                 <a:ea typeface="Courier New" pitchFamily="34" charset="-122"/>
                 <a:cs typeface="Courier New" pitchFamily="34" charset="-120"/>
               </a:rPr>
-              <a:t>INTEGRATION CONSTRAINTS</a:t>
+              <a:t>INTEGRATION, ONE DEVICE</a:t>
             </a:r>
             <a:endParaRPr lang="en-US" sz="900" dirty="0"/>
           </a:p>
@@ -4775,7 +4953,7 @@
                 <a:ea typeface="Courier New" pitchFamily="34" charset="-122"/>
                 <a:cs typeface="Courier New" pitchFamily="34" charset="-120"/>
               </a:rPr>
-              <a:t>SHEET 10/11  REV C  2026-09-07</a:t>
+              <a:t>SHEET 10/13  REV C  2026-09-07</a:t>
             </a:r>
             <a:endParaRPr lang="en-US" sz="900" dirty="0"/>
           </a:p>
@@ -4878,146 +5056,22 @@
                 <a:ea typeface="Arial" pitchFamily="34" charset="-122"/>
                 <a:cs typeface="Arial" pitchFamily="34" charset="-120"/>
               </a:rPr>
-              <a:t>INTEGRATION CONSTRAINTS: THE LEDGER</a:t>
+              <a:t>INTEGRATION: THE HALVES ARE JOINED</a:t>
             </a:r>
             <a:endParaRPr lang="en-US" sz="2300" dirty="0"/>
           </a:p>
         </p:txBody>
       </p:sp>
-      <p:pic>
-        <p:nvPicPr>
-          <p:cNvPr id="10" name="Image 0" descr="C:/Users/deogr/AppData/Local/Temp/claude/C--Users-deogr-Documents-Fall-Project-Off-Grid-Vehicle-dection-project/e8b2e8fa-1513-4aa8-a8f6-ce4fcd20e664/scratchpad/mermaid_png/diag1.png">    </p:cNvPr>
-          <p:cNvPicPr>
-            <a:picLocks noChangeAspect="1"/>
-          </p:cNvPicPr>
-          <p:nvPr/>
-        </p:nvPicPr>
-        <p:blipFill>
-          <a:blip r:embed="rId1"/>
-          <a:stretch>
-            <a:fillRect/>
-          </a:stretch>
-        </p:blipFill>
-        <p:spPr>
-          <a:xfrm>
-            <a:off x="457200" y="1005840"/>
-            <a:ext cx="5669280" cy="1938528"/>
-          </a:xfrm>
-          <a:prstGeom prst="rect">
-            <a:avLst/>
-          </a:prstGeom>
-        </p:spPr>
-      </p:pic>
-      <p:sp>
-        <p:nvSpPr>
-          <p:cNvPr id="11" name="Shape 8"/>
+      <p:sp>
+        <p:nvSpPr>
+          <p:cNvPr id="10" name="Shape 8"/>
           <p:cNvSpPr/>
           <p:nvPr/>
         </p:nvSpPr>
         <p:spPr>
           <a:xfrm>
-            <a:off x="457200" y="1005840"/>
-            <a:ext cx="5669280" cy="1938528"/>
-          </a:xfrm>
-          <a:prstGeom prst="rect">
-            <a:avLst/>
-          </a:prstGeom>
-          <a:ln w="12700">
-            <a:solidFill>
-              <a:srgbClr val="9AA7BE"/>
-            </a:solidFill>
-            <a:prstDash val="solid"/>
-          </a:ln>
-        </p:spPr>
-      </p:sp>
-      <p:sp>
-        <p:nvSpPr>
-          <p:cNvPr id="12" name="Text 9"/>
-          <p:cNvSpPr txBox="1"/>
-          <p:nvPr/>
-        </p:nvSpPr>
-        <p:spPr>
-          <a:xfrm>
-            <a:off x="6400800" y="1097280"/>
-            <a:ext cx="5257800" cy="777240"/>
-          </a:xfrm>
-          <a:prstGeom prst="rect">
-            <a:avLst/>
-          </a:prstGeom>
-          <a:noFill/>
-          <a:ln/>
-        </p:spPr>
-        <p:txBody>
-          <a:bodyPr wrap="square" lIns="0" tIns="0" rIns="0" bIns="0" rtlCol="0" anchor="ctr"/>
-          <a:lstStyle/>
-          <a:p>
-            <a:pPr indent="0" marL="0">
-              <a:buNone/>
-            </a:pPr>
-            <a:r>
-              <a:rPr lang="en-US" sz="1250" dirty="0">
-                <a:solidFill>
-                  <a:srgbClr val="222A3F"/>
-                </a:solidFill>
-                <a:latin typeface="Arial" pitchFamily="34" charset="0"/>
-                <a:ea typeface="Arial" pitchFamily="34" charset="-122"/>
-                <a:cs typeface="Arial" pitchFamily="34" charset="-120"/>
-              </a:rPr>
-              <a:t>Every constraint below was discovered on the bench or on the road, and each one shaped the design. None are theoretical.</a:t>
-            </a:r>
-            <a:endParaRPr lang="en-US" sz="1250" dirty="0"/>
-          </a:p>
-        </p:txBody>
-      </p:sp>
-      <p:sp>
-        <p:nvSpPr>
-          <p:cNvPr id="13" name="Text 10"/>
-          <p:cNvSpPr txBox="1"/>
-          <p:nvPr/>
-        </p:nvSpPr>
-        <p:spPr>
-          <a:xfrm>
-            <a:off x="6400800" y="1965960"/>
-            <a:ext cx="5257800" cy="868680"/>
-          </a:xfrm>
-          <a:prstGeom prst="rect">
-            <a:avLst/>
-          </a:prstGeom>
-          <a:noFill/>
-          <a:ln/>
-        </p:spPr>
-        <p:txBody>
-          <a:bodyPr wrap="square" lIns="0" tIns="0" rIns="0" bIns="0" rtlCol="0" anchor="ctr"/>
-          <a:lstStyle/>
-          <a:p>
-            <a:pPr indent="0" marL="0">
-              <a:buNone/>
-            </a:pPr>
-            <a:r>
-              <a:rPr lang="en-US" sz="1200" b="1" dirty="0">
-                <a:solidFill>
-                  <a:srgbClr val="16213D"/>
-                </a:solidFill>
-                <a:latin typeface="Courier New" pitchFamily="34" charset="0"/>
-                <a:ea typeface="Courier New" pitchFamily="34" charset="-122"/>
-                <a:cs typeface="Courier New" pitchFamily="34" charset="-120"/>
-              </a:rPr>
-              <a:t>TEST SEQUENCE: provision radio 2, bench two-radio decode, two-vehicle drive test, range characterization.</a:t>
-            </a:r>
-            <a:endParaRPr lang="en-US" sz="1200" dirty="0"/>
-          </a:p>
-        </p:txBody>
-      </p:sp>
-      <p:sp>
-        <p:nvSpPr>
-          <p:cNvPr id="14" name="Shape 11"/>
-          <p:cNvSpPr/>
-          <p:nvPr/>
-        </p:nvSpPr>
-        <p:spPr>
-          <a:xfrm>
-            <a:off x="457200" y="3154680"/>
-            <a:ext cx="3657600" cy="1426464"/>
+            <a:off x="457200" y="1097280"/>
+            <a:ext cx="5760720" cy="804672"/>
           </a:xfrm>
           <a:prstGeom prst="rect">
             <a:avLst/>
@@ -5035,14 +5089,14 @@
       </p:sp>
       <p:sp>
         <p:nvSpPr>
-          <p:cNvPr id="15" name="Text 12"/>
-          <p:cNvSpPr txBox="1"/>
-          <p:nvPr/>
-        </p:nvSpPr>
-        <p:spPr>
-          <a:xfrm>
-            <a:off x="585216" y="3218688"/>
-            <a:ext cx="3383280" cy="237744"/>
+          <p:cNvPr id="11" name="Text 9"/>
+          <p:cNvSpPr txBox="1"/>
+          <p:nvPr/>
+        </p:nvSpPr>
+        <p:spPr>
+          <a:xfrm>
+            <a:off x="594360" y="1152144"/>
+            <a:ext cx="3840480" cy="713232"/>
           </a:xfrm>
           <a:prstGeom prst="rect">
             <a:avLst/>
@@ -5058,30 +5112,86 @@
               <a:buNone/>
             </a:pPr>
             <a:r>
-              <a:rPr lang="en-US" sz="1050" b="1" dirty="0">
-                <a:solidFill>
-                  <a:srgbClr val="D9488C"/>
+              <a:rPr lang="en-US" sz="1150" b="1" dirty="0">
+                <a:solidFill>
+                  <a:srgbClr val="16213D"/>
+                </a:solidFill>
+                <a:latin typeface="Arial" pitchFamily="34" charset="0"/>
+                <a:ea typeface="Arial" pitchFamily="34" charset="-122"/>
+                <a:cs typeface="Arial" pitchFamily="34" charset="-120"/>
+              </a:rPr>
+              <a:t>GPS to radio</a:t>
+            </a:r>
+            <a:endParaRPr lang="en-US" sz="1150" dirty="0"/>
+          </a:p>
+          <a:p>
+            <a:pPr indent="0" marL="0">
+              <a:buNone/>
+            </a:pPr>
+            <a:r>
+              <a:rPr lang="en-US" sz="950" dirty="0">
+                <a:solidFill>
+                  <a:srgbClr val="5E6B85"/>
+                </a:solidFill>
+                <a:latin typeface="Arial" pitchFamily="34" charset="0"/>
+                <a:ea typeface="Arial" pitchFamily="34" charset="-122"/>
+                <a:cs typeface="Arial" pitchFamily="34" charset="-120"/>
+              </a:rPr>
+              <a:t>satellites acquired, fixes flowing over UART</a:t>
+            </a:r>
+            <a:endParaRPr lang="en-US" sz="1150" dirty="0"/>
+          </a:p>
+        </p:txBody>
+      </p:sp>
+      <p:sp>
+        <p:nvSpPr>
+          <p:cNvPr id="12" name="Text 10"/>
+          <p:cNvSpPr txBox="1"/>
+          <p:nvPr/>
+        </p:nvSpPr>
+        <p:spPr>
+          <a:xfrm>
+            <a:off x="4526280" y="1170432"/>
+            <a:ext cx="868680" cy="274320"/>
+          </a:xfrm>
+          <a:prstGeom prst="rect">
+            <a:avLst/>
+          </a:prstGeom>
+          <a:noFill/>
+          <a:ln/>
+        </p:spPr>
+        <p:txBody>
+          <a:bodyPr wrap="square" lIns="0" tIns="0" rIns="0" bIns="0" rtlCol="0" anchor="ctr"/>
+          <a:lstStyle/>
+          <a:p>
+            <a:pPr algn="ctr" indent="0" marL="0">
+              <a:buNone/>
+            </a:pPr>
+            <a:r>
+              <a:rPr lang="en-US" sz="950" b="1" dirty="0">
+                <a:solidFill>
+                  <a:srgbClr val="1F9D68"/>
                 </a:solidFill>
                 <a:latin typeface="Courier New" pitchFamily="34" charset="0"/>
                 <a:ea typeface="Courier New" pitchFamily="34" charset="-122"/>
                 <a:cs typeface="Courier New" pitchFamily="34" charset="-120"/>
               </a:rPr>
-              <a:t>RADIO / PHY</a:t>
-            </a:r>
-            <a:endParaRPr lang="en-US" sz="1050" dirty="0"/>
-          </a:p>
-        </p:txBody>
-      </p:sp>
-      <p:sp>
-        <p:nvSpPr>
-          <p:cNvPr id="16" name="Text 13"/>
-          <p:cNvSpPr txBox="1"/>
-          <p:nvPr/>
-        </p:nvSpPr>
-        <p:spPr>
-          <a:xfrm>
-            <a:off x="585216" y="3483864"/>
-            <a:ext cx="3419856" cy="1060704"/>
+              <a:t>PROVEN</a:t>
+            </a:r>
+            <a:endParaRPr lang="en-US" sz="950" dirty="0"/>
+          </a:p>
+        </p:txBody>
+      </p:sp>
+      <p:sp>
+        <p:nvSpPr>
+          <p:cNvPr id="13" name="Text 11"/>
+          <p:cNvSpPr txBox="1"/>
+          <p:nvPr/>
+        </p:nvSpPr>
+        <p:spPr>
+          <a:xfrm>
+            <a:off x="4526280" y="1463040"/>
+            <a:ext cx="1645920" cy="384048"/>
           </a:xfrm>
           <a:prstGeom prst="rect">
             <a:avLst/>
@@ -5097,30 +5207,54 @@
               <a:buNone/>
             </a:pPr>
             <a:r>
-              <a:rPr lang="en-US" sz="950" dirty="0">
-                <a:solidFill>
-                  <a:srgbClr val="222A3F"/>
-                </a:solidFill>
-                <a:latin typeface="Arial" pitchFamily="34" charset="0"/>
-                <a:ea typeface="Arial" pitchFamily="34" charset="-122"/>
-                <a:cs typeface="Arial" pitchFamily="34" charset="-120"/>
-              </a:rPr>
-              <a:t>Half a second of airtime per packet caps cadence at ten seconds. Utilization must stay under about 25%. The region must be set or transmit is disabled. The roof antenna is the single biggest range factor.</a:t>
-            </a:r>
-            <a:endParaRPr lang="en-US" sz="950" dirty="0"/>
-          </a:p>
-        </p:txBody>
-      </p:sp>
-      <p:sp>
-        <p:nvSpPr>
-          <p:cNvPr id="17" name="Shape 14"/>
+              <a:rPr lang="en-US" sz="800" dirty="0">
+                <a:solidFill>
+                  <a:srgbClr val="5E6B85"/>
+                </a:solidFill>
+                <a:latin typeface="Courier New" pitchFamily="34" charset="0"/>
+                <a:ea typeface="Courier New" pitchFamily="34" charset="-122"/>
+                <a:cs typeface="Courier New" pitchFamily="34" charset="-120"/>
+              </a:rPr>
+              <a:t>"own GPS: locked"</a:t>
+            </a:r>
+            <a:endParaRPr lang="en-US" sz="800" dirty="0"/>
+          </a:p>
+        </p:txBody>
+      </p:sp>
+      <p:sp>
+        <p:nvSpPr>
+          <p:cNvPr id="14" name="Shape 12"/>
           <p:cNvSpPr/>
           <p:nvPr/>
         </p:nvSpPr>
         <p:spPr>
           <a:xfrm>
-            <a:off x="4297680" y="3154680"/>
-            <a:ext cx="3657600" cy="1426464"/>
+            <a:off x="1051560" y="1901952"/>
+            <a:ext cx="0" cy="164592"/>
+          </a:xfrm>
+          <a:prstGeom prst="line">
+            <a:avLst/>
+          </a:prstGeom>
+          <a:noFill/>
+          <a:ln w="28575">
+            <a:solidFill>
+              <a:srgbClr val="D9488C"/>
+            </a:solidFill>
+            <a:prstDash val="solid"/>
+            <a:tailEnd type="triangle"/>
+          </a:ln>
+        </p:spPr>
+      </p:sp>
+      <p:sp>
+        <p:nvSpPr>
+          <p:cNvPr id="15" name="Shape 13"/>
+          <p:cNvSpPr/>
+          <p:nvPr/>
+        </p:nvSpPr>
+        <p:spPr>
+          <a:xfrm>
+            <a:off x="457200" y="2066544"/>
+            <a:ext cx="5760720" cy="804672"/>
           </a:xfrm>
           <a:prstGeom prst="rect">
             <a:avLst/>
@@ -5138,14 +5272,14 @@
       </p:sp>
       <p:sp>
         <p:nvSpPr>
-          <p:cNvPr id="18" name="Text 15"/>
-          <p:cNvSpPr txBox="1"/>
-          <p:nvPr/>
-        </p:nvSpPr>
-        <p:spPr>
-          <a:xfrm>
-            <a:off x="4425696" y="3218688"/>
-            <a:ext cx="3383280" cy="237744"/>
+          <p:cNvPr id="16" name="Text 14"/>
+          <p:cNvSpPr txBox="1"/>
+          <p:nvPr/>
+        </p:nvSpPr>
+        <p:spPr>
+          <a:xfrm>
+            <a:off x="594360" y="2121408"/>
+            <a:ext cx="3840480" cy="713232"/>
           </a:xfrm>
           <a:prstGeom prst="rect">
             <a:avLst/>
@@ -5161,30 +5295,86 @@
               <a:buNone/>
             </a:pPr>
             <a:r>
-              <a:rPr lang="en-US" sz="1050" b="1" dirty="0">
-                <a:solidFill>
-                  <a:srgbClr val="D9488C"/>
+              <a:rPr lang="en-US" sz="1150" b="1" dirty="0">
+                <a:solidFill>
+                  <a:srgbClr val="16213D"/>
+                </a:solidFill>
+                <a:latin typeface="Arial" pitchFamily="34" charset="0"/>
+                <a:ea typeface="Arial" pitchFamily="34" charset="-122"/>
+                <a:cs typeface="Arial" pitchFamily="34" charset="-120"/>
+              </a:rPr>
+              <a:t>Radio to display</a:t>
+            </a:r>
+            <a:endParaRPr lang="en-US" sz="1150" dirty="0"/>
+          </a:p>
+          <a:p>
+            <a:pPr indent="0" marL="0">
+              <a:buNone/>
+            </a:pPr>
+            <a:r>
+              <a:rPr lang="en-US" sz="950" dirty="0">
+                <a:solidFill>
+                  <a:srgbClr val="5E6B85"/>
+                </a:solidFill>
+                <a:latin typeface="Arial" pitchFamily="34" charset="0"/>
+                <a:ea typeface="Arial" pitchFamily="34" charset="-122"/>
+                <a:cs typeface="Arial" pitchFamily="34" charset="-120"/>
+              </a:rPr>
+              <a:t>BLE GATT link, automatic reconnect</a:t>
+            </a:r>
+            <a:endParaRPr lang="en-US" sz="1150" dirty="0"/>
+          </a:p>
+        </p:txBody>
+      </p:sp>
+      <p:sp>
+        <p:nvSpPr>
+          <p:cNvPr id="17" name="Text 15"/>
+          <p:cNvSpPr txBox="1"/>
+          <p:nvPr/>
+        </p:nvSpPr>
+        <p:spPr>
+          <a:xfrm>
+            <a:off x="4526280" y="2139696"/>
+            <a:ext cx="868680" cy="274320"/>
+          </a:xfrm>
+          <a:prstGeom prst="rect">
+            <a:avLst/>
+          </a:prstGeom>
+          <a:noFill/>
+          <a:ln/>
+        </p:spPr>
+        <p:txBody>
+          <a:bodyPr wrap="square" lIns="0" tIns="0" rIns="0" bIns="0" rtlCol="0" anchor="ctr"/>
+          <a:lstStyle/>
+          <a:p>
+            <a:pPr algn="ctr" indent="0" marL="0">
+              <a:buNone/>
+            </a:pPr>
+            <a:r>
+              <a:rPr lang="en-US" sz="950" b="1" dirty="0">
+                <a:solidFill>
+                  <a:srgbClr val="1F9D68"/>
                 </a:solidFill>
                 <a:latin typeface="Courier New" pitchFamily="34" charset="0"/>
                 <a:ea typeface="Courier New" pitchFamily="34" charset="-122"/>
                 <a:cs typeface="Courier New" pitchFamily="34" charset="-120"/>
               </a:rPr>
-              <a:t>GPS</a:t>
-            </a:r>
-            <a:endParaRPr lang="en-US" sz="1050" dirty="0"/>
-          </a:p>
-        </p:txBody>
-      </p:sp>
-      <p:sp>
-        <p:nvSpPr>
-          <p:cNvPr id="19" name="Text 16"/>
-          <p:cNvSpPr txBox="1"/>
-          <p:nvPr/>
-        </p:nvSpPr>
-        <p:spPr>
-          <a:xfrm>
-            <a:off x="4425696" y="3483864"/>
-            <a:ext cx="3419856" cy="1060704"/>
+              <a:t>PROVEN</a:t>
+            </a:r>
+            <a:endParaRPr lang="en-US" sz="950" dirty="0"/>
+          </a:p>
+        </p:txBody>
+      </p:sp>
+      <p:sp>
+        <p:nvSpPr>
+          <p:cNvPr id="18" name="Text 16"/>
+          <p:cNvSpPr txBox="1"/>
+          <p:nvPr/>
+        </p:nvSpPr>
+        <p:spPr>
+          <a:xfrm>
+            <a:off x="4526280" y="2432304"/>
+            <a:ext cx="1645920" cy="384048"/>
           </a:xfrm>
           <a:prstGeom prst="rect">
             <a:avLst/>
@@ -5200,30 +5390,54 @@
               <a:buNone/>
             </a:pPr>
             <a:r>
-              <a:rPr lang="en-US" sz="950" dirty="0">
-                <a:solidFill>
-                  <a:srgbClr val="222A3F"/>
-                </a:solidFill>
-                <a:latin typeface="Arial" pitchFamily="34" charset="0"/>
-                <a:ea typeface="Arial" pitchFamily="34" charset="-122"/>
-                <a:cs typeface="Arial" pitchFamily="34" charset="-120"/>
-              </a:rPr>
-              <a:t>Needs sky view: a windshield works, a desk does not. Cold start takes minutes. Indoor multipath fakes small phantom speeds, which the deadband removes. Fix rate must match broadcast rate.</a:t>
-            </a:r>
-            <a:endParaRPr lang="en-US" sz="950" dirty="0"/>
-          </a:p>
-        </p:txBody>
-      </p:sp>
-      <p:sp>
-        <p:nvSpPr>
-          <p:cNvPr id="20" name="Shape 17"/>
+              <a:rPr lang="en-US" sz="800" dirty="0">
+                <a:solidFill>
+                  <a:srgbClr val="5E6B85"/>
+                </a:solidFill>
+                <a:latin typeface="Courier New" pitchFamily="34" charset="0"/>
+                <a:ea typeface="Courier New" pitchFamily="34" charset="-122"/>
+                <a:cs typeface="Courier New" pitchFamily="34" charset="-120"/>
+              </a:rPr>
+              <a:t>"radio link: connected"</a:t>
+            </a:r>
+            <a:endParaRPr lang="en-US" sz="800" dirty="0"/>
+          </a:p>
+        </p:txBody>
+      </p:sp>
+      <p:sp>
+        <p:nvSpPr>
+          <p:cNvPr id="19" name="Shape 17"/>
           <p:cNvSpPr/>
           <p:nvPr/>
         </p:nvSpPr>
         <p:spPr>
           <a:xfrm>
-            <a:off x="8138160" y="3154680"/>
-            <a:ext cx="3657600" cy="1426464"/>
+            <a:off x="1051560" y="2871216"/>
+            <a:ext cx="0" cy="164592"/>
+          </a:xfrm>
+          <a:prstGeom prst="line">
+            <a:avLst/>
+          </a:prstGeom>
+          <a:noFill/>
+          <a:ln w="28575">
+            <a:solidFill>
+              <a:srgbClr val="D9488C"/>
+            </a:solidFill>
+            <a:prstDash val="solid"/>
+            <a:tailEnd type="triangle"/>
+          </a:ln>
+        </p:spPr>
+      </p:sp>
+      <p:sp>
+        <p:nvSpPr>
+          <p:cNvPr id="20" name="Shape 18"/>
+          <p:cNvSpPr/>
+          <p:nvPr/>
+        </p:nvSpPr>
+        <p:spPr>
+          <a:xfrm>
+            <a:off x="457200" y="3035808"/>
+            <a:ext cx="5760720" cy="804672"/>
           </a:xfrm>
           <a:prstGeom prst="rect">
             <a:avLst/>
@@ -5241,14 +5455,14 @@
       </p:sp>
       <p:sp>
         <p:nvSpPr>
-          <p:cNvPr id="21" name="Text 18"/>
-          <p:cNvSpPr txBox="1"/>
-          <p:nvPr/>
-        </p:nvSpPr>
-        <p:spPr>
-          <a:xfrm>
-            <a:off x="8266176" y="3218688"/>
-            <a:ext cx="3383280" cy="237744"/>
+          <p:cNvPr id="21" name="Text 19"/>
+          <p:cNvSpPr txBox="1"/>
+          <p:nvPr/>
+        </p:nvSpPr>
+        <p:spPr>
+          <a:xfrm>
+            <a:off x="594360" y="3090672"/>
+            <a:ext cx="3840480" cy="713232"/>
           </a:xfrm>
           <a:prstGeom prst="rect">
             <a:avLst/>
@@ -5264,30 +5478,86 @@
               <a:buNone/>
             </a:pPr>
             <a:r>
-              <a:rPr lang="en-US" sz="1050" b="1" dirty="0">
-                <a:solidFill>
-                  <a:srgbClr val="D9488C"/>
+              <a:rPr lang="en-US" sz="1150" b="1" dirty="0">
+                <a:solidFill>
+                  <a:srgbClr val="16213D"/>
+                </a:solidFill>
+                <a:latin typeface="Arial" pitchFamily="34" charset="0"/>
+                <a:ea typeface="Arial" pitchFamily="34" charset="-122"/>
+                <a:cs typeface="Arial" pitchFamily="34" charset="-120"/>
+              </a:rPr>
+              <a:t>Decode to TrackerState</a:t>
+            </a:r>
+            <a:endParaRPr lang="en-US" sz="1150" dirty="0"/>
+          </a:p>
+          <a:p>
+            <a:pPr indent="0" marL="0">
+              <a:buNone/>
+            </a:pPr>
+            <a:r>
+              <a:rPr lang="en-US" sz="950" dirty="0">
+                <a:solidFill>
+                  <a:srgbClr val="5E6B85"/>
+                </a:solidFill>
+                <a:latin typeface="Arial" pitchFamily="34" charset="0"/>
+                <a:ea typeface="Arial" pitchFamily="34" charset="-122"/>
+                <a:cs typeface="Arial" pitchFamily="34" charset="-120"/>
+              </a:rPr>
+              <a:t>protobuf frames become live coordinates</a:t>
+            </a:r>
+            <a:endParaRPr lang="en-US" sz="1150" dirty="0"/>
+          </a:p>
+        </p:txBody>
+      </p:sp>
+      <p:sp>
+        <p:nvSpPr>
+          <p:cNvPr id="22" name="Text 20"/>
+          <p:cNvSpPr txBox="1"/>
+          <p:nvPr/>
+        </p:nvSpPr>
+        <p:spPr>
+          <a:xfrm>
+            <a:off x="4526280" y="3108960"/>
+            <a:ext cx="868680" cy="274320"/>
+          </a:xfrm>
+          <a:prstGeom prst="rect">
+            <a:avLst/>
+          </a:prstGeom>
+          <a:noFill/>
+          <a:ln/>
+        </p:spPr>
+        <p:txBody>
+          <a:bodyPr wrap="square" lIns="0" tIns="0" rIns="0" bIns="0" rtlCol="0" anchor="ctr"/>
+          <a:lstStyle/>
+          <a:p>
+            <a:pPr algn="ctr" indent="0" marL="0">
+              <a:buNone/>
+            </a:pPr>
+            <a:r>
+              <a:rPr lang="en-US" sz="950" b="1" dirty="0">
+                <a:solidFill>
+                  <a:srgbClr val="1F9D68"/>
                 </a:solidFill>
                 <a:latin typeface="Courier New" pitchFamily="34" charset="0"/>
                 <a:ea typeface="Courier New" pitchFamily="34" charset="-122"/>
                 <a:cs typeface="Courier New" pitchFamily="34" charset="-120"/>
               </a:rPr>
-              <a:t>BLE LINK</a:t>
-            </a:r>
-            <a:endParaRPr lang="en-US" sz="1050" dirty="0"/>
-          </a:p>
-        </p:txBody>
-      </p:sp>
-      <p:sp>
-        <p:nvSpPr>
-          <p:cNvPr id="22" name="Text 19"/>
-          <p:cNvSpPr txBox="1"/>
-          <p:nvPr/>
-        </p:nvSpPr>
-        <p:spPr>
-          <a:xfrm>
-            <a:off x="8266176" y="3483864"/>
-            <a:ext cx="3419856" cy="1060704"/>
+              <a:t>PROVEN</a:t>
+            </a:r>
+            <a:endParaRPr lang="en-US" sz="950" dirty="0"/>
+          </a:p>
+        </p:txBody>
+      </p:sp>
+      <p:sp>
+        <p:nvSpPr>
+          <p:cNvPr id="23" name="Text 21"/>
+          <p:cNvSpPr txBox="1"/>
+          <p:nvPr/>
+        </p:nvSpPr>
+        <p:spPr>
+          <a:xfrm>
+            <a:off x="4526280" y="3401568"/>
+            <a:ext cx="1645920" cy="384048"/>
           </a:xfrm>
           <a:prstGeom prst="rect">
             <a:avLst/>
@@ -5303,30 +5573,54 @@
               <a:buNone/>
             </a:pPr>
             <a:r>
-              <a:rPr lang="en-US" sz="950" dirty="0">
-                <a:solidFill>
-                  <a:srgbClr val="222A3F"/>
-                </a:solidFill>
-                <a:latin typeface="Arial" pitchFamily="34" charset="0"/>
-                <a:ea typeface="Arial" pitchFamily="34" charset="-122"/>
-                <a:cs typeface="Arial" pitchFamily="34" charset="-120"/>
-              </a:rPr>
-              <a:t>The radio advertises only from boot until its first disconnect, so both units power up together. Exactly one client at a time: a phone app or USB session will take or mute the link.</a:t>
-            </a:r>
-            <a:endParaRPr lang="en-US" sz="950" dirty="0"/>
-          </a:p>
-        </p:txBody>
-      </p:sp>
-      <p:sp>
-        <p:nvSpPr>
-          <p:cNvPr id="23" name="Shape 20"/>
+              <a:rPr lang="en-US" sz="800" dirty="0">
+                <a:solidFill>
+                  <a:srgbClr val="5E6B85"/>
+                </a:solidFill>
+                <a:latin typeface="Courier New" pitchFamily="34" charset="0"/>
+                <a:ea typeface="Courier New" pitchFamily="34" charset="-122"/>
+                <a:cs typeface="Courier New" pitchFamily="34" charset="-120"/>
+              </a:rPr>
+              <a:t>"ME 33.60719 -101.89643"</a:t>
+            </a:r>
+            <a:endParaRPr lang="en-US" sz="800" dirty="0"/>
+          </a:p>
+        </p:txBody>
+      </p:sp>
+      <p:sp>
+        <p:nvSpPr>
+          <p:cNvPr id="24" name="Shape 22"/>
           <p:cNvSpPr/>
           <p:nvPr/>
         </p:nvSpPr>
         <p:spPr>
           <a:xfrm>
-            <a:off x="457200" y="4690872"/>
-            <a:ext cx="3657600" cy="1426464"/>
+            <a:off x="1051560" y="3840480"/>
+            <a:ext cx="0" cy="164592"/>
+          </a:xfrm>
+          <a:prstGeom prst="line">
+            <a:avLst/>
+          </a:prstGeom>
+          <a:noFill/>
+          <a:ln w="28575">
+            <a:solidFill>
+              <a:srgbClr val="D9488C"/>
+            </a:solidFill>
+            <a:prstDash val="solid"/>
+            <a:tailEnd type="triangle"/>
+          </a:ln>
+        </p:spPr>
+      </p:sp>
+      <p:sp>
+        <p:nvSpPr>
+          <p:cNvPr id="25" name="Shape 23"/>
+          <p:cNvSpPr/>
+          <p:nvPr/>
+        </p:nvSpPr>
+        <p:spPr>
+          <a:xfrm>
+            <a:off x="457200" y="4005072"/>
+            <a:ext cx="5760720" cy="804672"/>
           </a:xfrm>
           <a:prstGeom prst="rect">
             <a:avLst/>
@@ -5344,14 +5638,14 @@
       </p:sp>
       <p:sp>
         <p:nvSpPr>
-          <p:cNvPr id="24" name="Text 21"/>
-          <p:cNvSpPr txBox="1"/>
-          <p:nvPr/>
-        </p:nvSpPr>
-        <p:spPr>
-          <a:xfrm>
-            <a:off x="585216" y="4754880"/>
-            <a:ext cx="3383280" cy="237744"/>
+          <p:cNvPr id="26" name="Text 24"/>
+          <p:cNvSpPr txBox="1"/>
+          <p:nvPr/>
+        </p:nvSpPr>
+        <p:spPr>
+          <a:xfrm>
+            <a:off x="594360" y="4059936"/>
+            <a:ext cx="3840480" cy="713232"/>
           </a:xfrm>
           <a:prstGeom prst="rect">
             <a:avLst/>
@@ -5367,30 +5661,86 @@
               <a:buNone/>
             </a:pPr>
             <a:r>
-              <a:rPr lang="en-US" sz="1050" b="1" dirty="0">
-                <a:solidFill>
-                  <a:srgbClr val="D9488C"/>
+              <a:rPr lang="en-US" sz="1150" b="1" dirty="0">
+                <a:solidFill>
+                  <a:srgbClr val="16213D"/>
+                </a:solidFill>
+                <a:latin typeface="Arial" pitchFamily="34" charset="0"/>
+                <a:ea typeface="Arial" pitchFamily="34" charset="-122"/>
+                <a:cs typeface="Arial" pitchFamily="34" charset="-120"/>
+              </a:rPr>
+              <a:t>Navigation and UI</a:t>
+            </a:r>
+            <a:endParaRPr lang="en-US" sz="1150" dirty="0"/>
+          </a:p>
+          <a:p>
+            <a:pPr indent="0" marL="0">
+              <a:buNone/>
+            </a:pPr>
+            <a:r>
+              <a:rPr lang="en-US" sz="950" dirty="0">
+                <a:solidFill>
+                  <a:srgbClr val="5E6B85"/>
+                </a:solidFill>
+                <a:latin typeface="Arial" pitchFamily="34" charset="0"/>
+                <a:ea typeface="Arial" pitchFamily="34" charset="-122"/>
+                <a:cs typeface="Arial" pitchFamily="34" charset="-120"/>
+              </a:rPr>
+              <a:t>state-driven pages, honest ages, local clock</a:t>
+            </a:r>
+            <a:endParaRPr lang="en-US" sz="1150" dirty="0"/>
+          </a:p>
+        </p:txBody>
+      </p:sp>
+      <p:sp>
+        <p:nvSpPr>
+          <p:cNvPr id="27" name="Text 25"/>
+          <p:cNvSpPr txBox="1"/>
+          <p:nvPr/>
+        </p:nvSpPr>
+        <p:spPr>
+          <a:xfrm>
+            <a:off x="4526280" y="4078224"/>
+            <a:ext cx="868680" cy="274320"/>
+          </a:xfrm>
+          <a:prstGeom prst="rect">
+            <a:avLst/>
+          </a:prstGeom>
+          <a:noFill/>
+          <a:ln/>
+        </p:spPr>
+        <p:txBody>
+          <a:bodyPr wrap="square" lIns="0" tIns="0" rIns="0" bIns="0" rtlCol="0" anchor="ctr"/>
+          <a:lstStyle/>
+          <a:p>
+            <a:pPr algn="ctr" indent="0" marL="0">
+              <a:buNone/>
+            </a:pPr>
+            <a:r>
+              <a:rPr lang="en-US" sz="950" b="1" dirty="0">
+                <a:solidFill>
+                  <a:srgbClr val="1F9D68"/>
                 </a:solidFill>
                 <a:latin typeface="Courier New" pitchFamily="34" charset="0"/>
                 <a:ea typeface="Courier New" pitchFamily="34" charset="-122"/>
                 <a:cs typeface="Courier New" pitchFamily="34" charset="-120"/>
               </a:rPr>
-              <a:t>DISPLAY</a:t>
-            </a:r>
-            <a:endParaRPr lang="en-US" sz="1050" dirty="0"/>
-          </a:p>
-        </p:txBody>
-      </p:sp>
-      <p:sp>
-        <p:nvSpPr>
-          <p:cNvPr id="25" name="Text 22"/>
-          <p:cNvSpPr txBox="1"/>
-          <p:nvPr/>
-        </p:nvSpPr>
-        <p:spPr>
-          <a:xfrm>
-            <a:off x="585216" y="5020056"/>
-            <a:ext cx="3419856" cy="1060704"/>
+              <a:t>PROVEN</a:t>
+            </a:r>
+            <a:endParaRPr lang="en-US" sz="950" dirty="0"/>
+          </a:p>
+        </p:txBody>
+      </p:sp>
+      <p:sp>
+        <p:nvSpPr>
+          <p:cNvPr id="28" name="Text 26"/>
+          <p:cNvSpPr txBox="1"/>
+          <p:nvPr/>
+        </p:nvSpPr>
+        <p:spPr>
+          <a:xfrm>
+            <a:off x="4526280" y="4370832"/>
+            <a:ext cx="1645920" cy="384048"/>
           </a:xfrm>
           <a:prstGeom prst="rect">
             <a:avLst/>
@@ -5406,55 +5756,79 @@
               <a:buNone/>
             </a:pPr>
             <a:r>
-              <a:rPr lang="en-US" sz="950" dirty="0">
-                <a:solidFill>
-                  <a:srgbClr val="222A3F"/>
-                </a:solidFill>
-                <a:latin typeface="Arial" pitchFamily="34" charset="0"/>
-                <a:ea typeface="Arial" pitchFamily="34" charset="-122"/>
-                <a:cs typeface="Arial" pitchFamily="34" charset="-120"/>
-              </a:rPr>
-              <a:t>A one-bit reflective panel has no grayscale and needs ambient light at night; edge lighting is planned. The redraw budget is two full frames per second.</a:t>
-            </a:r>
-            <a:endParaRPr lang="en-US" sz="950" dirty="0"/>
-          </a:p>
-        </p:txBody>
-      </p:sp>
-      <p:sp>
-        <p:nvSpPr>
-          <p:cNvPr id="26" name="Shape 23"/>
+              <a:rPr lang="en-US" sz="800" dirty="0">
+                <a:solidFill>
+                  <a:srgbClr val="5E6B85"/>
+                </a:solidFill>
+                <a:latin typeface="Courier New" pitchFamily="34" charset="0"/>
+                <a:ea typeface="Courier New" pitchFamily="34" charset="-122"/>
+                <a:cs typeface="Courier New" pitchFamily="34" charset="-120"/>
+              </a:rPr>
+              <a:t>"6:59a CDT, age 55 s"</a:t>
+            </a:r>
+            <a:endParaRPr lang="en-US" sz="800" dirty="0"/>
+          </a:p>
+        </p:txBody>
+      </p:sp>
+      <p:sp>
+        <p:nvSpPr>
+          <p:cNvPr id="29" name="Shape 27"/>
           <p:cNvSpPr/>
           <p:nvPr/>
         </p:nvSpPr>
         <p:spPr>
           <a:xfrm>
-            <a:off x="4297680" y="4690872"/>
-            <a:ext cx="3657600" cy="1426464"/>
-          </a:xfrm>
-          <a:prstGeom prst="rect">
-            <a:avLst/>
-          </a:prstGeom>
-          <a:solidFill>
-            <a:srgbClr val="F2F5FA"/>
-          </a:solidFill>
-          <a:ln w="15875">
+            <a:off x="1051560" y="4809744"/>
+            <a:ext cx="0" cy="164592"/>
+          </a:xfrm>
+          <a:prstGeom prst="line">
+            <a:avLst/>
+          </a:prstGeom>
+          <a:noFill/>
+          <a:ln w="28575">
             <a:solidFill>
               <a:srgbClr val="D9488C"/>
             </a:solidFill>
             <a:prstDash val="solid"/>
+            <a:tailEnd type="triangle"/>
           </a:ln>
         </p:spPr>
       </p:sp>
       <p:sp>
         <p:nvSpPr>
-          <p:cNvPr id="27" name="Text 24"/>
-          <p:cNvSpPr txBox="1"/>
-          <p:nvPr/>
-        </p:nvSpPr>
-        <p:spPr>
-          <a:xfrm>
-            <a:off x="4425696" y="4754880"/>
-            <a:ext cx="3383280" cy="237744"/>
+          <p:cNvPr id="30" name="Shape 28"/>
+          <p:cNvSpPr/>
+          <p:nvPr/>
+        </p:nvSpPr>
+        <p:spPr>
+          <a:xfrm>
+            <a:off x="457200" y="4974336"/>
+            <a:ext cx="5760720" cy="804672"/>
+          </a:xfrm>
+          <a:prstGeom prst="rect">
+            <a:avLst/>
+          </a:prstGeom>
+          <a:solidFill>
+            <a:srgbClr val="FFFFFF"/>
+          </a:solidFill>
+          <a:ln w="15875">
+            <a:solidFill>
+              <a:srgbClr val="E58E1A"/>
+            </a:solidFill>
+            <a:prstDash val="dash"/>
+          </a:ln>
+        </p:spPr>
+      </p:sp>
+      <p:sp>
+        <p:nvSpPr>
+          <p:cNvPr id="31" name="Text 29"/>
+          <p:cNvSpPr txBox="1"/>
+          <p:nvPr/>
+        </p:nvSpPr>
+        <p:spPr>
+          <a:xfrm>
+            <a:off x="594360" y="5029200"/>
+            <a:ext cx="3840480" cy="713232"/>
           </a:xfrm>
           <a:prstGeom prst="rect">
             <a:avLst/>
@@ -5470,30 +5844,86 @@
               <a:buNone/>
             </a:pPr>
             <a:r>
-              <a:rPr lang="en-US" sz="1050" b="1" dirty="0">
-                <a:solidFill>
-                  <a:srgbClr val="D9488C"/>
+              <a:rPr lang="en-US" sz="1150" b="1" dirty="0">
+                <a:solidFill>
+                  <a:srgbClr val="16213D"/>
+                </a:solidFill>
+                <a:latin typeface="Arial" pitchFamily="34" charset="0"/>
+                <a:ea typeface="Arial" pitchFamily="34" charset="-122"/>
+                <a:cs typeface="Arial" pitchFamily="34" charset="-120"/>
+              </a:rPr>
+              <a:t>Partner over LoRa</a:t>
+            </a:r>
+            <a:endParaRPr lang="en-US" sz="1150" dirty="0"/>
+          </a:p>
+          <a:p>
+            <a:pPr indent="0" marL="0">
+              <a:buNone/>
+            </a:pPr>
+            <a:r>
+              <a:rPr lang="en-US" sz="950" dirty="0">
+                <a:solidFill>
+                  <a:srgbClr val="5E6B85"/>
+                </a:solidFill>
+                <a:latin typeface="Arial" pitchFamily="34" charset="0"/>
+                <a:ea typeface="Arial" pitchFamily="34" charset="-122"/>
+                <a:cs typeface="Arial" pitchFamily="34" charset="-120"/>
+              </a:rPr>
+              <a:t>second radio joins the encrypted channel</a:t>
+            </a:r>
+            <a:endParaRPr lang="en-US" sz="1150" dirty="0"/>
+          </a:p>
+        </p:txBody>
+      </p:sp>
+      <p:sp>
+        <p:nvSpPr>
+          <p:cNvPr id="32" name="Text 30"/>
+          <p:cNvSpPr txBox="1"/>
+          <p:nvPr/>
+        </p:nvSpPr>
+        <p:spPr>
+          <a:xfrm>
+            <a:off x="4526280" y="5047488"/>
+            <a:ext cx="868680" cy="274320"/>
+          </a:xfrm>
+          <a:prstGeom prst="rect">
+            <a:avLst/>
+          </a:prstGeom>
+          <a:noFill/>
+          <a:ln/>
+        </p:spPr>
+        <p:txBody>
+          <a:bodyPr wrap="square" lIns="0" tIns="0" rIns="0" bIns="0" rtlCol="0" anchor="ctr"/>
+          <a:lstStyle/>
+          <a:p>
+            <a:pPr algn="ctr" indent="0" marL="0">
+              <a:buNone/>
+            </a:pPr>
+            <a:r>
+              <a:rPr lang="en-US" sz="950" b="1" dirty="0">
+                <a:solidFill>
+                  <a:srgbClr val="B06207"/>
                 </a:solidFill>
                 <a:latin typeface="Courier New" pitchFamily="34" charset="0"/>
                 <a:ea typeface="Courier New" pitchFamily="34" charset="-122"/>
                 <a:cs typeface="Courier New" pitchFamily="34" charset="-120"/>
               </a:rPr>
-              <a:t>POWER</a:t>
-            </a:r>
-            <a:endParaRPr lang="en-US" sz="1050" dirty="0"/>
-          </a:p>
-        </p:txBody>
-      </p:sp>
-      <p:sp>
-        <p:nvSpPr>
-          <p:cNvPr id="28" name="Text 25"/>
-          <p:cNvSpPr txBox="1"/>
-          <p:nvPr/>
-        </p:nvSpPr>
-        <p:spPr>
-          <a:xfrm>
-            <a:off x="4425696" y="5020056"/>
-            <a:ext cx="3419856" cy="1060704"/>
+              <a:t>NEXT</a:t>
+            </a:r>
+            <a:endParaRPr lang="en-US" sz="950" dirty="0"/>
+          </a:p>
+        </p:txBody>
+      </p:sp>
+      <p:sp>
+        <p:nvSpPr>
+          <p:cNvPr id="33" name="Text 31"/>
+          <p:cNvSpPr txBox="1"/>
+          <p:nvPr/>
+        </p:nvSpPr>
+        <p:spPr>
+          <a:xfrm>
+            <a:off x="4526280" y="5340096"/>
+            <a:ext cx="1645920" cy="384048"/>
           </a:xfrm>
           <a:prstGeom prst="rect">
             <a:avLst/>
@@ -5509,110 +5939,284 @@
               <a:buNone/>
             </a:pPr>
             <a:r>
+              <a:rPr lang="en-US" sz="800" dirty="0">
+                <a:solidFill>
+                  <a:srgbClr val="5E6B85"/>
+                </a:solidFill>
+                <a:latin typeface="Courier New" pitchFamily="34" charset="0"/>
+                <a:ea typeface="Courier New" pitchFamily="34" charset="-122"/>
+                <a:cs typeface="Courier New" pitchFamily="34" charset="-120"/>
+              </a:rPr>
+              <a:t>"PTR no partner heard yet"</a:t>
+            </a:r>
+            <a:endParaRPr lang="en-US" sz="800" dirty="0"/>
+          </a:p>
+        </p:txBody>
+      </p:sp>
+      <p:pic>
+        <p:nvPicPr>
+          <p:cNvPr id="34" name="Image 0" descr="C:/Users/deogr/AppData/Local/Temp/claude/C--Users-deogr-Documents-Fall-Project-Off-Grid-Vehicle-dection-project/e8b2e8fa-1513-4aa8-a8f6-ce4fcd20e664/scratchpad/deck3/p_search.jpg">    </p:cNvPr>
+          <p:cNvPicPr>
+            <a:picLocks noChangeAspect="1"/>
+          </p:cNvPicPr>
+          <p:nvPr/>
+        </p:nvPicPr>
+        <p:blipFill>
+          <a:blip r:embed="rId1"/>
+          <a:stretch>
+            <a:fillRect/>
+          </a:stretch>
+        </p:blipFill>
+        <p:spPr>
+          <a:xfrm>
+            <a:off x="6537960" y="1097280"/>
+            <a:ext cx="2468880" cy="1938528"/>
+          </a:xfrm>
+          <a:prstGeom prst="rect">
+            <a:avLst/>
+          </a:prstGeom>
+        </p:spPr>
+      </p:pic>
+      <p:sp>
+        <p:nvSpPr>
+          <p:cNvPr id="35" name="Shape 32"/>
+          <p:cNvSpPr/>
+          <p:nvPr/>
+        </p:nvSpPr>
+        <p:spPr>
+          <a:xfrm>
+            <a:off x="6537960" y="1097280"/>
+            <a:ext cx="2468880" cy="1938528"/>
+          </a:xfrm>
+          <a:prstGeom prst="rect">
+            <a:avLst/>
+          </a:prstGeom>
+          <a:ln w="12700">
+            <a:solidFill>
+              <a:srgbClr val="9AA7BE"/>
+            </a:solidFill>
+            <a:prstDash val="solid"/>
+          </a:ln>
+        </p:spPr>
+      </p:sp>
+      <p:sp>
+        <p:nvSpPr>
+          <p:cNvPr id="36" name="Text 33"/>
+          <p:cNvSpPr txBox="1"/>
+          <p:nvPr/>
+        </p:nvSpPr>
+        <p:spPr>
+          <a:xfrm>
+            <a:off x="6537960" y="3063240"/>
+            <a:ext cx="2468880" cy="274320"/>
+          </a:xfrm>
+          <a:prstGeom prst="rect">
+            <a:avLst/>
+          </a:prstGeom>
+          <a:noFill/>
+          <a:ln/>
+        </p:spPr>
+        <p:txBody>
+          <a:bodyPr wrap="square" lIns="0" tIns="0" rIns="0" bIns="0" rtlCol="0" anchor="ctr"/>
+          <a:lstStyle/>
+          <a:p>
+            <a:pPr algn="ctr" indent="0" marL="0">
+              <a:buNone/>
+            </a:pPr>
+            <a:r>
               <a:rPr lang="en-US" sz="950" dirty="0">
                 <a:solidFill>
-                  <a:srgbClr val="222A3F"/>
+                  <a:srgbClr val="5E6B85"/>
+                </a:solidFill>
+                <a:latin typeface="Courier New" pitchFamily="34" charset="0"/>
+                <a:ea typeface="Courier New" pitchFamily="34" charset="-122"/>
+                <a:cs typeface="Courier New" pitchFamily="34" charset="-120"/>
+              </a:rPr>
+              <a:t>Boot state: link and GPS proven before any partner exists</a:t>
+            </a:r>
+            <a:endParaRPr lang="en-US" sz="950" dirty="0"/>
+          </a:p>
+        </p:txBody>
+      </p:sp>
+      <p:pic>
+        <p:nvPicPr>
+          <p:cNvPr id="37" name="Image 1" descr="C:/Users/deogr/AppData/Local/Temp/claude/C--Users-deogr-Documents-Fall-Project-Off-Grid-Vehicle-dection-project/e8b2e8fa-1513-4aa8-a8f6-ce4fcd20e664/scratchpad/deck3/p_overall.jpg">    </p:cNvPr>
+          <p:cNvPicPr>
+            <a:picLocks noChangeAspect="1"/>
+          </p:cNvPicPr>
+          <p:nvPr/>
+        </p:nvPicPr>
+        <p:blipFill>
+          <a:blip r:embed="rId2"/>
+          <a:stretch>
+            <a:fillRect/>
+          </a:stretch>
+        </p:blipFill>
+        <p:spPr>
+          <a:xfrm>
+            <a:off x="9189720" y="1097280"/>
+            <a:ext cx="2560320" cy="1847088"/>
+          </a:xfrm>
+          <a:prstGeom prst="rect">
+            <a:avLst/>
+          </a:prstGeom>
+        </p:spPr>
+      </p:pic>
+      <p:sp>
+        <p:nvSpPr>
+          <p:cNvPr id="38" name="Shape 34"/>
+          <p:cNvSpPr/>
+          <p:nvPr/>
+        </p:nvSpPr>
+        <p:spPr>
+          <a:xfrm>
+            <a:off x="9189720" y="1097280"/>
+            <a:ext cx="2560320" cy="1847088"/>
+          </a:xfrm>
+          <a:prstGeom prst="rect">
+            <a:avLst/>
+          </a:prstGeom>
+          <a:ln w="12700">
+            <a:solidFill>
+              <a:srgbClr val="9AA7BE"/>
+            </a:solidFill>
+            <a:prstDash val="solid"/>
+          </a:ln>
+        </p:spPr>
+      </p:sp>
+      <p:sp>
+        <p:nvSpPr>
+          <p:cNvPr id="39" name="Text 35"/>
+          <p:cNvSpPr txBox="1"/>
+          <p:nvPr/>
+        </p:nvSpPr>
+        <p:spPr>
+          <a:xfrm>
+            <a:off x="9189720" y="2971800"/>
+            <a:ext cx="2560320" cy="274320"/>
+          </a:xfrm>
+          <a:prstGeom prst="rect">
+            <a:avLst/>
+          </a:prstGeom>
+          <a:noFill/>
+          <a:ln/>
+        </p:spPr>
+        <p:txBody>
+          <a:bodyPr wrap="square" lIns="0" tIns="0" rIns="0" bIns="0" rtlCol="0" anchor="ctr"/>
+          <a:lstStyle/>
+          <a:p>
+            <a:pPr algn="ctr" indent="0" marL="0">
+              <a:buNone/>
+            </a:pPr>
+            <a:r>
+              <a:rPr lang="en-US" sz="950" dirty="0">
+                <a:solidFill>
+                  <a:srgbClr val="5E6B85"/>
+                </a:solidFill>
+                <a:latin typeface="Courier New" pitchFamily="34" charset="0"/>
+                <a:ea typeface="Courier New" pitchFamily="34" charset="-122"/>
+                <a:cs typeface="Courier New" pitchFamily="34" charset="-120"/>
+              </a:rPr>
+              <a:t>Live self fix decoded end to end; the gap is labeled honestly</a:t>
+            </a:r>
+            <a:endParaRPr lang="en-US" sz="950" dirty="0"/>
+          </a:p>
+        </p:txBody>
+      </p:sp>
+      <p:sp>
+        <p:nvSpPr>
+          <p:cNvPr id="40" name="Shape 36"/>
+          <p:cNvSpPr/>
+          <p:nvPr/>
+        </p:nvSpPr>
+        <p:spPr>
+          <a:xfrm>
+            <a:off x="6537960" y="3566160"/>
+            <a:ext cx="5212080" cy="2514600"/>
+          </a:xfrm>
+          <a:prstGeom prst="rect">
+            <a:avLst/>
+          </a:prstGeom>
+          <a:solidFill>
+            <a:srgbClr val="F2F5FA"/>
+          </a:solidFill>
+          <a:ln w="9525">
+            <a:solidFill>
+              <a:srgbClr val="9AA7BE"/>
+            </a:solidFill>
+            <a:prstDash val="solid"/>
+          </a:ln>
+        </p:spPr>
+      </p:sp>
+      <p:sp>
+        <p:nvSpPr>
+          <p:cNvPr id="41" name="Text 37"/>
+          <p:cNvSpPr txBox="1"/>
+          <p:nvPr/>
+        </p:nvSpPr>
+        <p:spPr>
+          <a:xfrm>
+            <a:off x="6720840" y="3703320"/>
+            <a:ext cx="4846320" cy="274320"/>
+          </a:xfrm>
+          <a:prstGeom prst="rect">
+            <a:avLst/>
+          </a:prstGeom>
+          <a:noFill/>
+          <a:ln/>
+        </p:spPr>
+        <p:txBody>
+          <a:bodyPr wrap="square" lIns="0" tIns="0" rIns="0" bIns="0" rtlCol="0" anchor="ctr"/>
+          <a:lstStyle/>
+          <a:p>
+            <a:pPr indent="0" marL="0">
+              <a:buNone/>
+            </a:pPr>
+            <a:r>
+              <a:rPr lang="en-US" sz="1150" b="1" spc="100" kern="0" dirty="0">
+                <a:solidFill>
+                  <a:srgbClr val="16213D"/>
                 </a:solidFill>
                 <a:latin typeface="Arial" pitchFamily="34" charset="0"/>
                 <a:ea typeface="Arial" pitchFamily="34" charset="-122"/>
                 <a:cs typeface="Arial" pitchFamily="34" charset="-120"/>
               </a:rPr>
-              <a:t>Cheap 12 volt USB adapters cut off on the radio's low current draw, so every adapter gets validated. Both units must share the vehicle's power timing.</a:t>
-            </a:r>
-            <a:endParaRPr lang="en-US" sz="950" dirty="0"/>
-          </a:p>
-        </p:txBody>
-      </p:sp>
-      <p:sp>
-        <p:nvSpPr>
-          <p:cNvPr id="29" name="Shape 26"/>
-          <p:cNvSpPr/>
-          <p:nvPr/>
-        </p:nvSpPr>
-        <p:spPr>
-          <a:xfrm>
-            <a:off x="8138160" y="4690872"/>
-            <a:ext cx="3657600" cy="1426464"/>
-          </a:xfrm>
-          <a:prstGeom prst="rect">
-            <a:avLst/>
-          </a:prstGeom>
-          <a:solidFill>
-            <a:srgbClr val="F2F5FA"/>
-          </a:solidFill>
-          <a:ln w="15875">
-            <a:solidFill>
-              <a:srgbClr val="D9488C"/>
-            </a:solidFill>
-            <a:prstDash val="solid"/>
-          </a:ln>
-        </p:spPr>
-      </p:sp>
-      <p:sp>
-        <p:nvSpPr>
-          <p:cNvPr id="30" name="Text 27"/>
-          <p:cNvSpPr txBox="1"/>
-          <p:nvPr/>
-        </p:nvSpPr>
-        <p:spPr>
-          <a:xfrm>
-            <a:off x="8266176" y="4754880"/>
-            <a:ext cx="3383280" cy="237744"/>
-          </a:xfrm>
-          <a:prstGeom prst="rect">
-            <a:avLst/>
-          </a:prstGeom>
-          <a:noFill/>
-          <a:ln/>
-        </p:spPr>
-        <p:txBody>
-          <a:bodyPr wrap="square" lIns="0" tIns="0" rIns="0" bIns="0" rtlCol="0" anchor="ctr"/>
-          <a:lstStyle/>
-          <a:p>
-            <a:pPr indent="0" marL="0">
-              <a:buNone/>
-            </a:pPr>
-            <a:r>
-              <a:rPr lang="en-US" sz="1050" b="1" dirty="0">
-                <a:solidFill>
-                  <a:srgbClr val="D9488C"/>
-                </a:solidFill>
-                <a:latin typeface="Courier New" pitchFamily="34" charset="0"/>
-                <a:ea typeface="Courier New" pitchFamily="34" charset="-122"/>
-                <a:cs typeface="Courier New" pitchFamily="34" charset="-120"/>
-              </a:rPr>
-              <a:t>PROVISIONING</a:t>
-            </a:r>
-            <a:endParaRPr lang="en-US" sz="1050" dirty="0"/>
-          </a:p>
-        </p:txBody>
-      </p:sp>
-      <p:sp>
-        <p:nvSpPr>
-          <p:cNvPr id="31" name="Text 28"/>
-          <p:cNvSpPr txBox="1"/>
-          <p:nvPr/>
-        </p:nvSpPr>
-        <p:spPr>
-          <a:xfrm>
-            <a:off x="8266176" y="5020056"/>
-            <a:ext cx="3419856" cy="1060704"/>
-          </a:xfrm>
-          <a:prstGeom prst="rect">
-            <a:avLst/>
-          </a:prstGeom>
-          <a:noFill/>
-          <a:ln/>
-        </p:spPr>
-        <p:txBody>
-          <a:bodyPr wrap="square" lIns="0" tIns="0" rIns="0" bIns="0" rtlCol="0" anchor="ctr"/>
-          <a:lstStyle/>
-          <a:p>
-            <a:pPr indent="0" marL="0">
-              <a:buNone/>
-            </a:pPr>
-            <a:r>
-              <a:rPr lang="en-US" sz="950" dirty="0">
+              <a:t>THE ONE-DEVICE TEST STRATEGY</a:t>
+            </a:r>
+            <a:endParaRPr lang="en-US" sz="1150" dirty="0"/>
+          </a:p>
+        </p:txBody>
+      </p:sp>
+      <p:sp>
+        <p:nvSpPr>
+          <p:cNvPr id="42" name="Text 38"/>
+          <p:cNvSpPr txBox="1"/>
+          <p:nvPr/>
+        </p:nvSpPr>
+        <p:spPr>
+          <a:xfrm>
+            <a:off x="6720840" y="4023360"/>
+            <a:ext cx="4892040" cy="2011680"/>
+          </a:xfrm>
+          <a:prstGeom prst="rect">
+            <a:avLst/>
+          </a:prstGeom>
+          <a:noFill/>
+          <a:ln/>
+        </p:spPr>
+        <p:txBody>
+          <a:bodyPr wrap="square" lIns="0" tIns="0" rIns="0" bIns="0" rtlCol="0" anchor="ctr"/>
+          <a:lstStyle/>
+          <a:p>
+            <a:pPr marL="342900" indent="-342900">
+              <a:spcAft>
+                <a:spcPts val="600"/>
+              </a:spcAft>
+              <a:buSzPct val="100000"/>
+              <a:buChar char="▪"/>
+            </a:pPr>
+            <a:r>
+              <a:rPr lang="en-US" sz="1050" dirty="0">
                 <a:solidFill>
                   <a:srgbClr val="222A3F"/>
                 </a:solidFill>
@@ -5620,9 +6224,48 @@
                 <a:ea typeface="Arial" pitchFamily="34" charset="-122"/>
                 <a:cs typeface="Arial" pitchFamily="34" charset="-120"/>
               </a:rPr>
-              <a:t>The channel URL carrying the encryption key must match on every radio. Node identities derive from the MAC address and survive reflashes. Every configuration write is read back and verified.</a:t>
-            </a:r>
-            <a:endParaRPr lang="en-US" sz="950" dirty="0"/>
+              <a:t>These photos are the integration milestone: backend and frontend running as one firmware on real hardware, with every layer except the last one exercised.</a:t>
+            </a:r>
+            <a:endParaRPr lang="en-US" sz="1050" dirty="0"/>
+          </a:p>
+          <a:p>
+            <a:pPr marL="342900" indent="-342900">
+              <a:spcAft>
+                <a:spcPts val="600"/>
+              </a:spcAft>
+              <a:buSzPct val="100000"/>
+              <a:buChar char="▪"/>
+            </a:pPr>
+            <a:r>
+              <a:rPr lang="en-US" sz="1050" dirty="0">
+                <a:solidFill>
+                  <a:srgbClr val="222A3F"/>
+                </a:solidFill>
+                <a:latin typeface="Arial" pitchFamily="34" charset="0"/>
+                <a:ea typeface="Arial" pitchFamily="34" charset="-122"/>
+                <a:cs typeface="Arial" pitchFamily="34" charset="-120"/>
+              </a:rPr>
+              <a:t>One device tracking itself proves four of the five layers with zero coordination cost. Every bug found here is a bug the two-vehicle test will not have to find.</a:t>
+            </a:r>
+            <a:endParaRPr lang="en-US" sz="1050" dirty="0"/>
+          </a:p>
+          <a:p>
+            <a:pPr marL="342900" indent="-342900">
+              <a:buSzPct val="100000"/>
+              <a:buChar char="▪"/>
+            </a:pPr>
+            <a:r>
+              <a:rPr lang="en-US" sz="1050" dirty="0">
+                <a:solidFill>
+                  <a:srgbClr val="222A3F"/>
+                </a:solidFill>
+                <a:latin typeface="Arial" pitchFamily="34" charset="0"/>
+                <a:ea typeface="Arial" pitchFamily="34" charset="-122"/>
+                <a:cs typeface="Arial" pitchFamily="34" charset="-120"/>
+              </a:rPr>
+              <a:t>When radio two joins the channel, the dashed layer closes and the same screens fill in with a real partner. Nothing else changes.</a:t>
+            </a:r>
+            <a:endParaRPr lang="en-US" sz="1050" dirty="0"/>
           </a:p>
         </p:txBody>
       </p:sp>
@@ -5775,7 +6418,7 @@
                 <a:ea typeface="Courier New" pitchFamily="34" charset="-122"/>
                 <a:cs typeface="Courier New" pitchFamily="34" charset="-120"/>
               </a:rPr>
-              <a:t>STATUS AND NEXT STEPS</a:t>
+              <a:t>INTEGRATION CONSTRAINTS</a:t>
             </a:r>
             <a:endParaRPr lang="en-US" sz="900" dirty="0"/>
           </a:p>
@@ -5814,7 +6457,1046 @@
                 <a:ea typeface="Courier New" pitchFamily="34" charset="-122"/>
                 <a:cs typeface="Courier New" pitchFamily="34" charset="-120"/>
               </a:rPr>
-              <a:t>SHEET 11/11  REV C  2026-09-07</a:t>
+              <a:t>SHEET 11/13  REV C  2026-09-07</a:t>
+            </a:r>
+            <a:endParaRPr lang="en-US" sz="900" dirty="0"/>
+          </a:p>
+        </p:txBody>
+      </p:sp>
+      <p:sp>
+        <p:nvSpPr>
+          <p:cNvPr id="7" name="Shape 5"/>
+          <p:cNvSpPr/>
+          <p:nvPr/>
+        </p:nvSpPr>
+        <p:spPr>
+          <a:xfrm>
+            <a:off x="9646920" y="347472"/>
+            <a:ext cx="2148840" cy="420624"/>
+          </a:xfrm>
+          <a:prstGeom prst="rect">
+            <a:avLst/>
+          </a:prstGeom>
+          <a:solidFill>
+            <a:srgbClr val="FFFFFF"/>
+          </a:solidFill>
+          <a:ln w="19050">
+            <a:solidFill>
+              <a:srgbClr val="D9488C"/>
+            </a:solidFill>
+            <a:prstDash val="solid"/>
+          </a:ln>
+        </p:spPr>
+      </p:sp>
+      <p:sp>
+        <p:nvSpPr>
+          <p:cNvPr id="8" name="Text 6"/>
+          <p:cNvSpPr txBox="1"/>
+          <p:nvPr/>
+        </p:nvSpPr>
+        <p:spPr>
+          <a:xfrm>
+            <a:off x="9646920" y="402336"/>
+            <a:ext cx="2148840" cy="310896"/>
+          </a:xfrm>
+          <a:prstGeom prst="rect">
+            <a:avLst/>
+          </a:prstGeom>
+          <a:noFill/>
+          <a:ln/>
+        </p:spPr>
+        <p:txBody>
+          <a:bodyPr wrap="square" lIns="0" tIns="0" rIns="0" bIns="0" rtlCol="0" anchor="ctr"/>
+          <a:lstStyle/>
+          <a:p>
+            <a:pPr algn="ctr" indent="0" marL="0">
+              <a:buNone/>
+            </a:pPr>
+            <a:r>
+              <a:rPr lang="en-US" sz="1100" b="1" dirty="0">
+                <a:solidFill>
+                  <a:srgbClr val="D9488C"/>
+                </a:solidFill>
+                <a:latin typeface="Courier New" pitchFamily="34" charset="0"/>
+                <a:ea typeface="Courier New" pitchFamily="34" charset="-122"/>
+                <a:cs typeface="Courier New" pitchFamily="34" charset="-120"/>
+              </a:rPr>
+              <a:t>OWNER: CANNON</a:t>
+            </a:r>
+            <a:endParaRPr lang="en-US" sz="1100" dirty="0"/>
+          </a:p>
+        </p:txBody>
+      </p:sp>
+      <p:sp>
+        <p:nvSpPr>
+          <p:cNvPr id="9" name="Text 7"/>
+          <p:cNvSpPr txBox="1"/>
+          <p:nvPr/>
+        </p:nvSpPr>
+        <p:spPr>
+          <a:xfrm>
+            <a:off x="457200" y="329184"/>
+            <a:ext cx="9052560" cy="566928"/>
+          </a:xfrm>
+          <a:prstGeom prst="rect">
+            <a:avLst/>
+          </a:prstGeom>
+          <a:noFill/>
+          <a:ln/>
+        </p:spPr>
+        <p:txBody>
+          <a:bodyPr wrap="square" lIns="0" tIns="0" rIns="0" bIns="0" rtlCol="0" anchor="ctr"/>
+          <a:lstStyle/>
+          <a:p>
+            <a:pPr indent="0" marL="0">
+              <a:buNone/>
+            </a:pPr>
+            <a:r>
+              <a:rPr lang="en-US" sz="2300" b="1" spc="200" kern="0" dirty="0">
+                <a:solidFill>
+                  <a:srgbClr val="16213D"/>
+                </a:solidFill>
+                <a:latin typeface="Arial" pitchFamily="34" charset="0"/>
+                <a:ea typeface="Arial" pitchFamily="34" charset="-122"/>
+                <a:cs typeface="Arial" pitchFamily="34" charset="-120"/>
+              </a:rPr>
+              <a:t>INTEGRATION CONSTRAINTS: THE LEDGER</a:t>
+            </a:r>
+            <a:endParaRPr lang="en-US" sz="2300" dirty="0"/>
+          </a:p>
+        </p:txBody>
+      </p:sp>
+      <p:pic>
+        <p:nvPicPr>
+          <p:cNvPr id="10" name="Image 0" descr="C:/Users/deogr/AppData/Local/Temp/claude/C--Users-deogr-Documents-Fall-Project-Off-Grid-Vehicle-dection-project/e8b2e8fa-1513-4aa8-a8f6-ce4fcd20e664/scratchpad/mermaid_png/diag1.png">    </p:cNvPr>
+          <p:cNvPicPr>
+            <a:picLocks noChangeAspect="1"/>
+          </p:cNvPicPr>
+          <p:nvPr/>
+        </p:nvPicPr>
+        <p:blipFill>
+          <a:blip r:embed="rId1"/>
+          <a:stretch>
+            <a:fillRect/>
+          </a:stretch>
+        </p:blipFill>
+        <p:spPr>
+          <a:xfrm>
+            <a:off x="457200" y="1005840"/>
+            <a:ext cx="5669280" cy="1938528"/>
+          </a:xfrm>
+          <a:prstGeom prst="rect">
+            <a:avLst/>
+          </a:prstGeom>
+        </p:spPr>
+      </p:pic>
+      <p:sp>
+        <p:nvSpPr>
+          <p:cNvPr id="11" name="Shape 8"/>
+          <p:cNvSpPr/>
+          <p:nvPr/>
+        </p:nvSpPr>
+        <p:spPr>
+          <a:xfrm>
+            <a:off x="457200" y="1005840"/>
+            <a:ext cx="5669280" cy="1938528"/>
+          </a:xfrm>
+          <a:prstGeom prst="rect">
+            <a:avLst/>
+          </a:prstGeom>
+          <a:ln w="12700">
+            <a:solidFill>
+              <a:srgbClr val="9AA7BE"/>
+            </a:solidFill>
+            <a:prstDash val="solid"/>
+          </a:ln>
+        </p:spPr>
+      </p:sp>
+      <p:sp>
+        <p:nvSpPr>
+          <p:cNvPr id="12" name="Text 9"/>
+          <p:cNvSpPr txBox="1"/>
+          <p:nvPr/>
+        </p:nvSpPr>
+        <p:spPr>
+          <a:xfrm>
+            <a:off x="6400800" y="1097280"/>
+            <a:ext cx="5257800" cy="777240"/>
+          </a:xfrm>
+          <a:prstGeom prst="rect">
+            <a:avLst/>
+          </a:prstGeom>
+          <a:noFill/>
+          <a:ln/>
+        </p:spPr>
+        <p:txBody>
+          <a:bodyPr wrap="square" lIns="0" tIns="0" rIns="0" bIns="0" rtlCol="0" anchor="ctr"/>
+          <a:lstStyle/>
+          <a:p>
+            <a:pPr indent="0" marL="0">
+              <a:buNone/>
+            </a:pPr>
+            <a:r>
+              <a:rPr lang="en-US" sz="1250" dirty="0">
+                <a:solidFill>
+                  <a:srgbClr val="222A3F"/>
+                </a:solidFill>
+                <a:latin typeface="Arial" pitchFamily="34" charset="0"/>
+                <a:ea typeface="Arial" pitchFamily="34" charset="-122"/>
+                <a:cs typeface="Arial" pitchFamily="34" charset="-120"/>
+              </a:rPr>
+              <a:t>Every constraint below was discovered on the bench or on the road, and each one shaped the design. None are theoretical.</a:t>
+            </a:r>
+            <a:endParaRPr lang="en-US" sz="1250" dirty="0"/>
+          </a:p>
+        </p:txBody>
+      </p:sp>
+      <p:sp>
+        <p:nvSpPr>
+          <p:cNvPr id="13" name="Text 10"/>
+          <p:cNvSpPr txBox="1"/>
+          <p:nvPr/>
+        </p:nvSpPr>
+        <p:spPr>
+          <a:xfrm>
+            <a:off x="6400800" y="1965960"/>
+            <a:ext cx="5257800" cy="868680"/>
+          </a:xfrm>
+          <a:prstGeom prst="rect">
+            <a:avLst/>
+          </a:prstGeom>
+          <a:noFill/>
+          <a:ln/>
+        </p:spPr>
+        <p:txBody>
+          <a:bodyPr wrap="square" lIns="0" tIns="0" rIns="0" bIns="0" rtlCol="0" anchor="ctr"/>
+          <a:lstStyle/>
+          <a:p>
+            <a:pPr indent="0" marL="0">
+              <a:buNone/>
+            </a:pPr>
+            <a:r>
+              <a:rPr lang="en-US" sz="1200" b="1" dirty="0">
+                <a:solidFill>
+                  <a:srgbClr val="16213D"/>
+                </a:solidFill>
+                <a:latin typeface="Courier New" pitchFamily="34" charset="0"/>
+                <a:ea typeface="Courier New" pitchFamily="34" charset="-122"/>
+                <a:cs typeface="Courier New" pitchFamily="34" charset="-120"/>
+              </a:rPr>
+              <a:t>TEST SEQUENCE: provision radio 2, bench two-radio decode, two-vehicle drive test, range characterization.</a:t>
+            </a:r>
+            <a:endParaRPr lang="en-US" sz="1200" dirty="0"/>
+          </a:p>
+        </p:txBody>
+      </p:sp>
+      <p:sp>
+        <p:nvSpPr>
+          <p:cNvPr id="14" name="Shape 11"/>
+          <p:cNvSpPr/>
+          <p:nvPr/>
+        </p:nvSpPr>
+        <p:spPr>
+          <a:xfrm>
+            <a:off x="457200" y="3154680"/>
+            <a:ext cx="3657600" cy="1426464"/>
+          </a:xfrm>
+          <a:prstGeom prst="rect">
+            <a:avLst/>
+          </a:prstGeom>
+          <a:solidFill>
+            <a:srgbClr val="F2F5FA"/>
+          </a:solidFill>
+          <a:ln w="15875">
+            <a:solidFill>
+              <a:srgbClr val="D9488C"/>
+            </a:solidFill>
+            <a:prstDash val="solid"/>
+          </a:ln>
+        </p:spPr>
+      </p:sp>
+      <p:sp>
+        <p:nvSpPr>
+          <p:cNvPr id="15" name="Text 12"/>
+          <p:cNvSpPr txBox="1"/>
+          <p:nvPr/>
+        </p:nvSpPr>
+        <p:spPr>
+          <a:xfrm>
+            <a:off x="585216" y="3218688"/>
+            <a:ext cx="3383280" cy="237744"/>
+          </a:xfrm>
+          <a:prstGeom prst="rect">
+            <a:avLst/>
+          </a:prstGeom>
+          <a:noFill/>
+          <a:ln/>
+        </p:spPr>
+        <p:txBody>
+          <a:bodyPr wrap="square" lIns="0" tIns="0" rIns="0" bIns="0" rtlCol="0" anchor="ctr"/>
+          <a:lstStyle/>
+          <a:p>
+            <a:pPr indent="0" marL="0">
+              <a:buNone/>
+            </a:pPr>
+            <a:r>
+              <a:rPr lang="en-US" sz="1050" b="1" dirty="0">
+                <a:solidFill>
+                  <a:srgbClr val="D9488C"/>
+                </a:solidFill>
+                <a:latin typeface="Courier New" pitchFamily="34" charset="0"/>
+                <a:ea typeface="Courier New" pitchFamily="34" charset="-122"/>
+                <a:cs typeface="Courier New" pitchFamily="34" charset="-120"/>
+              </a:rPr>
+              <a:t>RADIO / PHY</a:t>
+            </a:r>
+            <a:endParaRPr lang="en-US" sz="1050" dirty="0"/>
+          </a:p>
+        </p:txBody>
+      </p:sp>
+      <p:sp>
+        <p:nvSpPr>
+          <p:cNvPr id="16" name="Text 13"/>
+          <p:cNvSpPr txBox="1"/>
+          <p:nvPr/>
+        </p:nvSpPr>
+        <p:spPr>
+          <a:xfrm>
+            <a:off x="585216" y="3483864"/>
+            <a:ext cx="3419856" cy="1060704"/>
+          </a:xfrm>
+          <a:prstGeom prst="rect">
+            <a:avLst/>
+          </a:prstGeom>
+          <a:noFill/>
+          <a:ln/>
+        </p:spPr>
+        <p:txBody>
+          <a:bodyPr wrap="square" lIns="0" tIns="0" rIns="0" bIns="0" rtlCol="0" anchor="ctr"/>
+          <a:lstStyle/>
+          <a:p>
+            <a:pPr indent="0" marL="0">
+              <a:buNone/>
+            </a:pPr>
+            <a:r>
+              <a:rPr lang="en-US" sz="950" dirty="0">
+                <a:solidFill>
+                  <a:srgbClr val="222A3F"/>
+                </a:solidFill>
+                <a:latin typeface="Arial" pitchFamily="34" charset="0"/>
+                <a:ea typeface="Arial" pitchFamily="34" charset="-122"/>
+                <a:cs typeface="Arial" pitchFamily="34" charset="-120"/>
+              </a:rPr>
+              <a:t>Half a second of airtime per packet caps cadence at ten seconds. Utilization must stay under about 25%. The region must be set or transmit is disabled. The roof antenna is the single biggest range factor.</a:t>
+            </a:r>
+            <a:endParaRPr lang="en-US" sz="950" dirty="0"/>
+          </a:p>
+        </p:txBody>
+      </p:sp>
+      <p:sp>
+        <p:nvSpPr>
+          <p:cNvPr id="17" name="Shape 14"/>
+          <p:cNvSpPr/>
+          <p:nvPr/>
+        </p:nvSpPr>
+        <p:spPr>
+          <a:xfrm>
+            <a:off x="4297680" y="3154680"/>
+            <a:ext cx="3657600" cy="1426464"/>
+          </a:xfrm>
+          <a:prstGeom prst="rect">
+            <a:avLst/>
+          </a:prstGeom>
+          <a:solidFill>
+            <a:srgbClr val="F2F5FA"/>
+          </a:solidFill>
+          <a:ln w="15875">
+            <a:solidFill>
+              <a:srgbClr val="D9488C"/>
+            </a:solidFill>
+            <a:prstDash val="solid"/>
+          </a:ln>
+        </p:spPr>
+      </p:sp>
+      <p:sp>
+        <p:nvSpPr>
+          <p:cNvPr id="18" name="Text 15"/>
+          <p:cNvSpPr txBox="1"/>
+          <p:nvPr/>
+        </p:nvSpPr>
+        <p:spPr>
+          <a:xfrm>
+            <a:off x="4425696" y="3218688"/>
+            <a:ext cx="3383280" cy="237744"/>
+          </a:xfrm>
+          <a:prstGeom prst="rect">
+            <a:avLst/>
+          </a:prstGeom>
+          <a:noFill/>
+          <a:ln/>
+        </p:spPr>
+        <p:txBody>
+          <a:bodyPr wrap="square" lIns="0" tIns="0" rIns="0" bIns="0" rtlCol="0" anchor="ctr"/>
+          <a:lstStyle/>
+          <a:p>
+            <a:pPr indent="0" marL="0">
+              <a:buNone/>
+            </a:pPr>
+            <a:r>
+              <a:rPr lang="en-US" sz="1050" b="1" dirty="0">
+                <a:solidFill>
+                  <a:srgbClr val="D9488C"/>
+                </a:solidFill>
+                <a:latin typeface="Courier New" pitchFamily="34" charset="0"/>
+                <a:ea typeface="Courier New" pitchFamily="34" charset="-122"/>
+                <a:cs typeface="Courier New" pitchFamily="34" charset="-120"/>
+              </a:rPr>
+              <a:t>GPS</a:t>
+            </a:r>
+            <a:endParaRPr lang="en-US" sz="1050" dirty="0"/>
+          </a:p>
+        </p:txBody>
+      </p:sp>
+      <p:sp>
+        <p:nvSpPr>
+          <p:cNvPr id="19" name="Text 16"/>
+          <p:cNvSpPr txBox="1"/>
+          <p:nvPr/>
+        </p:nvSpPr>
+        <p:spPr>
+          <a:xfrm>
+            <a:off x="4425696" y="3483864"/>
+            <a:ext cx="3419856" cy="1060704"/>
+          </a:xfrm>
+          <a:prstGeom prst="rect">
+            <a:avLst/>
+          </a:prstGeom>
+          <a:noFill/>
+          <a:ln/>
+        </p:spPr>
+        <p:txBody>
+          <a:bodyPr wrap="square" lIns="0" tIns="0" rIns="0" bIns="0" rtlCol="0" anchor="ctr"/>
+          <a:lstStyle/>
+          <a:p>
+            <a:pPr indent="0" marL="0">
+              <a:buNone/>
+            </a:pPr>
+            <a:r>
+              <a:rPr lang="en-US" sz="950" dirty="0">
+                <a:solidFill>
+                  <a:srgbClr val="222A3F"/>
+                </a:solidFill>
+                <a:latin typeface="Arial" pitchFamily="34" charset="0"/>
+                <a:ea typeface="Arial" pitchFamily="34" charset="-122"/>
+                <a:cs typeface="Arial" pitchFamily="34" charset="-120"/>
+              </a:rPr>
+              <a:t>Needs sky view: a windshield works, a desk does not. Cold start takes minutes. Indoor multipath fakes small phantom speeds, which the deadband removes. Fix rate must match broadcast rate.</a:t>
+            </a:r>
+            <a:endParaRPr lang="en-US" sz="950" dirty="0"/>
+          </a:p>
+        </p:txBody>
+      </p:sp>
+      <p:sp>
+        <p:nvSpPr>
+          <p:cNvPr id="20" name="Shape 17"/>
+          <p:cNvSpPr/>
+          <p:nvPr/>
+        </p:nvSpPr>
+        <p:spPr>
+          <a:xfrm>
+            <a:off x="8138160" y="3154680"/>
+            <a:ext cx="3657600" cy="1426464"/>
+          </a:xfrm>
+          <a:prstGeom prst="rect">
+            <a:avLst/>
+          </a:prstGeom>
+          <a:solidFill>
+            <a:srgbClr val="F2F5FA"/>
+          </a:solidFill>
+          <a:ln w="15875">
+            <a:solidFill>
+              <a:srgbClr val="D9488C"/>
+            </a:solidFill>
+            <a:prstDash val="solid"/>
+          </a:ln>
+        </p:spPr>
+      </p:sp>
+      <p:sp>
+        <p:nvSpPr>
+          <p:cNvPr id="21" name="Text 18"/>
+          <p:cNvSpPr txBox="1"/>
+          <p:nvPr/>
+        </p:nvSpPr>
+        <p:spPr>
+          <a:xfrm>
+            <a:off x="8266176" y="3218688"/>
+            <a:ext cx="3383280" cy="237744"/>
+          </a:xfrm>
+          <a:prstGeom prst="rect">
+            <a:avLst/>
+          </a:prstGeom>
+          <a:noFill/>
+          <a:ln/>
+        </p:spPr>
+        <p:txBody>
+          <a:bodyPr wrap="square" lIns="0" tIns="0" rIns="0" bIns="0" rtlCol="0" anchor="ctr"/>
+          <a:lstStyle/>
+          <a:p>
+            <a:pPr indent="0" marL="0">
+              <a:buNone/>
+            </a:pPr>
+            <a:r>
+              <a:rPr lang="en-US" sz="1050" b="1" dirty="0">
+                <a:solidFill>
+                  <a:srgbClr val="D9488C"/>
+                </a:solidFill>
+                <a:latin typeface="Courier New" pitchFamily="34" charset="0"/>
+                <a:ea typeface="Courier New" pitchFamily="34" charset="-122"/>
+                <a:cs typeface="Courier New" pitchFamily="34" charset="-120"/>
+              </a:rPr>
+              <a:t>BLE LINK</a:t>
+            </a:r>
+            <a:endParaRPr lang="en-US" sz="1050" dirty="0"/>
+          </a:p>
+        </p:txBody>
+      </p:sp>
+      <p:sp>
+        <p:nvSpPr>
+          <p:cNvPr id="22" name="Text 19"/>
+          <p:cNvSpPr txBox="1"/>
+          <p:nvPr/>
+        </p:nvSpPr>
+        <p:spPr>
+          <a:xfrm>
+            <a:off x="8266176" y="3483864"/>
+            <a:ext cx="3419856" cy="1060704"/>
+          </a:xfrm>
+          <a:prstGeom prst="rect">
+            <a:avLst/>
+          </a:prstGeom>
+          <a:noFill/>
+          <a:ln/>
+        </p:spPr>
+        <p:txBody>
+          <a:bodyPr wrap="square" lIns="0" tIns="0" rIns="0" bIns="0" rtlCol="0" anchor="ctr"/>
+          <a:lstStyle/>
+          <a:p>
+            <a:pPr indent="0" marL="0">
+              <a:buNone/>
+            </a:pPr>
+            <a:r>
+              <a:rPr lang="en-US" sz="950" dirty="0">
+                <a:solidFill>
+                  <a:srgbClr val="222A3F"/>
+                </a:solidFill>
+                <a:latin typeface="Arial" pitchFamily="34" charset="0"/>
+                <a:ea typeface="Arial" pitchFamily="34" charset="-122"/>
+                <a:cs typeface="Arial" pitchFamily="34" charset="-120"/>
+              </a:rPr>
+              <a:t>The radio advertises only from boot until its first disconnect, so both units power up together. Exactly one client at a time: a phone app or USB session will take or mute the link.</a:t>
+            </a:r>
+            <a:endParaRPr lang="en-US" sz="950" dirty="0"/>
+          </a:p>
+        </p:txBody>
+      </p:sp>
+      <p:sp>
+        <p:nvSpPr>
+          <p:cNvPr id="23" name="Shape 20"/>
+          <p:cNvSpPr/>
+          <p:nvPr/>
+        </p:nvSpPr>
+        <p:spPr>
+          <a:xfrm>
+            <a:off x="457200" y="4690872"/>
+            <a:ext cx="3657600" cy="1426464"/>
+          </a:xfrm>
+          <a:prstGeom prst="rect">
+            <a:avLst/>
+          </a:prstGeom>
+          <a:solidFill>
+            <a:srgbClr val="F2F5FA"/>
+          </a:solidFill>
+          <a:ln w="15875">
+            <a:solidFill>
+              <a:srgbClr val="D9488C"/>
+            </a:solidFill>
+            <a:prstDash val="solid"/>
+          </a:ln>
+        </p:spPr>
+      </p:sp>
+      <p:sp>
+        <p:nvSpPr>
+          <p:cNvPr id="24" name="Text 21"/>
+          <p:cNvSpPr txBox="1"/>
+          <p:nvPr/>
+        </p:nvSpPr>
+        <p:spPr>
+          <a:xfrm>
+            <a:off x="585216" y="4754880"/>
+            <a:ext cx="3383280" cy="237744"/>
+          </a:xfrm>
+          <a:prstGeom prst="rect">
+            <a:avLst/>
+          </a:prstGeom>
+          <a:noFill/>
+          <a:ln/>
+        </p:spPr>
+        <p:txBody>
+          <a:bodyPr wrap="square" lIns="0" tIns="0" rIns="0" bIns="0" rtlCol="0" anchor="ctr"/>
+          <a:lstStyle/>
+          <a:p>
+            <a:pPr indent="0" marL="0">
+              <a:buNone/>
+            </a:pPr>
+            <a:r>
+              <a:rPr lang="en-US" sz="1050" b="1" dirty="0">
+                <a:solidFill>
+                  <a:srgbClr val="D9488C"/>
+                </a:solidFill>
+                <a:latin typeface="Courier New" pitchFamily="34" charset="0"/>
+                <a:ea typeface="Courier New" pitchFamily="34" charset="-122"/>
+                <a:cs typeface="Courier New" pitchFamily="34" charset="-120"/>
+              </a:rPr>
+              <a:t>DISPLAY</a:t>
+            </a:r>
+            <a:endParaRPr lang="en-US" sz="1050" dirty="0"/>
+          </a:p>
+        </p:txBody>
+      </p:sp>
+      <p:sp>
+        <p:nvSpPr>
+          <p:cNvPr id="25" name="Text 22"/>
+          <p:cNvSpPr txBox="1"/>
+          <p:nvPr/>
+        </p:nvSpPr>
+        <p:spPr>
+          <a:xfrm>
+            <a:off x="585216" y="5020056"/>
+            <a:ext cx="3419856" cy="1060704"/>
+          </a:xfrm>
+          <a:prstGeom prst="rect">
+            <a:avLst/>
+          </a:prstGeom>
+          <a:noFill/>
+          <a:ln/>
+        </p:spPr>
+        <p:txBody>
+          <a:bodyPr wrap="square" lIns="0" tIns="0" rIns="0" bIns="0" rtlCol="0" anchor="ctr"/>
+          <a:lstStyle/>
+          <a:p>
+            <a:pPr indent="0" marL="0">
+              <a:buNone/>
+            </a:pPr>
+            <a:r>
+              <a:rPr lang="en-US" sz="950" dirty="0">
+                <a:solidFill>
+                  <a:srgbClr val="222A3F"/>
+                </a:solidFill>
+                <a:latin typeface="Arial" pitchFamily="34" charset="0"/>
+                <a:ea typeface="Arial" pitchFamily="34" charset="-122"/>
+                <a:cs typeface="Arial" pitchFamily="34" charset="-120"/>
+              </a:rPr>
+              <a:t>A one-bit reflective panel has no grayscale and needs ambient light at night; edge lighting is planned. The redraw budget is two full frames per second.</a:t>
+            </a:r>
+            <a:endParaRPr lang="en-US" sz="950" dirty="0"/>
+          </a:p>
+        </p:txBody>
+      </p:sp>
+      <p:sp>
+        <p:nvSpPr>
+          <p:cNvPr id="26" name="Shape 23"/>
+          <p:cNvSpPr/>
+          <p:nvPr/>
+        </p:nvSpPr>
+        <p:spPr>
+          <a:xfrm>
+            <a:off x="4297680" y="4690872"/>
+            <a:ext cx="3657600" cy="1426464"/>
+          </a:xfrm>
+          <a:prstGeom prst="rect">
+            <a:avLst/>
+          </a:prstGeom>
+          <a:solidFill>
+            <a:srgbClr val="F2F5FA"/>
+          </a:solidFill>
+          <a:ln w="15875">
+            <a:solidFill>
+              <a:srgbClr val="D9488C"/>
+            </a:solidFill>
+            <a:prstDash val="solid"/>
+          </a:ln>
+        </p:spPr>
+      </p:sp>
+      <p:sp>
+        <p:nvSpPr>
+          <p:cNvPr id="27" name="Text 24"/>
+          <p:cNvSpPr txBox="1"/>
+          <p:nvPr/>
+        </p:nvSpPr>
+        <p:spPr>
+          <a:xfrm>
+            <a:off x="4425696" y="4754880"/>
+            <a:ext cx="3383280" cy="237744"/>
+          </a:xfrm>
+          <a:prstGeom prst="rect">
+            <a:avLst/>
+          </a:prstGeom>
+          <a:noFill/>
+          <a:ln/>
+        </p:spPr>
+        <p:txBody>
+          <a:bodyPr wrap="square" lIns="0" tIns="0" rIns="0" bIns="0" rtlCol="0" anchor="ctr"/>
+          <a:lstStyle/>
+          <a:p>
+            <a:pPr indent="0" marL="0">
+              <a:buNone/>
+            </a:pPr>
+            <a:r>
+              <a:rPr lang="en-US" sz="1050" b="1" dirty="0">
+                <a:solidFill>
+                  <a:srgbClr val="D9488C"/>
+                </a:solidFill>
+                <a:latin typeface="Courier New" pitchFamily="34" charset="0"/>
+                <a:ea typeface="Courier New" pitchFamily="34" charset="-122"/>
+                <a:cs typeface="Courier New" pitchFamily="34" charset="-120"/>
+              </a:rPr>
+              <a:t>POWER</a:t>
+            </a:r>
+            <a:endParaRPr lang="en-US" sz="1050" dirty="0"/>
+          </a:p>
+        </p:txBody>
+      </p:sp>
+      <p:sp>
+        <p:nvSpPr>
+          <p:cNvPr id="28" name="Text 25"/>
+          <p:cNvSpPr txBox="1"/>
+          <p:nvPr/>
+        </p:nvSpPr>
+        <p:spPr>
+          <a:xfrm>
+            <a:off x="4425696" y="5020056"/>
+            <a:ext cx="3419856" cy="1060704"/>
+          </a:xfrm>
+          <a:prstGeom prst="rect">
+            <a:avLst/>
+          </a:prstGeom>
+          <a:noFill/>
+          <a:ln/>
+        </p:spPr>
+        <p:txBody>
+          <a:bodyPr wrap="square" lIns="0" tIns="0" rIns="0" bIns="0" rtlCol="0" anchor="ctr"/>
+          <a:lstStyle/>
+          <a:p>
+            <a:pPr indent="0" marL="0">
+              <a:buNone/>
+            </a:pPr>
+            <a:r>
+              <a:rPr lang="en-US" sz="950" dirty="0">
+                <a:solidFill>
+                  <a:srgbClr val="222A3F"/>
+                </a:solidFill>
+                <a:latin typeface="Arial" pitchFamily="34" charset="0"/>
+                <a:ea typeface="Arial" pitchFamily="34" charset="-122"/>
+                <a:cs typeface="Arial" pitchFamily="34" charset="-120"/>
+              </a:rPr>
+              <a:t>Cheap 12 volt USB adapters cut off on the radio's low current draw, so every adapter gets validated. Both units must share the vehicle's power timing.</a:t>
+            </a:r>
+            <a:endParaRPr lang="en-US" sz="950" dirty="0"/>
+          </a:p>
+        </p:txBody>
+      </p:sp>
+      <p:sp>
+        <p:nvSpPr>
+          <p:cNvPr id="29" name="Shape 26"/>
+          <p:cNvSpPr/>
+          <p:nvPr/>
+        </p:nvSpPr>
+        <p:spPr>
+          <a:xfrm>
+            <a:off x="8138160" y="4690872"/>
+            <a:ext cx="3657600" cy="1426464"/>
+          </a:xfrm>
+          <a:prstGeom prst="rect">
+            <a:avLst/>
+          </a:prstGeom>
+          <a:solidFill>
+            <a:srgbClr val="F2F5FA"/>
+          </a:solidFill>
+          <a:ln w="15875">
+            <a:solidFill>
+              <a:srgbClr val="D9488C"/>
+            </a:solidFill>
+            <a:prstDash val="solid"/>
+          </a:ln>
+        </p:spPr>
+      </p:sp>
+      <p:sp>
+        <p:nvSpPr>
+          <p:cNvPr id="30" name="Text 27"/>
+          <p:cNvSpPr txBox="1"/>
+          <p:nvPr/>
+        </p:nvSpPr>
+        <p:spPr>
+          <a:xfrm>
+            <a:off x="8266176" y="4754880"/>
+            <a:ext cx="3383280" cy="237744"/>
+          </a:xfrm>
+          <a:prstGeom prst="rect">
+            <a:avLst/>
+          </a:prstGeom>
+          <a:noFill/>
+          <a:ln/>
+        </p:spPr>
+        <p:txBody>
+          <a:bodyPr wrap="square" lIns="0" tIns="0" rIns="0" bIns="0" rtlCol="0" anchor="ctr"/>
+          <a:lstStyle/>
+          <a:p>
+            <a:pPr indent="0" marL="0">
+              <a:buNone/>
+            </a:pPr>
+            <a:r>
+              <a:rPr lang="en-US" sz="1050" b="1" dirty="0">
+                <a:solidFill>
+                  <a:srgbClr val="D9488C"/>
+                </a:solidFill>
+                <a:latin typeface="Courier New" pitchFamily="34" charset="0"/>
+                <a:ea typeface="Courier New" pitchFamily="34" charset="-122"/>
+                <a:cs typeface="Courier New" pitchFamily="34" charset="-120"/>
+              </a:rPr>
+              <a:t>PROVISIONING</a:t>
+            </a:r>
+            <a:endParaRPr lang="en-US" sz="1050" dirty="0"/>
+          </a:p>
+        </p:txBody>
+      </p:sp>
+      <p:sp>
+        <p:nvSpPr>
+          <p:cNvPr id="31" name="Text 28"/>
+          <p:cNvSpPr txBox="1"/>
+          <p:nvPr/>
+        </p:nvSpPr>
+        <p:spPr>
+          <a:xfrm>
+            <a:off x="8266176" y="5020056"/>
+            <a:ext cx="3419856" cy="1060704"/>
+          </a:xfrm>
+          <a:prstGeom prst="rect">
+            <a:avLst/>
+          </a:prstGeom>
+          <a:noFill/>
+          <a:ln/>
+        </p:spPr>
+        <p:txBody>
+          <a:bodyPr wrap="square" lIns="0" tIns="0" rIns="0" bIns="0" rtlCol="0" anchor="ctr"/>
+          <a:lstStyle/>
+          <a:p>
+            <a:pPr indent="0" marL="0">
+              <a:buNone/>
+            </a:pPr>
+            <a:r>
+              <a:rPr lang="en-US" sz="950" dirty="0">
+                <a:solidFill>
+                  <a:srgbClr val="222A3F"/>
+                </a:solidFill>
+                <a:latin typeface="Arial" pitchFamily="34" charset="0"/>
+                <a:ea typeface="Arial" pitchFamily="34" charset="-122"/>
+                <a:cs typeface="Arial" pitchFamily="34" charset="-120"/>
+              </a:rPr>
+              <a:t>The channel URL carrying the encryption key must match on every radio. Node identities derive from the MAC address and survive reflashes. Every configuration write is read back and verified.</a:t>
+            </a:r>
+            <a:endParaRPr lang="en-US" sz="950" dirty="0"/>
+          </a:p>
+        </p:txBody>
+      </p:sp>
+    </p:spTree>
+  </p:cSld>
+  <p:clrMapOvr>
+    <a:masterClrMapping/>
+  </p:clrMapOvr>
+</p:sld>
+</file>
+
+<file path=ppt/slides/slide12.xml><?xml version="1.0" encoding="utf-8"?>
+<p:sld xmlns:a="http://schemas.openxmlformats.org/drawingml/2006/main" xmlns:r="http://schemas.openxmlformats.org/officeDocument/2006/relationships" xmlns:p="http://schemas.openxmlformats.org/presentationml/2006/main">
+  <p:cSld name="Slide 12">
+    <p:bg>
+      <p:bgPr>
+        <a:solidFill>
+          <a:srgbClr val="FFFFFF"/>
+        </a:solidFill>
+      </p:bgPr>
+    </p:bg>
+    <p:spTree>
+      <p:nvGrpSpPr>
+        <p:cNvPr id="1" name=""/>
+        <p:cNvGrpSpPr/>
+        <p:nvPr/>
+      </p:nvGrpSpPr>
+      <p:grpSpPr>
+        <a:xfrm>
+          <a:off x="0" y="0"/>
+          <a:ext cx="0" cy="0"/>
+          <a:chOff x="0" y="0"/>
+          <a:chExt cx="0" cy="0"/>
+        </a:xfrm>
+      </p:grpSpPr>
+      <p:sp>
+        <p:nvSpPr>
+          <p:cNvPr id="2" name="Shape 0"/>
+          <p:cNvSpPr/>
+          <p:nvPr/>
+        </p:nvSpPr>
+        <p:spPr>
+          <a:xfrm>
+            <a:off x="164592" y="146304"/>
+            <a:ext cx="11859768" cy="6565392"/>
+          </a:xfrm>
+          <a:prstGeom prst="rect">
+            <a:avLst/>
+          </a:prstGeom>
+          <a:ln w="22225">
+            <a:solidFill>
+              <a:srgbClr val="16213D"/>
+            </a:solidFill>
+            <a:prstDash val="solid"/>
+          </a:ln>
+        </p:spPr>
+      </p:sp>
+      <p:sp>
+        <p:nvSpPr>
+          <p:cNvPr id="3" name="Shape 1"/>
+          <p:cNvSpPr/>
+          <p:nvPr/>
+        </p:nvSpPr>
+        <p:spPr>
+          <a:xfrm>
+            <a:off x="164592" y="6272784"/>
+            <a:ext cx="11859768" cy="0"/>
+          </a:xfrm>
+          <a:prstGeom prst="line">
+            <a:avLst/>
+          </a:prstGeom>
+          <a:noFill/>
+          <a:ln w="12700">
+            <a:solidFill>
+              <a:srgbClr val="16213D"/>
+            </a:solidFill>
+            <a:prstDash val="solid"/>
+          </a:ln>
+        </p:spPr>
+      </p:sp>
+      <p:sp>
+        <p:nvSpPr>
+          <p:cNvPr id="4" name="Text 2"/>
+          <p:cNvSpPr txBox="1"/>
+          <p:nvPr/>
+        </p:nvSpPr>
+        <p:spPr>
+          <a:xfrm>
+            <a:off x="320040" y="6345936"/>
+            <a:ext cx="4206240" cy="292608"/>
+          </a:xfrm>
+          <a:prstGeom prst="rect">
+            <a:avLst/>
+          </a:prstGeom>
+          <a:noFill/>
+          <a:ln/>
+        </p:spPr>
+        <p:txBody>
+          <a:bodyPr wrap="square" lIns="0" tIns="0" rIns="0" bIns="0" rtlCol="0" anchor="ctr"/>
+          <a:lstStyle/>
+          <a:p>
+            <a:pPr indent="0" marL="0">
+              <a:buNone/>
+            </a:pPr>
+            <a:r>
+              <a:rPr lang="en-US" sz="900" dirty="0">
+                <a:solidFill>
+                  <a:srgbClr val="5E6B85"/>
+                </a:solidFill>
+                <a:latin typeface="Courier New" pitchFamily="34" charset="0"/>
+                <a:ea typeface="Courier New" pitchFamily="34" charset="-122"/>
+                <a:cs typeface="Courier New" pitchFamily="34" charset="-120"/>
+              </a:rPr>
+              <a:t>GROUP 9  |  OFF-GRID VEHICLE TRACKER</a:t>
+            </a:r>
+            <a:endParaRPr lang="en-US" sz="900" dirty="0"/>
+          </a:p>
+        </p:txBody>
+      </p:sp>
+      <p:sp>
+        <p:nvSpPr>
+          <p:cNvPr id="5" name="Text 3"/>
+          <p:cNvSpPr txBox="1"/>
+          <p:nvPr/>
+        </p:nvSpPr>
+        <p:spPr>
+          <a:xfrm>
+            <a:off x="4572000" y="6345936"/>
+            <a:ext cx="4206240" cy="292608"/>
+          </a:xfrm>
+          <a:prstGeom prst="rect">
+            <a:avLst/>
+          </a:prstGeom>
+          <a:noFill/>
+          <a:ln/>
+        </p:spPr>
+        <p:txBody>
+          <a:bodyPr wrap="square" lIns="0" tIns="0" rIns="0" bIns="0" rtlCol="0" anchor="ctr"/>
+          <a:lstStyle/>
+          <a:p>
+            <a:pPr algn="ctr" indent="0" marL="0">
+              <a:buNone/>
+            </a:pPr>
+            <a:r>
+              <a:rPr lang="en-US" sz="900" dirty="0">
+                <a:solidFill>
+                  <a:srgbClr val="5E6B85"/>
+                </a:solidFill>
+                <a:latin typeface="Courier New" pitchFamily="34" charset="0"/>
+                <a:ea typeface="Courier New" pitchFamily="34" charset="-122"/>
+                <a:cs typeface="Courier New" pitchFamily="34" charset="-120"/>
+              </a:rPr>
+              <a:t>STATUS AND NEXT STEPS</a:t>
+            </a:r>
+            <a:endParaRPr lang="en-US" sz="900" dirty="0"/>
+          </a:p>
+        </p:txBody>
+      </p:sp>
+      <p:sp>
+        <p:nvSpPr>
+          <p:cNvPr id="6" name="Text 4"/>
+          <p:cNvSpPr txBox="1"/>
+          <p:nvPr/>
+        </p:nvSpPr>
+        <p:spPr>
+          <a:xfrm>
+            <a:off x="8869680" y="6345936"/>
+            <a:ext cx="3017520" cy="292608"/>
+          </a:xfrm>
+          <a:prstGeom prst="rect">
+            <a:avLst/>
+          </a:prstGeom>
+          <a:noFill/>
+          <a:ln/>
+        </p:spPr>
+        <p:txBody>
+          <a:bodyPr wrap="square" lIns="0" tIns="0" rIns="0" bIns="0" rtlCol="0" anchor="ctr"/>
+          <a:lstStyle/>
+          <a:p>
+            <a:pPr algn="r" indent="0" marL="0">
+              <a:buNone/>
+            </a:pPr>
+            <a:r>
+              <a:rPr lang="en-US" sz="900" dirty="0">
+                <a:solidFill>
+                  <a:srgbClr val="5E6B85"/>
+                </a:solidFill>
+                <a:latin typeface="Courier New" pitchFamily="34" charset="0"/>
+                <a:ea typeface="Courier New" pitchFamily="34" charset="-122"/>
+                <a:cs typeface="Courier New" pitchFamily="34" charset="-120"/>
+              </a:rPr>
+              <a:t>SHEET 12/13  REV C  2026-09-07</a:t>
             </a:r>
             <a:endParaRPr lang="en-US" sz="900" dirty="0"/>
           </a:p>
@@ -6611,6 +8293,1081 @@
               <a:t>One radio still talks to itself. But every layer between a GPS fix and the driver's arrow is now real, tested code. Radio number two turns this into a tracker.</a:t>
             </a:r>
             <a:endParaRPr lang="en-US" sz="1250" dirty="0"/>
+          </a:p>
+        </p:txBody>
+      </p:sp>
+    </p:spTree>
+  </p:cSld>
+  <p:clrMapOvr>
+    <a:masterClrMapping/>
+  </p:clrMapOvr>
+</p:sld>
+</file>
+
+<file path=ppt/slides/slide13.xml><?xml version="1.0" encoding="utf-8"?>
+<p:sld xmlns:a="http://schemas.openxmlformats.org/drawingml/2006/main" xmlns:r="http://schemas.openxmlformats.org/officeDocument/2006/relationships" xmlns:p="http://schemas.openxmlformats.org/presentationml/2006/main">
+  <p:cSld name="Slide 13">
+    <p:bg>
+      <p:bgPr>
+        <a:solidFill>
+          <a:srgbClr val="FFFFFF"/>
+        </a:solidFill>
+      </p:bgPr>
+    </p:bg>
+    <p:spTree>
+      <p:nvGrpSpPr>
+        <p:cNvPr id="1" name=""/>
+        <p:cNvGrpSpPr/>
+        <p:nvPr/>
+      </p:nvGrpSpPr>
+      <p:grpSpPr>
+        <a:xfrm>
+          <a:off x="0" y="0"/>
+          <a:ext cx="0" cy="0"/>
+          <a:chOff x="0" y="0"/>
+          <a:chExt cx="0" cy="0"/>
+        </a:xfrm>
+      </p:grpSpPr>
+      <p:sp>
+        <p:nvSpPr>
+          <p:cNvPr id="2" name="Shape 0"/>
+          <p:cNvSpPr/>
+          <p:nvPr/>
+        </p:nvSpPr>
+        <p:spPr>
+          <a:xfrm>
+            <a:off x="164592" y="146304"/>
+            <a:ext cx="11859768" cy="6565392"/>
+          </a:xfrm>
+          <a:prstGeom prst="rect">
+            <a:avLst/>
+          </a:prstGeom>
+          <a:ln w="22225">
+            <a:solidFill>
+              <a:srgbClr val="16213D"/>
+            </a:solidFill>
+            <a:prstDash val="solid"/>
+          </a:ln>
+        </p:spPr>
+      </p:sp>
+      <p:sp>
+        <p:nvSpPr>
+          <p:cNvPr id="3" name="Shape 1"/>
+          <p:cNvSpPr/>
+          <p:nvPr/>
+        </p:nvSpPr>
+        <p:spPr>
+          <a:xfrm>
+            <a:off x="164592" y="6272784"/>
+            <a:ext cx="11859768" cy="0"/>
+          </a:xfrm>
+          <a:prstGeom prst="line">
+            <a:avLst/>
+          </a:prstGeom>
+          <a:noFill/>
+          <a:ln w="12700">
+            <a:solidFill>
+              <a:srgbClr val="16213D"/>
+            </a:solidFill>
+            <a:prstDash val="solid"/>
+          </a:ln>
+        </p:spPr>
+      </p:sp>
+      <p:sp>
+        <p:nvSpPr>
+          <p:cNvPr id="4" name="Text 2"/>
+          <p:cNvSpPr txBox="1"/>
+          <p:nvPr/>
+        </p:nvSpPr>
+        <p:spPr>
+          <a:xfrm>
+            <a:off x="320040" y="6345936"/>
+            <a:ext cx="4206240" cy="292608"/>
+          </a:xfrm>
+          <a:prstGeom prst="rect">
+            <a:avLst/>
+          </a:prstGeom>
+          <a:noFill/>
+          <a:ln/>
+        </p:spPr>
+        <p:txBody>
+          <a:bodyPr wrap="square" lIns="0" tIns="0" rIns="0" bIns="0" rtlCol="0" anchor="ctr"/>
+          <a:lstStyle/>
+          <a:p>
+            <a:pPr indent="0" marL="0">
+              <a:buNone/>
+            </a:pPr>
+            <a:r>
+              <a:rPr lang="en-US" sz="900" dirty="0">
+                <a:solidFill>
+                  <a:srgbClr val="5E6B85"/>
+                </a:solidFill>
+                <a:latin typeface="Courier New" pitchFamily="34" charset="0"/>
+                <a:ea typeface="Courier New" pitchFamily="34" charset="-122"/>
+                <a:cs typeface="Courier New" pitchFamily="34" charset="-120"/>
+              </a:rPr>
+              <a:t>GROUP 9  |  OFF-GRID VEHICLE TRACKER</a:t>
+            </a:r>
+            <a:endParaRPr lang="en-US" sz="900" dirty="0"/>
+          </a:p>
+        </p:txBody>
+      </p:sp>
+      <p:sp>
+        <p:nvSpPr>
+          <p:cNvPr id="5" name="Text 3"/>
+          <p:cNvSpPr txBox="1"/>
+          <p:nvPr/>
+        </p:nvSpPr>
+        <p:spPr>
+          <a:xfrm>
+            <a:off x="4572000" y="6345936"/>
+            <a:ext cx="4206240" cy="292608"/>
+          </a:xfrm>
+          <a:prstGeom prst="rect">
+            <a:avLst/>
+          </a:prstGeom>
+          <a:noFill/>
+          <a:ln/>
+        </p:spPr>
+        <p:txBody>
+          <a:bodyPr wrap="square" lIns="0" tIns="0" rIns="0" bIns="0" rtlCol="0" anchor="ctr"/>
+          <a:lstStyle/>
+          <a:p>
+            <a:pPr algn="ctr" indent="0" marL="0">
+              <a:buNone/>
+            </a:pPr>
+            <a:r>
+              <a:rPr lang="en-US" sz="900" dirty="0">
+                <a:solidFill>
+                  <a:srgbClr val="5E6B85"/>
+                </a:solidFill>
+                <a:latin typeface="Courier New" pitchFamily="34" charset="0"/>
+                <a:ea typeface="Courier New" pitchFamily="34" charset="-122"/>
+                <a:cs typeface="Courier New" pitchFamily="34" charset="-120"/>
+              </a:rPr>
+              <a:t>REFERENCES</a:t>
+            </a:r>
+            <a:endParaRPr lang="en-US" sz="900" dirty="0"/>
+          </a:p>
+        </p:txBody>
+      </p:sp>
+      <p:sp>
+        <p:nvSpPr>
+          <p:cNvPr id="6" name="Text 4"/>
+          <p:cNvSpPr txBox="1"/>
+          <p:nvPr/>
+        </p:nvSpPr>
+        <p:spPr>
+          <a:xfrm>
+            <a:off x="8869680" y="6345936"/>
+            <a:ext cx="3017520" cy="292608"/>
+          </a:xfrm>
+          <a:prstGeom prst="rect">
+            <a:avLst/>
+          </a:prstGeom>
+          <a:noFill/>
+          <a:ln/>
+        </p:spPr>
+        <p:txBody>
+          <a:bodyPr wrap="square" lIns="0" tIns="0" rIns="0" bIns="0" rtlCol="0" anchor="ctr"/>
+          <a:lstStyle/>
+          <a:p>
+            <a:pPr algn="r" indent="0" marL="0">
+              <a:buNone/>
+            </a:pPr>
+            <a:r>
+              <a:rPr lang="en-US" sz="900" dirty="0">
+                <a:solidFill>
+                  <a:srgbClr val="5E6B85"/>
+                </a:solidFill>
+                <a:latin typeface="Courier New" pitchFamily="34" charset="0"/>
+                <a:ea typeface="Courier New" pitchFamily="34" charset="-122"/>
+                <a:cs typeface="Courier New" pitchFamily="34" charset="-120"/>
+              </a:rPr>
+              <a:t>SHEET 13/13  REV C  2026-09-07</a:t>
+            </a:r>
+            <a:endParaRPr lang="en-US" sz="900" dirty="0"/>
+          </a:p>
+        </p:txBody>
+      </p:sp>
+      <p:sp>
+        <p:nvSpPr>
+          <p:cNvPr id="7" name="Text 5"/>
+          <p:cNvSpPr txBox="1"/>
+          <p:nvPr/>
+        </p:nvSpPr>
+        <p:spPr>
+          <a:xfrm>
+            <a:off x="457200" y="329184"/>
+            <a:ext cx="9052560" cy="566928"/>
+          </a:xfrm>
+          <a:prstGeom prst="rect">
+            <a:avLst/>
+          </a:prstGeom>
+          <a:noFill/>
+          <a:ln/>
+        </p:spPr>
+        <p:txBody>
+          <a:bodyPr wrap="square" lIns="0" tIns="0" rIns="0" bIns="0" rtlCol="0" anchor="ctr"/>
+          <a:lstStyle/>
+          <a:p>
+            <a:pPr indent="0" marL="0">
+              <a:buNone/>
+            </a:pPr>
+            <a:r>
+              <a:rPr lang="en-US" sz="2300" b="1" spc="200" kern="0" dirty="0">
+                <a:solidFill>
+                  <a:srgbClr val="16213D"/>
+                </a:solidFill>
+                <a:latin typeface="Arial" pitchFamily="34" charset="0"/>
+                <a:ea typeface="Arial" pitchFamily="34" charset="-122"/>
+                <a:cs typeface="Arial" pitchFamily="34" charset="-120"/>
+              </a:rPr>
+              <a:t>REFERENCES</a:t>
+            </a:r>
+            <a:endParaRPr lang="en-US" sz="2300" dirty="0"/>
+          </a:p>
+        </p:txBody>
+      </p:sp>
+      <p:sp>
+        <p:nvSpPr>
+          <p:cNvPr id="8" name="Text 6"/>
+          <p:cNvSpPr txBox="1"/>
+          <p:nvPr/>
+        </p:nvSpPr>
+        <p:spPr>
+          <a:xfrm>
+            <a:off x="457200" y="1143000"/>
+            <a:ext cx="457200" cy="274320"/>
+          </a:xfrm>
+          <a:prstGeom prst="rect">
+            <a:avLst/>
+          </a:prstGeom>
+          <a:noFill/>
+          <a:ln/>
+        </p:spPr>
+        <p:txBody>
+          <a:bodyPr wrap="square" lIns="0" tIns="0" rIns="0" bIns="0" rtlCol="0" anchor="ctr"/>
+          <a:lstStyle/>
+          <a:p>
+            <a:pPr indent="0" marL="0">
+              <a:buNone/>
+            </a:pPr>
+            <a:r>
+              <a:rPr lang="en-US" sz="1050" b="1" dirty="0">
+                <a:solidFill>
+                  <a:srgbClr val="E58E1A"/>
+                </a:solidFill>
+                <a:latin typeface="Courier New" pitchFamily="34" charset="0"/>
+                <a:ea typeface="Courier New" pitchFamily="34" charset="-122"/>
+                <a:cs typeface="Courier New" pitchFamily="34" charset="-120"/>
+              </a:rPr>
+              <a:t>[1]</a:t>
+            </a:r>
+            <a:endParaRPr lang="en-US" sz="1050" dirty="0"/>
+          </a:p>
+        </p:txBody>
+      </p:sp>
+      <p:sp>
+        <p:nvSpPr>
+          <p:cNvPr id="9" name="Text 7"/>
+          <p:cNvSpPr txBox="1"/>
+          <p:nvPr/>
+        </p:nvSpPr>
+        <p:spPr>
+          <a:xfrm>
+            <a:off x="960120" y="1143000"/>
+            <a:ext cx="5074920" cy="932688"/>
+          </a:xfrm>
+          <a:prstGeom prst="rect">
+            <a:avLst/>
+          </a:prstGeom>
+          <a:noFill/>
+          <a:ln/>
+        </p:spPr>
+        <p:txBody>
+          <a:bodyPr wrap="square" lIns="0" tIns="0" rIns="0" bIns="0" rtlCol="0" anchor="ctr"/>
+          <a:lstStyle/>
+          <a:p>
+            <a:pPr indent="0" marL="0">
+              <a:buNone/>
+            </a:pPr>
+            <a:r>
+              <a:rPr lang="en-US" sz="1000" dirty="0">
+                <a:solidFill>
+                  <a:srgbClr val="222A3F"/>
+                </a:solidFill>
+                <a:latin typeface="Arial" pitchFamily="34" charset="0"/>
+                <a:ea typeface="Arial" pitchFamily="34" charset="-122"/>
+                <a:cs typeface="Arial" pitchFamily="34" charset="-120"/>
+              </a:rPr>
+              <a:t>Semtech Corp., SX1276/77/78/79 LoRa Transceiver Datasheet. Demodulator SNR limit per spreading factor (SF11 = -17.5 dB), used in the sensitivity calculation on sheet 08.</a:t>
+            </a:r>
+            <a:endParaRPr lang="en-US" sz="1000" dirty="0"/>
+          </a:p>
+        </p:txBody>
+      </p:sp>
+      <p:sp>
+        <p:nvSpPr>
+          <p:cNvPr id="10" name="Text 8"/>
+          <p:cNvSpPr txBox="1"/>
+          <p:nvPr/>
+        </p:nvSpPr>
+        <p:spPr>
+          <a:xfrm>
+            <a:off x="457200" y="2130552"/>
+            <a:ext cx="457200" cy="274320"/>
+          </a:xfrm>
+          <a:prstGeom prst="rect">
+            <a:avLst/>
+          </a:prstGeom>
+          <a:noFill/>
+          <a:ln/>
+        </p:spPr>
+        <p:txBody>
+          <a:bodyPr wrap="square" lIns="0" tIns="0" rIns="0" bIns="0" rtlCol="0" anchor="ctr"/>
+          <a:lstStyle/>
+          <a:p>
+            <a:pPr indent="0" marL="0">
+              <a:buNone/>
+            </a:pPr>
+            <a:r>
+              <a:rPr lang="en-US" sz="1050" b="1" dirty="0">
+                <a:solidFill>
+                  <a:srgbClr val="E58E1A"/>
+                </a:solidFill>
+                <a:latin typeface="Courier New" pitchFamily="34" charset="0"/>
+                <a:ea typeface="Courier New" pitchFamily="34" charset="-122"/>
+                <a:cs typeface="Courier New" pitchFamily="34" charset="-120"/>
+              </a:rPr>
+              <a:t>[2]</a:t>
+            </a:r>
+            <a:endParaRPr lang="en-US" sz="1050" dirty="0"/>
+          </a:p>
+        </p:txBody>
+      </p:sp>
+      <p:sp>
+        <p:nvSpPr>
+          <p:cNvPr id="11" name="Text 9"/>
+          <p:cNvSpPr txBox="1"/>
+          <p:nvPr/>
+        </p:nvSpPr>
+        <p:spPr>
+          <a:xfrm>
+            <a:off x="960120" y="2130552"/>
+            <a:ext cx="5074920" cy="932688"/>
+          </a:xfrm>
+          <a:prstGeom prst="rect">
+            <a:avLst/>
+          </a:prstGeom>
+          <a:noFill/>
+          <a:ln/>
+        </p:spPr>
+        <p:txBody>
+          <a:bodyPr wrap="square" lIns="0" tIns="0" rIns="0" bIns="0" rtlCol="0" anchor="ctr"/>
+          <a:lstStyle/>
+          <a:p>
+            <a:pPr indent="0" marL="0">
+              <a:buNone/>
+            </a:pPr>
+            <a:r>
+              <a:rPr lang="en-US" sz="1000" dirty="0">
+                <a:solidFill>
+                  <a:srgbClr val="222A3F"/>
+                </a:solidFill>
+                <a:latin typeface="Arial" pitchFamily="34" charset="0"/>
+                <a:ea typeface="Arial" pitchFamily="34" charset="-122"/>
+                <a:cs typeface="Arial" pitchFamily="34" charset="-120"/>
+              </a:rPr>
+              <a:t>Semtech Corp., AN1200.22, LoRa Modulation Basics. Symbol duration T_sym = 2^SF / BW, packet airtime, and processing gain.</a:t>
+            </a:r>
+            <a:endParaRPr lang="en-US" sz="1000" dirty="0"/>
+          </a:p>
+        </p:txBody>
+      </p:sp>
+      <p:sp>
+        <p:nvSpPr>
+          <p:cNvPr id="12" name="Text 10"/>
+          <p:cNvSpPr txBox="1"/>
+          <p:nvPr/>
+        </p:nvSpPr>
+        <p:spPr>
+          <a:xfrm>
+            <a:off x="457200" y="3118104"/>
+            <a:ext cx="457200" cy="274320"/>
+          </a:xfrm>
+          <a:prstGeom prst="rect">
+            <a:avLst/>
+          </a:prstGeom>
+          <a:noFill/>
+          <a:ln/>
+        </p:spPr>
+        <p:txBody>
+          <a:bodyPr wrap="square" lIns="0" tIns="0" rIns="0" bIns="0" rtlCol="0" anchor="ctr"/>
+          <a:lstStyle/>
+          <a:p>
+            <a:pPr indent="0" marL="0">
+              <a:buNone/>
+            </a:pPr>
+            <a:r>
+              <a:rPr lang="en-US" sz="1050" b="1" dirty="0">
+                <a:solidFill>
+                  <a:srgbClr val="E58E1A"/>
+                </a:solidFill>
+                <a:latin typeface="Courier New" pitchFamily="34" charset="0"/>
+                <a:ea typeface="Courier New" pitchFamily="34" charset="-122"/>
+                <a:cs typeface="Courier New" pitchFamily="34" charset="-120"/>
+              </a:rPr>
+              <a:t>[3]</a:t>
+            </a:r>
+            <a:endParaRPr lang="en-US" sz="1050" dirty="0"/>
+          </a:p>
+        </p:txBody>
+      </p:sp>
+      <p:sp>
+        <p:nvSpPr>
+          <p:cNvPr id="13" name="Text 11"/>
+          <p:cNvSpPr txBox="1"/>
+          <p:nvPr/>
+        </p:nvSpPr>
+        <p:spPr>
+          <a:xfrm>
+            <a:off x="960120" y="3118104"/>
+            <a:ext cx="5074920" cy="932688"/>
+          </a:xfrm>
+          <a:prstGeom prst="rect">
+            <a:avLst/>
+          </a:prstGeom>
+          <a:noFill/>
+          <a:ln/>
+        </p:spPr>
+        <p:txBody>
+          <a:bodyPr wrap="square" lIns="0" tIns="0" rIns="0" bIns="0" rtlCol="0" anchor="ctr"/>
+          <a:lstStyle/>
+          <a:p>
+            <a:pPr indent="0" marL="0">
+              <a:buNone/>
+            </a:pPr>
+            <a:r>
+              <a:rPr lang="en-US" sz="1000" dirty="0">
+                <a:solidFill>
+                  <a:srgbClr val="222A3F"/>
+                </a:solidFill>
+                <a:latin typeface="Arial" pitchFamily="34" charset="0"/>
+                <a:ea typeface="Arial" pitchFamily="34" charset="-122"/>
+                <a:cs typeface="Arial" pitchFamily="34" charset="-120"/>
+              </a:rPr>
+              <a:t>Semtech Corp., SX1261/2 Transceiver Datasheet. The radio IC on the Heltec V4; sensitivity and transmit specifications.</a:t>
+            </a:r>
+            <a:endParaRPr lang="en-US" sz="1000" dirty="0"/>
+          </a:p>
+        </p:txBody>
+      </p:sp>
+      <p:sp>
+        <p:nvSpPr>
+          <p:cNvPr id="14" name="Text 12"/>
+          <p:cNvSpPr txBox="1"/>
+          <p:nvPr/>
+        </p:nvSpPr>
+        <p:spPr>
+          <a:xfrm>
+            <a:off x="457200" y="4105656"/>
+            <a:ext cx="457200" cy="274320"/>
+          </a:xfrm>
+          <a:prstGeom prst="rect">
+            <a:avLst/>
+          </a:prstGeom>
+          <a:noFill/>
+          <a:ln/>
+        </p:spPr>
+        <p:txBody>
+          <a:bodyPr wrap="square" lIns="0" tIns="0" rIns="0" bIns="0" rtlCol="0" anchor="ctr"/>
+          <a:lstStyle/>
+          <a:p>
+            <a:pPr indent="0" marL="0">
+              <a:buNone/>
+            </a:pPr>
+            <a:r>
+              <a:rPr lang="en-US" sz="1050" b="1" dirty="0">
+                <a:solidFill>
+                  <a:srgbClr val="E58E1A"/>
+                </a:solidFill>
+                <a:latin typeface="Courier New" pitchFamily="34" charset="0"/>
+                <a:ea typeface="Courier New" pitchFamily="34" charset="-122"/>
+                <a:cs typeface="Courier New" pitchFamily="34" charset="-120"/>
+              </a:rPr>
+              <a:t>[4]</a:t>
+            </a:r>
+            <a:endParaRPr lang="en-US" sz="1050" dirty="0"/>
+          </a:p>
+        </p:txBody>
+      </p:sp>
+      <p:sp>
+        <p:nvSpPr>
+          <p:cNvPr id="15" name="Text 13"/>
+          <p:cNvSpPr txBox="1"/>
+          <p:nvPr/>
+        </p:nvSpPr>
+        <p:spPr>
+          <a:xfrm>
+            <a:off x="960120" y="4105656"/>
+            <a:ext cx="5074920" cy="932688"/>
+          </a:xfrm>
+          <a:prstGeom prst="rect">
+            <a:avLst/>
+          </a:prstGeom>
+          <a:noFill/>
+          <a:ln/>
+        </p:spPr>
+        <p:txBody>
+          <a:bodyPr wrap="square" lIns="0" tIns="0" rIns="0" bIns="0" rtlCol="0" anchor="ctr"/>
+          <a:lstStyle/>
+          <a:p>
+            <a:pPr indent="0" marL="0">
+              <a:buNone/>
+            </a:pPr>
+            <a:r>
+              <a:rPr lang="en-US" sz="1000" dirty="0">
+                <a:solidFill>
+                  <a:srgbClr val="222A3F"/>
+                </a:solidFill>
+                <a:latin typeface="Arial" pitchFamily="34" charset="0"/>
+                <a:ea typeface="Arial" pitchFamily="34" charset="-122"/>
+                <a:cs typeface="Arial" pitchFamily="34" charset="-120"/>
+              </a:rPr>
+              <a:t>Meshtastic Project Documentation, LoRa and Position Configuration (meshtastic.org/docs). Modem presets, smart broadcast, position precision, and the ~25% channel-utilization transmit limit.</a:t>
+            </a:r>
+            <a:endParaRPr lang="en-US" sz="1000" dirty="0"/>
+          </a:p>
+        </p:txBody>
+      </p:sp>
+      <p:sp>
+        <p:nvSpPr>
+          <p:cNvPr id="16" name="Text 14"/>
+          <p:cNvSpPr txBox="1"/>
+          <p:nvPr/>
+        </p:nvSpPr>
+        <p:spPr>
+          <a:xfrm>
+            <a:off x="457200" y="5093208"/>
+            <a:ext cx="457200" cy="274320"/>
+          </a:xfrm>
+          <a:prstGeom prst="rect">
+            <a:avLst/>
+          </a:prstGeom>
+          <a:noFill/>
+          <a:ln/>
+        </p:spPr>
+        <p:txBody>
+          <a:bodyPr wrap="square" lIns="0" tIns="0" rIns="0" bIns="0" rtlCol="0" anchor="ctr"/>
+          <a:lstStyle/>
+          <a:p>
+            <a:pPr indent="0" marL="0">
+              <a:buNone/>
+            </a:pPr>
+            <a:r>
+              <a:rPr lang="en-US" sz="1050" b="1" dirty="0">
+                <a:solidFill>
+                  <a:srgbClr val="E58E1A"/>
+                </a:solidFill>
+                <a:latin typeface="Courier New" pitchFamily="34" charset="0"/>
+                <a:ea typeface="Courier New" pitchFamily="34" charset="-122"/>
+                <a:cs typeface="Courier New" pitchFamily="34" charset="-120"/>
+              </a:rPr>
+              <a:t>[5]</a:t>
+            </a:r>
+            <a:endParaRPr lang="en-US" sz="1050" dirty="0"/>
+          </a:p>
+        </p:txBody>
+      </p:sp>
+      <p:sp>
+        <p:nvSpPr>
+          <p:cNvPr id="17" name="Text 15"/>
+          <p:cNvSpPr txBox="1"/>
+          <p:nvPr/>
+        </p:nvSpPr>
+        <p:spPr>
+          <a:xfrm>
+            <a:off x="960120" y="5093208"/>
+            <a:ext cx="5074920" cy="932688"/>
+          </a:xfrm>
+          <a:prstGeom prst="rect">
+            <a:avLst/>
+          </a:prstGeom>
+          <a:noFill/>
+          <a:ln/>
+        </p:spPr>
+        <p:txBody>
+          <a:bodyPr wrap="square" lIns="0" tIns="0" rIns="0" bIns="0" rtlCol="0" anchor="ctr"/>
+          <a:lstStyle/>
+          <a:p>
+            <a:pPr indent="0" marL="0">
+              <a:buNone/>
+            </a:pPr>
+            <a:r>
+              <a:rPr lang="en-US" sz="1000" dirty="0">
+                <a:solidFill>
+                  <a:srgbClr val="222A3F"/>
+                </a:solidFill>
+                <a:latin typeface="Arial" pitchFamily="34" charset="0"/>
+                <a:ea typeface="Arial" pitchFamily="34" charset="-122"/>
+                <a:cs typeface="Arial" pitchFamily="34" charset="-120"/>
+              </a:rPr>
+              <a:t>Meshtastic Protobufs Repository (github.com/meshtastic/protobufs). The published message schema our decoder is generated from, including Position field units.</a:t>
+            </a:r>
+            <a:endParaRPr lang="en-US" sz="1000" dirty="0"/>
+          </a:p>
+        </p:txBody>
+      </p:sp>
+      <p:sp>
+        <p:nvSpPr>
+          <p:cNvPr id="18" name="Text 16"/>
+          <p:cNvSpPr txBox="1"/>
+          <p:nvPr/>
+        </p:nvSpPr>
+        <p:spPr>
+          <a:xfrm>
+            <a:off x="6263640" y="1143000"/>
+            <a:ext cx="457200" cy="274320"/>
+          </a:xfrm>
+          <a:prstGeom prst="rect">
+            <a:avLst/>
+          </a:prstGeom>
+          <a:noFill/>
+          <a:ln/>
+        </p:spPr>
+        <p:txBody>
+          <a:bodyPr wrap="square" lIns="0" tIns="0" rIns="0" bIns="0" rtlCol="0" anchor="ctr"/>
+          <a:lstStyle/>
+          <a:p>
+            <a:pPr indent="0" marL="0">
+              <a:buNone/>
+            </a:pPr>
+            <a:r>
+              <a:rPr lang="en-US" sz="1050" b="1" dirty="0">
+                <a:solidFill>
+                  <a:srgbClr val="E58E1A"/>
+                </a:solidFill>
+                <a:latin typeface="Courier New" pitchFamily="34" charset="0"/>
+                <a:ea typeface="Courier New" pitchFamily="34" charset="-122"/>
+                <a:cs typeface="Courier New" pitchFamily="34" charset="-120"/>
+              </a:rPr>
+              <a:t>[6]</a:t>
+            </a:r>
+            <a:endParaRPr lang="en-US" sz="1050" dirty="0"/>
+          </a:p>
+        </p:txBody>
+      </p:sp>
+      <p:sp>
+        <p:nvSpPr>
+          <p:cNvPr id="19" name="Text 17"/>
+          <p:cNvSpPr txBox="1"/>
+          <p:nvPr/>
+        </p:nvSpPr>
+        <p:spPr>
+          <a:xfrm>
+            <a:off x="6766560" y="1143000"/>
+            <a:ext cx="5074920" cy="932688"/>
+          </a:xfrm>
+          <a:prstGeom prst="rect">
+            <a:avLst/>
+          </a:prstGeom>
+          <a:noFill/>
+          <a:ln/>
+        </p:spPr>
+        <p:txBody>
+          <a:bodyPr wrap="square" lIns="0" tIns="0" rIns="0" bIns="0" rtlCol="0" anchor="ctr"/>
+          <a:lstStyle/>
+          <a:p>
+            <a:pPr indent="0" marL="0">
+              <a:buNone/>
+            </a:pPr>
+            <a:r>
+              <a:rPr lang="en-US" sz="1000" dirty="0">
+                <a:solidFill>
+                  <a:srgbClr val="222A3F"/>
+                </a:solidFill>
+                <a:latin typeface="Arial" pitchFamily="34" charset="0"/>
+                <a:ea typeface="Arial" pitchFamily="34" charset="-122"/>
+                <a:cs typeface="Arial" pitchFamily="34" charset="-120"/>
+              </a:rPr>
+              <a:t>FCC Rules, 47 CFR 15.247. Operation in the 902 to 928 MHz ISM band.</a:t>
+            </a:r>
+            <a:endParaRPr lang="en-US" sz="1000" dirty="0"/>
+          </a:p>
+        </p:txBody>
+      </p:sp>
+      <p:sp>
+        <p:nvSpPr>
+          <p:cNvPr id="20" name="Text 18"/>
+          <p:cNvSpPr txBox="1"/>
+          <p:nvPr/>
+        </p:nvSpPr>
+        <p:spPr>
+          <a:xfrm>
+            <a:off x="6263640" y="2130552"/>
+            <a:ext cx="457200" cy="274320"/>
+          </a:xfrm>
+          <a:prstGeom prst="rect">
+            <a:avLst/>
+          </a:prstGeom>
+          <a:noFill/>
+          <a:ln/>
+        </p:spPr>
+        <p:txBody>
+          <a:bodyPr wrap="square" lIns="0" tIns="0" rIns="0" bIns="0" rtlCol="0" anchor="ctr"/>
+          <a:lstStyle/>
+          <a:p>
+            <a:pPr indent="0" marL="0">
+              <a:buNone/>
+            </a:pPr>
+            <a:r>
+              <a:rPr lang="en-US" sz="1050" b="1" dirty="0">
+                <a:solidFill>
+                  <a:srgbClr val="E58E1A"/>
+                </a:solidFill>
+                <a:latin typeface="Courier New" pitchFamily="34" charset="0"/>
+                <a:ea typeface="Courier New" pitchFamily="34" charset="-122"/>
+                <a:cs typeface="Courier New" pitchFamily="34" charset="-120"/>
+              </a:rPr>
+              <a:t>[7]</a:t>
+            </a:r>
+            <a:endParaRPr lang="en-US" sz="1050" dirty="0"/>
+          </a:p>
+        </p:txBody>
+      </p:sp>
+      <p:sp>
+        <p:nvSpPr>
+          <p:cNvPr id="21" name="Text 19"/>
+          <p:cNvSpPr txBox="1"/>
+          <p:nvPr/>
+        </p:nvSpPr>
+        <p:spPr>
+          <a:xfrm>
+            <a:off x="6766560" y="2130552"/>
+            <a:ext cx="5074920" cy="932688"/>
+          </a:xfrm>
+          <a:prstGeom prst="rect">
+            <a:avLst/>
+          </a:prstGeom>
+          <a:noFill/>
+          <a:ln/>
+        </p:spPr>
+        <p:txBody>
+          <a:bodyPr wrap="square" lIns="0" tIns="0" rIns="0" bIns="0" rtlCol="0" anchor="ctr"/>
+          <a:lstStyle/>
+          <a:p>
+            <a:pPr indent="0" marL="0">
+              <a:buNone/>
+            </a:pPr>
+            <a:r>
+              <a:rPr lang="en-US" sz="1000" dirty="0">
+                <a:solidFill>
+                  <a:srgbClr val="222A3F"/>
+                </a:solidFill>
+                <a:latin typeface="Arial" pitchFamily="34" charset="0"/>
+                <a:ea typeface="Arial" pitchFamily="34" charset="-122"/>
+                <a:cs typeface="Arial" pitchFamily="34" charset="-120"/>
+              </a:rPr>
+              <a:t>ITU-R Recommendation M.1371, Automatic Identification System (AIS). Vessel reporting intervals of 2 s to 3 min; the precedent for beacon-then-animate navigation displays.</a:t>
+            </a:r>
+            <a:endParaRPr lang="en-US" sz="1000" dirty="0"/>
+          </a:p>
+        </p:txBody>
+      </p:sp>
+      <p:sp>
+        <p:nvSpPr>
+          <p:cNvPr id="22" name="Text 20"/>
+          <p:cNvSpPr txBox="1"/>
+          <p:nvPr/>
+        </p:nvSpPr>
+        <p:spPr>
+          <a:xfrm>
+            <a:off x="6263640" y="3118104"/>
+            <a:ext cx="457200" cy="274320"/>
+          </a:xfrm>
+          <a:prstGeom prst="rect">
+            <a:avLst/>
+          </a:prstGeom>
+          <a:noFill/>
+          <a:ln/>
+        </p:spPr>
+        <p:txBody>
+          <a:bodyPr wrap="square" lIns="0" tIns="0" rIns="0" bIns="0" rtlCol="0" anchor="ctr"/>
+          <a:lstStyle/>
+          <a:p>
+            <a:pPr indent="0" marL="0">
+              <a:buNone/>
+            </a:pPr>
+            <a:r>
+              <a:rPr lang="en-US" sz="1050" b="1" dirty="0">
+                <a:solidFill>
+                  <a:srgbClr val="E58E1A"/>
+                </a:solidFill>
+                <a:latin typeface="Courier New" pitchFamily="34" charset="0"/>
+                <a:ea typeface="Courier New" pitchFamily="34" charset="-122"/>
+                <a:cs typeface="Courier New" pitchFamily="34" charset="-120"/>
+              </a:rPr>
+              <a:t>[8]</a:t>
+            </a:r>
+            <a:endParaRPr lang="en-US" sz="1050" dirty="0"/>
+          </a:p>
+        </p:txBody>
+      </p:sp>
+      <p:sp>
+        <p:nvSpPr>
+          <p:cNvPr id="23" name="Text 21"/>
+          <p:cNvSpPr txBox="1"/>
+          <p:nvPr/>
+        </p:nvSpPr>
+        <p:spPr>
+          <a:xfrm>
+            <a:off x="6766560" y="3118104"/>
+            <a:ext cx="5074920" cy="932688"/>
+          </a:xfrm>
+          <a:prstGeom prst="rect">
+            <a:avLst/>
+          </a:prstGeom>
+          <a:noFill/>
+          <a:ln/>
+        </p:spPr>
+        <p:txBody>
+          <a:bodyPr wrap="square" lIns="0" tIns="0" rIns="0" bIns="0" rtlCol="0" anchor="ctr"/>
+          <a:lstStyle/>
+          <a:p>
+            <a:pPr indent="0" marL="0">
+              <a:buNone/>
+            </a:pPr>
+            <a:r>
+              <a:rPr lang="en-US" sz="1000" dirty="0">
+                <a:solidFill>
+                  <a:srgbClr val="222A3F"/>
+                </a:solidFill>
+                <a:latin typeface="Arial" pitchFamily="34" charset="0"/>
+                <a:ea typeface="Arial" pitchFamily="34" charset="-122"/>
+                <a:cs typeface="Arial" pitchFamily="34" charset="-120"/>
+              </a:rPr>
+              <a:t>R. W. Sinnott, Virtues of the Haversine, Sky &amp; Telescope, vol. 68, no. 2, p. 159, 1984. The great-circle distance formula used in nav.c.</a:t>
+            </a:r>
+            <a:endParaRPr lang="en-US" sz="1000" dirty="0"/>
+          </a:p>
+        </p:txBody>
+      </p:sp>
+      <p:sp>
+        <p:nvSpPr>
+          <p:cNvPr id="24" name="Text 22"/>
+          <p:cNvSpPr txBox="1"/>
+          <p:nvPr/>
+        </p:nvSpPr>
+        <p:spPr>
+          <a:xfrm>
+            <a:off x="6263640" y="4105656"/>
+            <a:ext cx="457200" cy="274320"/>
+          </a:xfrm>
+          <a:prstGeom prst="rect">
+            <a:avLst/>
+          </a:prstGeom>
+          <a:noFill/>
+          <a:ln/>
+        </p:spPr>
+        <p:txBody>
+          <a:bodyPr wrap="square" lIns="0" tIns="0" rIns="0" bIns="0" rtlCol="0" anchor="ctr"/>
+          <a:lstStyle/>
+          <a:p>
+            <a:pPr indent="0" marL="0">
+              <a:buNone/>
+            </a:pPr>
+            <a:r>
+              <a:rPr lang="en-US" sz="1050" b="1" dirty="0">
+                <a:solidFill>
+                  <a:srgbClr val="E58E1A"/>
+                </a:solidFill>
+                <a:latin typeface="Courier New" pitchFamily="34" charset="0"/>
+                <a:ea typeface="Courier New" pitchFamily="34" charset="-122"/>
+                <a:cs typeface="Courier New" pitchFamily="34" charset="-120"/>
+              </a:rPr>
+              <a:t>[9]</a:t>
+            </a:r>
+            <a:endParaRPr lang="en-US" sz="1050" dirty="0"/>
+          </a:p>
+        </p:txBody>
+      </p:sp>
+      <p:sp>
+        <p:nvSpPr>
+          <p:cNvPr id="25" name="Text 23"/>
+          <p:cNvSpPr txBox="1"/>
+          <p:nvPr/>
+        </p:nvSpPr>
+        <p:spPr>
+          <a:xfrm>
+            <a:off x="6766560" y="4105656"/>
+            <a:ext cx="5074920" cy="932688"/>
+          </a:xfrm>
+          <a:prstGeom prst="rect">
+            <a:avLst/>
+          </a:prstGeom>
+          <a:noFill/>
+          <a:ln/>
+        </p:spPr>
+        <p:txBody>
+          <a:bodyPr wrap="square" lIns="0" tIns="0" rIns="0" bIns="0" rtlCol="0" anchor="ctr"/>
+          <a:lstStyle/>
+          <a:p>
+            <a:pPr indent="0" marL="0">
+              <a:buNone/>
+            </a:pPr>
+            <a:r>
+              <a:rPr lang="en-US" sz="1000" dirty="0">
+                <a:solidFill>
+                  <a:srgbClr val="222A3F"/>
+                </a:solidFill>
+                <a:latin typeface="Arial" pitchFamily="34" charset="0"/>
+                <a:ea typeface="Arial" pitchFamily="34" charset="-122"/>
+                <a:cs typeface="Arial" pitchFamily="34" charset="-120"/>
+              </a:rPr>
+              <a:t>Bluetooth SIG, Bluetooth Core Specification (GATT). The service and characteristic model behind the Meshtastic Client API.</a:t>
+            </a:r>
+            <a:endParaRPr lang="en-US" sz="1000" dirty="0"/>
+          </a:p>
+        </p:txBody>
+      </p:sp>
+      <p:sp>
+        <p:nvSpPr>
+          <p:cNvPr id="26" name="Text 24"/>
+          <p:cNvSpPr txBox="1"/>
+          <p:nvPr/>
+        </p:nvSpPr>
+        <p:spPr>
+          <a:xfrm>
+            <a:off x="6263640" y="5093208"/>
+            <a:ext cx="457200" cy="274320"/>
+          </a:xfrm>
+          <a:prstGeom prst="rect">
+            <a:avLst/>
+          </a:prstGeom>
+          <a:noFill/>
+          <a:ln/>
+        </p:spPr>
+        <p:txBody>
+          <a:bodyPr wrap="square" lIns="0" tIns="0" rIns="0" bIns="0" rtlCol="0" anchor="ctr"/>
+          <a:lstStyle/>
+          <a:p>
+            <a:pPr indent="0" marL="0">
+              <a:buNone/>
+            </a:pPr>
+            <a:r>
+              <a:rPr lang="en-US" sz="1050" b="1" dirty="0">
+                <a:solidFill>
+                  <a:srgbClr val="E58E1A"/>
+                </a:solidFill>
+                <a:latin typeface="Courier New" pitchFamily="34" charset="0"/>
+                <a:ea typeface="Courier New" pitchFamily="34" charset="-122"/>
+                <a:cs typeface="Courier New" pitchFamily="34" charset="-120"/>
+              </a:rPr>
+              <a:t>[10]</a:t>
+            </a:r>
+            <a:endParaRPr lang="en-US" sz="1050" dirty="0"/>
+          </a:p>
+        </p:txBody>
+      </p:sp>
+      <p:sp>
+        <p:nvSpPr>
+          <p:cNvPr id="27" name="Text 25"/>
+          <p:cNvSpPr txBox="1"/>
+          <p:nvPr/>
+        </p:nvSpPr>
+        <p:spPr>
+          <a:xfrm>
+            <a:off x="6766560" y="5093208"/>
+            <a:ext cx="5074920" cy="932688"/>
+          </a:xfrm>
+          <a:prstGeom prst="rect">
+            <a:avLst/>
+          </a:prstGeom>
+          <a:noFill/>
+          <a:ln/>
+        </p:spPr>
+        <p:txBody>
+          <a:bodyPr wrap="square" lIns="0" tIns="0" rIns="0" bIns="0" rtlCol="0" anchor="ctr"/>
+          <a:lstStyle/>
+          <a:p>
+            <a:pPr indent="0" marL="0">
+              <a:buNone/>
+            </a:pPr>
+            <a:r>
+              <a:rPr lang="en-US" sz="1000" dirty="0">
+                <a:solidFill>
+                  <a:srgbClr val="222A3F"/>
+                </a:solidFill>
+                <a:latin typeface="Arial" pitchFamily="34" charset="0"/>
+                <a:ea typeface="Arial" pitchFamily="34" charset="-122"/>
+                <a:cs typeface="Arial" pitchFamily="34" charset="-120"/>
+              </a:rPr>
+              <a:t>Group 9 repository: docs/TELECOM_ANALYSIS.md, docs/ARCHITECTURE.md, docs/BLE_LINK_WALKTHROUGH.md, hardware/README.md. The project's own link budget, architecture, protocol walkthrough, and provisioning recipe.</a:t>
+            </a:r>
+            <a:endParaRPr lang="en-US" sz="1000" dirty="0"/>
+          </a:p>
+        </p:txBody>
+      </p:sp>
+      <p:sp>
+        <p:nvSpPr>
+          <p:cNvPr id="28" name="Shape 26"/>
+          <p:cNvSpPr/>
+          <p:nvPr/>
+        </p:nvSpPr>
+        <p:spPr>
+          <a:xfrm>
+            <a:off x="457200" y="5989320"/>
+            <a:ext cx="11292840" cy="0"/>
+          </a:xfrm>
+          <a:prstGeom prst="line">
+            <a:avLst/>
+          </a:prstGeom>
+          <a:noFill/>
+          <a:ln w="9525">
+            <a:solidFill>
+              <a:srgbClr val="9AA7BE"/>
+            </a:solidFill>
+            <a:prstDash val="solid"/>
+          </a:ln>
+        </p:spPr>
+      </p:sp>
+      <p:sp>
+        <p:nvSpPr>
+          <p:cNvPr id="29" name="Text 27"/>
+          <p:cNvSpPr txBox="1"/>
+          <p:nvPr/>
+        </p:nvSpPr>
+        <p:spPr>
+          <a:xfrm>
+            <a:off x="457200" y="6035040"/>
+            <a:ext cx="11292840" cy="237744"/>
+          </a:xfrm>
+          <a:prstGeom prst="rect">
+            <a:avLst/>
+          </a:prstGeom>
+          <a:noFill/>
+          <a:ln/>
+        </p:spPr>
+        <p:txBody>
+          <a:bodyPr wrap="square" lIns="0" tIns="0" rIns="0" bIns="0" rtlCol="0" anchor="ctr"/>
+          <a:lstStyle/>
+          <a:p>
+            <a:pPr indent="0" marL="0">
+              <a:buNone/>
+            </a:pPr>
+            <a:r>
+              <a:rPr lang="en-US" sz="850" dirty="0">
+                <a:solidFill>
+                  <a:srgbClr val="5E6B85"/>
+                </a:solidFill>
+                <a:latin typeface="Courier New" pitchFamily="34" charset="0"/>
+                <a:ea typeface="Courier New" pitchFamily="34" charset="-122"/>
+                <a:cs typeface="Courier New" pitchFamily="34" charset="-120"/>
+              </a:rPr>
+              <a:t>All firmware, documentation, logs, and this deck's generator are version controlled at github.com/deosgracius/offgrid-vehicle-tracker</a:t>
+            </a:r>
+            <a:endParaRPr lang="en-US" sz="850" dirty="0"/>
           </a:p>
         </p:txBody>
       </p:sp>
@@ -6802,7 +9559,7 @@
                 <a:ea typeface="Courier New" pitchFamily="34" charset="-122"/>
                 <a:cs typeface="Courier New" pitchFamily="34" charset="-120"/>
               </a:rPr>
-              <a:t>SHEET 02/11  REV C  2026-09-07</a:t>
+              <a:t>SHEET 02/13  REV C  2026-09-07</a:t>
             </a:r>
             <a:endParaRPr lang="en-US" sz="900" dirty="0"/>
           </a:p>
@@ -7366,7 +10123,7 @@
                 <a:ea typeface="Courier New" pitchFamily="34" charset="-122"/>
                 <a:cs typeface="Courier New" pitchFamily="34" charset="-120"/>
               </a:rPr>
-              <a:t>SHEET 03/11  REV C  2026-09-07</a:t>
+              <a:t>SHEET 03/13  REV C  2026-09-07</a:t>
             </a:r>
             <a:endParaRPr lang="en-US" sz="900" dirty="0"/>
           </a:p>
@@ -7791,7 +10548,7 @@
                 <a:ea typeface="Courier New" pitchFamily="34" charset="-122"/>
                 <a:cs typeface="Courier New" pitchFamily="34" charset="-120"/>
               </a:rPr>
-              <a:t>SHEET 04/11  REV C  2026-09-07</a:t>
+              <a:t>SHEET 04/13  REV C  2026-09-07</a:t>
             </a:r>
             <a:endParaRPr lang="en-US" sz="900" dirty="0"/>
           </a:p>
@@ -8913,7 +11670,7 @@
                 <a:ea typeface="Courier New" pitchFamily="34" charset="-122"/>
                 <a:cs typeface="Courier New" pitchFamily="34" charset="-120"/>
               </a:rPr>
-              <a:t>SHEET 05/11  REV C  2026-09-07</a:t>
+              <a:t>SHEET 05/13  REV C  2026-09-07</a:t>
             </a:r>
             <a:endParaRPr lang="en-US" sz="900" dirty="0"/>
           </a:p>
@@ -10011,7 +12768,7 @@
                 <a:ea typeface="Courier New" pitchFamily="34" charset="-122"/>
                 <a:cs typeface="Courier New" pitchFamily="34" charset="-120"/>
               </a:rPr>
-              <a:t>SHEET 06/11  REV C  2026-09-07</a:t>
+              <a:t>SHEET 06/13  REV C  2026-09-07</a:t>
             </a:r>
             <a:endParaRPr lang="en-US" sz="900" dirty="0"/>
           </a:p>
@@ -10815,7 +13572,7 @@
                 <a:ea typeface="Courier New" pitchFamily="34" charset="-122"/>
                 <a:cs typeface="Courier New" pitchFamily="34" charset="-120"/>
               </a:rPr>
-              <a:t>SHEET 07/11  REV C  2026-09-07</a:t>
+              <a:t>SHEET 07/13  REV C  2026-09-07</a:t>
             </a:r>
             <a:endParaRPr lang="en-US" sz="900" dirty="0"/>
           </a:p>
@@ -11533,7 +14290,7 @@
                 <a:ea typeface="Courier New" pitchFamily="34" charset="-122"/>
                 <a:cs typeface="Courier New" pitchFamily="34" charset="-120"/>
               </a:rPr>
-              <a:t>SHEET 08/11  REV C  2026-09-07</a:t>
+              <a:t>SHEET 08/13  REV C  2026-09-07</a:t>
             </a:r>
             <a:endParaRPr lang="en-US" sz="900" dirty="0"/>
           </a:p>
@@ -12224,7 +14981,7 @@
                 <a:ea typeface="Courier New" pitchFamily="34" charset="-122"/>
                 <a:cs typeface="Courier New" pitchFamily="34" charset="-120"/>
               </a:rPr>
-              <a:t>SHEET 09/11  REV C  2026-09-07</a:t>
+              <a:t>SHEET 09/13  REV C  2026-09-07</a:t>
             </a:r>
             <a:endParaRPr lang="en-US" sz="900" dirty="0"/>
           </a:p>

</xml_diff>

<commit_message>
Sheet 10 position cross-check via Meshtastic web client + ref links
Cannon sheet now carries the accuracy argument: the display photo and
the Meshtastic web client map screenshot show the same fix read from
the same radio by two independent programs (node ead4, connected,
firmware confirmed in the sidebar). References sheet and briefing gain
direct links for all ten citations.

Co-Authored-By: Claude Fable 5 <noreply@anthropic.com>
</commit_message>
<xml_diff>
--- a/docs/presentations/Group9_Presentation3_Week3.pptx
+++ b/docs/presentations/Group9_Presentation3_Week3.pptx
@@ -5955,7 +5955,7 @@
       </p:sp>
       <p:pic>
         <p:nvPicPr>
-          <p:cNvPr id="34" name="Image 0" descr="C:/Users/deogr/AppData/Local/Temp/claude/C--Users-deogr-Documents-Fall-Project-Off-Grid-Vehicle-dection-project/e8b2e8fa-1513-4aa8-a8f6-ce4fcd20e664/scratchpad/deck3/p_search.jpg">    </p:cNvPr>
+          <p:cNvPr id="34" name="Image 0" descr="C:/Users/deogr/AppData/Local/Temp/claude/C--Users-deogr-Documents-Fall-Project-Off-Grid-Vehicle-dection-project/e8b2e8fa-1513-4aa8-a8f6-ce4fcd20e664/scratchpad/deck3/p_overall.jpg">    </p:cNvPr>
           <p:cNvPicPr>
             <a:picLocks noChangeAspect="1"/>
           </p:cNvPicPr>
@@ -5970,7 +5970,7 @@
         <p:spPr>
           <a:xfrm>
             <a:off x="6537960" y="1097280"/>
-            <a:ext cx="2468880" cy="1938528"/>
+            <a:ext cx="2468880" cy="1773936"/>
           </a:xfrm>
           <a:prstGeom prst="rect">
             <a:avLst/>
@@ -5986,7 +5986,7 @@
         <p:spPr>
           <a:xfrm>
             <a:off x="6537960" y="1097280"/>
-            <a:ext cx="2468880" cy="1938528"/>
+            <a:ext cx="2468880" cy="1773936"/>
           </a:xfrm>
           <a:prstGeom prst="rect">
             <a:avLst/>
@@ -6007,7 +6007,7 @@
         </p:nvSpPr>
         <p:spPr>
           <a:xfrm>
-            <a:off x="6537960" y="3063240"/>
+            <a:off x="6537960" y="2898648"/>
             <a:ext cx="2468880" cy="274320"/>
           </a:xfrm>
           <a:prstGeom prst="rect">
@@ -6032,15 +6032,157 @@
                 <a:ea typeface="Courier New" pitchFamily="34" charset="-122"/>
                 <a:cs typeface="Courier New" pitchFamily="34" charset="-120"/>
               </a:rPr>
-              <a:t>Boot state: link and GPS proven before any partner exists</a:t>
+              <a:t>Our display: ME 33.60719 -101.89643</a:t>
             </a:r>
             <a:endParaRPr lang="en-US" sz="950" dirty="0"/>
+          </a:p>
+        </p:txBody>
+      </p:sp>
+      <p:sp>
+        <p:nvSpPr>
+          <p:cNvPr id="37" name="Shape 34"/>
+          <p:cNvSpPr/>
+          <p:nvPr/>
+        </p:nvSpPr>
+        <p:spPr>
+          <a:xfrm>
+            <a:off x="9144000" y="1097280"/>
+            <a:ext cx="2606040" cy="2066544"/>
+          </a:xfrm>
+          <a:prstGeom prst="rect">
+            <a:avLst/>
+          </a:prstGeom>
+          <a:solidFill>
+            <a:srgbClr val="F2F5FA"/>
+          </a:solidFill>
+          <a:ln w="15875">
+            <a:solidFill>
+              <a:srgbClr val="1F9D68"/>
+            </a:solidFill>
+            <a:prstDash val="solid"/>
+          </a:ln>
+        </p:spPr>
+      </p:sp>
+      <p:sp>
+        <p:nvSpPr>
+          <p:cNvPr id="38" name="Text 35"/>
+          <p:cNvSpPr txBox="1"/>
+          <p:nvPr/>
+        </p:nvSpPr>
+        <p:spPr>
+          <a:xfrm>
+            <a:off x="9281160" y="1207008"/>
+            <a:ext cx="2377440" cy="274320"/>
+          </a:xfrm>
+          <a:prstGeom prst="rect">
+            <a:avLst/>
+          </a:prstGeom>
+          <a:noFill/>
+          <a:ln/>
+        </p:spPr>
+        <p:txBody>
+          <a:bodyPr wrap="square" lIns="0" tIns="0" rIns="0" bIns="0" rtlCol="0" anchor="ctr"/>
+          <a:lstStyle/>
+          <a:p>
+            <a:pPr indent="0" marL="0">
+              <a:buNone/>
+            </a:pPr>
+            <a:r>
+              <a:rPr lang="en-US" sz="1050" b="1" spc="100" kern="0" dirty="0">
+                <a:solidFill>
+                  <a:srgbClr val="1F9D68"/>
+                </a:solidFill>
+                <a:latin typeface="Arial" pitchFamily="34" charset="0"/>
+                <a:ea typeface="Arial" pitchFamily="34" charset="-122"/>
+                <a:cs typeface="Arial" pitchFamily="34" charset="-120"/>
+              </a:rPr>
+              <a:t>POSITION CROSS-CHECK</a:t>
+            </a:r>
+            <a:endParaRPr lang="en-US" sz="1050" dirty="0"/>
+          </a:p>
+        </p:txBody>
+      </p:sp>
+      <p:sp>
+        <p:nvSpPr>
+          <p:cNvPr id="39" name="Text 36"/>
+          <p:cNvSpPr txBox="1"/>
+          <p:nvPr/>
+        </p:nvSpPr>
+        <p:spPr>
+          <a:xfrm>
+            <a:off x="9281160" y="1499616"/>
+            <a:ext cx="2377440" cy="1609344"/>
+          </a:xfrm>
+          <a:prstGeom prst="rect">
+            <a:avLst/>
+          </a:prstGeom>
+          <a:noFill/>
+          <a:ln/>
+        </p:spPr>
+        <p:txBody>
+          <a:bodyPr wrap="square" lIns="0" tIns="0" rIns="0" bIns="0" rtlCol="0" anchor="ctr"/>
+          <a:lstStyle/>
+          <a:p>
+            <a:pPr indent="0" marL="0">
+              <a:buNone/>
+            </a:pPr>
+            <a:r>
+              <a:rPr lang="en-US" sz="950" dirty="0">
+                <a:solidFill>
+                  <a:srgbClr val="222A3F"/>
+                </a:solidFill>
+                <a:latin typeface="Arial" pitchFamily="34" charset="0"/>
+                <a:ea typeface="Arial" pitchFamily="34" charset="-122"/>
+                <a:cs typeface="Arial" pitchFamily="34" charset="-120"/>
+              </a:rPr>
+              <a:t>The fix on our display and the marker on the standard Meshtastic web client are the same position, read from the same radio by two independent programs. Agreement between clients that share no code is the accuracy check. Radio two will fill the PTR row through this same pipeline.</a:t>
+            </a:r>
+            <a:endParaRPr lang="en-US" sz="950" dirty="0"/>
+          </a:p>
+        </p:txBody>
+      </p:sp>
+      <p:sp>
+        <p:nvSpPr>
+          <p:cNvPr id="40" name="Text 37"/>
+          <p:cNvSpPr txBox="1"/>
+          <p:nvPr/>
+        </p:nvSpPr>
+        <p:spPr>
+          <a:xfrm>
+            <a:off x="6537960" y="3273552"/>
+            <a:ext cx="5212080" cy="237744"/>
+          </a:xfrm>
+          <a:prstGeom prst="rect">
+            <a:avLst/>
+          </a:prstGeom>
+          <a:noFill/>
+          <a:ln/>
+        </p:spPr>
+        <p:txBody>
+          <a:bodyPr wrap="square" lIns="0" tIns="0" rIns="0" bIns="0" rtlCol="0" anchor="ctr"/>
+          <a:lstStyle/>
+          <a:p>
+            <a:pPr indent="0" marL="0">
+              <a:buNone/>
+            </a:pPr>
+            <a:r>
+              <a:rPr lang="en-US" sz="850" b="1" dirty="0">
+                <a:solidFill>
+                  <a:srgbClr val="5E6B85"/>
+                </a:solidFill>
+                <a:latin typeface="Courier New" pitchFamily="34" charset="0"/>
+                <a:ea typeface="Courier New" pitchFamily="34" charset="-122"/>
+                <a:cs typeface="Courier New" pitchFamily="34" charset="-120"/>
+              </a:rPr>
+              <a:t>INDEPENDENT CLIENT: MESHTASTIC WEB APP, SAME RADIO, NODE ead4 CONNECTED</a:t>
+            </a:r>
+            <a:endParaRPr lang="en-US" sz="850" dirty="0"/>
           </a:p>
         </p:txBody>
       </p:sp>
       <p:pic>
         <p:nvPicPr>
-          <p:cNvPr id="37" name="Image 1" descr="C:/Users/deogr/AppData/Local/Temp/claude/C--Users-deogr-Documents-Fall-Project-Off-Grid-Vehicle-dection-project/e8b2e8fa-1513-4aa8-a8f6-ce4fcd20e664/scratchpad/deck3/p_overall.jpg">    </p:cNvPr>
+          <p:cNvPr id="41" name="Image 1" descr="C:/Users/deogr/AppData/Local/Temp/claude/C--Users-deogr-Documents-Fall-Project-Off-Grid-Vehicle-dection-project/e8b2e8fa-1513-4aa8-a8f6-ce4fcd20e664/scratchpad/deck3/p_map.png">    </p:cNvPr>
           <p:cNvPicPr>
             <a:picLocks noChangeAspect="1"/>
           </p:cNvPicPr>
@@ -6054,8 +6196,8 @@
         </p:blipFill>
         <p:spPr>
           <a:xfrm>
-            <a:off x="9189720" y="1097280"/>
-            <a:ext cx="2560320" cy="1847088"/>
+            <a:off x="6537960" y="3529584"/>
+            <a:ext cx="3703320" cy="2670048"/>
           </a:xfrm>
           <a:prstGeom prst="rect">
             <a:avLst/>
@@ -6064,14 +6206,14 @@
       </p:pic>
       <p:sp>
         <p:nvSpPr>
-          <p:cNvPr id="38" name="Shape 34"/>
+          <p:cNvPr id="42" name="Shape 38"/>
           <p:cNvSpPr/>
           <p:nvPr/>
         </p:nvSpPr>
         <p:spPr>
           <a:xfrm>
-            <a:off x="9189720" y="1097280"/>
-            <a:ext cx="2560320" cy="1847088"/>
+            <a:off x="6537960" y="3529584"/>
+            <a:ext cx="3703320" cy="2670048"/>
           </a:xfrm>
           <a:prstGeom prst="rect">
             <a:avLst/>
@@ -6086,186 +6228,40 @@
       </p:sp>
       <p:sp>
         <p:nvSpPr>
-          <p:cNvPr id="39" name="Text 35"/>
-          <p:cNvSpPr txBox="1"/>
-          <p:nvPr/>
-        </p:nvSpPr>
-        <p:spPr>
-          <a:xfrm>
-            <a:off x="9189720" y="2971800"/>
-            <a:ext cx="2560320" cy="274320"/>
-          </a:xfrm>
-          <a:prstGeom prst="rect">
-            <a:avLst/>
-          </a:prstGeom>
-          <a:noFill/>
-          <a:ln/>
-        </p:spPr>
-        <p:txBody>
-          <a:bodyPr wrap="square" lIns="0" tIns="0" rIns="0" bIns="0" rtlCol="0" anchor="ctr"/>
-          <a:lstStyle/>
-          <a:p>
-            <a:pPr algn="ctr" indent="0" marL="0">
-              <a:buNone/>
-            </a:pPr>
-            <a:r>
-              <a:rPr lang="en-US" sz="950" dirty="0">
+          <p:cNvPr id="43" name="Text 39"/>
+          <p:cNvSpPr txBox="1"/>
+          <p:nvPr/>
+        </p:nvSpPr>
+        <p:spPr>
+          <a:xfrm>
+            <a:off x="10378440" y="3529584"/>
+            <a:ext cx="1371600" cy="2670048"/>
+          </a:xfrm>
+          <a:prstGeom prst="rect">
+            <a:avLst/>
+          </a:prstGeom>
+          <a:noFill/>
+          <a:ln/>
+        </p:spPr>
+        <p:txBody>
+          <a:bodyPr wrap="square" lIns="0" tIns="0" rIns="0" bIns="0" rtlCol="0" anchor="ctr"/>
+          <a:lstStyle/>
+          <a:p>
+            <a:pPr indent="0" marL="0">
+              <a:buNone/>
+            </a:pPr>
+            <a:r>
+              <a:rPr lang="en-US" sz="900" dirty="0">
                 <a:solidFill>
                   <a:srgbClr val="5E6B85"/>
-                </a:solidFill>
-                <a:latin typeface="Courier New" pitchFamily="34" charset="0"/>
-                <a:ea typeface="Courier New" pitchFamily="34" charset="-122"/>
-                <a:cs typeface="Courier New" pitchFamily="34" charset="-120"/>
-              </a:rPr>
-              <a:t>Live self fix decoded end to end; the gap is labeled honestly</a:t>
-            </a:r>
-            <a:endParaRPr lang="en-US" sz="950" dirty="0"/>
-          </a:p>
-        </p:txBody>
-      </p:sp>
-      <p:sp>
-        <p:nvSpPr>
-          <p:cNvPr id="40" name="Shape 36"/>
-          <p:cNvSpPr/>
-          <p:nvPr/>
-        </p:nvSpPr>
-        <p:spPr>
-          <a:xfrm>
-            <a:off x="6537960" y="3566160"/>
-            <a:ext cx="5212080" cy="2514600"/>
-          </a:xfrm>
-          <a:prstGeom prst="rect">
-            <a:avLst/>
-          </a:prstGeom>
-          <a:solidFill>
-            <a:srgbClr val="F2F5FA"/>
-          </a:solidFill>
-          <a:ln w="9525">
-            <a:solidFill>
-              <a:srgbClr val="9AA7BE"/>
-            </a:solidFill>
-            <a:prstDash val="solid"/>
-          </a:ln>
-        </p:spPr>
-      </p:sp>
-      <p:sp>
-        <p:nvSpPr>
-          <p:cNvPr id="41" name="Text 37"/>
-          <p:cNvSpPr txBox="1"/>
-          <p:nvPr/>
-        </p:nvSpPr>
-        <p:spPr>
-          <a:xfrm>
-            <a:off x="6720840" y="3703320"/>
-            <a:ext cx="4846320" cy="274320"/>
-          </a:xfrm>
-          <a:prstGeom prst="rect">
-            <a:avLst/>
-          </a:prstGeom>
-          <a:noFill/>
-          <a:ln/>
-        </p:spPr>
-        <p:txBody>
-          <a:bodyPr wrap="square" lIns="0" tIns="0" rIns="0" bIns="0" rtlCol="0" anchor="ctr"/>
-          <a:lstStyle/>
-          <a:p>
-            <a:pPr indent="0" marL="0">
-              <a:buNone/>
-            </a:pPr>
-            <a:r>
-              <a:rPr lang="en-US" sz="1150" b="1" spc="100" kern="0" dirty="0">
-                <a:solidFill>
-                  <a:srgbClr val="16213D"/>
                 </a:solidFill>
                 <a:latin typeface="Arial" pitchFamily="34" charset="0"/>
                 <a:ea typeface="Arial" pitchFamily="34" charset="-122"/>
                 <a:cs typeface="Arial" pitchFamily="34" charset="-120"/>
               </a:rPr>
-              <a:t>THE ONE-DEVICE TEST STRATEGY</a:t>
-            </a:r>
-            <a:endParaRPr lang="en-US" sz="1150" dirty="0"/>
-          </a:p>
-        </p:txBody>
-      </p:sp>
-      <p:sp>
-        <p:nvSpPr>
-          <p:cNvPr id="42" name="Text 38"/>
-          <p:cNvSpPr txBox="1"/>
-          <p:nvPr/>
-        </p:nvSpPr>
-        <p:spPr>
-          <a:xfrm>
-            <a:off x="6720840" y="4023360"/>
-            <a:ext cx="4892040" cy="2011680"/>
-          </a:xfrm>
-          <a:prstGeom prst="rect">
-            <a:avLst/>
-          </a:prstGeom>
-          <a:noFill/>
-          <a:ln/>
-        </p:spPr>
-        <p:txBody>
-          <a:bodyPr wrap="square" lIns="0" tIns="0" rIns="0" bIns="0" rtlCol="0" anchor="ctr"/>
-          <a:lstStyle/>
-          <a:p>
-            <a:pPr marL="342900" indent="-342900">
-              <a:spcAft>
-                <a:spcPts val="600"/>
-              </a:spcAft>
-              <a:buSzPct val="100000"/>
-              <a:buChar char="▪"/>
-            </a:pPr>
-            <a:r>
-              <a:rPr lang="en-US" sz="1050" dirty="0">
-                <a:solidFill>
-                  <a:srgbClr val="222A3F"/>
-                </a:solidFill>
-                <a:latin typeface="Arial" pitchFamily="34" charset="0"/>
-                <a:ea typeface="Arial" pitchFamily="34" charset="-122"/>
-                <a:cs typeface="Arial" pitchFamily="34" charset="-120"/>
-              </a:rPr>
-              <a:t>These photos are the integration milestone: backend and frontend running as one firmware on real hardware, with every layer except the last one exercised.</a:t>
-            </a:r>
-            <a:endParaRPr lang="en-US" sz="1050" dirty="0"/>
-          </a:p>
-          <a:p>
-            <a:pPr marL="342900" indent="-342900">
-              <a:spcAft>
-                <a:spcPts val="600"/>
-              </a:spcAft>
-              <a:buSzPct val="100000"/>
-              <a:buChar char="▪"/>
-            </a:pPr>
-            <a:r>
-              <a:rPr lang="en-US" sz="1050" dirty="0">
-                <a:solidFill>
-                  <a:srgbClr val="222A3F"/>
-                </a:solidFill>
-                <a:latin typeface="Arial" pitchFamily="34" charset="0"/>
-                <a:ea typeface="Arial" pitchFamily="34" charset="-122"/>
-                <a:cs typeface="Arial" pitchFamily="34" charset="-120"/>
-              </a:rPr>
-              <a:t>One device tracking itself proves four of the five layers with zero coordination cost. Every bug found here is a bug the two-vehicle test will not have to find.</a:t>
-            </a:r>
-            <a:endParaRPr lang="en-US" sz="1050" dirty="0"/>
-          </a:p>
-          <a:p>
-            <a:pPr marL="342900" indent="-342900">
-              <a:buSzPct val="100000"/>
-              <a:buChar char="▪"/>
-            </a:pPr>
-            <a:r>
-              <a:rPr lang="en-US" sz="1050" dirty="0">
-                <a:solidFill>
-                  <a:srgbClr val="222A3F"/>
-                </a:solidFill>
-                <a:latin typeface="Arial" pitchFamily="34" charset="0"/>
-                <a:ea typeface="Arial" pitchFamily="34" charset="-122"/>
-                <a:cs typeface="Arial" pitchFamily="34" charset="-120"/>
-              </a:rPr>
-              <a:t>When radio two joins the channel, the dashed layer closes and the same screens fill in with a real partner. Nothing else changes.</a:t>
-            </a:r>
-            <a:endParaRPr lang="en-US" sz="1050" dirty="0"/>
+              <a:t>One device proves four of five layers at zero coordination cost. The dashed layer waits only for radio two; no display code changes.</a:t>
+            </a:r>
+            <a:endParaRPr lang="en-US" sz="900" dirty="0"/>
           </a:p>
         </p:txBody>
       </p:sp>
@@ -8537,7 +8533,7 @@
         </p:nvSpPr>
         <p:spPr>
           <a:xfrm>
-            <a:off x="457200" y="1143000"/>
+            <a:off x="457200" y="1115568"/>
             <a:ext cx="457200" cy="274320"/>
           </a:xfrm>
           <a:prstGeom prst="rect">
@@ -8554,7 +8550,7 @@
               <a:buNone/>
             </a:pPr>
             <a:r>
-              <a:rPr lang="en-US" sz="1050" b="1" dirty="0">
+              <a:rPr lang="en-US" sz="1000" b="1" dirty="0">
                 <a:solidFill>
                   <a:srgbClr val="E58E1A"/>
                 </a:solidFill>
@@ -8564,7 +8560,7 @@
               </a:rPr>
               <a:t>[1]</a:t>
             </a:r>
-            <a:endParaRPr lang="en-US" sz="1050" dirty="0"/>
+            <a:endParaRPr lang="en-US" sz="1000" dirty="0"/>
           </a:p>
         </p:txBody>
       </p:sp>
@@ -8576,24 +8572,24 @@
         </p:nvSpPr>
         <p:spPr>
           <a:xfrm>
-            <a:off x="960120" y="1143000"/>
-            <a:ext cx="5074920" cy="932688"/>
-          </a:xfrm>
-          <a:prstGeom prst="rect">
-            <a:avLst/>
-          </a:prstGeom>
-          <a:noFill/>
-          <a:ln/>
-        </p:spPr>
-        <p:txBody>
-          <a:bodyPr wrap="square" lIns="0" tIns="0" rIns="0" bIns="0" rtlCol="0" anchor="ctr"/>
-          <a:lstStyle/>
-          <a:p>
-            <a:pPr indent="0" marL="0">
-              <a:buNone/>
-            </a:pPr>
-            <a:r>
-              <a:rPr lang="en-US" sz="1000" dirty="0">
+            <a:off x="960120" y="1115568"/>
+            <a:ext cx="5074920" cy="658368"/>
+          </a:xfrm>
+          <a:prstGeom prst="rect">
+            <a:avLst/>
+          </a:prstGeom>
+          <a:noFill/>
+          <a:ln/>
+        </p:spPr>
+        <p:txBody>
+          <a:bodyPr wrap="square" lIns="0" tIns="0" rIns="0" bIns="0" rtlCol="0" anchor="ctr"/>
+          <a:lstStyle/>
+          <a:p>
+            <a:pPr indent="0" marL="0">
+              <a:buNone/>
+            </a:pPr>
+            <a:r>
+              <a:rPr lang="en-US" sz="950" dirty="0">
                 <a:solidFill>
                   <a:srgbClr val="222A3F"/>
                 </a:solidFill>
@@ -8601,9 +8597,9 @@
                 <a:ea typeface="Arial" pitchFamily="34" charset="-122"/>
                 <a:cs typeface="Arial" pitchFamily="34" charset="-120"/>
               </a:rPr>
-              <a:t>Semtech Corp., SX1276/77/78/79 LoRa Transceiver Datasheet. Demodulator SNR limit per spreading factor (SF11 = -17.5 dB), used in the sensitivity calculation on sheet 08.</a:t>
-            </a:r>
-            <a:endParaRPr lang="en-US" sz="1000" dirty="0"/>
+              <a:t>Semtech Corp., SX1276/77/78/79 LoRa Transceiver Datasheet. Demodulator SNR limit per spreading factor (SF11 = -17.5 dB), used on sheet 08.</a:t>
+            </a:r>
+            <a:endParaRPr lang="en-US" sz="950" dirty="0"/>
           </a:p>
         </p:txBody>
       </p:sp>
@@ -8615,63 +8611,102 @@
         </p:nvSpPr>
         <p:spPr>
           <a:xfrm>
-            <a:off x="457200" y="2130552"/>
-            <a:ext cx="457200" cy="274320"/>
-          </a:xfrm>
-          <a:prstGeom prst="rect">
-            <a:avLst/>
-          </a:prstGeom>
-          <a:noFill/>
-          <a:ln/>
-        </p:spPr>
-        <p:txBody>
-          <a:bodyPr wrap="square" lIns="0" tIns="0" rIns="0" bIns="0" rtlCol="0" anchor="ctr"/>
-          <a:lstStyle/>
-          <a:p>
-            <a:pPr indent="0" marL="0">
-              <a:buNone/>
-            </a:pPr>
-            <a:r>
-              <a:rPr lang="en-US" sz="1050" b="1" dirty="0">
-                <a:solidFill>
-                  <a:srgbClr val="E58E1A"/>
+            <a:off x="960120" y="1773936"/>
+            <a:ext cx="5074920" cy="219456"/>
+          </a:xfrm>
+          <a:prstGeom prst="rect">
+            <a:avLst/>
+          </a:prstGeom>
+          <a:noFill/>
+          <a:ln/>
+        </p:spPr>
+        <p:txBody>
+          <a:bodyPr wrap="square" lIns="0" tIns="0" rIns="0" bIns="0" rtlCol="0" anchor="ctr"/>
+          <a:lstStyle/>
+          <a:p>
+            <a:pPr indent="0" marL="0">
+              <a:buNone/>
+            </a:pPr>
+            <a:r>
+              <a:rPr lang="en-US" sz="800" dirty="0">
+                <a:solidFill>
+                  <a:srgbClr val="1199BD"/>
                 </a:solidFill>
                 <a:latin typeface="Courier New" pitchFamily="34" charset="0"/>
                 <a:ea typeface="Courier New" pitchFamily="34" charset="-122"/>
                 <a:cs typeface="Courier New" pitchFamily="34" charset="-120"/>
               </a:rPr>
+              <a:t>semtech.com/products/wireless-rf/lora-connect/sx1276</a:t>
+            </a:r>
+            <a:endParaRPr lang="en-US" sz="800" dirty="0"/>
+          </a:p>
+        </p:txBody>
+      </p:sp>
+      <p:sp>
+        <p:nvSpPr>
+          <p:cNvPr id="11" name="Text 9"/>
+          <p:cNvSpPr txBox="1"/>
+          <p:nvPr/>
+        </p:nvSpPr>
+        <p:spPr>
+          <a:xfrm>
+            <a:off x="457200" y="2084832"/>
+            <a:ext cx="457200" cy="274320"/>
+          </a:xfrm>
+          <a:prstGeom prst="rect">
+            <a:avLst/>
+          </a:prstGeom>
+          <a:noFill/>
+          <a:ln/>
+        </p:spPr>
+        <p:txBody>
+          <a:bodyPr wrap="square" lIns="0" tIns="0" rIns="0" bIns="0" rtlCol="0" anchor="ctr"/>
+          <a:lstStyle/>
+          <a:p>
+            <a:pPr indent="0" marL="0">
+              <a:buNone/>
+            </a:pPr>
+            <a:r>
+              <a:rPr lang="en-US" sz="1000" b="1" dirty="0">
+                <a:solidFill>
+                  <a:srgbClr val="E58E1A"/>
+                </a:solidFill>
+                <a:latin typeface="Courier New" pitchFamily="34" charset="0"/>
+                <a:ea typeface="Courier New" pitchFamily="34" charset="-122"/>
+                <a:cs typeface="Courier New" pitchFamily="34" charset="-120"/>
+              </a:rPr>
               <a:t>[2]</a:t>
             </a:r>
-            <a:endParaRPr lang="en-US" sz="1050" dirty="0"/>
-          </a:p>
-        </p:txBody>
-      </p:sp>
-      <p:sp>
-        <p:nvSpPr>
-          <p:cNvPr id="11" name="Text 9"/>
-          <p:cNvSpPr txBox="1"/>
-          <p:nvPr/>
-        </p:nvSpPr>
-        <p:spPr>
-          <a:xfrm>
-            <a:off x="960120" y="2130552"/>
-            <a:ext cx="5074920" cy="932688"/>
-          </a:xfrm>
-          <a:prstGeom prst="rect">
-            <a:avLst/>
-          </a:prstGeom>
-          <a:noFill/>
-          <a:ln/>
-        </p:spPr>
-        <p:txBody>
-          <a:bodyPr wrap="square" lIns="0" tIns="0" rIns="0" bIns="0" rtlCol="0" anchor="ctr"/>
-          <a:lstStyle/>
-          <a:p>
-            <a:pPr indent="0" marL="0">
-              <a:buNone/>
-            </a:pPr>
-            <a:r>
-              <a:rPr lang="en-US" sz="1000" dirty="0">
+            <a:endParaRPr lang="en-US" sz="1000" dirty="0"/>
+          </a:p>
+        </p:txBody>
+      </p:sp>
+      <p:sp>
+        <p:nvSpPr>
+          <p:cNvPr id="12" name="Text 10"/>
+          <p:cNvSpPr txBox="1"/>
+          <p:nvPr/>
+        </p:nvSpPr>
+        <p:spPr>
+          <a:xfrm>
+            <a:off x="960120" y="2084832"/>
+            <a:ext cx="5074920" cy="658368"/>
+          </a:xfrm>
+          <a:prstGeom prst="rect">
+            <a:avLst/>
+          </a:prstGeom>
+          <a:noFill/>
+          <a:ln/>
+        </p:spPr>
+        <p:txBody>
+          <a:bodyPr wrap="square" lIns="0" tIns="0" rIns="0" bIns="0" rtlCol="0" anchor="ctr"/>
+          <a:lstStyle/>
+          <a:p>
+            <a:pPr indent="0" marL="0">
+              <a:buNone/>
+            </a:pPr>
+            <a:r>
+              <a:rPr lang="en-US" sz="950" dirty="0">
                 <a:solidFill>
                   <a:srgbClr val="222A3F"/>
                 </a:solidFill>
@@ -8681,75 +8716,114 @@
               </a:rPr>
               <a:t>Semtech Corp., AN1200.22, LoRa Modulation Basics. Symbol duration T_sym = 2^SF / BW, packet airtime, and processing gain.</a:t>
             </a:r>
-            <a:endParaRPr lang="en-US" sz="1000" dirty="0"/>
-          </a:p>
-        </p:txBody>
-      </p:sp>
-      <p:sp>
-        <p:nvSpPr>
-          <p:cNvPr id="12" name="Text 10"/>
-          <p:cNvSpPr txBox="1"/>
-          <p:nvPr/>
-        </p:nvSpPr>
-        <p:spPr>
-          <a:xfrm>
-            <a:off x="457200" y="3118104"/>
-            <a:ext cx="457200" cy="274320"/>
-          </a:xfrm>
-          <a:prstGeom prst="rect">
-            <a:avLst/>
-          </a:prstGeom>
-          <a:noFill/>
-          <a:ln/>
-        </p:spPr>
-        <p:txBody>
-          <a:bodyPr wrap="square" lIns="0" tIns="0" rIns="0" bIns="0" rtlCol="0" anchor="ctr"/>
-          <a:lstStyle/>
-          <a:p>
-            <a:pPr indent="0" marL="0">
-              <a:buNone/>
-            </a:pPr>
-            <a:r>
-              <a:rPr lang="en-US" sz="1050" b="1" dirty="0">
-                <a:solidFill>
-                  <a:srgbClr val="E58E1A"/>
+            <a:endParaRPr lang="en-US" sz="950" dirty="0"/>
+          </a:p>
+        </p:txBody>
+      </p:sp>
+      <p:sp>
+        <p:nvSpPr>
+          <p:cNvPr id="13" name="Text 11"/>
+          <p:cNvSpPr txBox="1"/>
+          <p:nvPr/>
+        </p:nvSpPr>
+        <p:spPr>
+          <a:xfrm>
+            <a:off x="960120" y="2743200"/>
+            <a:ext cx="5074920" cy="219456"/>
+          </a:xfrm>
+          <a:prstGeom prst="rect">
+            <a:avLst/>
+          </a:prstGeom>
+          <a:noFill/>
+          <a:ln/>
+        </p:spPr>
+        <p:txBody>
+          <a:bodyPr wrap="square" lIns="0" tIns="0" rIns="0" bIns="0" rtlCol="0" anchor="ctr"/>
+          <a:lstStyle/>
+          <a:p>
+            <a:pPr indent="0" marL="0">
+              <a:buNone/>
+            </a:pPr>
+            <a:r>
+              <a:rPr lang="en-US" sz="800" dirty="0">
+                <a:solidFill>
+                  <a:srgbClr val="1199BD"/>
                 </a:solidFill>
                 <a:latin typeface="Courier New" pitchFamily="34" charset="0"/>
                 <a:ea typeface="Courier New" pitchFamily="34" charset="-122"/>
                 <a:cs typeface="Courier New" pitchFamily="34" charset="-120"/>
               </a:rPr>
+              <a:t>info.semtech.com/find-documentation  (search AN1200.22)</a:t>
+            </a:r>
+            <a:endParaRPr lang="en-US" sz="800" dirty="0"/>
+          </a:p>
+        </p:txBody>
+      </p:sp>
+      <p:sp>
+        <p:nvSpPr>
+          <p:cNvPr id="14" name="Text 12"/>
+          <p:cNvSpPr txBox="1"/>
+          <p:nvPr/>
+        </p:nvSpPr>
+        <p:spPr>
+          <a:xfrm>
+            <a:off x="457200" y="3054096"/>
+            <a:ext cx="457200" cy="274320"/>
+          </a:xfrm>
+          <a:prstGeom prst="rect">
+            <a:avLst/>
+          </a:prstGeom>
+          <a:noFill/>
+          <a:ln/>
+        </p:spPr>
+        <p:txBody>
+          <a:bodyPr wrap="square" lIns="0" tIns="0" rIns="0" bIns="0" rtlCol="0" anchor="ctr"/>
+          <a:lstStyle/>
+          <a:p>
+            <a:pPr indent="0" marL="0">
+              <a:buNone/>
+            </a:pPr>
+            <a:r>
+              <a:rPr lang="en-US" sz="1000" b="1" dirty="0">
+                <a:solidFill>
+                  <a:srgbClr val="E58E1A"/>
+                </a:solidFill>
+                <a:latin typeface="Courier New" pitchFamily="34" charset="0"/>
+                <a:ea typeface="Courier New" pitchFamily="34" charset="-122"/>
+                <a:cs typeface="Courier New" pitchFamily="34" charset="-120"/>
+              </a:rPr>
               <a:t>[3]</a:t>
             </a:r>
-            <a:endParaRPr lang="en-US" sz="1050" dirty="0"/>
-          </a:p>
-        </p:txBody>
-      </p:sp>
-      <p:sp>
-        <p:nvSpPr>
-          <p:cNvPr id="13" name="Text 11"/>
-          <p:cNvSpPr txBox="1"/>
-          <p:nvPr/>
-        </p:nvSpPr>
-        <p:spPr>
-          <a:xfrm>
-            <a:off x="960120" y="3118104"/>
-            <a:ext cx="5074920" cy="932688"/>
-          </a:xfrm>
-          <a:prstGeom prst="rect">
-            <a:avLst/>
-          </a:prstGeom>
-          <a:noFill/>
-          <a:ln/>
-        </p:spPr>
-        <p:txBody>
-          <a:bodyPr wrap="square" lIns="0" tIns="0" rIns="0" bIns="0" rtlCol="0" anchor="ctr"/>
-          <a:lstStyle/>
-          <a:p>
-            <a:pPr indent="0" marL="0">
-              <a:buNone/>
-            </a:pPr>
-            <a:r>
-              <a:rPr lang="en-US" sz="1000" dirty="0">
+            <a:endParaRPr lang="en-US" sz="1000" dirty="0"/>
+          </a:p>
+        </p:txBody>
+      </p:sp>
+      <p:sp>
+        <p:nvSpPr>
+          <p:cNvPr id="15" name="Text 13"/>
+          <p:cNvSpPr txBox="1"/>
+          <p:nvPr/>
+        </p:nvSpPr>
+        <p:spPr>
+          <a:xfrm>
+            <a:off x="960120" y="3054096"/>
+            <a:ext cx="5074920" cy="658368"/>
+          </a:xfrm>
+          <a:prstGeom prst="rect">
+            <a:avLst/>
+          </a:prstGeom>
+          <a:noFill/>
+          <a:ln/>
+        </p:spPr>
+        <p:txBody>
+          <a:bodyPr wrap="square" lIns="0" tIns="0" rIns="0" bIns="0" rtlCol="0" anchor="ctr"/>
+          <a:lstStyle/>
+          <a:p>
+            <a:pPr indent="0" marL="0">
+              <a:buNone/>
+            </a:pPr>
+            <a:r>
+              <a:rPr lang="en-US" sz="950" dirty="0">
                 <a:solidFill>
                   <a:srgbClr val="222A3F"/>
                 </a:solidFill>
@@ -8759,75 +8833,114 @@
               </a:rPr>
               <a:t>Semtech Corp., SX1261/2 Transceiver Datasheet. The radio IC on the Heltec V4; sensitivity and transmit specifications.</a:t>
             </a:r>
-            <a:endParaRPr lang="en-US" sz="1000" dirty="0"/>
-          </a:p>
-        </p:txBody>
-      </p:sp>
-      <p:sp>
-        <p:nvSpPr>
-          <p:cNvPr id="14" name="Text 12"/>
-          <p:cNvSpPr txBox="1"/>
-          <p:nvPr/>
-        </p:nvSpPr>
-        <p:spPr>
-          <a:xfrm>
-            <a:off x="457200" y="4105656"/>
-            <a:ext cx="457200" cy="274320"/>
-          </a:xfrm>
-          <a:prstGeom prst="rect">
-            <a:avLst/>
-          </a:prstGeom>
-          <a:noFill/>
-          <a:ln/>
-        </p:spPr>
-        <p:txBody>
-          <a:bodyPr wrap="square" lIns="0" tIns="0" rIns="0" bIns="0" rtlCol="0" anchor="ctr"/>
-          <a:lstStyle/>
-          <a:p>
-            <a:pPr indent="0" marL="0">
-              <a:buNone/>
-            </a:pPr>
-            <a:r>
-              <a:rPr lang="en-US" sz="1050" b="1" dirty="0">
-                <a:solidFill>
-                  <a:srgbClr val="E58E1A"/>
+            <a:endParaRPr lang="en-US" sz="950" dirty="0"/>
+          </a:p>
+        </p:txBody>
+      </p:sp>
+      <p:sp>
+        <p:nvSpPr>
+          <p:cNvPr id="16" name="Text 14"/>
+          <p:cNvSpPr txBox="1"/>
+          <p:nvPr/>
+        </p:nvSpPr>
+        <p:spPr>
+          <a:xfrm>
+            <a:off x="960120" y="3712464"/>
+            <a:ext cx="5074920" cy="219456"/>
+          </a:xfrm>
+          <a:prstGeom prst="rect">
+            <a:avLst/>
+          </a:prstGeom>
+          <a:noFill/>
+          <a:ln/>
+        </p:spPr>
+        <p:txBody>
+          <a:bodyPr wrap="square" lIns="0" tIns="0" rIns="0" bIns="0" rtlCol="0" anchor="ctr"/>
+          <a:lstStyle/>
+          <a:p>
+            <a:pPr indent="0" marL="0">
+              <a:buNone/>
+            </a:pPr>
+            <a:r>
+              <a:rPr lang="en-US" sz="800" dirty="0">
+                <a:solidFill>
+                  <a:srgbClr val="1199BD"/>
                 </a:solidFill>
                 <a:latin typeface="Courier New" pitchFamily="34" charset="0"/>
                 <a:ea typeface="Courier New" pitchFamily="34" charset="-122"/>
                 <a:cs typeface="Courier New" pitchFamily="34" charset="-120"/>
               </a:rPr>
+              <a:t>semtech.com/products/wireless-rf/lora-connect/sx1262</a:t>
+            </a:r>
+            <a:endParaRPr lang="en-US" sz="800" dirty="0"/>
+          </a:p>
+        </p:txBody>
+      </p:sp>
+      <p:sp>
+        <p:nvSpPr>
+          <p:cNvPr id="17" name="Text 15"/>
+          <p:cNvSpPr txBox="1"/>
+          <p:nvPr/>
+        </p:nvSpPr>
+        <p:spPr>
+          <a:xfrm>
+            <a:off x="457200" y="4023360"/>
+            <a:ext cx="457200" cy="274320"/>
+          </a:xfrm>
+          <a:prstGeom prst="rect">
+            <a:avLst/>
+          </a:prstGeom>
+          <a:noFill/>
+          <a:ln/>
+        </p:spPr>
+        <p:txBody>
+          <a:bodyPr wrap="square" lIns="0" tIns="0" rIns="0" bIns="0" rtlCol="0" anchor="ctr"/>
+          <a:lstStyle/>
+          <a:p>
+            <a:pPr indent="0" marL="0">
+              <a:buNone/>
+            </a:pPr>
+            <a:r>
+              <a:rPr lang="en-US" sz="1000" b="1" dirty="0">
+                <a:solidFill>
+                  <a:srgbClr val="E58E1A"/>
+                </a:solidFill>
+                <a:latin typeface="Courier New" pitchFamily="34" charset="0"/>
+                <a:ea typeface="Courier New" pitchFamily="34" charset="-122"/>
+                <a:cs typeface="Courier New" pitchFamily="34" charset="-120"/>
+              </a:rPr>
               <a:t>[4]</a:t>
             </a:r>
-            <a:endParaRPr lang="en-US" sz="1050" dirty="0"/>
-          </a:p>
-        </p:txBody>
-      </p:sp>
-      <p:sp>
-        <p:nvSpPr>
-          <p:cNvPr id="15" name="Text 13"/>
-          <p:cNvSpPr txBox="1"/>
-          <p:nvPr/>
-        </p:nvSpPr>
-        <p:spPr>
-          <a:xfrm>
-            <a:off x="960120" y="4105656"/>
-            <a:ext cx="5074920" cy="932688"/>
-          </a:xfrm>
-          <a:prstGeom prst="rect">
-            <a:avLst/>
-          </a:prstGeom>
-          <a:noFill/>
-          <a:ln/>
-        </p:spPr>
-        <p:txBody>
-          <a:bodyPr wrap="square" lIns="0" tIns="0" rIns="0" bIns="0" rtlCol="0" anchor="ctr"/>
-          <a:lstStyle/>
-          <a:p>
-            <a:pPr indent="0" marL="0">
-              <a:buNone/>
-            </a:pPr>
-            <a:r>
-              <a:rPr lang="en-US" sz="1000" dirty="0">
+            <a:endParaRPr lang="en-US" sz="1000" dirty="0"/>
+          </a:p>
+        </p:txBody>
+      </p:sp>
+      <p:sp>
+        <p:nvSpPr>
+          <p:cNvPr id="18" name="Text 16"/>
+          <p:cNvSpPr txBox="1"/>
+          <p:nvPr/>
+        </p:nvSpPr>
+        <p:spPr>
+          <a:xfrm>
+            <a:off x="960120" y="4023360"/>
+            <a:ext cx="5074920" cy="658368"/>
+          </a:xfrm>
+          <a:prstGeom prst="rect">
+            <a:avLst/>
+          </a:prstGeom>
+          <a:noFill/>
+          <a:ln/>
+        </p:spPr>
+        <p:txBody>
+          <a:bodyPr wrap="square" lIns="0" tIns="0" rIns="0" bIns="0" rtlCol="0" anchor="ctr"/>
+          <a:lstStyle/>
+          <a:p>
+            <a:pPr indent="0" marL="0">
+              <a:buNone/>
+            </a:pPr>
+            <a:r>
+              <a:rPr lang="en-US" sz="950" dirty="0">
                 <a:solidFill>
                   <a:srgbClr val="222A3F"/>
                 </a:solidFill>
@@ -8835,77 +8948,116 @@
                 <a:ea typeface="Arial" pitchFamily="34" charset="-122"/>
                 <a:cs typeface="Arial" pitchFamily="34" charset="-120"/>
               </a:rPr>
-              <a:t>Meshtastic Project Documentation, LoRa and Position Configuration (meshtastic.org/docs). Modem presets, smart broadcast, position precision, and the ~25% channel-utilization transmit limit.</a:t>
-            </a:r>
-            <a:endParaRPr lang="en-US" sz="1000" dirty="0"/>
-          </a:p>
-        </p:txBody>
-      </p:sp>
-      <p:sp>
-        <p:nvSpPr>
-          <p:cNvPr id="16" name="Text 14"/>
-          <p:cNvSpPr txBox="1"/>
-          <p:nvPr/>
-        </p:nvSpPr>
-        <p:spPr>
-          <a:xfrm>
-            <a:off x="457200" y="5093208"/>
-            <a:ext cx="457200" cy="274320"/>
-          </a:xfrm>
-          <a:prstGeom prst="rect">
-            <a:avLst/>
-          </a:prstGeom>
-          <a:noFill/>
-          <a:ln/>
-        </p:spPr>
-        <p:txBody>
-          <a:bodyPr wrap="square" lIns="0" tIns="0" rIns="0" bIns="0" rtlCol="0" anchor="ctr"/>
-          <a:lstStyle/>
-          <a:p>
-            <a:pPr indent="0" marL="0">
-              <a:buNone/>
-            </a:pPr>
-            <a:r>
-              <a:rPr lang="en-US" sz="1050" b="1" dirty="0">
-                <a:solidFill>
-                  <a:srgbClr val="E58E1A"/>
+              <a:t>Meshtastic Project Documentation, LoRa and Position Configuration. Presets, smart broadcast, position precision, the ~25% utilization limit.</a:t>
+            </a:r>
+            <a:endParaRPr lang="en-US" sz="950" dirty="0"/>
+          </a:p>
+        </p:txBody>
+      </p:sp>
+      <p:sp>
+        <p:nvSpPr>
+          <p:cNvPr id="19" name="Text 17"/>
+          <p:cNvSpPr txBox="1"/>
+          <p:nvPr/>
+        </p:nvSpPr>
+        <p:spPr>
+          <a:xfrm>
+            <a:off x="960120" y="4681728"/>
+            <a:ext cx="5074920" cy="219456"/>
+          </a:xfrm>
+          <a:prstGeom prst="rect">
+            <a:avLst/>
+          </a:prstGeom>
+          <a:noFill/>
+          <a:ln/>
+        </p:spPr>
+        <p:txBody>
+          <a:bodyPr wrap="square" lIns="0" tIns="0" rIns="0" bIns="0" rtlCol="0" anchor="ctr"/>
+          <a:lstStyle/>
+          <a:p>
+            <a:pPr indent="0" marL="0">
+              <a:buNone/>
+            </a:pPr>
+            <a:r>
+              <a:rPr lang="en-US" sz="800" dirty="0">
+                <a:solidFill>
+                  <a:srgbClr val="1199BD"/>
                 </a:solidFill>
                 <a:latin typeface="Courier New" pitchFamily="34" charset="0"/>
                 <a:ea typeface="Courier New" pitchFamily="34" charset="-122"/>
                 <a:cs typeface="Courier New" pitchFamily="34" charset="-120"/>
               </a:rPr>
+              <a:t>meshtastic.org/docs/configuration/radio/lora  ·  /position</a:t>
+            </a:r>
+            <a:endParaRPr lang="en-US" sz="800" dirty="0"/>
+          </a:p>
+        </p:txBody>
+      </p:sp>
+      <p:sp>
+        <p:nvSpPr>
+          <p:cNvPr id="20" name="Text 18"/>
+          <p:cNvSpPr txBox="1"/>
+          <p:nvPr/>
+        </p:nvSpPr>
+        <p:spPr>
+          <a:xfrm>
+            <a:off x="457200" y="4992624"/>
+            <a:ext cx="457200" cy="274320"/>
+          </a:xfrm>
+          <a:prstGeom prst="rect">
+            <a:avLst/>
+          </a:prstGeom>
+          <a:noFill/>
+          <a:ln/>
+        </p:spPr>
+        <p:txBody>
+          <a:bodyPr wrap="square" lIns="0" tIns="0" rIns="0" bIns="0" rtlCol="0" anchor="ctr"/>
+          <a:lstStyle/>
+          <a:p>
+            <a:pPr indent="0" marL="0">
+              <a:buNone/>
+            </a:pPr>
+            <a:r>
+              <a:rPr lang="en-US" sz="1000" b="1" dirty="0">
+                <a:solidFill>
+                  <a:srgbClr val="E58E1A"/>
+                </a:solidFill>
+                <a:latin typeface="Courier New" pitchFamily="34" charset="0"/>
+                <a:ea typeface="Courier New" pitchFamily="34" charset="-122"/>
+                <a:cs typeface="Courier New" pitchFamily="34" charset="-120"/>
+              </a:rPr>
               <a:t>[5]</a:t>
             </a:r>
-            <a:endParaRPr lang="en-US" sz="1050" dirty="0"/>
-          </a:p>
-        </p:txBody>
-      </p:sp>
-      <p:sp>
-        <p:nvSpPr>
-          <p:cNvPr id="17" name="Text 15"/>
-          <p:cNvSpPr txBox="1"/>
-          <p:nvPr/>
-        </p:nvSpPr>
-        <p:spPr>
-          <a:xfrm>
-            <a:off x="960120" y="5093208"/>
-            <a:ext cx="5074920" cy="932688"/>
-          </a:xfrm>
-          <a:prstGeom prst="rect">
-            <a:avLst/>
-          </a:prstGeom>
-          <a:noFill/>
-          <a:ln/>
-        </p:spPr>
-        <p:txBody>
-          <a:bodyPr wrap="square" lIns="0" tIns="0" rIns="0" bIns="0" rtlCol="0" anchor="ctr"/>
-          <a:lstStyle/>
-          <a:p>
-            <a:pPr indent="0" marL="0">
-              <a:buNone/>
-            </a:pPr>
-            <a:r>
-              <a:rPr lang="en-US" sz="1000" dirty="0">
+            <a:endParaRPr lang="en-US" sz="1000" dirty="0"/>
+          </a:p>
+        </p:txBody>
+      </p:sp>
+      <p:sp>
+        <p:nvSpPr>
+          <p:cNvPr id="21" name="Text 19"/>
+          <p:cNvSpPr txBox="1"/>
+          <p:nvPr/>
+        </p:nvSpPr>
+        <p:spPr>
+          <a:xfrm>
+            <a:off x="960120" y="4992624"/>
+            <a:ext cx="5074920" cy="658368"/>
+          </a:xfrm>
+          <a:prstGeom prst="rect">
+            <a:avLst/>
+          </a:prstGeom>
+          <a:noFill/>
+          <a:ln/>
+        </p:spPr>
+        <p:txBody>
+          <a:bodyPr wrap="square" lIns="0" tIns="0" rIns="0" bIns="0" rtlCol="0" anchor="ctr"/>
+          <a:lstStyle/>
+          <a:p>
+            <a:pPr indent="0" marL="0">
+              <a:buNone/>
+            </a:pPr>
+            <a:r>
+              <a:rPr lang="en-US" sz="950" dirty="0">
                 <a:solidFill>
                   <a:srgbClr val="222A3F"/>
                 </a:solidFill>
@@ -8913,77 +9065,116 @@
                 <a:ea typeface="Arial" pitchFamily="34" charset="-122"/>
                 <a:cs typeface="Arial" pitchFamily="34" charset="-120"/>
               </a:rPr>
-              <a:t>Meshtastic Protobufs Repository (github.com/meshtastic/protobufs). The published message schema our decoder is generated from, including Position field units.</a:t>
-            </a:r>
-            <a:endParaRPr lang="en-US" sz="1000" dirty="0"/>
-          </a:p>
-        </p:txBody>
-      </p:sp>
-      <p:sp>
-        <p:nvSpPr>
-          <p:cNvPr id="18" name="Text 16"/>
-          <p:cNvSpPr txBox="1"/>
-          <p:nvPr/>
-        </p:nvSpPr>
-        <p:spPr>
-          <a:xfrm>
-            <a:off x="6263640" y="1143000"/>
-            <a:ext cx="457200" cy="274320"/>
-          </a:xfrm>
-          <a:prstGeom prst="rect">
-            <a:avLst/>
-          </a:prstGeom>
-          <a:noFill/>
-          <a:ln/>
-        </p:spPr>
-        <p:txBody>
-          <a:bodyPr wrap="square" lIns="0" tIns="0" rIns="0" bIns="0" rtlCol="0" anchor="ctr"/>
-          <a:lstStyle/>
-          <a:p>
-            <a:pPr indent="0" marL="0">
-              <a:buNone/>
-            </a:pPr>
-            <a:r>
-              <a:rPr lang="en-US" sz="1050" b="1" dirty="0">
-                <a:solidFill>
-                  <a:srgbClr val="E58E1A"/>
+              <a:t>Meshtastic Protobufs Repository. The published message schema our decoder is generated from, including Position field units.</a:t>
+            </a:r>
+            <a:endParaRPr lang="en-US" sz="950" dirty="0"/>
+          </a:p>
+        </p:txBody>
+      </p:sp>
+      <p:sp>
+        <p:nvSpPr>
+          <p:cNvPr id="22" name="Text 20"/>
+          <p:cNvSpPr txBox="1"/>
+          <p:nvPr/>
+        </p:nvSpPr>
+        <p:spPr>
+          <a:xfrm>
+            <a:off x="960120" y="5650992"/>
+            <a:ext cx="5074920" cy="219456"/>
+          </a:xfrm>
+          <a:prstGeom prst="rect">
+            <a:avLst/>
+          </a:prstGeom>
+          <a:noFill/>
+          <a:ln/>
+        </p:spPr>
+        <p:txBody>
+          <a:bodyPr wrap="square" lIns="0" tIns="0" rIns="0" bIns="0" rtlCol="0" anchor="ctr"/>
+          <a:lstStyle/>
+          <a:p>
+            <a:pPr indent="0" marL="0">
+              <a:buNone/>
+            </a:pPr>
+            <a:r>
+              <a:rPr lang="en-US" sz="800" dirty="0">
+                <a:solidFill>
+                  <a:srgbClr val="1199BD"/>
                 </a:solidFill>
                 <a:latin typeface="Courier New" pitchFamily="34" charset="0"/>
                 <a:ea typeface="Courier New" pitchFamily="34" charset="-122"/>
                 <a:cs typeface="Courier New" pitchFamily="34" charset="-120"/>
               </a:rPr>
+              <a:t>github.com/meshtastic/protobufs</a:t>
+            </a:r>
+            <a:endParaRPr lang="en-US" sz="800" dirty="0"/>
+          </a:p>
+        </p:txBody>
+      </p:sp>
+      <p:sp>
+        <p:nvSpPr>
+          <p:cNvPr id="23" name="Text 21"/>
+          <p:cNvSpPr txBox="1"/>
+          <p:nvPr/>
+        </p:nvSpPr>
+        <p:spPr>
+          <a:xfrm>
+            <a:off x="6263640" y="1115568"/>
+            <a:ext cx="457200" cy="274320"/>
+          </a:xfrm>
+          <a:prstGeom prst="rect">
+            <a:avLst/>
+          </a:prstGeom>
+          <a:noFill/>
+          <a:ln/>
+        </p:spPr>
+        <p:txBody>
+          <a:bodyPr wrap="square" lIns="0" tIns="0" rIns="0" bIns="0" rtlCol="0" anchor="ctr"/>
+          <a:lstStyle/>
+          <a:p>
+            <a:pPr indent="0" marL="0">
+              <a:buNone/>
+            </a:pPr>
+            <a:r>
+              <a:rPr lang="en-US" sz="1000" b="1" dirty="0">
+                <a:solidFill>
+                  <a:srgbClr val="E58E1A"/>
+                </a:solidFill>
+                <a:latin typeface="Courier New" pitchFamily="34" charset="0"/>
+                <a:ea typeface="Courier New" pitchFamily="34" charset="-122"/>
+                <a:cs typeface="Courier New" pitchFamily="34" charset="-120"/>
+              </a:rPr>
               <a:t>[6]</a:t>
             </a:r>
-            <a:endParaRPr lang="en-US" sz="1050" dirty="0"/>
-          </a:p>
-        </p:txBody>
-      </p:sp>
-      <p:sp>
-        <p:nvSpPr>
-          <p:cNvPr id="19" name="Text 17"/>
-          <p:cNvSpPr txBox="1"/>
-          <p:nvPr/>
-        </p:nvSpPr>
-        <p:spPr>
-          <a:xfrm>
-            <a:off x="6766560" y="1143000"/>
-            <a:ext cx="5074920" cy="932688"/>
-          </a:xfrm>
-          <a:prstGeom prst="rect">
-            <a:avLst/>
-          </a:prstGeom>
-          <a:noFill/>
-          <a:ln/>
-        </p:spPr>
-        <p:txBody>
-          <a:bodyPr wrap="square" lIns="0" tIns="0" rIns="0" bIns="0" rtlCol="0" anchor="ctr"/>
-          <a:lstStyle/>
-          <a:p>
-            <a:pPr indent="0" marL="0">
-              <a:buNone/>
-            </a:pPr>
-            <a:r>
-              <a:rPr lang="en-US" sz="1000" dirty="0">
+            <a:endParaRPr lang="en-US" sz="1000" dirty="0"/>
+          </a:p>
+        </p:txBody>
+      </p:sp>
+      <p:sp>
+        <p:nvSpPr>
+          <p:cNvPr id="24" name="Text 22"/>
+          <p:cNvSpPr txBox="1"/>
+          <p:nvPr/>
+        </p:nvSpPr>
+        <p:spPr>
+          <a:xfrm>
+            <a:off x="6766560" y="1115568"/>
+            <a:ext cx="5074920" cy="658368"/>
+          </a:xfrm>
+          <a:prstGeom prst="rect">
+            <a:avLst/>
+          </a:prstGeom>
+          <a:noFill/>
+          <a:ln/>
+        </p:spPr>
+        <p:txBody>
+          <a:bodyPr wrap="square" lIns="0" tIns="0" rIns="0" bIns="0" rtlCol="0" anchor="ctr"/>
+          <a:lstStyle/>
+          <a:p>
+            <a:pPr indent="0" marL="0">
+              <a:buNone/>
+            </a:pPr>
+            <a:r>
+              <a:rPr lang="en-US" sz="950" dirty="0">
                 <a:solidFill>
                   <a:srgbClr val="222A3F"/>
                 </a:solidFill>
@@ -8993,75 +9184,114 @@
               </a:rPr>
               <a:t>FCC Rules, 47 CFR 15.247. Operation in the 902 to 928 MHz ISM band.</a:t>
             </a:r>
-            <a:endParaRPr lang="en-US" sz="1000" dirty="0"/>
-          </a:p>
-        </p:txBody>
-      </p:sp>
-      <p:sp>
-        <p:nvSpPr>
-          <p:cNvPr id="20" name="Text 18"/>
-          <p:cNvSpPr txBox="1"/>
-          <p:nvPr/>
-        </p:nvSpPr>
-        <p:spPr>
-          <a:xfrm>
-            <a:off x="6263640" y="2130552"/>
-            <a:ext cx="457200" cy="274320"/>
-          </a:xfrm>
-          <a:prstGeom prst="rect">
-            <a:avLst/>
-          </a:prstGeom>
-          <a:noFill/>
-          <a:ln/>
-        </p:spPr>
-        <p:txBody>
-          <a:bodyPr wrap="square" lIns="0" tIns="0" rIns="0" bIns="0" rtlCol="0" anchor="ctr"/>
-          <a:lstStyle/>
-          <a:p>
-            <a:pPr indent="0" marL="0">
-              <a:buNone/>
-            </a:pPr>
-            <a:r>
-              <a:rPr lang="en-US" sz="1050" b="1" dirty="0">
-                <a:solidFill>
-                  <a:srgbClr val="E58E1A"/>
+            <a:endParaRPr lang="en-US" sz="950" dirty="0"/>
+          </a:p>
+        </p:txBody>
+      </p:sp>
+      <p:sp>
+        <p:nvSpPr>
+          <p:cNvPr id="25" name="Text 23"/>
+          <p:cNvSpPr txBox="1"/>
+          <p:nvPr/>
+        </p:nvSpPr>
+        <p:spPr>
+          <a:xfrm>
+            <a:off x="6766560" y="1773936"/>
+            <a:ext cx="5074920" cy="219456"/>
+          </a:xfrm>
+          <a:prstGeom prst="rect">
+            <a:avLst/>
+          </a:prstGeom>
+          <a:noFill/>
+          <a:ln/>
+        </p:spPr>
+        <p:txBody>
+          <a:bodyPr wrap="square" lIns="0" tIns="0" rIns="0" bIns="0" rtlCol="0" anchor="ctr"/>
+          <a:lstStyle/>
+          <a:p>
+            <a:pPr indent="0" marL="0">
+              <a:buNone/>
+            </a:pPr>
+            <a:r>
+              <a:rPr lang="en-US" sz="800" dirty="0">
+                <a:solidFill>
+                  <a:srgbClr val="1199BD"/>
                 </a:solidFill>
                 <a:latin typeface="Courier New" pitchFamily="34" charset="0"/>
                 <a:ea typeface="Courier New" pitchFamily="34" charset="-122"/>
                 <a:cs typeface="Courier New" pitchFamily="34" charset="-120"/>
               </a:rPr>
+              <a:t>ecfr.gov/current/title-47/part-15/section-15.247</a:t>
+            </a:r>
+            <a:endParaRPr lang="en-US" sz="800" dirty="0"/>
+          </a:p>
+        </p:txBody>
+      </p:sp>
+      <p:sp>
+        <p:nvSpPr>
+          <p:cNvPr id="26" name="Text 24"/>
+          <p:cNvSpPr txBox="1"/>
+          <p:nvPr/>
+        </p:nvSpPr>
+        <p:spPr>
+          <a:xfrm>
+            <a:off x="6263640" y="2084832"/>
+            <a:ext cx="457200" cy="274320"/>
+          </a:xfrm>
+          <a:prstGeom prst="rect">
+            <a:avLst/>
+          </a:prstGeom>
+          <a:noFill/>
+          <a:ln/>
+        </p:spPr>
+        <p:txBody>
+          <a:bodyPr wrap="square" lIns="0" tIns="0" rIns="0" bIns="0" rtlCol="0" anchor="ctr"/>
+          <a:lstStyle/>
+          <a:p>
+            <a:pPr indent="0" marL="0">
+              <a:buNone/>
+            </a:pPr>
+            <a:r>
+              <a:rPr lang="en-US" sz="1000" b="1" dirty="0">
+                <a:solidFill>
+                  <a:srgbClr val="E58E1A"/>
+                </a:solidFill>
+                <a:latin typeface="Courier New" pitchFamily="34" charset="0"/>
+                <a:ea typeface="Courier New" pitchFamily="34" charset="-122"/>
+                <a:cs typeface="Courier New" pitchFamily="34" charset="-120"/>
+              </a:rPr>
               <a:t>[7]</a:t>
             </a:r>
-            <a:endParaRPr lang="en-US" sz="1050" dirty="0"/>
-          </a:p>
-        </p:txBody>
-      </p:sp>
-      <p:sp>
-        <p:nvSpPr>
-          <p:cNvPr id="21" name="Text 19"/>
-          <p:cNvSpPr txBox="1"/>
-          <p:nvPr/>
-        </p:nvSpPr>
-        <p:spPr>
-          <a:xfrm>
-            <a:off x="6766560" y="2130552"/>
-            <a:ext cx="5074920" cy="932688"/>
-          </a:xfrm>
-          <a:prstGeom prst="rect">
-            <a:avLst/>
-          </a:prstGeom>
-          <a:noFill/>
-          <a:ln/>
-        </p:spPr>
-        <p:txBody>
-          <a:bodyPr wrap="square" lIns="0" tIns="0" rIns="0" bIns="0" rtlCol="0" anchor="ctr"/>
-          <a:lstStyle/>
-          <a:p>
-            <a:pPr indent="0" marL="0">
-              <a:buNone/>
-            </a:pPr>
-            <a:r>
-              <a:rPr lang="en-US" sz="1000" dirty="0">
+            <a:endParaRPr lang="en-US" sz="1000" dirty="0"/>
+          </a:p>
+        </p:txBody>
+      </p:sp>
+      <p:sp>
+        <p:nvSpPr>
+          <p:cNvPr id="27" name="Text 25"/>
+          <p:cNvSpPr txBox="1"/>
+          <p:nvPr/>
+        </p:nvSpPr>
+        <p:spPr>
+          <a:xfrm>
+            <a:off x="6766560" y="2084832"/>
+            <a:ext cx="5074920" cy="658368"/>
+          </a:xfrm>
+          <a:prstGeom prst="rect">
+            <a:avLst/>
+          </a:prstGeom>
+          <a:noFill/>
+          <a:ln/>
+        </p:spPr>
+        <p:txBody>
+          <a:bodyPr wrap="square" lIns="0" tIns="0" rIns="0" bIns="0" rtlCol="0" anchor="ctr"/>
+          <a:lstStyle/>
+          <a:p>
+            <a:pPr indent="0" marL="0">
+              <a:buNone/>
+            </a:pPr>
+            <a:r>
+              <a:rPr lang="en-US" sz="950" dirty="0">
                 <a:solidFill>
                   <a:srgbClr val="222A3F"/>
                 </a:solidFill>
@@ -9069,77 +9299,116 @@
                 <a:ea typeface="Arial" pitchFamily="34" charset="-122"/>
                 <a:cs typeface="Arial" pitchFamily="34" charset="-120"/>
               </a:rPr>
-              <a:t>ITU-R Recommendation M.1371, Automatic Identification System (AIS). Vessel reporting intervals of 2 s to 3 min; the precedent for beacon-then-animate navigation displays.</a:t>
-            </a:r>
-            <a:endParaRPr lang="en-US" sz="1000" dirty="0"/>
-          </a:p>
-        </p:txBody>
-      </p:sp>
-      <p:sp>
-        <p:nvSpPr>
-          <p:cNvPr id="22" name="Text 20"/>
-          <p:cNvSpPr txBox="1"/>
-          <p:nvPr/>
-        </p:nvSpPr>
-        <p:spPr>
-          <a:xfrm>
-            <a:off x="6263640" y="3118104"/>
-            <a:ext cx="457200" cy="274320"/>
-          </a:xfrm>
-          <a:prstGeom prst="rect">
-            <a:avLst/>
-          </a:prstGeom>
-          <a:noFill/>
-          <a:ln/>
-        </p:spPr>
-        <p:txBody>
-          <a:bodyPr wrap="square" lIns="0" tIns="0" rIns="0" bIns="0" rtlCol="0" anchor="ctr"/>
-          <a:lstStyle/>
-          <a:p>
-            <a:pPr indent="0" marL="0">
-              <a:buNone/>
-            </a:pPr>
-            <a:r>
-              <a:rPr lang="en-US" sz="1050" b="1" dirty="0">
-                <a:solidFill>
-                  <a:srgbClr val="E58E1A"/>
+              <a:t>ITU-R Recommendation M.1371, Automatic Identification System (AIS). Reporting intervals of 2 s to 3 min; the beacon-then-animate precedent.</a:t>
+            </a:r>
+            <a:endParaRPr lang="en-US" sz="950" dirty="0"/>
+          </a:p>
+        </p:txBody>
+      </p:sp>
+      <p:sp>
+        <p:nvSpPr>
+          <p:cNvPr id="28" name="Text 26"/>
+          <p:cNvSpPr txBox="1"/>
+          <p:nvPr/>
+        </p:nvSpPr>
+        <p:spPr>
+          <a:xfrm>
+            <a:off x="6766560" y="2743200"/>
+            <a:ext cx="5074920" cy="219456"/>
+          </a:xfrm>
+          <a:prstGeom prst="rect">
+            <a:avLst/>
+          </a:prstGeom>
+          <a:noFill/>
+          <a:ln/>
+        </p:spPr>
+        <p:txBody>
+          <a:bodyPr wrap="square" lIns="0" tIns="0" rIns="0" bIns="0" rtlCol="0" anchor="ctr"/>
+          <a:lstStyle/>
+          <a:p>
+            <a:pPr indent="0" marL="0">
+              <a:buNone/>
+            </a:pPr>
+            <a:r>
+              <a:rPr lang="en-US" sz="800" dirty="0">
+                <a:solidFill>
+                  <a:srgbClr val="1199BD"/>
                 </a:solidFill>
                 <a:latin typeface="Courier New" pitchFamily="34" charset="0"/>
                 <a:ea typeface="Courier New" pitchFamily="34" charset="-122"/>
                 <a:cs typeface="Courier New" pitchFamily="34" charset="-120"/>
               </a:rPr>
+              <a:t>itu.int/rec/R-REC-M.1371</a:t>
+            </a:r>
+            <a:endParaRPr lang="en-US" sz="800" dirty="0"/>
+          </a:p>
+        </p:txBody>
+      </p:sp>
+      <p:sp>
+        <p:nvSpPr>
+          <p:cNvPr id="29" name="Text 27"/>
+          <p:cNvSpPr txBox="1"/>
+          <p:nvPr/>
+        </p:nvSpPr>
+        <p:spPr>
+          <a:xfrm>
+            <a:off x="6263640" y="3054096"/>
+            <a:ext cx="457200" cy="274320"/>
+          </a:xfrm>
+          <a:prstGeom prst="rect">
+            <a:avLst/>
+          </a:prstGeom>
+          <a:noFill/>
+          <a:ln/>
+        </p:spPr>
+        <p:txBody>
+          <a:bodyPr wrap="square" lIns="0" tIns="0" rIns="0" bIns="0" rtlCol="0" anchor="ctr"/>
+          <a:lstStyle/>
+          <a:p>
+            <a:pPr indent="0" marL="0">
+              <a:buNone/>
+            </a:pPr>
+            <a:r>
+              <a:rPr lang="en-US" sz="1000" b="1" dirty="0">
+                <a:solidFill>
+                  <a:srgbClr val="E58E1A"/>
+                </a:solidFill>
+                <a:latin typeface="Courier New" pitchFamily="34" charset="0"/>
+                <a:ea typeface="Courier New" pitchFamily="34" charset="-122"/>
+                <a:cs typeface="Courier New" pitchFamily="34" charset="-120"/>
+              </a:rPr>
               <a:t>[8]</a:t>
             </a:r>
-            <a:endParaRPr lang="en-US" sz="1050" dirty="0"/>
-          </a:p>
-        </p:txBody>
-      </p:sp>
-      <p:sp>
-        <p:nvSpPr>
-          <p:cNvPr id="23" name="Text 21"/>
-          <p:cNvSpPr txBox="1"/>
-          <p:nvPr/>
-        </p:nvSpPr>
-        <p:spPr>
-          <a:xfrm>
-            <a:off x="6766560" y="3118104"/>
-            <a:ext cx="5074920" cy="932688"/>
-          </a:xfrm>
-          <a:prstGeom prst="rect">
-            <a:avLst/>
-          </a:prstGeom>
-          <a:noFill/>
-          <a:ln/>
-        </p:spPr>
-        <p:txBody>
-          <a:bodyPr wrap="square" lIns="0" tIns="0" rIns="0" bIns="0" rtlCol="0" anchor="ctr"/>
-          <a:lstStyle/>
-          <a:p>
-            <a:pPr indent="0" marL="0">
-              <a:buNone/>
-            </a:pPr>
-            <a:r>
-              <a:rPr lang="en-US" sz="1000" dirty="0">
+            <a:endParaRPr lang="en-US" sz="1000" dirty="0"/>
+          </a:p>
+        </p:txBody>
+      </p:sp>
+      <p:sp>
+        <p:nvSpPr>
+          <p:cNvPr id="30" name="Text 28"/>
+          <p:cNvSpPr txBox="1"/>
+          <p:nvPr/>
+        </p:nvSpPr>
+        <p:spPr>
+          <a:xfrm>
+            <a:off x="6766560" y="3054096"/>
+            <a:ext cx="5074920" cy="658368"/>
+          </a:xfrm>
+          <a:prstGeom prst="rect">
+            <a:avLst/>
+          </a:prstGeom>
+          <a:noFill/>
+          <a:ln/>
+        </p:spPr>
+        <p:txBody>
+          <a:bodyPr wrap="square" lIns="0" tIns="0" rIns="0" bIns="0" rtlCol="0" anchor="ctr"/>
+          <a:lstStyle/>
+          <a:p>
+            <a:pPr indent="0" marL="0">
+              <a:buNone/>
+            </a:pPr>
+            <a:r>
+              <a:rPr lang="en-US" sz="950" dirty="0">
                 <a:solidFill>
                   <a:srgbClr val="222A3F"/>
                 </a:solidFill>
@@ -9147,77 +9416,116 @@
                 <a:ea typeface="Arial" pitchFamily="34" charset="-122"/>
                 <a:cs typeface="Arial" pitchFamily="34" charset="-120"/>
               </a:rPr>
-              <a:t>R. W. Sinnott, Virtues of the Haversine, Sky &amp; Telescope, vol. 68, no. 2, p. 159, 1984. The great-circle distance formula used in nav.c.</a:t>
-            </a:r>
-            <a:endParaRPr lang="en-US" sz="1000" dirty="0"/>
-          </a:p>
-        </p:txBody>
-      </p:sp>
-      <p:sp>
-        <p:nvSpPr>
-          <p:cNvPr id="24" name="Text 22"/>
-          <p:cNvSpPr txBox="1"/>
-          <p:nvPr/>
-        </p:nvSpPr>
-        <p:spPr>
-          <a:xfrm>
-            <a:off x="6263640" y="4105656"/>
-            <a:ext cx="457200" cy="274320"/>
-          </a:xfrm>
-          <a:prstGeom prst="rect">
-            <a:avLst/>
-          </a:prstGeom>
-          <a:noFill/>
-          <a:ln/>
-        </p:spPr>
-        <p:txBody>
-          <a:bodyPr wrap="square" lIns="0" tIns="0" rIns="0" bIns="0" rtlCol="0" anchor="ctr"/>
-          <a:lstStyle/>
-          <a:p>
-            <a:pPr indent="0" marL="0">
-              <a:buNone/>
-            </a:pPr>
-            <a:r>
-              <a:rPr lang="en-US" sz="1050" b="1" dirty="0">
-                <a:solidFill>
-                  <a:srgbClr val="E58E1A"/>
+              <a:t>R. W. Sinnott, Virtues of the Haversine, Sky &amp; Telescope, vol. 68, no. 2, p. 159, 1984. The distance formula used in nav.c.</a:t>
+            </a:r>
+            <a:endParaRPr lang="en-US" sz="950" dirty="0"/>
+          </a:p>
+        </p:txBody>
+      </p:sp>
+      <p:sp>
+        <p:nvSpPr>
+          <p:cNvPr id="31" name="Text 29"/>
+          <p:cNvSpPr txBox="1"/>
+          <p:nvPr/>
+        </p:nvSpPr>
+        <p:spPr>
+          <a:xfrm>
+            <a:off x="6766560" y="3712464"/>
+            <a:ext cx="5074920" cy="219456"/>
+          </a:xfrm>
+          <a:prstGeom prst="rect">
+            <a:avLst/>
+          </a:prstGeom>
+          <a:noFill/>
+          <a:ln/>
+        </p:spPr>
+        <p:txBody>
+          <a:bodyPr wrap="square" lIns="0" tIns="0" rIns="0" bIns="0" rtlCol="0" anchor="ctr"/>
+          <a:lstStyle/>
+          <a:p>
+            <a:pPr indent="0" marL="0">
+              <a:buNone/>
+            </a:pPr>
+            <a:r>
+              <a:rPr lang="en-US" sz="800" dirty="0">
+                <a:solidFill>
+                  <a:srgbClr val="1199BD"/>
                 </a:solidFill>
                 <a:latin typeface="Courier New" pitchFamily="34" charset="0"/>
                 <a:ea typeface="Courier New" pitchFamily="34" charset="-122"/>
                 <a:cs typeface="Courier New" pitchFamily="34" charset="-120"/>
               </a:rPr>
+              <a:t>movable-type.co.uk/scripts/latlong.html  (implementation ref)</a:t>
+            </a:r>
+            <a:endParaRPr lang="en-US" sz="800" dirty="0"/>
+          </a:p>
+        </p:txBody>
+      </p:sp>
+      <p:sp>
+        <p:nvSpPr>
+          <p:cNvPr id="32" name="Text 30"/>
+          <p:cNvSpPr txBox="1"/>
+          <p:nvPr/>
+        </p:nvSpPr>
+        <p:spPr>
+          <a:xfrm>
+            <a:off x="6263640" y="4023360"/>
+            <a:ext cx="457200" cy="274320"/>
+          </a:xfrm>
+          <a:prstGeom prst="rect">
+            <a:avLst/>
+          </a:prstGeom>
+          <a:noFill/>
+          <a:ln/>
+        </p:spPr>
+        <p:txBody>
+          <a:bodyPr wrap="square" lIns="0" tIns="0" rIns="0" bIns="0" rtlCol="0" anchor="ctr"/>
+          <a:lstStyle/>
+          <a:p>
+            <a:pPr indent="0" marL="0">
+              <a:buNone/>
+            </a:pPr>
+            <a:r>
+              <a:rPr lang="en-US" sz="1000" b="1" dirty="0">
+                <a:solidFill>
+                  <a:srgbClr val="E58E1A"/>
+                </a:solidFill>
+                <a:latin typeface="Courier New" pitchFamily="34" charset="0"/>
+                <a:ea typeface="Courier New" pitchFamily="34" charset="-122"/>
+                <a:cs typeface="Courier New" pitchFamily="34" charset="-120"/>
+              </a:rPr>
               <a:t>[9]</a:t>
             </a:r>
-            <a:endParaRPr lang="en-US" sz="1050" dirty="0"/>
-          </a:p>
-        </p:txBody>
-      </p:sp>
-      <p:sp>
-        <p:nvSpPr>
-          <p:cNvPr id="25" name="Text 23"/>
-          <p:cNvSpPr txBox="1"/>
-          <p:nvPr/>
-        </p:nvSpPr>
-        <p:spPr>
-          <a:xfrm>
-            <a:off x="6766560" y="4105656"/>
-            <a:ext cx="5074920" cy="932688"/>
-          </a:xfrm>
-          <a:prstGeom prst="rect">
-            <a:avLst/>
-          </a:prstGeom>
-          <a:noFill/>
-          <a:ln/>
-        </p:spPr>
-        <p:txBody>
-          <a:bodyPr wrap="square" lIns="0" tIns="0" rIns="0" bIns="0" rtlCol="0" anchor="ctr"/>
-          <a:lstStyle/>
-          <a:p>
-            <a:pPr indent="0" marL="0">
-              <a:buNone/>
-            </a:pPr>
-            <a:r>
-              <a:rPr lang="en-US" sz="1000" dirty="0">
+            <a:endParaRPr lang="en-US" sz="1000" dirty="0"/>
+          </a:p>
+        </p:txBody>
+      </p:sp>
+      <p:sp>
+        <p:nvSpPr>
+          <p:cNvPr id="33" name="Text 31"/>
+          <p:cNvSpPr txBox="1"/>
+          <p:nvPr/>
+        </p:nvSpPr>
+        <p:spPr>
+          <a:xfrm>
+            <a:off x="6766560" y="4023360"/>
+            <a:ext cx="5074920" cy="658368"/>
+          </a:xfrm>
+          <a:prstGeom prst="rect">
+            <a:avLst/>
+          </a:prstGeom>
+          <a:noFill/>
+          <a:ln/>
+        </p:spPr>
+        <p:txBody>
+          <a:bodyPr wrap="square" lIns="0" tIns="0" rIns="0" bIns="0" rtlCol="0" anchor="ctr"/>
+          <a:lstStyle/>
+          <a:p>
+            <a:pPr indent="0" marL="0">
+              <a:buNone/>
+            </a:pPr>
+            <a:r>
+              <a:rPr lang="en-US" sz="950" dirty="0">
                 <a:solidFill>
                   <a:srgbClr val="222A3F"/>
                 </a:solidFill>
@@ -9227,75 +9535,114 @@
               </a:rPr>
               <a:t>Bluetooth SIG, Bluetooth Core Specification (GATT). The service and characteristic model behind the Meshtastic Client API.</a:t>
             </a:r>
-            <a:endParaRPr lang="en-US" sz="1000" dirty="0"/>
-          </a:p>
-        </p:txBody>
-      </p:sp>
-      <p:sp>
-        <p:nvSpPr>
-          <p:cNvPr id="26" name="Text 24"/>
-          <p:cNvSpPr txBox="1"/>
-          <p:nvPr/>
-        </p:nvSpPr>
-        <p:spPr>
-          <a:xfrm>
-            <a:off x="6263640" y="5093208"/>
-            <a:ext cx="457200" cy="274320"/>
-          </a:xfrm>
-          <a:prstGeom prst="rect">
-            <a:avLst/>
-          </a:prstGeom>
-          <a:noFill/>
-          <a:ln/>
-        </p:spPr>
-        <p:txBody>
-          <a:bodyPr wrap="square" lIns="0" tIns="0" rIns="0" bIns="0" rtlCol="0" anchor="ctr"/>
-          <a:lstStyle/>
-          <a:p>
-            <a:pPr indent="0" marL="0">
-              <a:buNone/>
-            </a:pPr>
-            <a:r>
-              <a:rPr lang="en-US" sz="1050" b="1" dirty="0">
-                <a:solidFill>
-                  <a:srgbClr val="E58E1A"/>
+            <a:endParaRPr lang="en-US" sz="950" dirty="0"/>
+          </a:p>
+        </p:txBody>
+      </p:sp>
+      <p:sp>
+        <p:nvSpPr>
+          <p:cNvPr id="34" name="Text 32"/>
+          <p:cNvSpPr txBox="1"/>
+          <p:nvPr/>
+        </p:nvSpPr>
+        <p:spPr>
+          <a:xfrm>
+            <a:off x="6766560" y="4681728"/>
+            <a:ext cx="5074920" cy="219456"/>
+          </a:xfrm>
+          <a:prstGeom prst="rect">
+            <a:avLst/>
+          </a:prstGeom>
+          <a:noFill/>
+          <a:ln/>
+        </p:spPr>
+        <p:txBody>
+          <a:bodyPr wrap="square" lIns="0" tIns="0" rIns="0" bIns="0" rtlCol="0" anchor="ctr"/>
+          <a:lstStyle/>
+          <a:p>
+            <a:pPr indent="0" marL="0">
+              <a:buNone/>
+            </a:pPr>
+            <a:r>
+              <a:rPr lang="en-US" sz="800" dirty="0">
+                <a:solidFill>
+                  <a:srgbClr val="1199BD"/>
                 </a:solidFill>
                 <a:latin typeface="Courier New" pitchFamily="34" charset="0"/>
                 <a:ea typeface="Courier New" pitchFamily="34" charset="-122"/>
                 <a:cs typeface="Courier New" pitchFamily="34" charset="-120"/>
               </a:rPr>
+              <a:t>bluetooth.com/specifications/specs/core-specification</a:t>
+            </a:r>
+            <a:endParaRPr lang="en-US" sz="800" dirty="0"/>
+          </a:p>
+        </p:txBody>
+      </p:sp>
+      <p:sp>
+        <p:nvSpPr>
+          <p:cNvPr id="35" name="Text 33"/>
+          <p:cNvSpPr txBox="1"/>
+          <p:nvPr/>
+        </p:nvSpPr>
+        <p:spPr>
+          <a:xfrm>
+            <a:off x="6263640" y="4992624"/>
+            <a:ext cx="457200" cy="274320"/>
+          </a:xfrm>
+          <a:prstGeom prst="rect">
+            <a:avLst/>
+          </a:prstGeom>
+          <a:noFill/>
+          <a:ln/>
+        </p:spPr>
+        <p:txBody>
+          <a:bodyPr wrap="square" lIns="0" tIns="0" rIns="0" bIns="0" rtlCol="0" anchor="ctr"/>
+          <a:lstStyle/>
+          <a:p>
+            <a:pPr indent="0" marL="0">
+              <a:buNone/>
+            </a:pPr>
+            <a:r>
+              <a:rPr lang="en-US" sz="1000" b="1" dirty="0">
+                <a:solidFill>
+                  <a:srgbClr val="E58E1A"/>
+                </a:solidFill>
+                <a:latin typeface="Courier New" pitchFamily="34" charset="0"/>
+                <a:ea typeface="Courier New" pitchFamily="34" charset="-122"/>
+                <a:cs typeface="Courier New" pitchFamily="34" charset="-120"/>
+              </a:rPr>
               <a:t>[10]</a:t>
             </a:r>
-            <a:endParaRPr lang="en-US" sz="1050" dirty="0"/>
-          </a:p>
-        </p:txBody>
-      </p:sp>
-      <p:sp>
-        <p:nvSpPr>
-          <p:cNvPr id="27" name="Text 25"/>
-          <p:cNvSpPr txBox="1"/>
-          <p:nvPr/>
-        </p:nvSpPr>
-        <p:spPr>
-          <a:xfrm>
-            <a:off x="6766560" y="5093208"/>
-            <a:ext cx="5074920" cy="932688"/>
-          </a:xfrm>
-          <a:prstGeom prst="rect">
-            <a:avLst/>
-          </a:prstGeom>
-          <a:noFill/>
-          <a:ln/>
-        </p:spPr>
-        <p:txBody>
-          <a:bodyPr wrap="square" lIns="0" tIns="0" rIns="0" bIns="0" rtlCol="0" anchor="ctr"/>
-          <a:lstStyle/>
-          <a:p>
-            <a:pPr indent="0" marL="0">
-              <a:buNone/>
-            </a:pPr>
-            <a:r>
-              <a:rPr lang="en-US" sz="1000" dirty="0">
+            <a:endParaRPr lang="en-US" sz="1000" dirty="0"/>
+          </a:p>
+        </p:txBody>
+      </p:sp>
+      <p:sp>
+        <p:nvSpPr>
+          <p:cNvPr id="36" name="Text 34"/>
+          <p:cNvSpPr txBox="1"/>
+          <p:nvPr/>
+        </p:nvSpPr>
+        <p:spPr>
+          <a:xfrm>
+            <a:off x="6766560" y="4992624"/>
+            <a:ext cx="5074920" cy="658368"/>
+          </a:xfrm>
+          <a:prstGeom prst="rect">
+            <a:avLst/>
+          </a:prstGeom>
+          <a:noFill/>
+          <a:ln/>
+        </p:spPr>
+        <p:txBody>
+          <a:bodyPr wrap="square" lIns="0" tIns="0" rIns="0" bIns="0" rtlCol="0" anchor="ctr"/>
+          <a:lstStyle/>
+          <a:p>
+            <a:pPr indent="0" marL="0">
+              <a:buNone/>
+            </a:pPr>
+            <a:r>
+              <a:rPr lang="en-US" sz="950" dirty="0">
                 <a:solidFill>
                   <a:srgbClr val="222A3F"/>
                 </a:solidFill>
@@ -9303,15 +9650,54 @@
                 <a:ea typeface="Arial" pitchFamily="34" charset="-122"/>
                 <a:cs typeface="Arial" pitchFamily="34" charset="-120"/>
               </a:rPr>
-              <a:t>Group 9 repository: docs/TELECOM_ANALYSIS.md, docs/ARCHITECTURE.md, docs/BLE_LINK_WALKTHROUGH.md, hardware/README.md. The project's own link budget, architecture, protocol walkthrough, and provisioning recipe.</a:t>
-            </a:r>
-            <a:endParaRPr lang="en-US" sz="1000" dirty="0"/>
-          </a:p>
-        </p:txBody>
-      </p:sp>
-      <p:sp>
-        <p:nvSpPr>
-          <p:cNvPr id="28" name="Shape 26"/>
+              <a:t>Group 9 repository: TELECOM_ANALYSIS, ARCHITECTURE, BLE_LINK_WALKTHROUGH, hardware/README. Our link budget, architecture, and recipes.</a:t>
+            </a:r>
+            <a:endParaRPr lang="en-US" sz="950" dirty="0"/>
+          </a:p>
+        </p:txBody>
+      </p:sp>
+      <p:sp>
+        <p:nvSpPr>
+          <p:cNvPr id="37" name="Text 35"/>
+          <p:cNvSpPr txBox="1"/>
+          <p:nvPr/>
+        </p:nvSpPr>
+        <p:spPr>
+          <a:xfrm>
+            <a:off x="6766560" y="5650992"/>
+            <a:ext cx="5074920" cy="219456"/>
+          </a:xfrm>
+          <a:prstGeom prst="rect">
+            <a:avLst/>
+          </a:prstGeom>
+          <a:noFill/>
+          <a:ln/>
+        </p:spPr>
+        <p:txBody>
+          <a:bodyPr wrap="square" lIns="0" tIns="0" rIns="0" bIns="0" rtlCol="0" anchor="ctr"/>
+          <a:lstStyle/>
+          <a:p>
+            <a:pPr indent="0" marL="0">
+              <a:buNone/>
+            </a:pPr>
+            <a:r>
+              <a:rPr lang="en-US" sz="800" dirty="0">
+                <a:solidFill>
+                  <a:srgbClr val="1199BD"/>
+                </a:solidFill>
+                <a:latin typeface="Courier New" pitchFamily="34" charset="0"/>
+                <a:ea typeface="Courier New" pitchFamily="34" charset="-122"/>
+                <a:cs typeface="Courier New" pitchFamily="34" charset="-120"/>
+              </a:rPr>
+              <a:t>github.com/deosgracius/offgrid-vehicle-tracker</a:t>
+            </a:r>
+            <a:endParaRPr lang="en-US" sz="800" dirty="0"/>
+          </a:p>
+        </p:txBody>
+      </p:sp>
+      <p:sp>
+        <p:nvSpPr>
+          <p:cNvPr id="38" name="Shape 36"/>
           <p:cNvSpPr/>
           <p:nvPr/>
         </p:nvSpPr>
@@ -9334,7 +9720,7 @@
       </p:sp>
       <p:sp>
         <p:nvSpPr>
-          <p:cNvPr id="29" name="Text 27"/>
+          <p:cNvPr id="39" name="Text 37"/>
           <p:cNvSpPr txBox="1"/>
           <p:nvPr/>
         </p:nvSpPr>

</xml_diff>

<commit_message>
Sheet 10: both device photos restored, map zoomed one notch on ead4
Co-Authored-By: Claude Fable 5 <noreply@anthropic.com>
</commit_message>
<xml_diff>
--- a/docs/presentations/Group9_Presentation3_Week3.pptx
+++ b/docs/presentations/Group9_Presentation3_Week3.pptx
@@ -5071,7 +5071,7 @@
         <p:spPr>
           <a:xfrm>
             <a:off x="457200" y="1097280"/>
-            <a:ext cx="5760720" cy="804672"/>
+            <a:ext cx="5120640" cy="804672"/>
           </a:xfrm>
           <a:prstGeom prst="rect">
             <a:avLst/>
@@ -5096,23 +5096,23 @@
         <p:spPr>
           <a:xfrm>
             <a:off x="594360" y="1152144"/>
-            <a:ext cx="3840480" cy="713232"/>
-          </a:xfrm>
-          <a:prstGeom prst="rect">
-            <a:avLst/>
-          </a:prstGeom>
-          <a:noFill/>
-          <a:ln/>
-        </p:spPr>
-        <p:txBody>
-          <a:bodyPr wrap="square" lIns="0" tIns="0" rIns="0" bIns="0" rtlCol="0" anchor="ctr"/>
-          <a:lstStyle/>
-          <a:p>
-            <a:pPr indent="0" marL="0">
-              <a:buNone/>
-            </a:pPr>
-            <a:r>
-              <a:rPr lang="en-US" sz="1150" b="1" dirty="0">
+            <a:ext cx="3291840" cy="713232"/>
+          </a:xfrm>
+          <a:prstGeom prst="rect">
+            <a:avLst/>
+          </a:prstGeom>
+          <a:noFill/>
+          <a:ln/>
+        </p:spPr>
+        <p:txBody>
+          <a:bodyPr wrap="square" lIns="0" tIns="0" rIns="0" bIns="0" rtlCol="0" anchor="ctr"/>
+          <a:lstStyle/>
+          <a:p>
+            <a:pPr indent="0" marL="0">
+              <a:buNone/>
+            </a:pPr>
+            <a:r>
+              <a:rPr lang="en-US" sz="1100" b="1" dirty="0">
                 <a:solidFill>
                   <a:srgbClr val="16213D"/>
                 </a:solidFill>
@@ -5122,14 +5122,14 @@
               </a:rPr>
               <a:t>GPS to radio</a:t>
             </a:r>
-            <a:endParaRPr lang="en-US" sz="1150" dirty="0"/>
-          </a:p>
-          <a:p>
-            <a:pPr indent="0" marL="0">
-              <a:buNone/>
-            </a:pPr>
-            <a:r>
-              <a:rPr lang="en-US" sz="950" dirty="0">
+            <a:endParaRPr lang="en-US" sz="1100" dirty="0"/>
+          </a:p>
+          <a:p>
+            <a:pPr indent="0" marL="0">
+              <a:buNone/>
+            </a:pPr>
+            <a:r>
+              <a:rPr lang="en-US" sz="900" dirty="0">
                 <a:solidFill>
                   <a:srgbClr val="5E6B85"/>
                 </a:solidFill>
@@ -5139,7 +5139,7 @@
               </a:rPr>
               <a:t>satellites acquired, fixes flowing over UART</a:t>
             </a:r>
-            <a:endParaRPr lang="en-US" sz="1150" dirty="0"/>
+            <a:endParaRPr lang="en-US" sz="1100" dirty="0"/>
           </a:p>
         </p:txBody>
       </p:sp>
@@ -5151,8 +5151,8 @@
         </p:nvSpPr>
         <p:spPr>
           <a:xfrm>
-            <a:off x="4526280" y="1170432"/>
-            <a:ext cx="868680" cy="274320"/>
+            <a:off x="3977640" y="1170432"/>
+            <a:ext cx="777240" cy="274320"/>
           </a:xfrm>
           <a:prstGeom prst="rect">
             <a:avLst/>
@@ -5168,7 +5168,7 @@
               <a:buNone/>
             </a:pPr>
             <a:r>
-              <a:rPr lang="en-US" sz="950" b="1" dirty="0">
+              <a:rPr lang="en-US" sz="900" b="1" dirty="0">
                 <a:solidFill>
                   <a:srgbClr val="1F9D68"/>
                 </a:solidFill>
@@ -5178,7 +5178,7 @@
               </a:rPr>
               <a:t>PROVEN</a:t>
             </a:r>
-            <a:endParaRPr lang="en-US" sz="950" dirty="0"/>
+            <a:endParaRPr lang="en-US" sz="900" dirty="0"/>
           </a:p>
         </p:txBody>
       </p:sp>
@@ -5190,24 +5190,24 @@
         </p:nvSpPr>
         <p:spPr>
           <a:xfrm>
-            <a:off x="4526280" y="1463040"/>
-            <a:ext cx="1645920" cy="384048"/>
-          </a:xfrm>
-          <a:prstGeom prst="rect">
-            <a:avLst/>
-          </a:prstGeom>
-          <a:noFill/>
-          <a:ln/>
-        </p:spPr>
-        <p:txBody>
-          <a:bodyPr wrap="square" lIns="0" tIns="0" rIns="0" bIns="0" rtlCol="0" anchor="ctr"/>
-          <a:lstStyle/>
-          <a:p>
-            <a:pPr indent="0" marL="0">
-              <a:buNone/>
-            </a:pPr>
-            <a:r>
-              <a:rPr lang="en-US" sz="800" dirty="0">
+            <a:off x="3950208" y="1463040"/>
+            <a:ext cx="1572768" cy="384048"/>
+          </a:xfrm>
+          <a:prstGeom prst="rect">
+            <a:avLst/>
+          </a:prstGeom>
+          <a:noFill/>
+          <a:ln/>
+        </p:spPr>
+        <p:txBody>
+          <a:bodyPr wrap="square" lIns="0" tIns="0" rIns="0" bIns="0" rtlCol="0" anchor="ctr"/>
+          <a:lstStyle/>
+          <a:p>
+            <a:pPr indent="0" marL="0">
+              <a:buNone/>
+            </a:pPr>
+            <a:r>
+              <a:rPr lang="en-US" sz="750" dirty="0">
                 <a:solidFill>
                   <a:srgbClr val="5E6B85"/>
                 </a:solidFill>
@@ -5217,7 +5217,7 @@
               </a:rPr>
               <a:t>"own GPS: locked"</a:t>
             </a:r>
-            <a:endParaRPr lang="en-US" sz="800" dirty="0"/>
+            <a:endParaRPr lang="en-US" sz="750" dirty="0"/>
           </a:p>
         </p:txBody>
       </p:sp>
@@ -5229,7 +5229,7 @@
         </p:nvSpPr>
         <p:spPr>
           <a:xfrm>
-            <a:off x="1051560" y="1901952"/>
+            <a:off x="1005840" y="1901952"/>
             <a:ext cx="0" cy="164592"/>
           </a:xfrm>
           <a:prstGeom prst="line">
@@ -5254,7 +5254,7 @@
         <p:spPr>
           <a:xfrm>
             <a:off x="457200" y="2066544"/>
-            <a:ext cx="5760720" cy="804672"/>
+            <a:ext cx="5120640" cy="804672"/>
           </a:xfrm>
           <a:prstGeom prst="rect">
             <a:avLst/>
@@ -5279,23 +5279,23 @@
         <p:spPr>
           <a:xfrm>
             <a:off x="594360" y="2121408"/>
-            <a:ext cx="3840480" cy="713232"/>
-          </a:xfrm>
-          <a:prstGeom prst="rect">
-            <a:avLst/>
-          </a:prstGeom>
-          <a:noFill/>
-          <a:ln/>
-        </p:spPr>
-        <p:txBody>
-          <a:bodyPr wrap="square" lIns="0" tIns="0" rIns="0" bIns="0" rtlCol="0" anchor="ctr"/>
-          <a:lstStyle/>
-          <a:p>
-            <a:pPr indent="0" marL="0">
-              <a:buNone/>
-            </a:pPr>
-            <a:r>
-              <a:rPr lang="en-US" sz="1150" b="1" dirty="0">
+            <a:ext cx="3291840" cy="713232"/>
+          </a:xfrm>
+          <a:prstGeom prst="rect">
+            <a:avLst/>
+          </a:prstGeom>
+          <a:noFill/>
+          <a:ln/>
+        </p:spPr>
+        <p:txBody>
+          <a:bodyPr wrap="square" lIns="0" tIns="0" rIns="0" bIns="0" rtlCol="0" anchor="ctr"/>
+          <a:lstStyle/>
+          <a:p>
+            <a:pPr indent="0" marL="0">
+              <a:buNone/>
+            </a:pPr>
+            <a:r>
+              <a:rPr lang="en-US" sz="1100" b="1" dirty="0">
                 <a:solidFill>
                   <a:srgbClr val="16213D"/>
                 </a:solidFill>
@@ -5305,14 +5305,14 @@
               </a:rPr>
               <a:t>Radio to display</a:t>
             </a:r>
-            <a:endParaRPr lang="en-US" sz="1150" dirty="0"/>
-          </a:p>
-          <a:p>
-            <a:pPr indent="0" marL="0">
-              <a:buNone/>
-            </a:pPr>
-            <a:r>
-              <a:rPr lang="en-US" sz="950" dirty="0">
+            <a:endParaRPr lang="en-US" sz="1100" dirty="0"/>
+          </a:p>
+          <a:p>
+            <a:pPr indent="0" marL="0">
+              <a:buNone/>
+            </a:pPr>
+            <a:r>
+              <a:rPr lang="en-US" sz="900" dirty="0">
                 <a:solidFill>
                   <a:srgbClr val="5E6B85"/>
                 </a:solidFill>
@@ -5322,7 +5322,7 @@
               </a:rPr>
               <a:t>BLE GATT link, automatic reconnect</a:t>
             </a:r>
-            <a:endParaRPr lang="en-US" sz="1150" dirty="0"/>
+            <a:endParaRPr lang="en-US" sz="1100" dirty="0"/>
           </a:p>
         </p:txBody>
       </p:sp>
@@ -5334,8 +5334,8 @@
         </p:nvSpPr>
         <p:spPr>
           <a:xfrm>
-            <a:off x="4526280" y="2139696"/>
-            <a:ext cx="868680" cy="274320"/>
+            <a:off x="3977640" y="2139696"/>
+            <a:ext cx="777240" cy="274320"/>
           </a:xfrm>
           <a:prstGeom prst="rect">
             <a:avLst/>
@@ -5351,7 +5351,7 @@
               <a:buNone/>
             </a:pPr>
             <a:r>
-              <a:rPr lang="en-US" sz="950" b="1" dirty="0">
+              <a:rPr lang="en-US" sz="900" b="1" dirty="0">
                 <a:solidFill>
                   <a:srgbClr val="1F9D68"/>
                 </a:solidFill>
@@ -5361,7 +5361,7 @@
               </a:rPr>
               <a:t>PROVEN</a:t>
             </a:r>
-            <a:endParaRPr lang="en-US" sz="950" dirty="0"/>
+            <a:endParaRPr lang="en-US" sz="900" dirty="0"/>
           </a:p>
         </p:txBody>
       </p:sp>
@@ -5373,24 +5373,24 @@
         </p:nvSpPr>
         <p:spPr>
           <a:xfrm>
-            <a:off x="4526280" y="2432304"/>
-            <a:ext cx="1645920" cy="384048"/>
-          </a:xfrm>
-          <a:prstGeom prst="rect">
-            <a:avLst/>
-          </a:prstGeom>
-          <a:noFill/>
-          <a:ln/>
-        </p:spPr>
-        <p:txBody>
-          <a:bodyPr wrap="square" lIns="0" tIns="0" rIns="0" bIns="0" rtlCol="0" anchor="ctr"/>
-          <a:lstStyle/>
-          <a:p>
-            <a:pPr indent="0" marL="0">
-              <a:buNone/>
-            </a:pPr>
-            <a:r>
-              <a:rPr lang="en-US" sz="800" dirty="0">
+            <a:off x="3950208" y="2432304"/>
+            <a:ext cx="1572768" cy="384048"/>
+          </a:xfrm>
+          <a:prstGeom prst="rect">
+            <a:avLst/>
+          </a:prstGeom>
+          <a:noFill/>
+          <a:ln/>
+        </p:spPr>
+        <p:txBody>
+          <a:bodyPr wrap="square" lIns="0" tIns="0" rIns="0" bIns="0" rtlCol="0" anchor="ctr"/>
+          <a:lstStyle/>
+          <a:p>
+            <a:pPr indent="0" marL="0">
+              <a:buNone/>
+            </a:pPr>
+            <a:r>
+              <a:rPr lang="en-US" sz="750" dirty="0">
                 <a:solidFill>
                   <a:srgbClr val="5E6B85"/>
                 </a:solidFill>
@@ -5400,7 +5400,7 @@
               </a:rPr>
               <a:t>"radio link: connected"</a:t>
             </a:r>
-            <a:endParaRPr lang="en-US" sz="800" dirty="0"/>
+            <a:endParaRPr lang="en-US" sz="750" dirty="0"/>
           </a:p>
         </p:txBody>
       </p:sp>
@@ -5412,7 +5412,7 @@
         </p:nvSpPr>
         <p:spPr>
           <a:xfrm>
-            <a:off x="1051560" y="2871216"/>
+            <a:off x="1005840" y="2871216"/>
             <a:ext cx="0" cy="164592"/>
           </a:xfrm>
           <a:prstGeom prst="line">
@@ -5437,7 +5437,7 @@
         <p:spPr>
           <a:xfrm>
             <a:off x="457200" y="3035808"/>
-            <a:ext cx="5760720" cy="804672"/>
+            <a:ext cx="5120640" cy="804672"/>
           </a:xfrm>
           <a:prstGeom prst="rect">
             <a:avLst/>
@@ -5462,23 +5462,23 @@
         <p:spPr>
           <a:xfrm>
             <a:off x="594360" y="3090672"/>
-            <a:ext cx="3840480" cy="713232"/>
-          </a:xfrm>
-          <a:prstGeom prst="rect">
-            <a:avLst/>
-          </a:prstGeom>
-          <a:noFill/>
-          <a:ln/>
-        </p:spPr>
-        <p:txBody>
-          <a:bodyPr wrap="square" lIns="0" tIns="0" rIns="0" bIns="0" rtlCol="0" anchor="ctr"/>
-          <a:lstStyle/>
-          <a:p>
-            <a:pPr indent="0" marL="0">
-              <a:buNone/>
-            </a:pPr>
-            <a:r>
-              <a:rPr lang="en-US" sz="1150" b="1" dirty="0">
+            <a:ext cx="3291840" cy="713232"/>
+          </a:xfrm>
+          <a:prstGeom prst="rect">
+            <a:avLst/>
+          </a:prstGeom>
+          <a:noFill/>
+          <a:ln/>
+        </p:spPr>
+        <p:txBody>
+          <a:bodyPr wrap="square" lIns="0" tIns="0" rIns="0" bIns="0" rtlCol="0" anchor="ctr"/>
+          <a:lstStyle/>
+          <a:p>
+            <a:pPr indent="0" marL="0">
+              <a:buNone/>
+            </a:pPr>
+            <a:r>
+              <a:rPr lang="en-US" sz="1100" b="1" dirty="0">
                 <a:solidFill>
                   <a:srgbClr val="16213D"/>
                 </a:solidFill>
@@ -5488,14 +5488,14 @@
               </a:rPr>
               <a:t>Decode to TrackerState</a:t>
             </a:r>
-            <a:endParaRPr lang="en-US" sz="1150" dirty="0"/>
-          </a:p>
-          <a:p>
-            <a:pPr indent="0" marL="0">
-              <a:buNone/>
-            </a:pPr>
-            <a:r>
-              <a:rPr lang="en-US" sz="950" dirty="0">
+            <a:endParaRPr lang="en-US" sz="1100" dirty="0"/>
+          </a:p>
+          <a:p>
+            <a:pPr indent="0" marL="0">
+              <a:buNone/>
+            </a:pPr>
+            <a:r>
+              <a:rPr lang="en-US" sz="900" dirty="0">
                 <a:solidFill>
                   <a:srgbClr val="5E6B85"/>
                 </a:solidFill>
@@ -5505,7 +5505,7 @@
               </a:rPr>
               <a:t>protobuf frames become live coordinates</a:t>
             </a:r>
-            <a:endParaRPr lang="en-US" sz="1150" dirty="0"/>
+            <a:endParaRPr lang="en-US" sz="1100" dirty="0"/>
           </a:p>
         </p:txBody>
       </p:sp>
@@ -5517,8 +5517,8 @@
         </p:nvSpPr>
         <p:spPr>
           <a:xfrm>
-            <a:off x="4526280" y="3108960"/>
-            <a:ext cx="868680" cy="274320"/>
+            <a:off x="3977640" y="3108960"/>
+            <a:ext cx="777240" cy="274320"/>
           </a:xfrm>
           <a:prstGeom prst="rect">
             <a:avLst/>
@@ -5534,7 +5534,7 @@
               <a:buNone/>
             </a:pPr>
             <a:r>
-              <a:rPr lang="en-US" sz="950" b="1" dirty="0">
+              <a:rPr lang="en-US" sz="900" b="1" dirty="0">
                 <a:solidFill>
                   <a:srgbClr val="1F9D68"/>
                 </a:solidFill>
@@ -5544,7 +5544,7 @@
               </a:rPr>
               <a:t>PROVEN</a:t>
             </a:r>
-            <a:endParaRPr lang="en-US" sz="950" dirty="0"/>
+            <a:endParaRPr lang="en-US" sz="900" dirty="0"/>
           </a:p>
         </p:txBody>
       </p:sp>
@@ -5556,24 +5556,24 @@
         </p:nvSpPr>
         <p:spPr>
           <a:xfrm>
-            <a:off x="4526280" y="3401568"/>
-            <a:ext cx="1645920" cy="384048"/>
-          </a:xfrm>
-          <a:prstGeom prst="rect">
-            <a:avLst/>
-          </a:prstGeom>
-          <a:noFill/>
-          <a:ln/>
-        </p:spPr>
-        <p:txBody>
-          <a:bodyPr wrap="square" lIns="0" tIns="0" rIns="0" bIns="0" rtlCol="0" anchor="ctr"/>
-          <a:lstStyle/>
-          <a:p>
-            <a:pPr indent="0" marL="0">
-              <a:buNone/>
-            </a:pPr>
-            <a:r>
-              <a:rPr lang="en-US" sz="800" dirty="0">
+            <a:off x="3950208" y="3401568"/>
+            <a:ext cx="1572768" cy="384048"/>
+          </a:xfrm>
+          <a:prstGeom prst="rect">
+            <a:avLst/>
+          </a:prstGeom>
+          <a:noFill/>
+          <a:ln/>
+        </p:spPr>
+        <p:txBody>
+          <a:bodyPr wrap="square" lIns="0" tIns="0" rIns="0" bIns="0" rtlCol="0" anchor="ctr"/>
+          <a:lstStyle/>
+          <a:p>
+            <a:pPr indent="0" marL="0">
+              <a:buNone/>
+            </a:pPr>
+            <a:r>
+              <a:rPr lang="en-US" sz="750" dirty="0">
                 <a:solidFill>
                   <a:srgbClr val="5E6B85"/>
                 </a:solidFill>
@@ -5583,7 +5583,7 @@
               </a:rPr>
               <a:t>"ME 33.60719 -101.89643"</a:t>
             </a:r>
-            <a:endParaRPr lang="en-US" sz="800" dirty="0"/>
+            <a:endParaRPr lang="en-US" sz="750" dirty="0"/>
           </a:p>
         </p:txBody>
       </p:sp>
@@ -5595,7 +5595,7 @@
         </p:nvSpPr>
         <p:spPr>
           <a:xfrm>
-            <a:off x="1051560" y="3840480"/>
+            <a:off x="1005840" y="3840480"/>
             <a:ext cx="0" cy="164592"/>
           </a:xfrm>
           <a:prstGeom prst="line">
@@ -5620,7 +5620,7 @@
         <p:spPr>
           <a:xfrm>
             <a:off x="457200" y="4005072"/>
-            <a:ext cx="5760720" cy="804672"/>
+            <a:ext cx="5120640" cy="804672"/>
           </a:xfrm>
           <a:prstGeom prst="rect">
             <a:avLst/>
@@ -5645,23 +5645,23 @@
         <p:spPr>
           <a:xfrm>
             <a:off x="594360" y="4059936"/>
-            <a:ext cx="3840480" cy="713232"/>
-          </a:xfrm>
-          <a:prstGeom prst="rect">
-            <a:avLst/>
-          </a:prstGeom>
-          <a:noFill/>
-          <a:ln/>
-        </p:spPr>
-        <p:txBody>
-          <a:bodyPr wrap="square" lIns="0" tIns="0" rIns="0" bIns="0" rtlCol="0" anchor="ctr"/>
-          <a:lstStyle/>
-          <a:p>
-            <a:pPr indent="0" marL="0">
-              <a:buNone/>
-            </a:pPr>
-            <a:r>
-              <a:rPr lang="en-US" sz="1150" b="1" dirty="0">
+            <a:ext cx="3291840" cy="713232"/>
+          </a:xfrm>
+          <a:prstGeom prst="rect">
+            <a:avLst/>
+          </a:prstGeom>
+          <a:noFill/>
+          <a:ln/>
+        </p:spPr>
+        <p:txBody>
+          <a:bodyPr wrap="square" lIns="0" tIns="0" rIns="0" bIns="0" rtlCol="0" anchor="ctr"/>
+          <a:lstStyle/>
+          <a:p>
+            <a:pPr indent="0" marL="0">
+              <a:buNone/>
+            </a:pPr>
+            <a:r>
+              <a:rPr lang="en-US" sz="1100" b="1" dirty="0">
                 <a:solidFill>
                   <a:srgbClr val="16213D"/>
                 </a:solidFill>
@@ -5671,14 +5671,14 @@
               </a:rPr>
               <a:t>Navigation and UI</a:t>
             </a:r>
-            <a:endParaRPr lang="en-US" sz="1150" dirty="0"/>
-          </a:p>
-          <a:p>
-            <a:pPr indent="0" marL="0">
-              <a:buNone/>
-            </a:pPr>
-            <a:r>
-              <a:rPr lang="en-US" sz="950" dirty="0">
+            <a:endParaRPr lang="en-US" sz="1100" dirty="0"/>
+          </a:p>
+          <a:p>
+            <a:pPr indent="0" marL="0">
+              <a:buNone/>
+            </a:pPr>
+            <a:r>
+              <a:rPr lang="en-US" sz="900" dirty="0">
                 <a:solidFill>
                   <a:srgbClr val="5E6B85"/>
                 </a:solidFill>
@@ -5688,7 +5688,7 @@
               </a:rPr>
               <a:t>state-driven pages, honest ages, local clock</a:t>
             </a:r>
-            <a:endParaRPr lang="en-US" sz="1150" dirty="0"/>
+            <a:endParaRPr lang="en-US" sz="1100" dirty="0"/>
           </a:p>
         </p:txBody>
       </p:sp>
@@ -5700,8 +5700,8 @@
         </p:nvSpPr>
         <p:spPr>
           <a:xfrm>
-            <a:off x="4526280" y="4078224"/>
-            <a:ext cx="868680" cy="274320"/>
+            <a:off x="3977640" y="4078224"/>
+            <a:ext cx="777240" cy="274320"/>
           </a:xfrm>
           <a:prstGeom prst="rect">
             <a:avLst/>
@@ -5717,7 +5717,7 @@
               <a:buNone/>
             </a:pPr>
             <a:r>
-              <a:rPr lang="en-US" sz="950" b="1" dirty="0">
+              <a:rPr lang="en-US" sz="900" b="1" dirty="0">
                 <a:solidFill>
                   <a:srgbClr val="1F9D68"/>
                 </a:solidFill>
@@ -5727,7 +5727,7 @@
               </a:rPr>
               <a:t>PROVEN</a:t>
             </a:r>
-            <a:endParaRPr lang="en-US" sz="950" dirty="0"/>
+            <a:endParaRPr lang="en-US" sz="900" dirty="0"/>
           </a:p>
         </p:txBody>
       </p:sp>
@@ -5739,24 +5739,24 @@
         </p:nvSpPr>
         <p:spPr>
           <a:xfrm>
-            <a:off x="4526280" y="4370832"/>
-            <a:ext cx="1645920" cy="384048"/>
-          </a:xfrm>
-          <a:prstGeom prst="rect">
-            <a:avLst/>
-          </a:prstGeom>
-          <a:noFill/>
-          <a:ln/>
-        </p:spPr>
-        <p:txBody>
-          <a:bodyPr wrap="square" lIns="0" tIns="0" rIns="0" bIns="0" rtlCol="0" anchor="ctr"/>
-          <a:lstStyle/>
-          <a:p>
-            <a:pPr indent="0" marL="0">
-              <a:buNone/>
-            </a:pPr>
-            <a:r>
-              <a:rPr lang="en-US" sz="800" dirty="0">
+            <a:off x="3950208" y="4370832"/>
+            <a:ext cx="1572768" cy="384048"/>
+          </a:xfrm>
+          <a:prstGeom prst="rect">
+            <a:avLst/>
+          </a:prstGeom>
+          <a:noFill/>
+          <a:ln/>
+        </p:spPr>
+        <p:txBody>
+          <a:bodyPr wrap="square" lIns="0" tIns="0" rIns="0" bIns="0" rtlCol="0" anchor="ctr"/>
+          <a:lstStyle/>
+          <a:p>
+            <a:pPr indent="0" marL="0">
+              <a:buNone/>
+            </a:pPr>
+            <a:r>
+              <a:rPr lang="en-US" sz="750" dirty="0">
                 <a:solidFill>
                   <a:srgbClr val="5E6B85"/>
                 </a:solidFill>
@@ -5766,7 +5766,7 @@
               </a:rPr>
               <a:t>"6:59a CDT, age 55 s"</a:t>
             </a:r>
-            <a:endParaRPr lang="en-US" sz="800" dirty="0"/>
+            <a:endParaRPr lang="en-US" sz="750" dirty="0"/>
           </a:p>
         </p:txBody>
       </p:sp>
@@ -5778,7 +5778,7 @@
         </p:nvSpPr>
         <p:spPr>
           <a:xfrm>
-            <a:off x="1051560" y="4809744"/>
+            <a:off x="1005840" y="4809744"/>
             <a:ext cx="0" cy="164592"/>
           </a:xfrm>
           <a:prstGeom prst="line">
@@ -5803,7 +5803,7 @@
         <p:spPr>
           <a:xfrm>
             <a:off x="457200" y="4974336"/>
-            <a:ext cx="5760720" cy="804672"/>
+            <a:ext cx="5120640" cy="804672"/>
           </a:xfrm>
           <a:prstGeom prst="rect">
             <a:avLst/>
@@ -5828,23 +5828,23 @@
         <p:spPr>
           <a:xfrm>
             <a:off x="594360" y="5029200"/>
-            <a:ext cx="3840480" cy="713232"/>
-          </a:xfrm>
-          <a:prstGeom prst="rect">
-            <a:avLst/>
-          </a:prstGeom>
-          <a:noFill/>
-          <a:ln/>
-        </p:spPr>
-        <p:txBody>
-          <a:bodyPr wrap="square" lIns="0" tIns="0" rIns="0" bIns="0" rtlCol="0" anchor="ctr"/>
-          <a:lstStyle/>
-          <a:p>
-            <a:pPr indent="0" marL="0">
-              <a:buNone/>
-            </a:pPr>
-            <a:r>
-              <a:rPr lang="en-US" sz="1150" b="1" dirty="0">
+            <a:ext cx="3291840" cy="713232"/>
+          </a:xfrm>
+          <a:prstGeom prst="rect">
+            <a:avLst/>
+          </a:prstGeom>
+          <a:noFill/>
+          <a:ln/>
+        </p:spPr>
+        <p:txBody>
+          <a:bodyPr wrap="square" lIns="0" tIns="0" rIns="0" bIns="0" rtlCol="0" anchor="ctr"/>
+          <a:lstStyle/>
+          <a:p>
+            <a:pPr indent="0" marL="0">
+              <a:buNone/>
+            </a:pPr>
+            <a:r>
+              <a:rPr lang="en-US" sz="1100" b="1" dirty="0">
                 <a:solidFill>
                   <a:srgbClr val="16213D"/>
                 </a:solidFill>
@@ -5854,14 +5854,14 @@
               </a:rPr>
               <a:t>Partner over LoRa</a:t>
             </a:r>
-            <a:endParaRPr lang="en-US" sz="1150" dirty="0"/>
-          </a:p>
-          <a:p>
-            <a:pPr indent="0" marL="0">
-              <a:buNone/>
-            </a:pPr>
-            <a:r>
-              <a:rPr lang="en-US" sz="950" dirty="0">
+            <a:endParaRPr lang="en-US" sz="1100" dirty="0"/>
+          </a:p>
+          <a:p>
+            <a:pPr indent="0" marL="0">
+              <a:buNone/>
+            </a:pPr>
+            <a:r>
+              <a:rPr lang="en-US" sz="900" dirty="0">
                 <a:solidFill>
                   <a:srgbClr val="5E6B85"/>
                 </a:solidFill>
@@ -5871,7 +5871,7 @@
               </a:rPr>
               <a:t>second radio joins the encrypted channel</a:t>
             </a:r>
-            <a:endParaRPr lang="en-US" sz="1150" dirty="0"/>
+            <a:endParaRPr lang="en-US" sz="1100" dirty="0"/>
           </a:p>
         </p:txBody>
       </p:sp>
@@ -5883,8 +5883,8 @@
         </p:nvSpPr>
         <p:spPr>
           <a:xfrm>
-            <a:off x="4526280" y="5047488"/>
-            <a:ext cx="868680" cy="274320"/>
+            <a:off x="3977640" y="5047488"/>
+            <a:ext cx="777240" cy="274320"/>
           </a:xfrm>
           <a:prstGeom prst="rect">
             <a:avLst/>
@@ -5900,7 +5900,7 @@
               <a:buNone/>
             </a:pPr>
             <a:r>
-              <a:rPr lang="en-US" sz="950" b="1" dirty="0">
+              <a:rPr lang="en-US" sz="900" b="1" dirty="0">
                 <a:solidFill>
                   <a:srgbClr val="B06207"/>
                 </a:solidFill>
@@ -5910,7 +5910,7 @@
               </a:rPr>
               <a:t>NEXT</a:t>
             </a:r>
-            <a:endParaRPr lang="en-US" sz="950" dirty="0"/>
+            <a:endParaRPr lang="en-US" sz="900" dirty="0"/>
           </a:p>
         </p:txBody>
       </p:sp>
@@ -5922,24 +5922,24 @@
         </p:nvSpPr>
         <p:spPr>
           <a:xfrm>
-            <a:off x="4526280" y="5340096"/>
-            <a:ext cx="1645920" cy="384048"/>
-          </a:xfrm>
-          <a:prstGeom prst="rect">
-            <a:avLst/>
-          </a:prstGeom>
-          <a:noFill/>
-          <a:ln/>
-        </p:spPr>
-        <p:txBody>
-          <a:bodyPr wrap="square" lIns="0" tIns="0" rIns="0" bIns="0" rtlCol="0" anchor="ctr"/>
-          <a:lstStyle/>
-          <a:p>
-            <a:pPr indent="0" marL="0">
-              <a:buNone/>
-            </a:pPr>
-            <a:r>
-              <a:rPr lang="en-US" sz="800" dirty="0">
+            <a:off x="3950208" y="5340096"/>
+            <a:ext cx="1572768" cy="384048"/>
+          </a:xfrm>
+          <a:prstGeom prst="rect">
+            <a:avLst/>
+          </a:prstGeom>
+          <a:noFill/>
+          <a:ln/>
+        </p:spPr>
+        <p:txBody>
+          <a:bodyPr wrap="square" lIns="0" tIns="0" rIns="0" bIns="0" rtlCol="0" anchor="ctr"/>
+          <a:lstStyle/>
+          <a:p>
+            <a:pPr indent="0" marL="0">
+              <a:buNone/>
+            </a:pPr>
+            <a:r>
+              <a:rPr lang="en-US" sz="750" dirty="0">
                 <a:solidFill>
                   <a:srgbClr val="5E6B85"/>
                 </a:solidFill>
@@ -5949,13 +5949,13 @@
               </a:rPr>
               <a:t>"PTR no partner heard yet"</a:t>
             </a:r>
-            <a:endParaRPr lang="en-US" sz="800" dirty="0"/>
+            <a:endParaRPr lang="en-US" sz="750" dirty="0"/>
           </a:p>
         </p:txBody>
       </p:sp>
       <p:pic>
         <p:nvPicPr>
-          <p:cNvPr id="34" name="Image 0" descr="C:/Users/deogr/AppData/Local/Temp/claude/C--Users-deogr-Documents-Fall-Project-Off-Grid-Vehicle-dection-project/e8b2e8fa-1513-4aa8-a8f6-ce4fcd20e664/scratchpad/deck3/p_overall.jpg">    </p:cNvPr>
+          <p:cNvPr id="34" name="Image 0" descr="C:/Users/deogr/AppData/Local/Temp/claude/C--Users-deogr-Documents-Fall-Project-Off-Grid-Vehicle-dection-project/e8b2e8fa-1513-4aa8-a8f6-ce4fcd20e664/scratchpad/deck3/p_search.jpg">    </p:cNvPr>
           <p:cNvPicPr>
             <a:picLocks noChangeAspect="1"/>
           </p:cNvPicPr>
@@ -5969,8 +5969,8 @@
         </p:blipFill>
         <p:spPr>
           <a:xfrm>
-            <a:off x="6537960" y="1097280"/>
-            <a:ext cx="2468880" cy="1773936"/>
+            <a:off x="5852160" y="1097280"/>
+            <a:ext cx="1783080" cy="1399032"/>
           </a:xfrm>
           <a:prstGeom prst="rect">
             <a:avLst/>
@@ -5985,8 +5985,8 @@
         </p:nvSpPr>
         <p:spPr>
           <a:xfrm>
-            <a:off x="6537960" y="1097280"/>
-            <a:ext cx="2468880" cy="1773936"/>
+            <a:off x="5852160" y="1097280"/>
+            <a:ext cx="1783080" cy="1399032"/>
           </a:xfrm>
           <a:prstGeom prst="rect">
             <a:avLst/>
@@ -6007,8 +6007,8 @@
         </p:nvSpPr>
         <p:spPr>
           <a:xfrm>
-            <a:off x="6537960" y="2898648"/>
-            <a:ext cx="2468880" cy="274320"/>
+            <a:off x="5852160" y="2523744"/>
+            <a:ext cx="1783080" cy="274320"/>
           </a:xfrm>
           <a:prstGeom prst="rect">
             <a:avLst/>
@@ -6032,22 +6032,107 @@
                 <a:ea typeface="Courier New" pitchFamily="34" charset="-122"/>
                 <a:cs typeface="Courier New" pitchFamily="34" charset="-120"/>
               </a:rPr>
-              <a:t>Our display: ME 33.60719 -101.89643</a:t>
+              <a:t>Boot: link + GPS proven</a:t>
             </a:r>
             <a:endParaRPr lang="en-US" sz="950" dirty="0"/>
           </a:p>
         </p:txBody>
       </p:sp>
-      <p:sp>
-        <p:nvSpPr>
-          <p:cNvPr id="37" name="Shape 34"/>
+      <p:pic>
+        <p:nvPicPr>
+          <p:cNvPr id="37" name="Image 1" descr="C:/Users/deogr/AppData/Local/Temp/claude/C--Users-deogr-Documents-Fall-Project-Off-Grid-Vehicle-dection-project/e8b2e8fa-1513-4aa8-a8f6-ce4fcd20e664/scratchpad/deck3/p_overall.jpg">    </p:cNvPr>
+          <p:cNvPicPr>
+            <a:picLocks noChangeAspect="1"/>
+          </p:cNvPicPr>
+          <p:nvPr/>
+        </p:nvPicPr>
+        <p:blipFill>
+          <a:blip r:embed="rId2"/>
+          <a:stretch>
+            <a:fillRect/>
+          </a:stretch>
+        </p:blipFill>
+        <p:spPr>
+          <a:xfrm>
+            <a:off x="7772400" y="1097280"/>
+            <a:ext cx="1920240" cy="1380744"/>
+          </a:xfrm>
+          <a:prstGeom prst="rect">
+            <a:avLst/>
+          </a:prstGeom>
+        </p:spPr>
+      </p:pic>
+      <p:sp>
+        <p:nvSpPr>
+          <p:cNvPr id="38" name="Shape 34"/>
           <p:cNvSpPr/>
           <p:nvPr/>
         </p:nvSpPr>
         <p:spPr>
           <a:xfrm>
-            <a:off x="9144000" y="1097280"/>
-            <a:ext cx="2606040" cy="2066544"/>
+            <a:off x="7772400" y="1097280"/>
+            <a:ext cx="1920240" cy="1380744"/>
+          </a:xfrm>
+          <a:prstGeom prst="rect">
+            <a:avLst/>
+          </a:prstGeom>
+          <a:ln w="12700">
+            <a:solidFill>
+              <a:srgbClr val="9AA7BE"/>
+            </a:solidFill>
+            <a:prstDash val="solid"/>
+          </a:ln>
+        </p:spPr>
+      </p:sp>
+      <p:sp>
+        <p:nvSpPr>
+          <p:cNvPr id="39" name="Text 35"/>
+          <p:cNvSpPr txBox="1"/>
+          <p:nvPr/>
+        </p:nvSpPr>
+        <p:spPr>
+          <a:xfrm>
+            <a:off x="7772400" y="2505456"/>
+            <a:ext cx="1920240" cy="274320"/>
+          </a:xfrm>
+          <a:prstGeom prst="rect">
+            <a:avLst/>
+          </a:prstGeom>
+          <a:noFill/>
+          <a:ln/>
+        </p:spPr>
+        <p:txBody>
+          <a:bodyPr wrap="square" lIns="0" tIns="0" rIns="0" bIns="0" rtlCol="0" anchor="ctr"/>
+          <a:lstStyle/>
+          <a:p>
+            <a:pPr algn="ctr" indent="0" marL="0">
+              <a:buNone/>
+            </a:pPr>
+            <a:r>
+              <a:rPr lang="en-US" sz="950" dirty="0">
+                <a:solidFill>
+                  <a:srgbClr val="5E6B85"/>
+                </a:solidFill>
+                <a:latin typeface="Courier New" pitchFamily="34" charset="0"/>
+                <a:ea typeface="Courier New" pitchFamily="34" charset="-122"/>
+                <a:cs typeface="Courier New" pitchFamily="34" charset="-120"/>
+              </a:rPr>
+              <a:t>ME 33.60719 -101.89643</a:t>
+            </a:r>
+            <a:endParaRPr lang="en-US" sz="950" dirty="0"/>
+          </a:p>
+        </p:txBody>
+      </p:sp>
+      <p:sp>
+        <p:nvSpPr>
+          <p:cNvPr id="40" name="Shape 36"/>
+          <p:cNvSpPr/>
+          <p:nvPr/>
+        </p:nvSpPr>
+        <p:spPr>
+          <a:xfrm>
+            <a:off x="9829800" y="1097280"/>
+            <a:ext cx="1920240" cy="1828800"/>
           </a:xfrm>
           <a:prstGeom prst="rect">
             <a:avLst/>
@@ -6065,30 +6150,30 @@
       </p:sp>
       <p:sp>
         <p:nvSpPr>
-          <p:cNvPr id="38" name="Text 35"/>
-          <p:cNvSpPr txBox="1"/>
-          <p:nvPr/>
-        </p:nvSpPr>
-        <p:spPr>
-          <a:xfrm>
-            <a:off x="9281160" y="1207008"/>
-            <a:ext cx="2377440" cy="274320"/>
-          </a:xfrm>
-          <a:prstGeom prst="rect">
-            <a:avLst/>
-          </a:prstGeom>
-          <a:noFill/>
-          <a:ln/>
-        </p:spPr>
-        <p:txBody>
-          <a:bodyPr wrap="square" lIns="0" tIns="0" rIns="0" bIns="0" rtlCol="0" anchor="ctr"/>
-          <a:lstStyle/>
-          <a:p>
-            <a:pPr indent="0" marL="0">
-              <a:buNone/>
-            </a:pPr>
-            <a:r>
-              <a:rPr lang="en-US" sz="1050" b="1" spc="100" kern="0" dirty="0">
+          <p:cNvPr id="41" name="Text 37"/>
+          <p:cNvSpPr txBox="1"/>
+          <p:nvPr/>
+        </p:nvSpPr>
+        <p:spPr>
+          <a:xfrm>
+            <a:off x="9939528" y="1188720"/>
+            <a:ext cx="1737360" cy="457200"/>
+          </a:xfrm>
+          <a:prstGeom prst="rect">
+            <a:avLst/>
+          </a:prstGeom>
+          <a:noFill/>
+          <a:ln/>
+        </p:spPr>
+        <p:txBody>
+          <a:bodyPr wrap="square" lIns="0" tIns="0" rIns="0" bIns="0" rtlCol="0" anchor="ctr"/>
+          <a:lstStyle/>
+          <a:p>
+            <a:pPr indent="0" marL="0">
+              <a:buNone/>
+            </a:pPr>
+            <a:r>
+              <a:rPr lang="en-US" sz="1000" b="1" spc="100" kern="0" dirty="0">
                 <a:solidFill>
                   <a:srgbClr val="1F9D68"/>
                 </a:solidFill>
@@ -6098,36 +6183,36 @@
               </a:rPr>
               <a:t>POSITION CROSS-CHECK</a:t>
             </a:r>
-            <a:endParaRPr lang="en-US" sz="1050" dirty="0"/>
-          </a:p>
-        </p:txBody>
-      </p:sp>
-      <p:sp>
-        <p:nvSpPr>
-          <p:cNvPr id="39" name="Text 36"/>
-          <p:cNvSpPr txBox="1"/>
-          <p:nvPr/>
-        </p:nvSpPr>
-        <p:spPr>
-          <a:xfrm>
-            <a:off x="9281160" y="1499616"/>
-            <a:ext cx="2377440" cy="1609344"/>
-          </a:xfrm>
-          <a:prstGeom prst="rect">
-            <a:avLst/>
-          </a:prstGeom>
-          <a:noFill/>
-          <a:ln/>
-        </p:spPr>
-        <p:txBody>
-          <a:bodyPr wrap="square" lIns="0" tIns="0" rIns="0" bIns="0" rtlCol="0" anchor="ctr"/>
-          <a:lstStyle/>
-          <a:p>
-            <a:pPr indent="0" marL="0">
-              <a:buNone/>
-            </a:pPr>
-            <a:r>
-              <a:rPr lang="en-US" sz="950" dirty="0">
+            <a:endParaRPr lang="en-US" sz="1000" dirty="0"/>
+          </a:p>
+        </p:txBody>
+      </p:sp>
+      <p:sp>
+        <p:nvSpPr>
+          <p:cNvPr id="42" name="Text 38"/>
+          <p:cNvSpPr txBox="1"/>
+          <p:nvPr/>
+        </p:nvSpPr>
+        <p:spPr>
+          <a:xfrm>
+            <a:off x="9939528" y="1627632"/>
+            <a:ext cx="1719072" cy="1261872"/>
+          </a:xfrm>
+          <a:prstGeom prst="rect">
+            <a:avLst/>
+          </a:prstGeom>
+          <a:noFill/>
+          <a:ln/>
+        </p:spPr>
+        <p:txBody>
+          <a:bodyPr wrap="square" lIns="0" tIns="0" rIns="0" bIns="0" rtlCol="0" anchor="ctr"/>
+          <a:lstStyle/>
+          <a:p>
+            <a:pPr indent="0" marL="0">
+              <a:buNone/>
+            </a:pPr>
+            <a:r>
+              <a:rPr lang="en-US" sz="850" dirty="0">
                 <a:solidFill>
                   <a:srgbClr val="222A3F"/>
                 </a:solidFill>
@@ -6135,22 +6220,22 @@
                 <a:ea typeface="Arial" pitchFamily="34" charset="-122"/>
                 <a:cs typeface="Arial" pitchFamily="34" charset="-120"/>
               </a:rPr>
-              <a:t>The fix on our display and the marker on the standard Meshtastic web client are the same position, read from the same radio by two independent programs. Agreement between clients that share no code is the accuracy check. Radio two will fill the PTR row through this same pipeline.</a:t>
-            </a:r>
-            <a:endParaRPr lang="en-US" sz="950" dirty="0"/>
-          </a:p>
-        </p:txBody>
-      </p:sp>
-      <p:sp>
-        <p:nvSpPr>
-          <p:cNvPr id="40" name="Text 37"/>
-          <p:cNvSpPr txBox="1"/>
-          <p:nvPr/>
-        </p:nvSpPr>
-        <p:spPr>
-          <a:xfrm>
-            <a:off x="6537960" y="3273552"/>
-            <a:ext cx="5212080" cy="237744"/>
+              <a:t>Display and web-client marker show the same fix from the same radio, via two programs sharing no code. Independent agreement is the accuracy check.</a:t>
+            </a:r>
+            <a:endParaRPr lang="en-US" sz="850" dirty="0"/>
+          </a:p>
+        </p:txBody>
+      </p:sp>
+      <p:sp>
+        <p:nvSpPr>
+          <p:cNvPr id="43" name="Text 39"/>
+          <p:cNvSpPr txBox="1"/>
+          <p:nvPr/>
+        </p:nvSpPr>
+        <p:spPr>
+          <a:xfrm>
+            <a:off x="5852160" y="2999232"/>
+            <a:ext cx="5897880" cy="219456"/>
           </a:xfrm>
           <a:prstGeom prst="rect">
             <a:avLst/>
@@ -6182,22 +6267,22 @@
       </p:sp>
       <p:pic>
         <p:nvPicPr>
-          <p:cNvPr id="41" name="Image 1" descr="C:/Users/deogr/AppData/Local/Temp/claude/C--Users-deogr-Documents-Fall-Project-Off-Grid-Vehicle-dection-project/e8b2e8fa-1513-4aa8-a8f6-ce4fcd20e664/scratchpad/deck3/p_map.png">    </p:cNvPr>
+          <p:cNvPr id="44" name="Image 2" descr="C:/Users/deogr/AppData/Local/Temp/claude/C--Users-deogr-Documents-Fall-Project-Off-Grid-Vehicle-dection-project/e8b2e8fa-1513-4aa8-a8f6-ce4fcd20e664/scratchpad/deck3/p_map_zoom.png">    </p:cNvPr>
           <p:cNvPicPr>
             <a:picLocks noChangeAspect="1"/>
           </p:cNvPicPr>
           <p:nvPr/>
         </p:nvPicPr>
         <p:blipFill>
-          <a:blip r:embed="rId2"/>
+          <a:blip r:embed="rId3"/>
           <a:stretch>
             <a:fillRect/>
           </a:stretch>
         </p:blipFill>
         <p:spPr>
           <a:xfrm>
-            <a:off x="6537960" y="3529584"/>
-            <a:ext cx="3703320" cy="2670048"/>
+            <a:off x="5852160" y="3255264"/>
+            <a:ext cx="3977640" cy="2935224"/>
           </a:xfrm>
           <a:prstGeom prst="rect">
             <a:avLst/>
@@ -6206,14 +6291,14 @@
       </p:pic>
       <p:sp>
         <p:nvSpPr>
-          <p:cNvPr id="42" name="Shape 38"/>
+          <p:cNvPr id="45" name="Shape 40"/>
           <p:cNvSpPr/>
           <p:nvPr/>
         </p:nvSpPr>
         <p:spPr>
           <a:xfrm>
-            <a:off x="6537960" y="3529584"/>
-            <a:ext cx="3703320" cy="2670048"/>
+            <a:off x="5852160" y="3255264"/>
+            <a:ext cx="3977640" cy="2935224"/>
           </a:xfrm>
           <a:prstGeom prst="rect">
             <a:avLst/>
@@ -6228,14 +6313,14 @@
       </p:sp>
       <p:sp>
         <p:nvSpPr>
-          <p:cNvPr id="43" name="Text 39"/>
-          <p:cNvSpPr txBox="1"/>
-          <p:nvPr/>
-        </p:nvSpPr>
-        <p:spPr>
-          <a:xfrm>
-            <a:off x="10378440" y="3529584"/>
-            <a:ext cx="1371600" cy="2670048"/>
+          <p:cNvPr id="46" name="Text 41"/>
+          <p:cNvSpPr txBox="1"/>
+          <p:nvPr/>
+        </p:nvSpPr>
+        <p:spPr>
+          <a:xfrm>
+            <a:off x="10012680" y="3255264"/>
+            <a:ext cx="1737360" cy="2935224"/>
           </a:xfrm>
           <a:prstGeom prst="rect">
             <a:avLst/>
@@ -6259,7 +6344,7 @@
                 <a:ea typeface="Arial" pitchFamily="34" charset="-122"/>
                 <a:cs typeface="Arial" pitchFamily="34" charset="-120"/>
               </a:rPr>
-              <a:t>One device proves four of five layers at zero coordination cost. The dashed layer waits only for radio two; no display code changes.</a:t>
+              <a:t>One device proves four of five layers at zero coordination cost. Every bug found here never reaches the two-vehicle test. The dashed layer waits only for radio two; no display code changes.</a:t>
             </a:r>
             <a:endParaRPr lang="en-US" sz="900" dirty="0"/>
           </a:p>

</xml_diff>

<commit_message>
References: verified URLs, embedded as clickable hyperlinks
Every reference URL was fetched and confirmed live before shipping;
the eCFR link (which blocks automated access) was replaced with
Cornell Law LII stable mirror of 47 CFR 15.247. The URL lines on
sheet 14 are now real PowerPoint hyperlinks with tooltips, not plain
text, and the briefing carries the same full https URLs.

Co-Authored-By: Claude Fable 5 <noreply@anthropic.com>
</commit_message>
<xml_diff>
--- a/docs/presentations/Group9_Presentation3_Week3.pptx
+++ b/docs/presentations/Group9_Presentation3_Week3.pptx
@@ -9300,7 +9300,7 @@
                 <a:ea typeface="Arial" pitchFamily="34" charset="-122"/>
                 <a:cs typeface="Arial" pitchFamily="34" charset="-120"/>
               </a:rPr>
-              <a:t>Semtech Corp., SX1276/77/78/79 LoRa Transceiver Datasheet. Demodulator SNR limit per spreading factor (SF11 = -17.5 dB), used on sheet 08.</a:t>
+              <a:t>Semtech Corp., SX1276/77/78/79 LoRa Transceiver Datasheet. Demodulator SNR limit per spreading factor (SF11 = -17.5 dB), used on sheet 09.</a:t>
             </a:r>
             <a:endParaRPr lang="en-US" sz="950" dirty="0"/>
           </a:p>
@@ -9331,13 +9331,20 @@
               <a:buNone/>
             </a:pPr>
             <a:r>
-              <a:rPr lang="en-US" sz="800" dirty="0">
+              <a:rPr lang="en-US" sz="800" u="sng" dirty="0">
                 <a:solidFill>
                   <a:srgbClr val="1199BD"/>
                 </a:solidFill>
                 <a:latin typeface="Courier New" pitchFamily="34" charset="0"/>
                 <a:ea typeface="Courier New" pitchFamily="34" charset="-122"/>
                 <a:cs typeface="Courier New" pitchFamily="34" charset="-120"/>
+                <a:hlinkClick r:id="rId1" invalidUrl="" action="" tgtFrame="" tooltip="https://www.semtech.com/products/wireless-rf/lora-connect/sx1276" history="1" highlightClick="0" endSnd="0">
+                  <a:extLst>
+                    <a:ext uri="{A12FA001-AC4F-418D-AE19-62706E023703}">
+                      <ahyp:hlinkClr xmlns:ahyp="http://schemas.microsoft.com/office/drawing/2018/hyperlinkcolor" val="tx"/>
+                    </a:ext>
+                  </a:extLst>
+                </a:hlinkClick>
               </a:rPr>
               <a:t>semtech.com/products/wireless-rf/lora-connect/sx1276</a:t>
             </a:r>
@@ -9448,15 +9455,22 @@
               <a:buNone/>
             </a:pPr>
             <a:r>
-              <a:rPr lang="en-US" sz="800" dirty="0">
+              <a:rPr lang="en-US" sz="800" u="sng" dirty="0">
                 <a:solidFill>
                   <a:srgbClr val="1199BD"/>
                 </a:solidFill>
                 <a:latin typeface="Courier New" pitchFamily="34" charset="0"/>
                 <a:ea typeface="Courier New" pitchFamily="34" charset="-122"/>
                 <a:cs typeface="Courier New" pitchFamily="34" charset="-120"/>
-              </a:rPr>
-              <a:t>info.semtech.com/find-documentation  (search AN1200.22)</a:t>
+                <a:hlinkClick r:id="rId2" invalidUrl="" action="" tgtFrame="" tooltip="https://info.semtech.com/find-documentation" history="1" highlightClick="0" endSnd="0">
+                  <a:extLst>
+                    <a:ext uri="{A12FA001-AC4F-418D-AE19-62706E023703}">
+                      <ahyp:hlinkClr xmlns:ahyp="http://schemas.microsoft.com/office/drawing/2018/hyperlinkcolor" val="tx"/>
+                    </a:ext>
+                  </a:extLst>
+                </a:hlinkClick>
+              </a:rPr>
+              <a:t>info.semtech.com/find-documentation (search AN1200.22)</a:t>
             </a:r>
             <a:endParaRPr lang="en-US" sz="800" dirty="0"/>
           </a:p>
@@ -9565,13 +9579,20 @@
               <a:buNone/>
             </a:pPr>
             <a:r>
-              <a:rPr lang="en-US" sz="800" dirty="0">
+              <a:rPr lang="en-US" sz="800" u="sng" dirty="0">
                 <a:solidFill>
                   <a:srgbClr val="1199BD"/>
                 </a:solidFill>
                 <a:latin typeface="Courier New" pitchFamily="34" charset="0"/>
                 <a:ea typeface="Courier New" pitchFamily="34" charset="-122"/>
                 <a:cs typeface="Courier New" pitchFamily="34" charset="-120"/>
+                <a:hlinkClick r:id="rId3" invalidUrl="" action="" tgtFrame="" tooltip="https://www.semtech.com/products/wireless-rf/lora-connect/sx1262" history="1" highlightClick="0" endSnd="0">
+                  <a:extLst>
+                    <a:ext uri="{A12FA001-AC4F-418D-AE19-62706E023703}">
+                      <ahyp:hlinkClr xmlns:ahyp="http://schemas.microsoft.com/office/drawing/2018/hyperlinkcolor" val="tx"/>
+                    </a:ext>
+                  </a:extLst>
+                </a:hlinkClick>
               </a:rPr>
               <a:t>semtech.com/products/wireless-rf/lora-connect/sx1262</a:t>
             </a:r>
@@ -9682,15 +9703,22 @@
               <a:buNone/>
             </a:pPr>
             <a:r>
-              <a:rPr lang="en-US" sz="800" dirty="0">
+              <a:rPr lang="en-US" sz="800" u="sng" dirty="0">
                 <a:solidFill>
                   <a:srgbClr val="1199BD"/>
                 </a:solidFill>
                 <a:latin typeface="Courier New" pitchFamily="34" charset="0"/>
                 <a:ea typeface="Courier New" pitchFamily="34" charset="-122"/>
                 <a:cs typeface="Courier New" pitchFamily="34" charset="-120"/>
-              </a:rPr>
-              <a:t>meshtastic.org/docs/configuration/radio/lora  ·  /position</a:t>
+                <a:hlinkClick r:id="rId4" invalidUrl="" action="" tgtFrame="" tooltip="https://meshtastic.org/docs/configuration/radio/lora/" history="1" highlightClick="0" endSnd="0">
+                  <a:extLst>
+                    <a:ext uri="{A12FA001-AC4F-418D-AE19-62706E023703}">
+                      <ahyp:hlinkClr xmlns:ahyp="http://schemas.microsoft.com/office/drawing/2018/hyperlinkcolor" val="tx"/>
+                    </a:ext>
+                  </a:extLst>
+                </a:hlinkClick>
+              </a:rPr>
+              <a:t>meshtastic.org/docs/configuration/radio/lora</a:t>
             </a:r>
             <a:endParaRPr lang="en-US" sz="800" dirty="0"/>
           </a:p>
@@ -9799,13 +9827,20 @@
               <a:buNone/>
             </a:pPr>
             <a:r>
-              <a:rPr lang="en-US" sz="800" dirty="0">
+              <a:rPr lang="en-US" sz="800" u="sng" dirty="0">
                 <a:solidFill>
                   <a:srgbClr val="1199BD"/>
                 </a:solidFill>
                 <a:latin typeface="Courier New" pitchFamily="34" charset="0"/>
                 <a:ea typeface="Courier New" pitchFamily="34" charset="-122"/>
                 <a:cs typeface="Courier New" pitchFamily="34" charset="-120"/>
+                <a:hlinkClick r:id="rId5" invalidUrl="" action="" tgtFrame="" tooltip="https://github.com/meshtastic/protobufs" history="1" highlightClick="0" endSnd="0">
+                  <a:extLst>
+                    <a:ext uri="{A12FA001-AC4F-418D-AE19-62706E023703}">
+                      <ahyp:hlinkClr xmlns:ahyp="http://schemas.microsoft.com/office/drawing/2018/hyperlinkcolor" val="tx"/>
+                    </a:ext>
+                  </a:extLst>
+                </a:hlinkClick>
               </a:rPr>
               <a:t>github.com/meshtastic/protobufs</a:t>
             </a:r>
@@ -9916,15 +9951,22 @@
               <a:buNone/>
             </a:pPr>
             <a:r>
-              <a:rPr lang="en-US" sz="800" dirty="0">
+              <a:rPr lang="en-US" sz="800" u="sng" dirty="0">
                 <a:solidFill>
                   <a:srgbClr val="1199BD"/>
                 </a:solidFill>
                 <a:latin typeface="Courier New" pitchFamily="34" charset="0"/>
                 <a:ea typeface="Courier New" pitchFamily="34" charset="-122"/>
                 <a:cs typeface="Courier New" pitchFamily="34" charset="-120"/>
-              </a:rPr>
-              <a:t>ecfr.gov/current/title-47/part-15/section-15.247</a:t>
+                <a:hlinkClick r:id="rId6" invalidUrl="" action="" tgtFrame="" tooltip="https://www.law.cornell.edu/cfr/text/47/15.247" history="1" highlightClick="0" endSnd="0">
+                  <a:extLst>
+                    <a:ext uri="{A12FA001-AC4F-418D-AE19-62706E023703}">
+                      <ahyp:hlinkClr xmlns:ahyp="http://schemas.microsoft.com/office/drawing/2018/hyperlinkcolor" val="tx"/>
+                    </a:ext>
+                  </a:extLst>
+                </a:hlinkClick>
+              </a:rPr>
+              <a:t>law.cornell.edu/cfr/text/47/15.247</a:t>
             </a:r>
             <a:endParaRPr lang="en-US" sz="800" dirty="0"/>
           </a:p>
@@ -10033,15 +10075,22 @@
               <a:buNone/>
             </a:pPr>
             <a:r>
-              <a:rPr lang="en-US" sz="800" dirty="0">
+              <a:rPr lang="en-US" sz="800" u="sng" dirty="0">
                 <a:solidFill>
                   <a:srgbClr val="1199BD"/>
                 </a:solidFill>
                 <a:latin typeface="Courier New" pitchFamily="34" charset="0"/>
                 <a:ea typeface="Courier New" pitchFamily="34" charset="-122"/>
                 <a:cs typeface="Courier New" pitchFamily="34" charset="-120"/>
-              </a:rPr>
-              <a:t>itu.int/rec/R-REC-M.1371</a:t>
+                <a:hlinkClick r:id="rId7" invalidUrl="" action="" tgtFrame="" tooltip="https://www.itu.int/rec/R-REC-M.1371/en" history="1" highlightClick="0" endSnd="0">
+                  <a:extLst>
+                    <a:ext uri="{A12FA001-AC4F-418D-AE19-62706E023703}">
+                      <ahyp:hlinkClr xmlns:ahyp="http://schemas.microsoft.com/office/drawing/2018/hyperlinkcolor" val="tx"/>
+                    </a:ext>
+                  </a:extLst>
+                </a:hlinkClick>
+              </a:rPr>
+              <a:t>itu.int/rec/R-REC-M.1371/en</a:t>
             </a:r>
             <a:endParaRPr lang="en-US" sz="800" dirty="0"/>
           </a:p>
@@ -10150,15 +10199,22 @@
               <a:buNone/>
             </a:pPr>
             <a:r>
-              <a:rPr lang="en-US" sz="800" dirty="0">
+              <a:rPr lang="en-US" sz="800" u="sng" dirty="0">
                 <a:solidFill>
                   <a:srgbClr val="1199BD"/>
                 </a:solidFill>
                 <a:latin typeface="Courier New" pitchFamily="34" charset="0"/>
                 <a:ea typeface="Courier New" pitchFamily="34" charset="-122"/>
                 <a:cs typeface="Courier New" pitchFamily="34" charset="-120"/>
-              </a:rPr>
-              <a:t>movable-type.co.uk/scripts/latlong.html  (implementation ref)</a:t>
+                <a:hlinkClick r:id="rId8" invalidUrl="" action="" tgtFrame="" tooltip="https://www.movable-type.co.uk/scripts/latlong.html" history="1" highlightClick="0" endSnd="0">
+                  <a:extLst>
+                    <a:ext uri="{A12FA001-AC4F-418D-AE19-62706E023703}">
+                      <ahyp:hlinkClr xmlns:ahyp="http://schemas.microsoft.com/office/drawing/2018/hyperlinkcolor" val="tx"/>
+                    </a:ext>
+                  </a:extLst>
+                </a:hlinkClick>
+              </a:rPr>
+              <a:t>movable-type.co.uk/scripts/latlong.html (implementation ref)</a:t>
             </a:r>
             <a:endParaRPr lang="en-US" sz="800" dirty="0"/>
           </a:p>
@@ -10267,13 +10323,20 @@
               <a:buNone/>
             </a:pPr>
             <a:r>
-              <a:rPr lang="en-US" sz="800" dirty="0">
+              <a:rPr lang="en-US" sz="800" u="sng" dirty="0">
                 <a:solidFill>
                   <a:srgbClr val="1199BD"/>
                 </a:solidFill>
                 <a:latin typeface="Courier New" pitchFamily="34" charset="0"/>
                 <a:ea typeface="Courier New" pitchFamily="34" charset="-122"/>
                 <a:cs typeface="Courier New" pitchFamily="34" charset="-120"/>
+                <a:hlinkClick r:id="rId9" invalidUrl="" action="" tgtFrame="" tooltip="https://www.bluetooth.com/specifications/specs/core-specification/" history="1" highlightClick="0" endSnd="0">
+                  <a:extLst>
+                    <a:ext uri="{A12FA001-AC4F-418D-AE19-62706E023703}">
+                      <ahyp:hlinkClr xmlns:ahyp="http://schemas.microsoft.com/office/drawing/2018/hyperlinkcolor" val="tx"/>
+                    </a:ext>
+                  </a:extLst>
+                </a:hlinkClick>
               </a:rPr>
               <a:t>bluetooth.com/specifications/specs/core-specification</a:t>
             </a:r>
@@ -10384,13 +10447,20 @@
               <a:buNone/>
             </a:pPr>
             <a:r>
-              <a:rPr lang="en-US" sz="800" dirty="0">
+              <a:rPr lang="en-US" sz="800" u="sng" dirty="0">
                 <a:solidFill>
                   <a:srgbClr val="1199BD"/>
                 </a:solidFill>
                 <a:latin typeface="Courier New" pitchFamily="34" charset="0"/>
                 <a:ea typeface="Courier New" pitchFamily="34" charset="-122"/>
                 <a:cs typeface="Courier New" pitchFamily="34" charset="-120"/>
+                <a:hlinkClick r:id="rId10" invalidUrl="" action="" tgtFrame="" tooltip="https://github.com/deosgracius/offgrid-vehicle-tracker" history="1" highlightClick="0" endSnd="0">
+                  <a:extLst>
+                    <a:ext uri="{A12FA001-AC4F-418D-AE19-62706E023703}">
+                      <ahyp:hlinkClr xmlns:ahyp="http://schemas.microsoft.com/office/drawing/2018/hyperlinkcolor" val="tx"/>
+                    </a:ext>
+                  </a:extLst>
+                </a:hlinkClick>
               </a:rPr>
               <a:t>github.com/deosgracius/offgrid-vehicle-tracker</a:t>
             </a:r>

</xml_diff>

<commit_message>
Deck text trimmed: slides assert, notes and briefing explain
On-slide prose cut roughly in half across all fourteen sheets: short
declarative lines replace paragraph bullets, constraint cards halved,
verdict and caption cards tightened, remaining text bumped a size for
readability. All removed depth already lives in the speaker notes and
the presenter briefing.

Co-Authored-By: Claude Fable 5 <noreply@anthropic.com>
</commit_message>
<xml_diff>
--- a/docs/presentations/Group9_Presentation3_Week3.pptx
+++ b/docs/presentations/Group9_Presentation3_Week3.pptx
@@ -3179,7 +3179,7 @@
                 <a:ea typeface="Arial" pitchFamily="34" charset="-122"/>
                 <a:cs typeface="Arial" pitchFamily="34" charset="-120"/>
               </a:rPr>
-              <a:t>This week the display began showing a live vehicle: position decoded from real radio packets, an arrow computed from real navigation math, and a screen that moves every second. Each section of this review opens with its architecture, then shows the working hardware and the code behind it.</a:t>
+              <a:t>The display now shows a live vehicle: real packets, real navigation math, a screen that moves every second. Each section: architecture first, then the working hardware and its code.</a:t>
             </a:r>
             <a:endParaRPr lang="en-US" sz="1300" dirty="0"/>
           </a:p>
@@ -5268,7 +5268,7 @@
               <a:buNone/>
             </a:pPr>
             <a:r>
-              <a:rPr lang="en-US" sz="1050" dirty="0">
+              <a:rPr lang="en-US" sz="1200" dirty="0">
                 <a:solidFill>
                   <a:srgbClr val="222A3F"/>
                 </a:solidFill>
@@ -5276,9 +5276,9 @@
                 <a:ea typeface="Arial" pitchFamily="34" charset="-122"/>
                 <a:cs typeface="Arial" pitchFamily="34" charset="-120"/>
               </a:rPr>
-              <a:t>The update-rate wall. Channel airtime versus broadcast interval for two vehicles at 0.5 s per packet. One second sits at 100 percent, physical collapse; our 10 second point uses 10 percent, comfortably under the 25 percent ceiling the firmware enforces.</a:t>
-            </a:r>
-            <a:endParaRPr lang="en-US" sz="1050" dirty="0"/>
+              <a:t>The update-rate wall: 1 s would take 100% of the channel. Our point: 10 s, 10%, under the enforced 25% ceiling.</a:t>
+            </a:r>
+            <a:endParaRPr lang="en-US" sz="1200" dirty="0"/>
           </a:p>
         </p:txBody>
       </p:sp>
@@ -5307,7 +5307,7 @@
               <a:buNone/>
             </a:pPr>
             <a:r>
-              <a:rPr lang="en-US" sz="1050" dirty="0">
+              <a:rPr lang="en-US" sz="1200" dirty="0">
                 <a:solidFill>
                   <a:srgbClr val="222A3F"/>
                 </a:solidFill>
@@ -5315,9 +5315,9 @@
                 <a:ea typeface="Arial" pitchFamily="34" charset="-122"/>
                 <a:cs typeface="Arial" pitchFamily="34" charset="-120"/>
               </a:rPr>
-              <a:t>What the driver would see. Holding the raw fix leaves the display up to 200 m behind a vehicle at 45 mph. Dead reckoning bounds the worst case near 25 m during a maneuver, and each real fix snaps the error back to zero.</a:t>
-            </a:r>
-            <a:endParaRPr lang="en-US" sz="1050" dirty="0"/>
+              <a:t>Raw fix: up to 200 m behind at 45 mph. Dead reckoning: bounded near 25 m, snapped to zero by each real fix.</a:t>
+            </a:r>
+            <a:endParaRPr lang="en-US" sz="1200" dirty="0"/>
           </a:p>
         </p:txBody>
       </p:sp>
@@ -6830,7 +6830,7 @@
               <a:buNone/>
             </a:pPr>
             <a:r>
-              <a:rPr lang="en-US" sz="850" dirty="0">
+              <a:rPr lang="en-US" sz="950" dirty="0">
                 <a:solidFill>
                   <a:srgbClr val="222A3F"/>
                 </a:solidFill>
@@ -6838,9 +6838,9 @@
                 <a:ea typeface="Arial" pitchFamily="34" charset="-122"/>
                 <a:cs typeface="Arial" pitchFamily="34" charset="-120"/>
               </a:rPr>
-              <a:t>Display and web-client marker show the same fix from the same radio, via two programs sharing no code. Independent agreement is the accuracy check.</a:t>
-            </a:r>
-            <a:endParaRPr lang="en-US" sz="850" dirty="0"/>
+              <a:t>Same fix, same radio, two programs sharing no code. Agreement is the accuracy check.</a:t>
+            </a:r>
+            <a:endParaRPr lang="en-US" sz="950" dirty="0"/>
           </a:p>
         </p:txBody>
       </p:sp>
@@ -6954,7 +6954,7 @@
               <a:buNone/>
             </a:pPr>
             <a:r>
-              <a:rPr lang="en-US" sz="900" dirty="0">
+              <a:rPr lang="en-US" sz="1000" dirty="0">
                 <a:solidFill>
                   <a:srgbClr val="5E6B85"/>
                 </a:solidFill>
@@ -6962,9 +6962,9 @@
                 <a:ea typeface="Arial" pitchFamily="34" charset="-122"/>
                 <a:cs typeface="Arial" pitchFamily="34" charset="-120"/>
               </a:rPr>
-              <a:t>One device proves four of five layers at zero coordination cost. Every bug found here never reaches the two-vehicle test. The dashed layer waits only for radio two; no display code changes.</a:t>
-            </a:r>
-            <a:endParaRPr lang="en-US" sz="900" dirty="0"/>
+              <a:t>One device proves four of five layers. The dashed one waits only for radio two.</a:t>
+            </a:r>
+            <a:endParaRPr lang="en-US" sz="1000" dirty="0"/>
           </a:p>
         </p:txBody>
       </p:sp>
@@ -7486,7 +7486,7 @@
                 <a:ea typeface="Arial" pitchFamily="34" charset="-122"/>
                 <a:cs typeface="Arial" pitchFamily="34" charset="-120"/>
               </a:rPr>
-              <a:t>Half a second of airtime per packet caps cadence at ten seconds. Utilization must stay under about 25%. The region must be set or transmit is disabled. The roof antenna is the single biggest range factor.</a:t>
+              <a:t>0.5 s airtime caps cadence at 10 s. Utilization under ~25%. No region, no transmit. Roof antenna is the biggest range factor.</a:t>
             </a:r>
             <a:endParaRPr lang="en-US" sz="950" dirty="0"/>
           </a:p>
@@ -7589,7 +7589,7 @@
                 <a:ea typeface="Arial" pitchFamily="34" charset="-122"/>
                 <a:cs typeface="Arial" pitchFamily="34" charset="-120"/>
               </a:rPr>
-              <a:t>Needs sky view: a windshield works, a desk does not. Cold start takes minutes. Indoor multipath fakes small phantom speeds, which the deadband removes. Fix rate must match broadcast rate.</a:t>
+              <a:t>Needs sky view; cold start takes minutes. Indoor multipath fakes phantom speed (deadbanded). Fix rate must match broadcast rate.</a:t>
             </a:r>
             <a:endParaRPr lang="en-US" sz="950" dirty="0"/>
           </a:p>
@@ -7692,7 +7692,7 @@
                 <a:ea typeface="Arial" pitchFamily="34" charset="-122"/>
                 <a:cs typeface="Arial" pitchFamily="34" charset="-120"/>
               </a:rPr>
-              <a:t>The radio advertises only from boot until its first disconnect, so both units power up together. Exactly one client at a time: a phone app or USB session will take or mute the link.</a:t>
+              <a:t>The radio advertises only at boot: power both units together. One client at a time; a phone or USB session steals the link.</a:t>
             </a:r>
             <a:endParaRPr lang="en-US" sz="950" dirty="0"/>
           </a:p>
@@ -7795,7 +7795,7 @@
                 <a:ea typeface="Arial" pitchFamily="34" charset="-122"/>
                 <a:cs typeface="Arial" pitchFamily="34" charset="-120"/>
               </a:rPr>
-              <a:t>A one-bit reflective panel has no grayscale and needs ambient light at night; edge lighting is planned. The redraw budget is two full frames per second.</a:t>
+              <a:t>One-bit reflective panel: no grayscale, needs ambient light at night (edge light planned). 2 Hz redraw budget.</a:t>
             </a:r>
             <a:endParaRPr lang="en-US" sz="950" dirty="0"/>
           </a:p>
@@ -7898,7 +7898,7 @@
                 <a:ea typeface="Arial" pitchFamily="34" charset="-122"/>
                 <a:cs typeface="Arial" pitchFamily="34" charset="-120"/>
               </a:rPr>
-              <a:t>Cheap 12 volt USB adapters cut off on the radio's low current draw, so every adapter gets validated. Both units must share the vehicle's power timing.</a:t>
+              <a:t>Cheap 12 V USB adapters cut off on low draw: validate every adapter.</a:t>
             </a:r>
             <a:endParaRPr lang="en-US" sz="950" dirty="0"/>
           </a:p>
@@ -8001,7 +8001,7 @@
                 <a:ea typeface="Arial" pitchFamily="34" charset="-122"/>
                 <a:cs typeface="Arial" pitchFamily="34" charset="-120"/>
               </a:rPr>
-              <a:t>The channel URL carrying the encryption key must match on every radio. Node identities derive from the MAC address and survive reflashes. Every configuration write is read back and verified.</a:t>
+              <a:t>Channel URL (the AES key) must match on every radio. Node IDs survive reflashes. Read back every write.</a:t>
             </a:r>
             <a:endParaRPr lang="en-US" sz="950" dirty="0"/>
           </a:p>
@@ -8720,7 +8720,7 @@
               <a:buChar char="▪"/>
             </a:pPr>
             <a:r>
-              <a:rPr lang="en-US" sz="1200" dirty="0">
+              <a:rPr lang="en-US" sz="1250" dirty="0">
                 <a:solidFill>
                   <a:srgbClr val="222A3F"/>
                 </a:solidFill>
@@ -8728,9 +8728,9 @@
                 <a:ea typeface="Arial" pitchFamily="34" charset="-122"/>
                 <a:cs typeface="Arial" pitchFamily="34" charset="-120"/>
               </a:rPr>
-              <a:t>A GPS fix travels radio to radio to display to arrow at the 10 second cadence, with one-second motion from dead reckoning in between.</a:t>
-            </a:r>
-            <a:endParaRPr lang="en-US" sz="1200" dirty="0"/>
+              <a:t>GPS fix to arrow, end to end, at 10 s cadence with 1 Hz projected motion.</a:t>
+            </a:r>
+            <a:endParaRPr lang="en-US" sz="1250" dirty="0"/>
           </a:p>
           <a:p>
             <a:pPr marL="342900" indent="-342900">
@@ -8741,7 +8741,7 @@
               <a:buChar char="▪"/>
             </a:pPr>
             <a:r>
-              <a:rPr lang="en-US" sz="1200" dirty="0">
+              <a:rPr lang="en-US" sz="1250" dirty="0">
                 <a:solidFill>
                   <a:srgbClr val="222A3F"/>
                 </a:solidFill>
@@ -8749,9 +8749,9 @@
                 <a:ea typeface="Arial" pitchFamily="34" charset="-122"/>
                 <a:cs typeface="Arial" pitchFamily="34" charset="-120"/>
               </a:rPr>
-              <a:t>The clock derives its timezone from position, data ages stay honest, and ghost re-broadcasts are detected and labeled.</a:t>
-            </a:r>
-            <a:endParaRPr lang="en-US" sz="1200" dirty="0"/>
+              <a:t>Position-derived clock, honest ages, ghost re-broadcasts detected.</a:t>
+            </a:r>
+            <a:endParaRPr lang="en-US" sz="1250" dirty="0"/>
           </a:p>
           <a:p>
             <a:pPr marL="342900" indent="-342900">
@@ -8762,7 +8762,7 @@
               <a:buChar char="▪"/>
             </a:pPr>
             <a:r>
-              <a:rPr lang="en-US" sz="1200" dirty="0">
+              <a:rPr lang="en-US" sz="1250" dirty="0">
                 <a:solidFill>
                   <a:srgbClr val="222A3F"/>
                 </a:solidFill>
@@ -8770,9 +8770,9 @@
                 <a:ea typeface="Arial" pitchFamily="34" charset="-122"/>
                 <a:cs typeface="Arial" pitchFamily="34" charset="-120"/>
               </a:rPr>
-              <a:t>The link reconnected itself after every drop, across four drive tests.</a:t>
-            </a:r>
-            <a:endParaRPr lang="en-US" sz="1200" dirty="0"/>
+              <a:t>The link reconnected itself after every drop, four drive tests running.</a:t>
+            </a:r>
+            <a:endParaRPr lang="en-US" sz="1250" dirty="0"/>
           </a:p>
           <a:p>
             <a:pPr marL="342900" indent="-342900">
@@ -8780,7 +8780,7 @@
               <a:buChar char="▪"/>
             </a:pPr>
             <a:r>
-              <a:rPr lang="en-US" sz="1200" dirty="0">
+              <a:rPr lang="en-US" sz="1250" dirty="0">
                 <a:solidFill>
                   <a:srgbClr val="222A3F"/>
                 </a:solidFill>
@@ -8788,9 +8788,9 @@
                 <a:ea typeface="Arial" pitchFamily="34" charset="-122"/>
                 <a:cs typeface="Arial" pitchFamily="34" charset="-120"/>
               </a:rPr>
-              <a:t>A complete radio recovery drill was executed and documented: flash, provision, verify, in minutes.</a:t>
-            </a:r>
-            <a:endParaRPr lang="en-US" sz="1200" dirty="0"/>
+              <a:t>Full radio recovery drill: flash, provision, verify, in minutes.</a:t>
+            </a:r>
+            <a:endParaRPr lang="en-US" sz="1250" dirty="0"/>
           </a:p>
         </p:txBody>
       </p:sp>
@@ -8862,7 +8862,7 @@
               <a:buChar char="▪"/>
             </a:pPr>
             <a:r>
-              <a:rPr lang="en-US" sz="1200" dirty="0">
+              <a:rPr lang="en-US" sz="1250" dirty="0">
                 <a:solidFill>
                   <a:srgbClr val="222A3F"/>
                 </a:solidFill>
@@ -8870,9 +8870,9 @@
                 <a:ea typeface="Arial" pitchFamily="34" charset="-122"/>
                 <a:cs typeface="Arial" pitchFamily="34" charset="-120"/>
               </a:rPr>
-              <a:t>Victor provisions radio number two from the documented recipe, then the first two-radio bench decode.</a:t>
-            </a:r>
-            <a:endParaRPr lang="en-US" sz="1200" dirty="0"/>
+              <a:t>Victor: provision radio two from the recipe; first two-radio bench decode.</a:t>
+            </a:r>
+            <a:endParaRPr lang="en-US" sz="1250" dirty="0"/>
           </a:p>
           <a:p>
             <a:pPr marL="342900" indent="-342900">
@@ -8883,7 +8883,7 @@
               <a:buChar char="▪"/>
             </a:pPr>
             <a:r>
-              <a:rPr lang="en-US" sz="1200" dirty="0">
+              <a:rPr lang="en-US" sz="1250" dirty="0">
                 <a:solidFill>
                   <a:srgbClr val="222A3F"/>
                 </a:solidFill>
@@ -8891,9 +8891,9 @@
                 <a:ea typeface="Arial" pitchFamily="34" charset="-122"/>
                 <a:cs typeface="Arial" pitchFamily="34" charset="-120"/>
               </a:rPr>
-              <a:t>Cannon turns the constraints ledger into the drive-test protocol and the logging harness.</a:t>
-            </a:r>
-            <a:endParaRPr lang="en-US" sz="1200" dirty="0"/>
+              <a:t>Cannon: constraints ledger becomes the drive-test protocol and logging harness.</a:t>
+            </a:r>
+            <a:endParaRPr lang="en-US" sz="1250" dirty="0"/>
           </a:p>
           <a:p>
             <a:pPr marL="342900" indent="-342900">
@@ -8904,7 +8904,7 @@
               <a:buChar char="▪"/>
             </a:pPr>
             <a:r>
-              <a:rPr lang="en-US" sz="1200" dirty="0">
+              <a:rPr lang="en-US" sz="1250" dirty="0">
                 <a:solidFill>
                   <a:srgbClr val="222A3F"/>
                 </a:solidFill>
@@ -8912,9 +8912,9 @@
                 <a:ea typeface="Arial" pitchFamily="34" charset="-122"/>
                 <a:cs typeface="Arial" pitchFamily="34" charset="-120"/>
               </a:rPr>
-              <a:t>Deo and Josiah add partner selection stored in NVS and improve night readability.</a:t>
-            </a:r>
-            <a:endParaRPr lang="en-US" sz="1200" dirty="0"/>
+              <a:t>Deo and Josiah: partner selection in NVS; night readability.</a:t>
+            </a:r>
+            <a:endParaRPr lang="en-US" sz="1250" dirty="0"/>
           </a:p>
           <a:p>
             <a:pPr marL="342900" indent="-342900">
@@ -8922,7 +8922,7 @@
               <a:buChar char="▪"/>
             </a:pPr>
             <a:r>
-              <a:rPr lang="en-US" sz="1200" dirty="0">
+              <a:rPr lang="en-US" sz="1250" dirty="0">
                 <a:solidFill>
                   <a:srgbClr val="222A3F"/>
                 </a:solidFill>
@@ -8930,9 +8930,9 @@
                 <a:ea typeface="Arial" pitchFamily="34" charset="-122"/>
                 <a:cs typeface="Arial" pitchFamily="34" charset="-120"/>
               </a:rPr>
-              <a:t>Then the milestone: the first two-vehicle drive test, where the arrow points at a real partner.</a:t>
-            </a:r>
-            <a:endParaRPr lang="en-US" sz="1200" dirty="0"/>
+              <a:t>Then the milestone: the first two-vehicle drive test.</a:t>
+            </a:r>
+            <a:endParaRPr lang="en-US" sz="1250" dirty="0"/>
           </a:p>
         </p:txBody>
       </p:sp>
@@ -10941,7 +10941,7 @@
               <a:buChar char="▪"/>
             </a:pPr>
             <a:r>
-              <a:rPr lang="en-US" sz="1250" dirty="0">
+              <a:rPr lang="en-US" sz="1300" dirty="0">
                 <a:solidFill>
                   <a:srgbClr val="222A3F"/>
                 </a:solidFill>
@@ -10949,9 +10949,9 @@
                 <a:ea typeface="Arial" pitchFamily="34" charset="-122"/>
                 <a:cs typeface="Arial" pitchFamily="34" charset="-120"/>
               </a:rPr>
-              <a:t>Left region: one vehicle's hardware. The GNSS module feeds the Heltec radio, which drives the roof antenna. The Waveshare display sits beside it, and both share vehicle power.</a:t>
-            </a:r>
-            <a:endParaRPr lang="en-US" sz="1250" dirty="0"/>
+              <a:t>Left: one vehicle's hardware. GNSS feeds the radio; the radio drives the roof antenna.</a:t>
+            </a:r>
+            <a:endParaRPr lang="en-US" sz="1300" dirty="0"/>
           </a:p>
           <a:p>
             <a:pPr marL="342900" indent="-342900">
@@ -10962,7 +10962,7 @@
               <a:buChar char="▪"/>
             </a:pPr>
             <a:r>
-              <a:rPr lang="en-US" sz="1250" dirty="0">
+              <a:rPr lang="en-US" sz="1300" dirty="0">
                 <a:solidFill>
                   <a:srgbClr val="222A3F"/>
                 </a:solidFill>
@@ -10970,9 +10970,9 @@
                 <a:ea typeface="Arial" pitchFamily="34" charset="-122"/>
                 <a:cs typeface="Arial" pitchFamily="34" charset="-120"/>
               </a:rPr>
-              <a:t>Right region: inside the display firmware. My protocol chain writes the TrackerState contract; Josiah's navigation chain reads it. One writer, one reader.</a:t>
-            </a:r>
-            <a:endParaRPr lang="en-US" sz="1250" dirty="0"/>
+              <a:t>Right: the display firmware. Protocol writes TrackerState; navigation reads it. One writer, one reader.</a:t>
+            </a:r>
+            <a:endParaRPr lang="en-US" sz="1300" dirty="0"/>
           </a:p>
           <a:p>
             <a:pPr marL="342900" indent="-342900">
@@ -10983,7 +10983,7 @@
               <a:buChar char="▪"/>
             </a:pPr>
             <a:r>
-              <a:rPr lang="en-US" sz="1250" dirty="0">
+              <a:rPr lang="en-US" sz="1300" dirty="0">
                 <a:solidFill>
                   <a:srgbClr val="222A3F"/>
                 </a:solidFill>
@@ -10991,9 +10991,9 @@
                 <a:ea typeface="Arial" pitchFamily="34" charset="-122"/>
                 <a:cs typeface="Arial" pitchFamily="34" charset="-120"/>
               </a:rPr>
-              <a:t>Bottom strip: the same system seen as telecom layers. A 40 byte application payload rides a managed-flooding network onto a physical layer that decodes 15 dB below the noise floor.</a:t>
-            </a:r>
-            <a:endParaRPr lang="en-US" sz="1250" dirty="0"/>
+              <a:t>Bottom: the telecom view. A 40 byte payload on a PHY that decodes 15 dB below the noise.</a:t>
+            </a:r>
+            <a:endParaRPr lang="en-US" sz="1300" dirty="0"/>
           </a:p>
           <a:p>
             <a:pPr marL="342900" indent="-342900">
@@ -11001,7 +11001,7 @@
               <a:buChar char="▪"/>
             </a:pPr>
             <a:r>
-              <a:rPr lang="en-US" sz="1250" dirty="0">
+              <a:rPr lang="en-US" sz="1300" dirty="0">
                 <a:solidFill>
                   <a:srgbClr val="222A3F"/>
                 </a:solidFill>
@@ -11009,9 +11009,9 @@
                 <a:ea typeface="Arial" pitchFamily="34" charset="-122"/>
                 <a:cs typeface="Arial" pitchFamily="34" charset="-120"/>
               </a:rPr>
-              <a:t>Vehicle B is an identical copy. The symmetry is the design: no server, no master, no single point of failure.</a:t>
-            </a:r>
-            <a:endParaRPr lang="en-US" sz="1250" dirty="0"/>
+              <a:t>Vehicle B is an identical copy. No server, no master, no single point of failure.</a:t>
+            </a:r>
+            <a:endParaRPr lang="en-US" sz="1300" dirty="0"/>
           </a:p>
         </p:txBody>
       </p:sp>
@@ -11073,14 +11073,14 @@
               </a:rPr>
               <a:t>WHY THIS SHAPE</a:t>
             </a:r>
-            <a:endParaRPr lang="en-US" sz="1200" dirty="0"/>
-          </a:p>
-          <a:p>
-            <a:pPr indent="0" marL="0">
-              <a:buNone/>
-            </a:pPr>
-            <a:r>
-              <a:rPr lang="en-US" sz="1200" dirty="0">
+            <a:endParaRPr lang="en-US" sz="1250" dirty="0"/>
+          </a:p>
+          <a:p>
+            <a:pPr indent="0" marL="0">
+              <a:buNone/>
+            </a:pPr>
+            <a:r>
+              <a:rPr lang="en-US" sz="1250" dirty="0">
                 <a:solidFill>
                   <a:srgbClr val="FFFFFF"/>
                 </a:solidFill>
@@ -11088,9 +11088,9 @@
                 <a:ea typeface="Arial" pitchFamily="34" charset="-122"/>
                 <a:cs typeface="Arial" pitchFamily="34" charset="-120"/>
               </a:rPr>
-              <a:t>Everything difficult about long-range radio ships pre-tested inside stock Meshtastic. The green and blue chains on the right are the only custom code in the project, and they meet at exactly one struct.</a:t>
-            </a:r>
-            <a:endParaRPr lang="en-US" sz="1200" dirty="0"/>
+              <a:t>Everything hard about long-range radio ships pre-tested in Meshtastic. The chains on the right are the only custom code, and they meet at one struct.</a:t>
+            </a:r>
+            <a:endParaRPr lang="en-US" sz="1250" dirty="0"/>
           </a:p>
         </p:txBody>
       </p:sp>
@@ -12694,8 +12694,8 @@
         </p:nvSpPr>
         <p:spPr>
           <a:xfrm>
-            <a:off x="594360" y="4343400"/>
-            <a:ext cx="10972800" cy="1691640"/>
+            <a:off x="594360" y="4434840"/>
+            <a:ext cx="10972800" cy="1463040"/>
           </a:xfrm>
           <a:prstGeom prst="rect">
             <a:avLst/>
@@ -12715,7 +12715,7 @@
               <a:buChar char="▪"/>
             </a:pPr>
             <a:r>
-              <a:rPr lang="en-US" sz="1250" dirty="0">
+              <a:rPr lang="en-US" sz="1300" dirty="0">
                 <a:solidFill>
                   <a:srgbClr val="222A3F"/>
                 </a:solidFill>
@@ -12723,20 +12723,17 @@
                 <a:ea typeface="Arial" pitchFamily="34" charset="-122"/>
                 <a:cs typeface="Arial" pitchFamily="34" charset="-120"/>
               </a:rPr>
-              <a:t>The left chain is the backend. ble_link connects directly to the radio's remembered address, encrypts, subscribes, and drains the message queue. proto_decode turns each binary frame into named fields. node_table keeps both vehicles' fixes with honest timestamps, then publishes TrackerState.</a:t>
-            </a:r>
-            <a:endParaRPr lang="en-US" sz="1250" dirty="0"/>
+              <a:t>ble_link connects by remembered address, encrypts, subscribes, drains. proto_decode names the bytes. node_table keeps honest fixes and publishes TrackerState v2.</a:t>
+            </a:r>
+            <a:endParaRPr lang="en-US" sz="1300" dirty="0"/>
           </a:p>
           <a:p>
             <a:pPr marL="342900" indent="-342900">
-              <a:spcAft>
-                <a:spcPts val="600"/>
-              </a:spcAft>
               <a:buSzPct val="100000"/>
               <a:buChar char="▪"/>
             </a:pPr>
             <a:r>
-              <a:rPr lang="en-US" sz="1250" dirty="0">
+              <a:rPr lang="en-US" sz="1300" dirty="0">
                 <a:solidFill>
                   <a:srgbClr val="222A3F"/>
                 </a:solidFill>
@@ -12744,27 +12741,9 @@
                 <a:ea typeface="Arial" pitchFamily="34" charset="-122"/>
                 <a:cs typeface="Arial" pitchFamily="34" charset="-120"/>
               </a:rPr>
-              <a:t>The contract is version 2: both fixes now carry speed and age, and the struct carries the GPS wall clock that drives the on-screen time.</a:t>
-            </a:r>
-            <a:endParaRPr lang="en-US" sz="1250" dirty="0"/>
-          </a:p>
-          <a:p>
-            <a:pPr marL="342900" indent="-342900">
-              <a:buSzPct val="100000"/>
-              <a:buChar char="▪"/>
-            </a:pPr>
-            <a:r>
-              <a:rPr lang="en-US" sz="1250" dirty="0">
-                <a:solidFill>
-                  <a:srgbClr val="222A3F"/>
-                </a:solidFill>
-                <a:latin typeface="Arial" pitchFamily="34" charset="0"/>
-                <a:ea typeface="Arial" pitchFamily="34" charset="-122"/>
-                <a:cs typeface="Arial" pitchFamily="34" charset="-120"/>
-              </a:rPr>
-              <a:t>Status: live and road-tested. The link survives drops and reconnects on its own, positions decode at the 10 second broadcast cadence, and stale re-broadcasts can no longer masquerade as fresh data.</a:t>
-            </a:r>
-            <a:endParaRPr lang="en-US" sz="1250" dirty="0"/>
+              <a:t>Road-tested: the link reconnects itself, and stale re-broadcasts can no longer pose as fresh data.</a:t>
+            </a:r>
+            <a:endParaRPr lang="en-US" sz="1300" dirty="0"/>
           </a:p>
         </p:txBody>
       </p:sp>
@@ -13839,8 +13818,8 @@
         </p:nvSpPr>
         <p:spPr>
           <a:xfrm>
-            <a:off x="731520" y="4681728"/>
-            <a:ext cx="10744200" cy="1280160"/>
+            <a:off x="731520" y="4736592"/>
+            <a:ext cx="10744200" cy="1188720"/>
           </a:xfrm>
           <a:prstGeom prst="rect">
             <a:avLst/>
@@ -13859,7 +13838,7 @@
               <a:buNone/>
             </a:pPr>
             <a:r>
-              <a:rPr lang="en-US" sz="1250" dirty="0">
+              <a:rPr lang="en-US" sz="1300" dirty="0">
                 <a:solidFill>
                   <a:srgbClr val="222A3F"/>
                 </a:solidFill>
@@ -13867,16 +13846,16 @@
                 <a:ea typeface="Arial" pitchFamily="34" charset="-122"/>
                 <a:cs typeface="Arial" pitchFamily="34" charset="-120"/>
               </a:rPr>
-              <a:t>Four files, one direction of flow, one shared struct. The teal boxes are backend and the purple box is frontend. They meet only at the store functions, which take the mutex internally, so locked access is the only possible access.</a:t>
-            </a:r>
-            <a:endParaRPr lang="en-US" sz="1250" dirty="0"/>
-          </a:p>
-          <a:p>
-            <a:pPr indent="0" marL="0">
-              <a:buNone/>
-            </a:pPr>
-            <a:r>
-              <a:rPr lang="en-US" sz="1250" dirty="0">
+              <a:t>Four files, one direction of flow, one struct. The halves meet only at the store functions; the mutex cannot be bypassed.</a:t>
+            </a:r>
+            <a:endParaRPr lang="en-US" sz="1300" dirty="0"/>
+          </a:p>
+          <a:p>
+            <a:pPr indent="0" marL="0">
+              <a:buNone/>
+            </a:pPr>
+            <a:r>
+              <a:rPr lang="en-US" sz="1300" dirty="0">
                 <a:solidFill>
                   <a:srgbClr val="222A3F"/>
                 </a:solidFill>
@@ -13884,9 +13863,9 @@
                 <a:ea typeface="Arial" pitchFamily="34" charset="-122"/>
                 <a:cs typeface="Arial" pitchFamily="34" charset="-120"/>
               </a:rPr>
-              <a:t>Hardened by this week's road tests: wire speed converted from km/h at ingestion, a deadband that reads GPS jitter as zero, duplicate re-broadcast detection that keeps data ages honest, and a clock that can never run backwards.</a:t>
-            </a:r>
-            <a:endParaRPr lang="en-US" sz="1250" dirty="0"/>
+              <a:t>Road hardening: km/h converted at the door, jitter deadband, duplicate detection, a clock that cannot run backwards.</a:t>
+            </a:r>
+            <a:endParaRPr lang="en-US" sz="1300" dirty="0"/>
           </a:p>
         </p:txBody>
       </p:sp>
@@ -14855,8 +14834,8 @@
         </p:nvSpPr>
         <p:spPr>
           <a:xfrm>
-            <a:off x="457200" y="3794760"/>
-            <a:ext cx="11292840" cy="1417320"/>
+            <a:off x="457200" y="3840480"/>
+            <a:ext cx="11292840" cy="1325880"/>
           </a:xfrm>
           <a:prstGeom prst="rect">
             <a:avLst/>
@@ -14876,7 +14855,7 @@
               <a:buChar char="▪"/>
             </a:pPr>
             <a:r>
-              <a:rPr lang="en-US" sz="1250" dirty="0">
+              <a:rPr lang="en-US" sz="1300" dirty="0">
                 <a:solidFill>
                   <a:srgbClr val="222A3F"/>
                 </a:solidFill>
@@ -14884,9 +14863,9 @@
                 <a:ea typeface="Arial" pitchFamily="34" charset="-122"/>
                 <a:cs typeface="Arial" pitchFamily="34" charset="-120"/>
               </a:rPr>
-              <a:t>Heading comes from GPS course over ground. A magnetometer would be unreliable inside a steel cab, and below 5 mph the arrow falls back to a north-up compass rose because course is noise when parked.</a:t>
-            </a:r>
-            <a:endParaRPr lang="en-US" sz="1250" dirty="0"/>
+              <a:t>Heading from GPS course over ground: no magnetometer in a steel cab. Below 5 mph, north-up rose.</a:t>
+            </a:r>
+            <a:endParaRPr lang="en-US" sz="1300" dirty="0"/>
           </a:p>
           <a:p>
             <a:pPr marL="342900" indent="-342900">
@@ -14897,7 +14876,7 @@
               <a:buChar char="▪"/>
             </a:pPr>
             <a:r>
-              <a:rPr lang="en-US" sz="1250" dirty="0">
+              <a:rPr lang="en-US" sz="1300" dirty="0">
                 <a:solidFill>
                   <a:srgbClr val="222A3F"/>
                 </a:solidFill>
@@ -14905,9 +14884,9 @@
                 <a:ea typeface="Arial" pitchFamily="34" charset="-122"/>
                 <a:cs typeface="Arial" pitchFamily="34" charset="-120"/>
               </a:rPr>
-              <a:t>Every screen element is state-driven from the struct. The CHANGE COURSE banner engages after five seconds off course and clears on recovery, chevrons show the turn direction, the STALE banner appears past 120 seconds, and the clock derives its timezone from position.</a:t>
-            </a:r>
-            <a:endParaRPr lang="en-US" sz="1250" dirty="0"/>
+              <a:t>Every element is a state machine on the struct: CHANGE COURSE, chevrons, STALE past 120 s, position-derived clock.</a:t>
+            </a:r>
+            <a:endParaRPr lang="en-US" sz="1300" dirty="0"/>
           </a:p>
           <a:p>
             <a:pPr marL="342900" indent="-342900">
@@ -14915,7 +14894,7 @@
               <a:buChar char="▪"/>
             </a:pPr>
             <a:r>
-              <a:rPr lang="en-US" sz="1250" dirty="0">
+              <a:rPr lang="en-US" sz="1300" dirty="0">
                 <a:solidFill>
                   <a:srgbClr val="222A3F"/>
                 </a:solidFill>
@@ -14923,9 +14902,9 @@
                 <a:ea typeface="Arial" pitchFamily="34" charset="-122"/>
                 <a:cs typeface="Arial" pitchFamily="34" charset="-120"/>
               </a:rPr>
-              <a:t>Both files are pure C with no hardware dependencies, unit-tested on a laptop: 12 of 12 native tests pass.</a:t>
-            </a:r>
-            <a:endParaRPr lang="en-US" sz="1250" dirty="0"/>
+              <a:t>Pure C, no hardware dependencies: 12 of 12 native tests pass on a laptop.</a:t>
+            </a:r>
+            <a:endParaRPr lang="en-US" sz="1300" dirty="0"/>
           </a:p>
         </p:txBody>
       </p:sp>
@@ -14974,7 +14953,7 @@
               <a:buNone/>
             </a:pPr>
             <a:r>
-              <a:rPr lang="en-US" sz="1250" dirty="0">
+              <a:rPr lang="en-US" sz="1300" dirty="0">
                 <a:solidFill>
                   <a:srgbClr val="FFFFFF"/>
                 </a:solidFill>
@@ -14982,9 +14961,9 @@
                 <a:ea typeface="Arial" pitchFamily="34" charset="-122"/>
                 <a:cs typeface="Arial" pitchFamily="34" charset="-120"/>
               </a:rPr>
-              <a:t>Dead reckoning is why the screen feels live. Measurements arrive every ten seconds, the display re-projects both vehicles every second along their last course and speed, and each real fix snaps the estimate back to truth.</a:t>
-            </a:r>
-            <a:endParaRPr lang="en-US" sz="1250" dirty="0"/>
+              <a:t>Measurements every 10 s. The display projects both vehicles every second, and each real fix snaps it back to truth.</a:t>
+            </a:r>
+            <a:endParaRPr lang="en-US" sz="1300" dirty="0"/>
           </a:p>
         </p:txBody>
       </p:sp>
@@ -15718,7 +15697,7 @@
               <a:buChar char="▪"/>
             </a:pPr>
             <a:r>
-              <a:rPr lang="en-US" sz="1100" dirty="0">
+              <a:rPr lang="en-US" sz="1200" dirty="0">
                 <a:solidFill>
                   <a:srgbClr val="222A3F"/>
                 </a:solidFill>
@@ -15726,9 +15705,9 @@
                 <a:ea typeface="Arial" pitchFamily="34" charset="-122"/>
                 <a:cs typeface="Arial" pitchFamily="34" charset="-120"/>
               </a:rPr>
-              <a:t>Every value on these screens arrived by radio and was decoded by our own stack. There is no simulator in these photos.</a:t>
-            </a:r>
-            <a:endParaRPr lang="en-US" sz="1100" dirty="0"/>
+              <a:t>No simulator: every value arrived by radio.</a:t>
+            </a:r>
+            <a:endParaRPr lang="en-US" sz="1200" dirty="0"/>
           </a:p>
           <a:p>
             <a:pPr marL="342900" indent="-342900">
@@ -15739,7 +15718,7 @@
               <a:buChar char="▪"/>
             </a:pPr>
             <a:r>
-              <a:rPr lang="en-US" sz="1100" dirty="0">
+              <a:rPr lang="en-US" sz="1200" dirty="0">
                 <a:solidFill>
                   <a:srgbClr val="222A3F"/>
                 </a:solidFill>
@@ -15747,9 +15726,9 @@
                 <a:ea typeface="Arial" pitchFamily="34" charset="-122"/>
                 <a:cs typeface="Arial" pitchFamily="34" charset="-120"/>
               </a:rPr>
-              <a:t>The reflective panel gets sharper in more light, which is the opposite of a phone. It is built for a dashboard in the sun.</a:t>
-            </a:r>
-            <a:endParaRPr lang="en-US" sz="1100" dirty="0"/>
+              <a:t>Reflective panel: sharper in sunlight, built for a dash.</a:t>
+            </a:r>
+            <a:endParaRPr lang="en-US" sz="1200" dirty="0"/>
           </a:p>
           <a:p>
             <a:pPr marL="342900" indent="-342900">
@@ -15760,7 +15739,7 @@
               <a:buChar char="▪"/>
             </a:pPr>
             <a:r>
-              <a:rPr lang="en-US" sz="1100" dirty="0">
+              <a:rPr lang="en-US" sz="1200" dirty="0">
                 <a:solidFill>
                   <a:srgbClr val="222A3F"/>
                 </a:solidFill>
@@ -15768,9 +15747,9 @@
                 <a:ea typeface="Arial" pitchFamily="34" charset="-122"/>
                 <a:cs typeface="Arial" pitchFamily="34" charset="-120"/>
               </a:rPr>
-              <a:t>The age readout is the honesty metric. The driver always knows how fresh the information is, and a stale ghost says so.</a:t>
-            </a:r>
-            <a:endParaRPr lang="en-US" sz="1100" dirty="0"/>
+              <a:t>The age readout is the honesty metric.</a:t>
+            </a:r>
+            <a:endParaRPr lang="en-US" sz="1200" dirty="0"/>
           </a:p>
           <a:p>
             <a:pPr marL="342900" indent="-342900">
@@ -15778,7 +15757,7 @@
               <a:buChar char="▪"/>
             </a:pPr>
             <a:r>
-              <a:rPr lang="en-US" sz="1100" dirty="0">
+              <a:rPr lang="en-US" sz="1200" dirty="0">
                 <a:solidFill>
                   <a:srgbClr val="222A3F"/>
                 </a:solidFill>
@@ -15786,9 +15765,9 @@
                 <a:ea typeface="Arial" pitchFamily="34" charset="-122"/>
                 <a:cs typeface="Arial" pitchFamily="34" charset="-120"/>
               </a:rPr>
-              <a:t>The banner, the chevron, and the rose fallback are all state machines reacting to live data.</a:t>
-            </a:r>
-            <a:endParaRPr lang="en-US" sz="1100" dirty="0"/>
+              <a:t>Banner, chevron, rose: state machines on live data.</a:t>
+            </a:r>
+            <a:endParaRPr lang="en-US" sz="1200" dirty="0"/>
           </a:p>
         </p:txBody>
       </p:sp>
@@ -16373,7 +16352,7 @@
               <a:buChar char="▪"/>
             </a:pPr>
             <a:r>
-              <a:rPr lang="en-US" sz="1250" dirty="0">
+              <a:rPr lang="en-US" sz="1300" dirty="0">
                 <a:solidFill>
                   <a:srgbClr val="222A3F"/>
                 </a:solidFill>
@@ -16381,9 +16360,9 @@
                 <a:ea typeface="Arial" pitchFamily="34" charset="-122"/>
                 <a:cs typeface="Arial" pitchFamily="34" charset="-120"/>
               </a:rPr>
-              <a:t>Modulation is the LONG_FAST preset: spreading factor 11 over 250 kHz with rate 4/5 forward error correction, in the 915 MHz ISM band, on a private AES-256 channel at full position precision.</a:t>
-            </a:r>
-            <a:endParaRPr lang="en-US" sz="1250" dirty="0"/>
+              <a:t>LONG_FAST: SF11 over 250 kHz, FEC 4/5, 915 MHz ISM, private AES-256 channel, full precision.</a:t>
+            </a:r>
+            <a:endParaRPr lang="en-US" sz="1300" dirty="0"/>
           </a:p>
           <a:p>
             <a:pPr marL="342900" indent="-342900">
@@ -16394,7 +16373,7 @@
               <a:buChar char="▪"/>
             </a:pPr>
             <a:r>
-              <a:rPr lang="en-US" sz="1250" dirty="0">
+              <a:rPr lang="en-US" sz="1300" dirty="0">
                 <a:solidFill>
                   <a:srgbClr val="222A3F"/>
                 </a:solidFill>
@@ -16402,9 +16381,9 @@
                 <a:ea typeface="Arial" pitchFamily="34" charset="-122"/>
                 <a:cs typeface="Arial" pitchFamily="34" charset="-120"/>
               </a:rPr>
-              <a:t>Smart broadcast sends every 10 seconds or 20 meters while moving and every 60 seconds parked. GPS refresh also runs at 10 seconds, so every broadcast carries a genuinely new fix.</a:t>
-            </a:r>
-            <a:endParaRPr lang="en-US" sz="1250" dirty="0"/>
+              <a:t>Smart broadcast 10 s / 20 m moving, 60 s parked. GPS refresh 10 s: every broadcast carries a new fix.</a:t>
+            </a:r>
+            <a:endParaRPr lang="en-US" sz="1300" dirty="0"/>
           </a:p>
           <a:p>
             <a:pPr marL="342900" indent="-342900">
@@ -16412,7 +16391,7 @@
               <a:buChar char="▪"/>
             </a:pPr>
             <a:r>
-              <a:rPr lang="en-US" sz="1250" dirty="0">
+              <a:rPr lang="en-US" sz="1300" dirty="0">
                 <a:solidFill>
                   <a:srgbClr val="222A3F"/>
                 </a:solidFill>
@@ -16420,9 +16399,9 @@
                 <a:ea typeface="Arial" pitchFamily="34" charset="-122"/>
                 <a:cs typeface="Arial" pitchFamily="34" charset="-120"/>
               </a:rPr>
-              <a:t>The radio's own OLED is a free field debugger. It shows satellites, nodes heard, channel utilization, and the signal strength of the last packet.</a:t>
-            </a:r>
-            <a:endParaRPr lang="en-US" sz="1250" dirty="0"/>
+              <a:t>The OLED is the free field debugger: satellites, nodes, utilization, last RSSI.</a:t>
+            </a:r>
+            <a:endParaRPr lang="en-US" sz="1300" dirty="0"/>
           </a:p>
         </p:txBody>
       </p:sp>
@@ -16489,14 +16468,14 @@
               </a:rPr>
               <a:t>PROVISIONING DISCIPLINE (hardware/README.md)</a:t>
             </a:r>
-            <a:endParaRPr lang="en-US" sz="1200" dirty="0"/>
-          </a:p>
-          <a:p>
-            <a:pPr indent="0" marL="0">
-              <a:buNone/>
-            </a:pPr>
-            <a:r>
-              <a:rPr lang="en-US" sz="1200" dirty="0">
+            <a:endParaRPr lang="en-US" sz="1250" dirty="0"/>
+          </a:p>
+          <a:p>
+            <a:pPr indent="0" marL="0">
+              <a:buNone/>
+            </a:pPr>
+            <a:r>
+              <a:rPr lang="en-US" sz="1250" dirty="0">
                 <a:solidFill>
                   <a:srgbClr val="222A3F"/>
                 </a:solidFill>
@@ -16504,9 +16483,9 @@
                 <a:ea typeface="Arial" pitchFamily="34" charset="-122"/>
                 <a:cs typeface="Arial" pitchFamily="34" charset="-120"/>
               </a:rPr>
-              <a:t>Radio number two must join with the exact channel URL, which embeds the encryption key. Two traps are documented from experience: settings that trigger a reboot can silently revert when written over the CLI, so every write is read back and verified, and identical boards demand explicit upload ports when flashing.</a:t>
-            </a:r>
-            <a:endParaRPr lang="en-US" sz="1200" dirty="0"/>
+              <a:t>Radio 2 joins with the exact channel URL (it carries the AES key). Verify every CLI write; always name the upload port.</a:t>
+            </a:r>
+            <a:endParaRPr lang="en-US" sz="1250" dirty="0"/>
           </a:p>
         </p:txBody>
       </p:sp>
@@ -17390,7 +17369,7 @@
                 <a:ea typeface="Arial" pitchFamily="34" charset="-122"/>
                 <a:cs typeface="Arial" pitchFamily="34" charset="-120"/>
               </a:rPr>
-              <a:t>Information reaches the driver about one second after it exists, which is real time by any useful definition. A new measurement can only be taken every ten seconds because each broadcast costs half a second of shared airtime: at one hertz, two vehicles would demand the entire channel. The same spreading factor that makes packets slow lets the receiver decode 15 dB below the noise floor, and that is where the kilometers come from. Dead reckoning fills the gaps at one hertz. Rate and range are the same currency, and we spent it on range.</a:t>
+              <a:t>Delivery is real time: about one second. Sampling is 10 s, because airtime is the currency and we bought range with it. Dead reckoning fills the gap at 1 Hz.</a:t>
             </a:r>
             <a:endParaRPr lang="en-US" sz="1150" dirty="0"/>
           </a:p>

</xml_diff>

<commit_message>
Cover and status numbers synced with the live tracker: 42%, 96 h
Week-3 hours updated on the tracker (16 per teammate, 20 for Deo);
cover title block and status tiles now match it.

Co-Authored-By: Claude Fable 5 <noreply@anthropic.com>
</commit_message>
<xml_diff>
--- a/docs/presentations/Group9_Presentation3_Week3.pptx
+++ b/docs/presentations/Group9_Presentation3_Week3.pptx
@@ -4646,7 +4646,7 @@
                 <a:ea typeface="Arial" pitchFamily="34" charset="-122"/>
                 <a:cs typeface="Arial" pitchFamily="34" charset="-120"/>
               </a:rPr>
-              <a:t>29% vs 19% target, ahead</a:t>
+              <a:t>42% vs 19% target, ahead</a:t>
             </a:r>
             <a:endParaRPr lang="en-US" sz="1050" dirty="0"/>
           </a:p>
@@ -4747,7 +4747,7 @@
                 <a:ea typeface="Arial" pitchFamily="34" charset="-122"/>
                 <a:cs typeface="Arial" pitchFamily="34" charset="-120"/>
               </a:rPr>
-              <a:t>60 of 768 logged</a:t>
+              <a:t>96 of 768 logged</a:t>
             </a:r>
             <a:endParaRPr lang="en-US" sz="1050" dirty="0"/>
           </a:p>
@@ -8298,7 +8298,7 @@
                 <a:ea typeface="Arial" pitchFamily="34" charset="-122"/>
                 <a:cs typeface="Arial" pitchFamily="34" charset="-120"/>
               </a:rPr>
-              <a:t>29%</a:t>
+              <a:t>42%</a:t>
             </a:r>
             <a:endParaRPr lang="en-US" sz="2700" dirty="0"/>
           </a:p>
@@ -8337,7 +8337,7 @@
                 <a:ea typeface="Arial" pitchFamily="34" charset="-122"/>
                 <a:cs typeface="Arial" pitchFamily="34" charset="-120"/>
               </a:rPr>
-              <a:t>complete against a 19% week-three target</a:t>
+              <a:t>of tasks complete against a 19% week-three target</a:t>
             </a:r>
             <a:endParaRPr lang="en-US" sz="1050" dirty="0"/>
           </a:p>
@@ -8401,7 +8401,7 @@
                 <a:ea typeface="Arial" pitchFamily="34" charset="-122"/>
                 <a:cs typeface="Arial" pitchFamily="34" charset="-120"/>
               </a:rPr>
-              <a:t>60 h</a:t>
+              <a:t>96 h</a:t>
             </a:r>
             <a:endParaRPr lang="en-US" sz="2700" dirty="0"/>
           </a:p>
@@ -8440,7 +8440,7 @@
                 <a:ea typeface="Arial" pitchFamily="34" charset="-122"/>
                 <a:cs typeface="Arial" pitchFamily="34" charset="-120"/>
               </a:rPr>
-              <a:t>logged, eight hours per member this week</a:t>
+              <a:t>logged through week three</a:t>
             </a:r>
             <a:endParaRPr lang="en-US" sz="1050" dirty="0"/>
           </a:p>

</xml_diff>

<commit_message>
Hours finalized: Deo 27, Josiah 19, Victor and Cannon 16 (78 total)
Tracker week-3 entries adjusted to the agreed member totals; cover
title block and status tile now read 78 of 768.

Co-Authored-By: Claude Fable 5 <noreply@anthropic.com>
</commit_message>
<xml_diff>
--- a/docs/presentations/Group9_Presentation3_Week3.pptx
+++ b/docs/presentations/Group9_Presentation3_Week3.pptx
@@ -4747,7 +4747,7 @@
                 <a:ea typeface="Arial" pitchFamily="34" charset="-122"/>
                 <a:cs typeface="Arial" pitchFamily="34" charset="-120"/>
               </a:rPr>
-              <a:t>96 of 768 logged</a:t>
+              <a:t>78 of 768 logged</a:t>
             </a:r>
             <a:endParaRPr lang="en-US" sz="1050" dirty="0"/>
           </a:p>
@@ -8401,7 +8401,7 @@
                 <a:ea typeface="Arial" pitchFamily="34" charset="-122"/>
                 <a:cs typeface="Arial" pitchFamily="34" charset="-120"/>
               </a:rPr>
-              <a:t>96 h</a:t>
+              <a:t>78 h</a:t>
             </a:r>
             <a:endParaRPr lang="en-US" sz="2700" dirty="0"/>
           </a:p>

</xml_diff>